<commit_message>
Refine bilingual PNS asthma posters
</commit_message>
<xml_diff>
--- a/outputs/posters/poster_pns_asma_classico_en.pptx
+++ b/outputs/posters/poster_pns_asma_classico_en.pptx
@@ -3908,7 +3908,7 @@
 </file>
 
 <file path=ppt/slides/slide1.xml><?xml version="1.0" encoding="utf-8"?>
-<p:sld xmlns:p="http://schemas.openxmlformats.org/presentationml/2006/main">
+<p:sld xmlns:a="http://schemas.openxmlformats.org/drawingml/2006/main" xmlns:ns3="http://schemas.microsoft.com/office/drawing/2014/main" xmlns:ns4="http://schemas.microsoft.com/office/powerpoint/2010/main" xmlns:p="http://schemas.openxmlformats.org/presentationml/2006/main" xmlns:r="http://schemas.openxmlformats.org/officeDocument/2006/relationships">
   <p:cSld>
     <p:spTree>
       <p:nvGrpSpPr>
@@ -3917,27 +3917,27 @@
         <p:nvPr/>
       </p:nvGrpSpPr>
       <p:grpSpPr>
-        <a:xfrm xmlns:a="http://schemas.openxmlformats.org/drawingml/2006/main"/>
+        <a:xfrm/>
       </p:grpSpPr>
       <p:pic>
         <p:nvPicPr>
           <p:cNvPr id="87" name="Imagem 3"/>
           <p:cNvPicPr>
-            <a:picLocks xmlns:a="http://schemas.openxmlformats.org/drawingml/2006/main" noChangeAspect="1"/>
+            <a:picLocks noChangeAspect="1"/>
           </p:cNvPicPr>
           <p:nvPr/>
         </p:nvPicPr>
         <p:blipFill>
-          <a:blip xmlns:r="http://schemas.openxmlformats.org/officeDocument/2006/relationships" xmlns:a="http://schemas.openxmlformats.org/drawingml/2006/main" r:embed="R92a6a4354c494ac2"/>
-          <a:srcRect xmlns:a="http://schemas.openxmlformats.org/drawingml/2006/main" l="0" t="41985" r="50251" b="34197"/>
-          <a:stretch xmlns:a="http://schemas.openxmlformats.org/drawingml/2006/main"/>
+          <a:blip r:embed="R92a6a4354c494ac2"/>
+          <a:srcRect l="0" t="41985" r="50251" b="34197"/>
+          <a:stretch/>
         </p:blipFill>
         <p:spPr>
-          <a:xfrm xmlns:a="http://schemas.openxmlformats.org/drawingml/2006/main" rot="0" flipH="1" flipV="0">
+          <a:xfrm rot="0" flipH="1" flipV="0">
             <a:off x="17442037" y="0"/>
             <a:ext cx="17548975" cy="4696690"/>
           </a:xfrm>
-          <a:prstGeom xmlns:a="http://schemas.openxmlformats.org/drawingml/2006/main" prst="rect">
+          <a:prstGeom prst="rect">
             <a:avLst/>
           </a:prstGeom>
         </p:spPr>
@@ -3946,21 +3946,21 @@
         <p:nvPicPr>
           <p:cNvPr id="88" name="Imagem 7"/>
           <p:cNvPicPr>
-            <a:picLocks xmlns:a="http://schemas.openxmlformats.org/drawingml/2006/main" noChangeAspect="1"/>
+            <a:picLocks noChangeAspect="1"/>
           </p:cNvPicPr>
           <p:nvPr/>
         </p:nvPicPr>
         <p:blipFill>
-          <a:blip xmlns:r="http://schemas.openxmlformats.org/officeDocument/2006/relationships" xmlns:a="http://schemas.openxmlformats.org/drawingml/2006/main" r:embed="R92a6a4354c494ac2"/>
-          <a:srcRect xmlns:a="http://schemas.openxmlformats.org/drawingml/2006/main" l="0" t="0" r="0" b="0"/>
-          <a:stretch xmlns:a="http://schemas.openxmlformats.org/drawingml/2006/main"/>
+          <a:blip r:embed="R92a6a4354c494ac2"/>
+          <a:srcRect l="0" t="0" r="0" b="0"/>
+          <a:stretch/>
         </p:blipFill>
         <p:spPr>
-          <a:xfrm xmlns:a="http://schemas.openxmlformats.org/drawingml/2006/main" rot="0" flipH="0" flipV="0">
+          <a:xfrm rot="0" flipH="0" flipV="0">
             <a:off x="34816366" y="0"/>
             <a:ext cx="8384272" cy="4696690"/>
           </a:xfrm>
-          <a:prstGeom xmlns:a="http://schemas.openxmlformats.org/drawingml/2006/main" prst="rect">
+          <a:prstGeom prst="rect">
             <a:avLst/>
           </a:prstGeom>
         </p:spPr>
@@ -3969,21 +3969,21 @@
         <p:nvPicPr>
           <p:cNvPr id="89" name="Imagem 12"/>
           <p:cNvPicPr>
-            <a:picLocks xmlns:a="http://schemas.openxmlformats.org/drawingml/2006/main" noChangeAspect="1"/>
+            <a:picLocks noChangeAspect="1"/>
           </p:cNvPicPr>
           <p:nvPr/>
         </p:nvPicPr>
         <p:blipFill>
-          <a:blip xmlns:r="http://schemas.openxmlformats.org/officeDocument/2006/relationships" xmlns:a="http://schemas.openxmlformats.org/drawingml/2006/main" r:embed="R92a6a4354c494ac2"/>
-          <a:srcRect xmlns:a="http://schemas.openxmlformats.org/drawingml/2006/main" l="0" t="41985" r="50251" b="34197"/>
-          <a:stretch xmlns:a="http://schemas.openxmlformats.org/drawingml/2006/main"/>
+          <a:blip r:embed="R92a6a4354c494ac2"/>
+          <a:srcRect l="0" t="41985" r="50251" b="34197"/>
+          <a:stretch/>
         </p:blipFill>
         <p:spPr>
-          <a:xfrm xmlns:a="http://schemas.openxmlformats.org/drawingml/2006/main" rot="10800000" flipH="1" flipV="0">
+          <a:xfrm rot="10800000" flipH="1" flipV="0">
             <a:off x="0" y="0"/>
             <a:ext cx="17548975" cy="4696690"/>
           </a:xfrm>
-          <a:prstGeom xmlns:a="http://schemas.openxmlformats.org/drawingml/2006/main" prst="rect">
+          <a:prstGeom prst="rect">
             <a:avLst/>
           </a:prstGeom>
         </p:spPr>
@@ -3992,22 +3992,22 @@
         <p:nvPicPr>
           <p:cNvPr id="90" name="Imagem 1"/>
           <p:cNvPicPr>
-            <a:picLocks xmlns:a="http://schemas.openxmlformats.org/drawingml/2006/main" noChangeAspect="1"/>
+            <a:picLocks noChangeAspect="1"/>
           </p:cNvPicPr>
           <p:nvPr/>
         </p:nvPicPr>
         <p:blipFill>
-          <a:blip xmlns:r="http://schemas.openxmlformats.org/officeDocument/2006/relationships" xmlns:a="http://schemas.openxmlformats.org/drawingml/2006/main" r:embed="R5e1ee536de09402a"/>
-          <a:stretch xmlns:a="http://schemas.openxmlformats.org/drawingml/2006/main">
+          <a:blip r:embed="R5e1ee536de09402a"/>
+          <a:stretch>
             <a:fillRect l="0" t="0" r="0" b="0"/>
           </a:stretch>
         </p:blipFill>
         <p:spPr>
-          <a:xfrm xmlns:a="http://schemas.openxmlformats.org/drawingml/2006/main">
+          <a:xfrm>
             <a:off x="1104806" y="872837"/>
             <a:ext cx="12528492" cy="2767312"/>
           </a:xfrm>
-          <a:prstGeom xmlns:a="http://schemas.openxmlformats.org/drawingml/2006/main" prst="rect">
+          <a:prstGeom prst="rect">
             <a:avLst/>
           </a:prstGeom>
         </p:spPr>
@@ -4015,44 +4015,44 @@
       <p:sp>
         <p:nvSpPr>
           <p:cNvPr id="5" name="CustomShape 2">
-            <a:extLst xmlns:a="http://schemas.openxmlformats.org/drawingml/2006/main">
-              <a:ext uri="{FF2B5EF4-FFF2-40B4-BE49-F238E27FC236}">
-                <a16:creationId xmlns:a16="http://schemas.microsoft.com/office/drawing/2014/main" id="{97065EEA-1F97-B0AB-DB63-C703872D214C}"/>
-              </a:ext>
-            </a:extLst>
-          </p:cNvPr>
-          <p:cNvSpPr>
-            <a:spLocks xmlns:a="http://schemas.openxmlformats.org/drawingml/2006/main" noGrp="1"/>
+            <a:extLst>
+              <a:ext uri="{FF2B5EF4-FFF2-40B4-BE49-F238E27FC236}">
+                <ns3:creationId id="{97065EEA-1F97-B0AB-DB63-C703872D214C}"/>
+              </a:ext>
+            </a:extLst>
+          </p:cNvPr>
+          <p:cNvSpPr>
+            <a:spLocks noGrp="1"/>
           </p:cNvSpPr>
           <p:nvPr/>
         </p:nvSpPr>
         <p:spPr>
-          <a:xfrm xmlns:a="http://schemas.openxmlformats.org/drawingml/2006/main">
+          <a:xfrm>
             <a:off x="1104806" y="6598088"/>
             <a:ext cx="9653040" cy="912960"/>
           </a:xfrm>
-          <a:prstGeom xmlns:a="http://schemas.openxmlformats.org/drawingml/2006/main" prst="rect">
+          <a:prstGeom prst="rect">
             <a:avLst/>
           </a:prstGeom>
-          <a:solidFill xmlns:a="http://schemas.openxmlformats.org/drawingml/2006/main">
+          <a:solidFill>
             <a:srgbClr val="1C425B"/>
           </a:solidFill>
-          <a:ln xmlns:a="http://schemas.openxmlformats.org/drawingml/2006/main">
+          <a:ln>
             <a:noFill/>
           </a:ln>
         </p:spPr>
         <p:style>
-          <a:lnRef xmlns:a="http://schemas.openxmlformats.org/drawingml/2006/main" idx="0"/>
-          <a:fillRef xmlns:a="http://schemas.openxmlformats.org/drawingml/2006/main" idx="0"/>
-          <a:effectRef xmlns:a="http://schemas.openxmlformats.org/drawingml/2006/main" idx="0"/>
-          <a:fontRef xmlns:a="http://schemas.openxmlformats.org/drawingml/2006/main" idx="minor"/>
+          <a:lnRef idx="0"/>
+          <a:fillRef idx="0"/>
+          <a:effectRef idx="0"/>
+          <a:fontRef idx="minor"/>
         </p:style>
         <p:txBody>
-          <a:bodyPr xmlns:a="http://schemas.openxmlformats.org/drawingml/2006/main" lIns="90000" tIns="45000" rIns="90000" bIns="45000">
+          <a:bodyPr lIns="90000" tIns="45000" rIns="90000" bIns="45000">
             <a:spAutoFit/>
           </a:bodyPr>
-          <a:lstStyle xmlns:a="http://schemas.openxmlformats.org/drawingml/2006/main"/>
-          <a:p xmlns:a="http://schemas.openxmlformats.org/drawingml/2006/main">
+          <a:lstStyle/>
+          <a:p>
             <a:pPr algn="ctr">
               <a:lnSpc>
                 <a:spcPct val="100000"/>
@@ -4076,44 +4076,44 @@
       <p:sp>
         <p:nvSpPr>
           <p:cNvPr id="6" name="CustomShape 3">
-            <a:extLst xmlns:a="http://schemas.openxmlformats.org/drawingml/2006/main">
-              <a:ext uri="{FF2B5EF4-FFF2-40B4-BE49-F238E27FC236}">
-                <a16:creationId xmlns:a16="http://schemas.microsoft.com/office/drawing/2014/main" id="{48DB915D-16AC-E3B6-FAA3-E37C175959BE}"/>
-              </a:ext>
-            </a:extLst>
-          </p:cNvPr>
-          <p:cNvSpPr>
-            <a:spLocks xmlns:a="http://schemas.openxmlformats.org/drawingml/2006/main" noGrp="1"/>
+            <a:extLst>
+              <a:ext uri="{FF2B5EF4-FFF2-40B4-BE49-F238E27FC236}">
+                <ns3:creationId id="{48DB915D-16AC-E3B6-FAA3-E37C175959BE}"/>
+              </a:ext>
+            </a:extLst>
+          </p:cNvPr>
+          <p:cNvSpPr>
+            <a:spLocks noGrp="1"/>
           </p:cNvSpPr>
           <p:nvPr/>
         </p:nvSpPr>
         <p:spPr>
-          <a:xfrm xmlns:a="http://schemas.openxmlformats.org/drawingml/2006/main">
+          <a:xfrm>
             <a:off x="11615726" y="6598088"/>
             <a:ext cx="9662400" cy="912960"/>
           </a:xfrm>
-          <a:prstGeom xmlns:a="http://schemas.openxmlformats.org/drawingml/2006/main" prst="rect">
+          <a:prstGeom prst="rect">
             <a:avLst/>
           </a:prstGeom>
-          <a:solidFill xmlns:a="http://schemas.openxmlformats.org/drawingml/2006/main">
+          <a:solidFill>
             <a:srgbClr val="1C425B"/>
           </a:solidFill>
-          <a:ln xmlns:a="http://schemas.openxmlformats.org/drawingml/2006/main">
+          <a:ln>
             <a:noFill/>
           </a:ln>
         </p:spPr>
         <p:style>
-          <a:lnRef xmlns:a="http://schemas.openxmlformats.org/drawingml/2006/main" idx="0"/>
-          <a:fillRef xmlns:a="http://schemas.openxmlformats.org/drawingml/2006/main" idx="0"/>
-          <a:effectRef xmlns:a="http://schemas.openxmlformats.org/drawingml/2006/main" idx="0"/>
-          <a:fontRef xmlns:a="http://schemas.openxmlformats.org/drawingml/2006/main" idx="minor"/>
+          <a:lnRef idx="0"/>
+          <a:fillRef idx="0"/>
+          <a:effectRef idx="0"/>
+          <a:fontRef idx="minor"/>
         </p:style>
         <p:txBody>
-          <a:bodyPr xmlns:a="http://schemas.openxmlformats.org/drawingml/2006/main" lIns="90000" tIns="45000" rIns="90000" bIns="45000">
+          <a:bodyPr lIns="90000" tIns="45000" rIns="90000" bIns="45000">
             <a:spAutoFit/>
           </a:bodyPr>
-          <a:lstStyle xmlns:a="http://schemas.openxmlformats.org/drawingml/2006/main"/>
-          <a:p xmlns:a="http://schemas.openxmlformats.org/drawingml/2006/main">
+          <a:lstStyle/>
+          <a:p>
             <a:pPr algn="ctr">
               <a:lnSpc>
                 <a:spcPct val="100000"/>
@@ -4137,44 +4137,44 @@
       <p:sp>
         <p:nvSpPr>
           <p:cNvPr id="7" name="CustomShape 4">
-            <a:extLst xmlns:a="http://schemas.openxmlformats.org/drawingml/2006/main">
-              <a:ext uri="{FF2B5EF4-FFF2-40B4-BE49-F238E27FC236}">
-                <a16:creationId xmlns:a16="http://schemas.microsoft.com/office/drawing/2014/main" id="{7132C9E5-17D9-B264-0383-B2207A7F61D8}"/>
-              </a:ext>
-            </a:extLst>
-          </p:cNvPr>
-          <p:cNvSpPr>
-            <a:spLocks xmlns:a="http://schemas.openxmlformats.org/drawingml/2006/main" noGrp="1"/>
+            <a:extLst>
+              <a:ext uri="{FF2B5EF4-FFF2-40B4-BE49-F238E27FC236}">
+                <ns3:creationId id="{7132C9E5-17D9-B264-0383-B2207A7F61D8}"/>
+              </a:ext>
+            </a:extLst>
+          </p:cNvPr>
+          <p:cNvSpPr>
+            <a:spLocks noGrp="1"/>
           </p:cNvSpPr>
           <p:nvPr/>
         </p:nvSpPr>
         <p:spPr>
-          <a:xfrm xmlns:a="http://schemas.openxmlformats.org/drawingml/2006/main">
+          <a:xfrm>
             <a:off x="22079126" y="6598088"/>
             <a:ext cx="9771840" cy="912960"/>
           </a:xfrm>
-          <a:prstGeom xmlns:a="http://schemas.openxmlformats.org/drawingml/2006/main" prst="rect">
+          <a:prstGeom prst="rect">
             <a:avLst/>
           </a:prstGeom>
-          <a:solidFill xmlns:a="http://schemas.openxmlformats.org/drawingml/2006/main">
+          <a:solidFill>
             <a:srgbClr val="1C425B"/>
           </a:solidFill>
-          <a:ln xmlns:a="http://schemas.openxmlformats.org/drawingml/2006/main">
+          <a:ln>
             <a:noFill/>
           </a:ln>
         </p:spPr>
         <p:style>
-          <a:lnRef xmlns:a="http://schemas.openxmlformats.org/drawingml/2006/main" idx="0"/>
-          <a:fillRef xmlns:a="http://schemas.openxmlformats.org/drawingml/2006/main" idx="0"/>
-          <a:effectRef xmlns:a="http://schemas.openxmlformats.org/drawingml/2006/main" idx="0"/>
-          <a:fontRef xmlns:a="http://schemas.openxmlformats.org/drawingml/2006/main" idx="minor"/>
+          <a:lnRef idx="0"/>
+          <a:fillRef idx="0"/>
+          <a:effectRef idx="0"/>
+          <a:fontRef idx="minor"/>
         </p:style>
         <p:txBody>
-          <a:bodyPr xmlns:a="http://schemas.openxmlformats.org/drawingml/2006/main" lIns="90000" tIns="45000" rIns="90000" bIns="45000">
+          <a:bodyPr lIns="90000" tIns="45000" rIns="90000" bIns="45000">
             <a:spAutoFit/>
           </a:bodyPr>
-          <a:lstStyle xmlns:a="http://schemas.openxmlformats.org/drawingml/2006/main"/>
-          <a:p xmlns:a="http://schemas.openxmlformats.org/drawingml/2006/main">
+          <a:lstStyle/>
+          <a:p>
             <a:pPr algn="ctr">
               <a:lnSpc>
                 <a:spcPct val="100000"/>
@@ -4198,44 +4198,44 @@
       <p:sp>
         <p:nvSpPr>
           <p:cNvPr id="9" name="CustomShape 5">
-            <a:extLst xmlns:a="http://schemas.openxmlformats.org/drawingml/2006/main">
-              <a:ext uri="{FF2B5EF4-FFF2-40B4-BE49-F238E27FC236}">
-                <a16:creationId xmlns:a16="http://schemas.microsoft.com/office/drawing/2014/main" id="{406CF098-4E00-65B3-A2A1-8BB69B132374}"/>
-              </a:ext>
-            </a:extLst>
-          </p:cNvPr>
-          <p:cNvSpPr>
-            <a:spLocks xmlns:a="http://schemas.openxmlformats.org/drawingml/2006/main" noGrp="1"/>
+            <a:extLst>
+              <a:ext uri="{FF2B5EF4-FFF2-40B4-BE49-F238E27FC236}">
+                <ns3:creationId id="{406CF098-4E00-65B3-A2A1-8BB69B132374}"/>
+              </a:ext>
+            </a:extLst>
+          </p:cNvPr>
+          <p:cNvSpPr>
+            <a:spLocks noGrp="1"/>
           </p:cNvSpPr>
           <p:nvPr/>
         </p:nvSpPr>
         <p:spPr>
-          <a:xfrm xmlns:a="http://schemas.openxmlformats.org/drawingml/2006/main">
+          <a:xfrm>
             <a:off x="32586446" y="6598088"/>
             <a:ext cx="9653040" cy="912960"/>
           </a:xfrm>
-          <a:prstGeom xmlns:a="http://schemas.openxmlformats.org/drawingml/2006/main" prst="rect">
+          <a:prstGeom prst="rect">
             <a:avLst/>
           </a:prstGeom>
-          <a:solidFill xmlns:a="http://schemas.openxmlformats.org/drawingml/2006/main">
+          <a:solidFill>
             <a:srgbClr val="1C425B"/>
           </a:solidFill>
-          <a:ln xmlns:a="http://schemas.openxmlformats.org/drawingml/2006/main">
+          <a:ln>
             <a:noFill/>
           </a:ln>
         </p:spPr>
         <p:style>
-          <a:lnRef xmlns:a="http://schemas.openxmlformats.org/drawingml/2006/main" idx="0"/>
-          <a:fillRef xmlns:a="http://schemas.openxmlformats.org/drawingml/2006/main" idx="0"/>
-          <a:effectRef xmlns:a="http://schemas.openxmlformats.org/drawingml/2006/main" idx="0"/>
-          <a:fontRef xmlns:a="http://schemas.openxmlformats.org/drawingml/2006/main" idx="minor"/>
+          <a:lnRef idx="0"/>
+          <a:fillRef idx="0"/>
+          <a:effectRef idx="0"/>
+          <a:fontRef idx="minor"/>
         </p:style>
         <p:txBody>
-          <a:bodyPr xmlns:a="http://schemas.openxmlformats.org/drawingml/2006/main" lIns="90000" tIns="45000" rIns="90000" bIns="45000">
+          <a:bodyPr lIns="90000" tIns="45000" rIns="90000" bIns="45000">
             <a:spAutoFit/>
           </a:bodyPr>
-          <a:lstStyle xmlns:a="http://schemas.openxmlformats.org/drawingml/2006/main"/>
-          <a:p xmlns:a="http://schemas.openxmlformats.org/drawingml/2006/main">
+          <a:lstStyle/>
+          <a:p>
             <a:pPr algn="ctr">
               <a:lnSpc>
                 <a:spcPct val="100000"/>
@@ -4259,53 +4259,42 @@
       <p:sp>
         <p:nvSpPr>
           <p:cNvPr id="12" name="CustomShape 7">
-            <a:extLst xmlns:a="http://schemas.openxmlformats.org/drawingml/2006/main">
-              <a:ext uri="{FF2B5EF4-FFF2-40B4-BE49-F238E27FC236}">
-                <a16:creationId xmlns:a16="http://schemas.microsoft.com/office/drawing/2014/main" id="{46F6B3F1-1DAC-2C19-6C8C-4906F4C63E42}"/>
-              </a:ext>
-            </a:extLst>
-          </p:cNvPr>
-          <p:cNvSpPr>
-            <a:spLocks xmlns:a="http://schemas.openxmlformats.org/drawingml/2006/main" noGrp="1"/>
+            <a:extLst>
+              <a:ext uri="{FF2B5EF4-FFF2-40B4-BE49-F238E27FC236}">
+                <ns3:creationId id="{46F6B3F1-1DAC-2C19-6C8C-4906F4C63E42}"/>
+              </a:ext>
+            </a:extLst>
+          </p:cNvPr>
+          <p:cNvSpPr>
+            <a:spLocks noGrp="1"/>
           </p:cNvSpPr>
           <p:nvPr/>
         </p:nvSpPr>
         <p:spPr>
-          <a:xfrm xmlns:a="http://schemas.openxmlformats.org/drawingml/2006/main">
+          <a:xfrm>
             <a:off x="32586446" y="8174528"/>
             <a:ext cx="9653040" cy="9416880"/>
           </a:xfrm>
-          <a:prstGeom xmlns:a="http://schemas.openxmlformats.org/drawingml/2006/main" prst="rect">
+          <a:prstGeom prst="rect">
             <a:avLst/>
           </a:prstGeom>
-          <a:noFill xmlns:a="http://schemas.openxmlformats.org/drawingml/2006/main"/>
-          <a:ln xmlns:a="http://schemas.openxmlformats.org/drawingml/2006/main">
+          <a:noFill/>
+          <a:ln>
             <a:noFill/>
           </a:ln>
         </p:spPr>
         <p:style>
-          <a:lnRef xmlns:a="http://schemas.openxmlformats.org/drawingml/2006/main" idx="0"/>
-          <a:fillRef xmlns:a="http://schemas.openxmlformats.org/drawingml/2006/main" idx="0"/>
-          <a:effectRef xmlns:a="http://schemas.openxmlformats.org/drawingml/2006/main" idx="0"/>
-          <a:fontRef xmlns:a="http://schemas.openxmlformats.org/drawingml/2006/main" idx="minor"/>
+          <a:lnRef idx="0"/>
+          <a:fillRef idx="0"/>
+          <a:effectRef idx="0"/>
+          <a:fontRef idx="minor"/>
         </p:style>
         <p:txBody>
-          <a:bodyPr xmlns:a="http://schemas.openxmlformats.org/drawingml/2006/main" lIns="90000" tIns="45000" rIns="90000" bIns="45000">
+          <a:bodyPr lIns="90000" tIns="45000" rIns="90000" bIns="45000">
             <a:spAutoFit/>
           </a:bodyPr>
-          <a:lstStyle xmlns:a="http://schemas.openxmlformats.org/drawingml/2006/main"/>
-          <a:p xmlns:a="http://schemas.openxmlformats.org/drawingml/2006/main">
-            <a:pPr algn="l">
-              <a:lnSpc>
-                <a:spcPct val="100000"/>
-              </a:lnSpc>
-              <a:buNone/>
-              <a:defRPr sz="2475" b="0" i="0">
-                <a:solidFill>
-                  <a:srgbClr val="111111"/>
-                </a:solidFill>
-              </a:defRPr>
-            </a:pPr>
+          <a:lstStyle/>
+          <a:p>
             <a:r>
               <a:rPr sz="2475" b="0" i="0">
                 <a:solidFill>
@@ -4315,61 +4304,11 @@
                 <a:ea typeface="Calibri"/>
                 <a:cs typeface="Calibri"/>
               </a:rPr>
-              <a:t>PNS design: `pns_design()` with PSU, strata and selected-resident weight. Lonely PSU: `survey.lonely.psu = "adjust"` plus adjusted domains.</a:t>
-            </a:r>
-          </a:p>
-        </p:txBody>
-      </p:sp>
-      <p:sp>
-        <p:nvSpPr>
-          <p:cNvPr id="15" name="CustomShape 8">
-            <a:extLst xmlns:a="http://schemas.openxmlformats.org/drawingml/2006/main">
-              <a:ext uri="{FF2B5EF4-FFF2-40B4-BE49-F238E27FC236}">
-                <a16:creationId xmlns:a16="http://schemas.microsoft.com/office/drawing/2014/main" id="{4C49EDB1-E810-9E0B-42AE-0BB4D2F8F777}"/>
-              </a:ext>
-            </a:extLst>
-          </p:cNvPr>
-          <p:cNvSpPr>
-            <a:spLocks xmlns:a="http://schemas.openxmlformats.org/drawingml/2006/main" noGrp="1"/>
-          </p:cNvSpPr>
-          <p:nvPr/>
-        </p:nvSpPr>
-        <p:spPr>
-          <a:xfrm xmlns:a="http://schemas.openxmlformats.org/drawingml/2006/main">
-            <a:off x="1104806" y="8174528"/>
-            <a:ext cx="9653040" cy="9416880"/>
-          </a:xfrm>
-          <a:prstGeom xmlns:a="http://schemas.openxmlformats.org/drawingml/2006/main" prst="rect">
-            <a:avLst/>
-          </a:prstGeom>
-          <a:noFill xmlns:a="http://schemas.openxmlformats.org/drawingml/2006/main"/>
-          <a:ln xmlns:a="http://schemas.openxmlformats.org/drawingml/2006/main">
-            <a:noFill/>
-          </a:ln>
-        </p:spPr>
-        <p:style>
-          <a:lnRef xmlns:a="http://schemas.openxmlformats.org/drawingml/2006/main" idx="0"/>
-          <a:fillRef xmlns:a="http://schemas.openxmlformats.org/drawingml/2006/main" idx="0"/>
-          <a:effectRef xmlns:a="http://schemas.openxmlformats.org/drawingml/2006/main" idx="0"/>
-          <a:fontRef xmlns:a="http://schemas.openxmlformats.org/drawingml/2006/main" idx="minor"/>
-        </p:style>
-        <p:txBody>
-          <a:bodyPr xmlns:a="http://schemas.openxmlformats.org/drawingml/2006/main" lIns="90000" tIns="45000" rIns="90000" bIns="45000">
-            <a:spAutoFit/>
-          </a:bodyPr>
-          <a:lstStyle xmlns:a="http://schemas.openxmlformats.org/drawingml/2006/main"/>
-          <a:p xmlns:a="http://schemas.openxmlformats.org/drawingml/2006/main">
-            <a:pPr algn="l">
-              <a:lnSpc>
-                <a:spcPct val="100000"/>
-              </a:lnSpc>
-              <a:buNone/>
-              <a:defRPr sz="2475" b="0" i="0">
-                <a:solidFill>
-                  <a:srgbClr val="111111"/>
-                </a:solidFill>
-              </a:defRPr>
-            </a:pPr>
+              <a:t>• PNS 2013/2019 selected-resident microdata.</a:t>
+            </a:r>
+            <a:endParaRPr/>
+          </a:p>
+          <a:p>
             <a:r>
               <a:rPr sz="2475" b="0" i="0">
                 <a:solidFill>
@@ -4379,61 +4318,11 @@
                 <a:ea typeface="Calibri"/>
                 <a:cs typeface="Calibri"/>
               </a:rPr>
-              <a:t>The PNS supports estimates of physician-diagnosed asthma, attacks, risk factors and medication use under a complex design representative of Brazil and states.</a:t>
-            </a:r>
-          </a:p>
-        </p:txBody>
-      </p:sp>
-      <p:sp>
-        <p:nvSpPr>
-          <p:cNvPr id="16" name="CustomShape 9">
-            <a:extLst xmlns:a="http://schemas.openxmlformats.org/drawingml/2006/main">
-              <a:ext uri="{FF2B5EF4-FFF2-40B4-BE49-F238E27FC236}">
-                <a16:creationId xmlns:a16="http://schemas.microsoft.com/office/drawing/2014/main" id="{65D3F8EB-7D4A-E5C1-86CC-E56DD6393A42}"/>
-              </a:ext>
-            </a:extLst>
-          </p:cNvPr>
-          <p:cNvSpPr>
-            <a:spLocks xmlns:a="http://schemas.openxmlformats.org/drawingml/2006/main" noGrp="1"/>
-          </p:cNvSpPr>
-          <p:nvPr/>
-        </p:nvSpPr>
-        <p:spPr>
-          <a:xfrm xmlns:a="http://schemas.openxmlformats.org/drawingml/2006/main">
-            <a:off x="11555246" y="8174528"/>
-            <a:ext cx="9653040" cy="9416880"/>
-          </a:xfrm>
-          <a:prstGeom xmlns:a="http://schemas.openxmlformats.org/drawingml/2006/main" prst="rect">
-            <a:avLst/>
-          </a:prstGeom>
-          <a:noFill xmlns:a="http://schemas.openxmlformats.org/drawingml/2006/main"/>
-          <a:ln xmlns:a="http://schemas.openxmlformats.org/drawingml/2006/main">
-            <a:noFill/>
-          </a:ln>
-        </p:spPr>
-        <p:style>
-          <a:lnRef xmlns:a="http://schemas.openxmlformats.org/drawingml/2006/main" idx="0"/>
-          <a:fillRef xmlns:a="http://schemas.openxmlformats.org/drawingml/2006/main" idx="0"/>
-          <a:effectRef xmlns:a="http://schemas.openxmlformats.org/drawingml/2006/main" idx="0"/>
-          <a:fontRef xmlns:a="http://schemas.openxmlformats.org/drawingml/2006/main" idx="minor"/>
-        </p:style>
-        <p:txBody>
-          <a:bodyPr xmlns:a="http://schemas.openxmlformats.org/drawingml/2006/main" lIns="90000" tIns="45000" rIns="90000" bIns="45000">
-            <a:spAutoFit/>
-          </a:bodyPr>
-          <a:lstStyle xmlns:a="http://schemas.openxmlformats.org/drawingml/2006/main"/>
-          <a:p xmlns:a="http://schemas.openxmlformats.org/drawingml/2006/main">
-            <a:pPr algn="l">
-              <a:lnSpc>
-                <a:spcPct val="100000"/>
-              </a:lnSpc>
-              <a:buNone/>
-              <a:defRPr sz="2475" b="0" i="0">
-                <a:solidFill>
-                  <a:srgbClr val="111111"/>
-                </a:solidFill>
-              </a:defRPr>
-            </a:pPr>
+              <a:t>• Survey design with `pns_design()`: PSU, strata and weights.</a:t>
+            </a:r>
+            <a:endParaRPr/>
+          </a:p>
+          <a:p>
             <a:r>
               <a:rPr sz="2475" b="0" i="0">
                 <a:solidFill>
@@ -4443,61 +4332,51 @@
                 <a:ea typeface="Calibri"/>
                 <a:cs typeface="Calibri"/>
               </a:rPr>
-              <a:t>Compare 2013 and 2019 using weighted estimates, 95% CIs and state-level plots, interpreting change through interval overlap.</a:t>
-            </a:r>
-          </a:p>
-        </p:txBody>
-      </p:sp>
-      <p:sp>
-        <p:nvSpPr>
-          <p:cNvPr id="17" name="CustomShape 10">
-            <a:extLst xmlns:a="http://schemas.openxmlformats.org/drawingml/2006/main">
-              <a:ext uri="{FF2B5EF4-FFF2-40B4-BE49-F238E27FC236}">
-                <a16:creationId xmlns:a16="http://schemas.microsoft.com/office/drawing/2014/main" id="{A24DE532-511C-BC83-1589-77636C1DAD94}"/>
-              </a:ext>
-            </a:extLst>
-          </p:cNvPr>
-          <p:cNvSpPr>
-            <a:spLocks xmlns:a="http://schemas.openxmlformats.org/drawingml/2006/main" noGrp="1"/>
+              <a:t>• Proportions estimated with `svyciprop(method = "beta")`, avoiding Wald weaknesses in states and small domains.</a:t>
+            </a:r>
+            <a:endParaRPr/>
+          </a:p>
+        </p:txBody>
+      </p:sp>
+      <p:sp>
+        <p:nvSpPr>
+          <p:cNvPr id="15" name="CustomShape 8">
+            <a:extLst>
+              <a:ext uri="{FF2B5EF4-FFF2-40B4-BE49-F238E27FC236}">
+                <ns3:creationId id="{4C49EDB1-E810-9E0B-42AE-0BB4D2F8F777}"/>
+              </a:ext>
+            </a:extLst>
+          </p:cNvPr>
+          <p:cNvSpPr>
+            <a:spLocks noGrp="1"/>
           </p:cNvSpPr>
           <p:nvPr/>
         </p:nvSpPr>
         <p:spPr>
-          <a:xfrm xmlns:a="http://schemas.openxmlformats.org/drawingml/2006/main">
-            <a:off x="22070846" y="8174528"/>
+          <a:xfrm>
+            <a:off x="1104806" y="8174528"/>
             <a:ext cx="9653040" cy="9416880"/>
           </a:xfrm>
-          <a:prstGeom xmlns:a="http://schemas.openxmlformats.org/drawingml/2006/main" prst="rect">
+          <a:prstGeom prst="rect">
             <a:avLst/>
           </a:prstGeom>
-          <a:noFill xmlns:a="http://schemas.openxmlformats.org/drawingml/2006/main"/>
-          <a:ln xmlns:a="http://schemas.openxmlformats.org/drawingml/2006/main">
+          <a:noFill/>
+          <a:ln>
             <a:noFill/>
           </a:ln>
         </p:spPr>
         <p:style>
-          <a:lnRef xmlns:a="http://schemas.openxmlformats.org/drawingml/2006/main" idx="0"/>
-          <a:fillRef xmlns:a="http://schemas.openxmlformats.org/drawingml/2006/main" idx="0"/>
-          <a:effectRef xmlns:a="http://schemas.openxmlformats.org/drawingml/2006/main" idx="0"/>
-          <a:fontRef xmlns:a="http://schemas.openxmlformats.org/drawingml/2006/main" idx="minor"/>
+          <a:lnRef idx="0"/>
+          <a:fillRef idx="0"/>
+          <a:effectRef idx="0"/>
+          <a:fontRef idx="minor"/>
         </p:style>
         <p:txBody>
-          <a:bodyPr xmlns:a="http://schemas.openxmlformats.org/drawingml/2006/main" lIns="90000" tIns="45000" rIns="90000" bIns="45000">
+          <a:bodyPr lIns="90000" tIns="45000" rIns="90000" bIns="45000">
             <a:spAutoFit/>
           </a:bodyPr>
-          <a:lstStyle xmlns:a="http://schemas.openxmlformats.org/drawingml/2006/main"/>
-          <a:p xmlns:a="http://schemas.openxmlformats.org/drawingml/2006/main">
-            <a:pPr algn="l">
-              <a:lnSpc>
-                <a:spcPct val="100000"/>
-              </a:lnSpc>
-              <a:buNone/>
-              <a:defRPr sz="2475" b="0" i="0">
-                <a:solidFill>
-                  <a:srgbClr val="111111"/>
-                </a:solidFill>
-              </a:defRPr>
-            </a:pPr>
+          <a:lstStyle/>
+          <a:p>
             <a:r>
               <a:rPr sz="2475" b="0" i="0">
                 <a:solidFill>
@@ -4507,8 +4386,201 @@
                 <a:ea typeface="Calibri"/>
                 <a:cs typeface="Calibri"/>
               </a:rPr>
-              <a:t>Ignoring weights, strata and clusters underestimates uncertainty. A reproducible R workflow makes the analysis auditable and reusable.</a:t>
-            </a:r>
+              <a:t>• PNS is a population-based household survey with a complex sampling design.</a:t>
+            </a:r>
+            <a:endParaRPr/>
+          </a:p>
+          <a:p>
+            <a:r>
+              <a:rPr sz="2475" b="0" i="0">
+                <a:solidFill>
+                  <a:srgbClr val="111111"/>
+                </a:solidFill>
+                <a:latin typeface="Calibri"/>
+                <a:ea typeface="Calibri"/>
+                <a:cs typeface="Calibri"/>
+              </a:rPr>
+              <a:t>• Epidemiological indicators summarize diagnosis, attacks, treatment and risk factors.</a:t>
+            </a:r>
+            <a:endParaRPr/>
+          </a:p>
+          <a:p>
+            <a:r>
+              <a:rPr sz="2475" b="0" i="0">
+                <a:solidFill>
+                  <a:srgbClr val="111111"/>
+                </a:solidFill>
+                <a:latin typeface="Calibri"/>
+                <a:ea typeface="Calibri"/>
+                <a:cs typeface="Calibri"/>
+              </a:rPr>
+              <a:t>• Asthma combines chronic burden, acute episodes and continuous management needs.</a:t>
+            </a:r>
+            <a:endParaRPr/>
+          </a:p>
+        </p:txBody>
+      </p:sp>
+      <p:sp>
+        <p:nvSpPr>
+          <p:cNvPr id="16" name="CustomShape 9">
+            <a:extLst>
+              <a:ext uri="{FF2B5EF4-FFF2-40B4-BE49-F238E27FC236}">
+                <ns3:creationId id="{65D3F8EB-7D4A-E5C1-86CC-E56DD6393A42}"/>
+              </a:ext>
+            </a:extLst>
+          </p:cNvPr>
+          <p:cNvSpPr>
+            <a:spLocks noGrp="1"/>
+          </p:cNvSpPr>
+          <p:nvPr/>
+        </p:nvSpPr>
+        <p:spPr>
+          <a:xfrm>
+            <a:off x="11555246" y="8174528"/>
+            <a:ext cx="9653040" cy="9416880"/>
+          </a:xfrm>
+          <a:prstGeom prst="rect">
+            <a:avLst/>
+          </a:prstGeom>
+          <a:noFill/>
+          <a:ln>
+            <a:noFill/>
+          </a:ln>
+        </p:spPr>
+        <p:style>
+          <a:lnRef idx="0"/>
+          <a:fillRef idx="0"/>
+          <a:effectRef idx="0"/>
+          <a:fontRef idx="minor"/>
+        </p:style>
+        <p:txBody>
+          <a:bodyPr lIns="90000" tIns="45000" rIns="90000" bIns="45000">
+            <a:spAutoFit/>
+          </a:bodyPr>
+          <a:lstStyle/>
+          <a:p>
+            <a:r>
+              <a:rPr sz="2475" b="0" i="0">
+                <a:solidFill>
+                  <a:srgbClr val="111111"/>
+                </a:solidFill>
+                <a:latin typeface="Calibri"/>
+                <a:ea typeface="Calibri"/>
+                <a:cs typeface="Calibri"/>
+              </a:rPr>
+              <a:t>• Compare Brazil and states between 2013 and 2019.</a:t>
+            </a:r>
+            <a:endParaRPr/>
+          </a:p>
+          <a:p>
+            <a:r>
+              <a:rPr sz="2475" b="0" i="0">
+                <a:solidFill>
+                  <a:srgbClr val="111111"/>
+                </a:solidFill>
+                <a:latin typeface="Calibri"/>
+                <a:ea typeface="Calibri"/>
+                <a:cs typeface="Calibri"/>
+              </a:rPr>
+              <a:t>• Estimate prevalence, attacks, medication use, smoking and complementary indicators.</a:t>
+            </a:r>
+            <a:endParaRPr/>
+          </a:p>
+          <a:p>
+            <a:r>
+              <a:rPr sz="2475" b="0" i="0">
+                <a:solidFill>
+                  <a:srgbClr val="111111"/>
+                </a:solidFill>
+                <a:latin typeface="Calibri"/>
+                <a:ea typeface="Calibri"/>
+                <a:cs typeface="Calibri"/>
+              </a:rPr>
+              <a:t>• Interpret change through effect size and 95% CI overlap.</a:t>
+            </a:r>
+            <a:endParaRPr/>
+          </a:p>
+        </p:txBody>
+      </p:sp>
+      <p:sp>
+        <p:nvSpPr>
+          <p:cNvPr id="17" name="CustomShape 10">
+            <a:extLst>
+              <a:ext uri="{FF2B5EF4-FFF2-40B4-BE49-F238E27FC236}">
+                <ns3:creationId id="{A24DE532-511C-BC83-1589-77636C1DAD94}"/>
+              </a:ext>
+            </a:extLst>
+          </p:cNvPr>
+          <p:cNvSpPr>
+            <a:spLocks noGrp="1"/>
+          </p:cNvSpPr>
+          <p:nvPr/>
+        </p:nvSpPr>
+        <p:spPr>
+          <a:xfrm>
+            <a:off x="22070846" y="8174528"/>
+            <a:ext cx="9653040" cy="9416880"/>
+          </a:xfrm>
+          <a:prstGeom prst="rect">
+            <a:avLst/>
+          </a:prstGeom>
+          <a:noFill/>
+          <a:ln>
+            <a:noFill/>
+          </a:ln>
+        </p:spPr>
+        <p:style>
+          <a:lnRef idx="0"/>
+          <a:fillRef idx="0"/>
+          <a:effectRef idx="0"/>
+          <a:fontRef idx="minor"/>
+        </p:style>
+        <p:txBody>
+          <a:bodyPr lIns="90000" tIns="45000" rIns="90000" bIns="45000">
+            <a:spAutoFit/>
+          </a:bodyPr>
+          <a:lstStyle/>
+          <a:p>
+            <a:r>
+              <a:rPr sz="2475" b="0" i="0">
+                <a:solidFill>
+                  <a:srgbClr val="111111"/>
+                </a:solidFill>
+                <a:latin typeface="Calibri"/>
+                <a:ea typeface="Calibri"/>
+                <a:cs typeface="Calibri"/>
+              </a:rPr>
+              <a:t>• Weights, strata and clusters are required for valid inference.</a:t>
+            </a:r>
+            <a:endParaRPr/>
+          </a:p>
+          <a:p>
+            <a:r>
+              <a:rPr sz="2475" b="0" i="0">
+                <a:solidFill>
+                  <a:srgbClr val="111111"/>
+                </a:solidFill>
+                <a:latin typeface="Calibri"/>
+                <a:ea typeface="Calibri"/>
+                <a:cs typeface="Calibri"/>
+              </a:rPr>
+              <a:t>• The reproducible R workflow makes the analysis auditable and reusable.</a:t>
+            </a:r>
+            <a:endParaRPr/>
+          </a:p>
+          <a:p>
+            <a:r>
+              <a:rPr sz="2475" b="0" i="0">
+                <a:solidFill>
+                  <a:srgbClr val="111111"/>
+                </a:solidFill>
+                <a:latin typeface="Calibri"/>
+                <a:ea typeface="Calibri"/>
+                <a:cs typeface="Calibri"/>
+              </a:rPr>
+              <a:t>• The methodological report documents ETL, indicators, figures and cross-linked references.</a:t>
+            </a:r>
+            <a:endParaRPr/>
           </a:p>
         </p:txBody>
       </p:sp>
@@ -4516,22 +4588,22 @@
         <p:nvPicPr>
           <p:cNvPr id="99" name="Imagem 22"/>
           <p:cNvPicPr>
-            <a:picLocks xmlns:a="http://schemas.openxmlformats.org/drawingml/2006/main" noChangeAspect="1"/>
+            <a:picLocks noChangeAspect="1"/>
           </p:cNvPicPr>
           <p:nvPr/>
         </p:nvPicPr>
         <p:blipFill>
-          <a:blip xmlns:r="http://schemas.openxmlformats.org/officeDocument/2006/relationships" xmlns:a="http://schemas.openxmlformats.org/drawingml/2006/main" r:embed="Rf68f1039f77b468b"/>
-          <a:stretch xmlns:a="http://schemas.openxmlformats.org/drawingml/2006/main">
+          <a:blip r:embed="Rf68f1039f77b468b"/>
+          <a:stretch>
             <a:fillRect l="0" t="0" r="0" b="0"/>
           </a:stretch>
         </p:blipFill>
         <p:spPr>
-          <a:xfrm xmlns:a="http://schemas.openxmlformats.org/drawingml/2006/main">
+          <a:xfrm>
             <a:off x="16844210" y="1861013"/>
             <a:ext cx="23547763" cy="1483024"/>
           </a:xfrm>
-          <a:prstGeom xmlns:a="http://schemas.openxmlformats.org/drawingml/2006/main" prst="rect">
+          <a:prstGeom prst="rect">
             <a:avLst/>
           </a:prstGeom>
         </p:spPr>
@@ -4539,43 +4611,35 @@
       <p:sp>
         <p:nvSpPr>
           <p:cNvPr id="28" name="poster-title">
-            <a:extLst xmlns:a="http://schemas.openxmlformats.org/drawingml/2006/main">
-              <a:ext uri="{FF2B5EF4-FFF2-40B4-BE49-F238E27FC236}">
-                <a16:creationId xmlns:a16="http://schemas.microsoft.com/office/drawing/2014/main" id="{A0CC36A0-5086-4A9C-8A25-CD894F699C28}"/>
-              </a:ext>
-            </a:extLst>
-          </p:cNvPr>
-          <p:cNvSpPr>
-            <a:spLocks xmlns:a="http://schemas.openxmlformats.org/drawingml/2006/main" noGrp="1"/>
+            <a:extLst>
+              <a:ext uri="{FF2B5EF4-FFF2-40B4-BE49-F238E27FC236}">
+                <ns3:creationId id="{A0CC36A0-5086-4A9C-8A25-CD894F699C28}"/>
+              </a:ext>
+            </a:extLst>
+          </p:cNvPr>
+          <p:cNvSpPr>
+            <a:spLocks noGrp="1"/>
           </p:cNvSpPr>
           <p:nvPr/>
         </p:nvSpPr>
         <p:spPr>
-          <a:xfrm xmlns:a="http://schemas.openxmlformats.org/drawingml/2006/main">
+          <a:xfrm>
             <a:off x="1095375" y="4953000"/>
             <a:ext cx="31432500" cy="876300"/>
           </a:xfrm>
-          <a:prstGeom xmlns:a="http://schemas.openxmlformats.org/drawingml/2006/main" prst="rect">
+          <a:prstGeom prst="rect">
             <a:avLst/>
           </a:prstGeom>
-          <a:noFill xmlns:a="http://schemas.openxmlformats.org/drawingml/2006/main"/>
-          <a:ln xmlns:a="http://schemas.openxmlformats.org/drawingml/2006/main" w="0">
+          <a:noFill/>
+          <a:ln w="0">
             <a:noFill/>
             <a:prstDash val="solid"/>
           </a:ln>
         </p:spPr>
         <p:txBody>
-          <a:bodyPr xmlns:a="http://schemas.openxmlformats.org/drawingml/2006/main"/>
-          <a:lstStyle xmlns:a="http://schemas.openxmlformats.org/drawingml/2006/main"/>
-          <a:p xmlns:a="http://schemas.openxmlformats.org/drawingml/2006/main">
-            <a:pPr algn="l">
-              <a:buNone/>
-              <a:defRPr sz="3225" b="1" i="0">
-                <a:solidFill>
-                  <a:srgbClr val="1C425B"/>
-                </a:solidFill>
-              </a:defRPr>
-            </a:pPr>
+          <a:bodyPr/>
+          <a:lstStyle/>
+          <a:p>
             <a:r>
               <a:rPr sz="3225" b="1" i="0">
                 <a:solidFill>
@@ -4587,41 +4651,42 @@
               </a:rPr>
               <a:t>Asthma in Brazil, 2013-2019: reproducible estimates using the National Health Survey sampling design</a:t>
             </a:r>
+            <a:endParaRPr/>
           </a:p>
         </p:txBody>
       </p:sp>
       <p:sp>
         <p:nvSpPr>
           <p:cNvPr id="29" name="poster-authors">
-            <a:extLst xmlns:a="http://schemas.openxmlformats.org/drawingml/2006/main">
-              <a:ext uri="{FF2B5EF4-FFF2-40B4-BE49-F238E27FC236}">
-                <a16:creationId xmlns:a16="http://schemas.microsoft.com/office/drawing/2014/main" id="{692C2025-6F3C-483D-B06B-F1D5925F3BD5}"/>
-              </a:ext>
-            </a:extLst>
-          </p:cNvPr>
-          <p:cNvSpPr>
-            <a:spLocks xmlns:a="http://schemas.openxmlformats.org/drawingml/2006/main" noGrp="1"/>
+            <a:extLst>
+              <a:ext uri="{FF2B5EF4-FFF2-40B4-BE49-F238E27FC236}">
+                <ns3:creationId id="{692C2025-6F3C-483D-B06B-F1D5925F3BD5}"/>
+              </a:ext>
+            </a:extLst>
+          </p:cNvPr>
+          <p:cNvSpPr>
+            <a:spLocks noGrp="1"/>
           </p:cNvSpPr>
           <p:nvPr/>
         </p:nvSpPr>
         <p:spPr>
-          <a:xfrm xmlns:a="http://schemas.openxmlformats.org/drawingml/2006/main">
+          <a:xfrm>
             <a:off x="1095375" y="5857875"/>
             <a:ext cx="31432500" cy="457200"/>
           </a:xfrm>
-          <a:prstGeom xmlns:a="http://schemas.openxmlformats.org/drawingml/2006/main" prst="rect">
+          <a:prstGeom prst="rect">
             <a:avLst/>
           </a:prstGeom>
-          <a:noFill xmlns:a="http://schemas.openxmlformats.org/drawingml/2006/main"/>
-          <a:ln xmlns:a="http://schemas.openxmlformats.org/drawingml/2006/main" w="0">
+          <a:noFill/>
+          <a:ln w="0">
             <a:noFill/>
             <a:prstDash val="solid"/>
           </a:ln>
         </p:spPr>
         <p:txBody>
-          <a:bodyPr xmlns:a="http://schemas.openxmlformats.org/drawingml/2006/main"/>
-          <a:lstStyle xmlns:a="http://schemas.openxmlformats.org/drawingml/2006/main"/>
-          <a:p xmlns:a="http://schemas.openxmlformats.org/drawingml/2006/main">
+          <a:bodyPr/>
+          <a:lstStyle/>
+          <a:p>
             <a:pPr algn="l">
               <a:buNone/>
               <a:defRPr sz="1800" b="0" i="0">
@@ -4647,29 +4712,29 @@
       <p:sp>
         <p:nvSpPr>
           <p:cNvPr id="73" name="section-METHODOLOGY - ESTIMATORS">
-            <a:extLst xmlns:a="http://schemas.openxmlformats.org/drawingml/2006/main">
-              <a:ext uri="{FF2B5EF4-FFF2-40B4-BE49-F238E27FC236}">
-                <a16:creationId xmlns:a16="http://schemas.microsoft.com/office/drawing/2014/main" id="{CFC3F683-FD42-45E1-A63B-B3E7EDF0EB47}"/>
-              </a:ext>
-            </a:extLst>
-          </p:cNvPr>
-          <p:cNvSpPr>
-            <a:spLocks xmlns:a="http://schemas.openxmlformats.org/drawingml/2006/main" noGrp="1"/>
+            <a:extLst>
+              <a:ext uri="{FF2B5EF4-FFF2-40B4-BE49-F238E27FC236}">
+                <ns3:creationId id="{CFC3F683-FD42-45E1-A63B-B3E7EDF0EB47}"/>
+              </a:ext>
+            </a:extLst>
+          </p:cNvPr>
+          <p:cNvSpPr>
+            <a:spLocks noGrp="1"/>
           </p:cNvSpPr>
           <p:nvPr/>
         </p:nvSpPr>
         <p:spPr>
-          <a:xfrm xmlns:a="http://schemas.openxmlformats.org/drawingml/2006/main">
+          <a:xfrm>
             <a:off x="1095375" y="11382375"/>
             <a:ext cx="20097750" cy="857250"/>
           </a:xfrm>
-          <a:prstGeom xmlns:a="http://schemas.openxmlformats.org/drawingml/2006/main" prst="rect">
+          <a:prstGeom prst="rect">
             <a:avLst/>
           </a:prstGeom>
-          <a:solidFill xmlns:a="http://schemas.openxmlformats.org/drawingml/2006/main">
+          <a:solidFill>
             <a:srgbClr val="1C425B"/>
           </a:solidFill>
-          <a:ln xmlns:a="http://schemas.openxmlformats.org/drawingml/2006/main" w="0">
+          <a:ln w="0">
             <a:solidFill>
               <a:srgbClr val="1C425B"/>
             </a:solidFill>
@@ -4680,35 +4745,35 @@
       <p:sp>
         <p:nvSpPr>
           <p:cNvPr id="74" name="section-label-METHODOLOGY - ESTIMATORS">
-            <a:extLst xmlns:a="http://schemas.openxmlformats.org/drawingml/2006/main">
-              <a:ext uri="{FF2B5EF4-FFF2-40B4-BE49-F238E27FC236}">
-                <a16:creationId xmlns:a16="http://schemas.microsoft.com/office/drawing/2014/main" id="{6E6097E0-E32E-4523-9EBA-E09854F59366}"/>
-              </a:ext>
-            </a:extLst>
-          </p:cNvPr>
-          <p:cNvSpPr>
-            <a:spLocks xmlns:a="http://schemas.openxmlformats.org/drawingml/2006/main" noGrp="1"/>
+            <a:extLst>
+              <a:ext uri="{FF2B5EF4-FFF2-40B4-BE49-F238E27FC236}">
+                <ns3:creationId id="{6E6097E0-E32E-4523-9EBA-E09854F59366}"/>
+              </a:ext>
+            </a:extLst>
+          </p:cNvPr>
+          <p:cNvSpPr>
+            <a:spLocks noGrp="1"/>
           </p:cNvSpPr>
           <p:nvPr/>
         </p:nvSpPr>
         <p:spPr>
-          <a:xfrm xmlns:a="http://schemas.openxmlformats.org/drawingml/2006/main">
+          <a:xfrm>
             <a:off x="1095375" y="11477625"/>
             <a:ext cx="20097750" cy="781050"/>
           </a:xfrm>
-          <a:prstGeom xmlns:a="http://schemas.openxmlformats.org/drawingml/2006/main" prst="rect">
+          <a:prstGeom prst="rect">
             <a:avLst/>
           </a:prstGeom>
-          <a:noFill xmlns:a="http://schemas.openxmlformats.org/drawingml/2006/main"/>
-          <a:ln xmlns:a="http://schemas.openxmlformats.org/drawingml/2006/main" w="0">
+          <a:noFill/>
+          <a:ln w="0">
             <a:noFill/>
             <a:prstDash val="solid"/>
           </a:ln>
         </p:spPr>
         <p:txBody>
-          <a:bodyPr xmlns:a="http://schemas.openxmlformats.org/drawingml/2006/main"/>
-          <a:lstStyle xmlns:a="http://schemas.openxmlformats.org/drawingml/2006/main"/>
-          <a:p xmlns:a="http://schemas.openxmlformats.org/drawingml/2006/main">
+          <a:bodyPr/>
+          <a:lstStyle/>
+          <a:p>
             <a:pPr algn="ctr">
               <a:defRPr sz="2250" b="1" i="0">
                 <a:solidFill>
@@ -4733,42 +4798,35 @@
       <p:sp>
         <p:nvSpPr>
           <p:cNvPr id="75" name="method-detail-classic">
-            <a:extLst xmlns:a="http://schemas.openxmlformats.org/drawingml/2006/main">
-              <a:ext uri="{FF2B5EF4-FFF2-40B4-BE49-F238E27FC236}">
-                <a16:creationId xmlns:a16="http://schemas.microsoft.com/office/drawing/2014/main" id="{F5E5917A-3E97-4CAA-BFFC-D5EE88A457B8}"/>
-              </a:ext>
-            </a:extLst>
-          </p:cNvPr>
-          <p:cNvSpPr>
-            <a:spLocks xmlns:a="http://schemas.openxmlformats.org/drawingml/2006/main" noGrp="1"/>
+            <a:extLst>
+              <a:ext uri="{FF2B5EF4-FFF2-40B4-BE49-F238E27FC236}">
+                <ns3:creationId id="{F5E5917A-3E97-4CAA-BFFC-D5EE88A457B8}"/>
+              </a:ext>
+            </a:extLst>
+          </p:cNvPr>
+          <p:cNvSpPr>
+            <a:spLocks noGrp="1"/>
           </p:cNvSpPr>
           <p:nvPr/>
         </p:nvSpPr>
         <p:spPr>
-          <a:xfrm xmlns:a="http://schemas.openxmlformats.org/drawingml/2006/main">
+          <a:xfrm>
             <a:off x="1190625" y="12430125"/>
-            <a:ext cx="19907250" cy="4000500"/>
+            <a:ext cx="19907250" cy="2150000"/>
           </a:xfrm>
-          <a:prstGeom xmlns:a="http://schemas.openxmlformats.org/drawingml/2006/main" prst="rect">
+          <a:prstGeom prst="rect">
             <a:avLst/>
           </a:prstGeom>
-          <a:noFill xmlns:a="http://schemas.openxmlformats.org/drawingml/2006/main"/>
-          <a:ln xmlns:a="http://schemas.openxmlformats.org/drawingml/2006/main" w="0">
+          <a:noFill/>
+          <a:ln w="0">
             <a:noFill/>
             <a:prstDash val="solid"/>
           </a:ln>
         </p:spPr>
         <p:txBody>
-          <a:bodyPr xmlns:a="http://schemas.openxmlformats.org/drawingml/2006/main"/>
-          <a:lstStyle xmlns:a="http://schemas.openxmlformats.org/drawingml/2006/main"/>
-          <a:p xmlns:a="http://schemas.openxmlformats.org/drawingml/2006/main">
-            <a:pPr algn="l">
-              <a:defRPr sz="2325" b="0" i="0">
-                <a:solidFill>
-                  <a:srgbClr val="111111"/>
-                </a:solidFill>
-              </a:defRPr>
-            </a:pPr>
+          <a:bodyPr/>
+          <a:lstStyle/>
+          <a:p>
             <a:r>
               <a:rPr sz="2325" b="0" i="0">
                 <a:solidFill>
@@ -4778,37 +4836,66 @@
                 <a:ea typeface="Calibri"/>
                 <a:cs typeface="Calibri"/>
               </a:rPr>
-              <a:t>Weighted estimator: p_hat = sum(w_i y_i) / sum(w_i). Percent: 100*p_hat. Rate per 100,000: 100000*p_hat. 95% CI uses `survey::svyciprop(method = "beta")`, keeping the proportional scale before rescaling.</a:t>
-            </a:r>
+              <a:t>• Q074, Q076, Q07701/Q07704/Q07708 and P050 were recoded into comparable indicators.</a:t>
+            </a:r>
+            <a:endParaRPr/>
+          </a:p>
+          <a:p>
+            <a:r>
+              <a:rPr sz="2325" b="0" i="0">
+                <a:solidFill>
+                  <a:srgbClr val="111111"/>
+                </a:solidFill>
+                <a:latin typeface="Calibri"/>
+                <a:ea typeface="Calibri"/>
+                <a:cs typeface="Calibri"/>
+              </a:rPr>
+              <a:t>• Rates per 100,000 rescale weighted proportions while preserving original uncertainty.</a:t>
+            </a:r>
+            <a:endParaRPr/>
+          </a:p>
+          <a:p>
+            <a:r>
+              <a:rPr sz="2325" b="0" i="0">
+                <a:solidFill>
+                  <a:srgbClr val="111111"/>
+                </a:solidFill>
+                <a:latin typeface="Calibri"/>
+                <a:ea typeface="Calibri"/>
+                <a:cs typeface="Calibri"/>
+              </a:rPr>
+              <a:t>• 2013-2019 comparisons combine point estimates, 95% CIs and state-level reading.</a:t>
+            </a:r>
+            <a:endParaRPr/>
           </a:p>
         </p:txBody>
       </p:sp>
       <p:sp>
         <p:nvSpPr>
           <p:cNvPr id="76" name="section-READING THE RESULTS">
-            <a:extLst xmlns:a="http://schemas.openxmlformats.org/drawingml/2006/main">
-              <a:ext uri="{FF2B5EF4-FFF2-40B4-BE49-F238E27FC236}">
-                <a16:creationId xmlns:a16="http://schemas.microsoft.com/office/drawing/2014/main" id="{7AC056C2-F59A-4399-B0C4-A696A64C1482}"/>
-              </a:ext>
-            </a:extLst>
-          </p:cNvPr>
-          <p:cNvSpPr>
-            <a:spLocks xmlns:a="http://schemas.openxmlformats.org/drawingml/2006/main" noGrp="1"/>
+            <a:extLst>
+              <a:ext uri="{FF2B5EF4-FFF2-40B4-BE49-F238E27FC236}">
+                <ns3:creationId id="{7AC056C2-F59A-4399-B0C4-A696A64C1482}"/>
+              </a:ext>
+            </a:extLst>
+          </p:cNvPr>
+          <p:cNvSpPr>
+            <a:spLocks noGrp="1"/>
           </p:cNvSpPr>
           <p:nvPr/>
         </p:nvSpPr>
         <p:spPr>
-          <a:xfrm xmlns:a="http://schemas.openxmlformats.org/drawingml/2006/main">
+          <a:xfrm>
             <a:off x="22078950" y="11382375"/>
             <a:ext cx="20173950" cy="857250"/>
           </a:xfrm>
-          <a:prstGeom xmlns:a="http://schemas.openxmlformats.org/drawingml/2006/main" prst="rect">
+          <a:prstGeom prst="rect">
             <a:avLst/>
           </a:prstGeom>
-          <a:solidFill xmlns:a="http://schemas.openxmlformats.org/drawingml/2006/main">
+          <a:solidFill>
             <a:srgbClr val="1C425B"/>
           </a:solidFill>
-          <a:ln xmlns:a="http://schemas.openxmlformats.org/drawingml/2006/main" w="0">
+          <a:ln w="0">
             <a:solidFill>
               <a:srgbClr val="1C425B"/>
             </a:solidFill>
@@ -4819,35 +4906,35 @@
       <p:sp>
         <p:nvSpPr>
           <p:cNvPr id="77" name="section-label-READING THE RESULTS">
-            <a:extLst xmlns:a="http://schemas.openxmlformats.org/drawingml/2006/main">
-              <a:ext uri="{FF2B5EF4-FFF2-40B4-BE49-F238E27FC236}">
-                <a16:creationId xmlns:a16="http://schemas.microsoft.com/office/drawing/2014/main" id="{1F22A5DD-414B-476D-8B73-BEFF12E0A1A3}"/>
-              </a:ext>
-            </a:extLst>
-          </p:cNvPr>
-          <p:cNvSpPr>
-            <a:spLocks xmlns:a="http://schemas.openxmlformats.org/drawingml/2006/main" noGrp="1"/>
+            <a:extLst>
+              <a:ext uri="{FF2B5EF4-FFF2-40B4-BE49-F238E27FC236}">
+                <ns3:creationId id="{1F22A5DD-414B-476D-8B73-BEFF12E0A1A3}"/>
+              </a:ext>
+            </a:extLst>
+          </p:cNvPr>
+          <p:cNvSpPr>
+            <a:spLocks noGrp="1"/>
           </p:cNvSpPr>
           <p:nvPr/>
         </p:nvSpPr>
         <p:spPr>
-          <a:xfrm xmlns:a="http://schemas.openxmlformats.org/drawingml/2006/main">
+          <a:xfrm>
             <a:off x="22078950" y="11477625"/>
             <a:ext cx="20173950" cy="781050"/>
           </a:xfrm>
-          <a:prstGeom xmlns:a="http://schemas.openxmlformats.org/drawingml/2006/main" prst="rect">
+          <a:prstGeom prst="rect">
             <a:avLst/>
           </a:prstGeom>
-          <a:noFill xmlns:a="http://schemas.openxmlformats.org/drawingml/2006/main"/>
-          <a:ln xmlns:a="http://schemas.openxmlformats.org/drawingml/2006/main" w="0">
+          <a:noFill/>
+          <a:ln w="0">
             <a:noFill/>
             <a:prstDash val="solid"/>
           </a:ln>
         </p:spPr>
         <p:txBody>
-          <a:bodyPr xmlns:a="http://schemas.openxmlformats.org/drawingml/2006/main"/>
-          <a:lstStyle xmlns:a="http://schemas.openxmlformats.org/drawingml/2006/main"/>
-          <a:p xmlns:a="http://schemas.openxmlformats.org/drawingml/2006/main">
+          <a:bodyPr/>
+          <a:lstStyle/>
+          <a:p>
             <a:pPr algn="ctr">
               <a:defRPr sz="2250" b="1" i="0">
                 <a:solidFill>
@@ -4872,42 +4959,35 @@
       <p:sp>
         <p:nvSpPr>
           <p:cNvPr id="78" name="analysis-detail-classic">
-            <a:extLst xmlns:a="http://schemas.openxmlformats.org/drawingml/2006/main">
-              <a:ext uri="{FF2B5EF4-FFF2-40B4-BE49-F238E27FC236}">
-                <a16:creationId xmlns:a16="http://schemas.microsoft.com/office/drawing/2014/main" id="{B213A8E8-6A9D-47B3-AE14-B7E979E2D6AD}"/>
-              </a:ext>
-            </a:extLst>
-          </p:cNvPr>
-          <p:cNvSpPr>
-            <a:spLocks xmlns:a="http://schemas.openxmlformats.org/drawingml/2006/main" noGrp="1"/>
+            <a:extLst>
+              <a:ext uri="{FF2B5EF4-FFF2-40B4-BE49-F238E27FC236}">
+                <ns3:creationId id="{B213A8E8-6A9D-47B3-AE14-B7E979E2D6AD}"/>
+              </a:ext>
+            </a:extLst>
+          </p:cNvPr>
+          <p:cNvSpPr>
+            <a:spLocks noGrp="1"/>
           </p:cNvSpPr>
           <p:nvPr/>
         </p:nvSpPr>
         <p:spPr>
-          <a:xfrm xmlns:a="http://schemas.openxmlformats.org/drawingml/2006/main">
+          <a:xfrm>
             <a:off x="22174200" y="12430125"/>
             <a:ext cx="19907250" cy="4095750"/>
           </a:xfrm>
-          <a:prstGeom xmlns:a="http://schemas.openxmlformats.org/drawingml/2006/main" prst="rect">
+          <a:prstGeom prst="rect">
             <a:avLst/>
           </a:prstGeom>
-          <a:noFill xmlns:a="http://schemas.openxmlformats.org/drawingml/2006/main"/>
-          <a:ln xmlns:a="http://schemas.openxmlformats.org/drawingml/2006/main" w="0">
+          <a:noFill/>
+          <a:ln w="0">
             <a:noFill/>
             <a:prstDash val="solid"/>
           </a:ln>
         </p:spPr>
         <p:txBody>
-          <a:bodyPr xmlns:a="http://schemas.openxmlformats.org/drawingml/2006/main"/>
-          <a:lstStyle xmlns:a="http://schemas.openxmlformats.org/drawingml/2006/main"/>
-          <a:p xmlns:a="http://schemas.openxmlformats.org/drawingml/2006/main">
-            <a:pPr algn="l">
-              <a:defRPr sz="2325" b="0" i="0">
-                <a:solidFill>
-                  <a:srgbClr val="111111"/>
-                </a:solidFill>
-              </a:defRPr>
-            </a:pPr>
+          <a:bodyPr/>
+          <a:lstStyle/>
+          <a:p>
             <a:r>
               <a:rPr sz="2325" b="0" i="0">
                 <a:solidFill>
@@ -4917,50 +4997,114 @@
                 <a:ea typeface="Calibri"/>
                 <a:cs typeface="Calibri"/>
               </a:rPr>
-              <a:t>Asthma increased in Brazil (4.41% to 5.40%; non-overlapping CIs). Attacks were stable (38.3% to 37.7%; overlapping CIs). Medication use among people with asthma decreased (81.5% to 64.4%); the population rate of medication users has overlapping CIs.</a:t>
-            </a:r>
+              <a:t>• Physician-diagnosed asthma increased in Brazil: 4.41% -&gt; 5.40%; CIs did not overlap.</a:t>
+            </a:r>
+            <a:endParaRPr/>
+          </a:p>
+          <a:p>
+            <a:r>
+              <a:rPr sz="2325" b="0" i="0">
+                <a:solidFill>
+                  <a:srgbClr val="111111"/>
+                </a:solidFill>
+                <a:latin typeface="Calibri"/>
+                <a:ea typeface="Calibri"/>
+                <a:cs typeface="Calibri"/>
+              </a:rPr>
+              <a:t>• Attacks in the previous 12 months were approximately stable: 38.3% -&gt; 37.7%.</a:t>
+            </a:r>
+            <a:endParaRPr/>
+          </a:p>
+          <a:p>
+            <a:r>
+              <a:rPr sz="2325" b="0" i="0">
+                <a:solidFill>
+                  <a:srgbClr val="111111"/>
+                </a:solidFill>
+                <a:latin typeface="Calibri"/>
+                <a:ea typeface="Calibri"/>
+                <a:cs typeface="Calibri"/>
+              </a:rPr>
+              <a:t>• Oral medication or inhaler use among people with asthma declined: 81.5% -&gt; 64.4%; interpret cautiously.</a:t>
+            </a:r>
+            <a:endParaRPr/>
+          </a:p>
+          <a:p>
+            <a:r>
+              <a:rPr sz="2325" b="0" i="0">
+                <a:solidFill>
+                  <a:srgbClr val="111111"/>
+                </a:solidFill>
+                <a:latin typeface="Calibri"/>
+                <a:ea typeface="Calibri"/>
+                <a:cs typeface="Calibri"/>
+              </a:rPr>
+              <a:t>• Population medication rates separate total burden from the share among diagnosed people.</a:t>
+            </a:r>
+            <a:endParaRPr/>
+          </a:p>
+          <a:p>
+            <a:r>
+              <a:rPr sz="2325" b="0" i="0">
+                <a:solidFill>
+                  <a:srgbClr val="111111"/>
+                </a:solidFill>
+                <a:latin typeface="Calibri"/>
+                <a:ea typeface="Calibri"/>
+                <a:cs typeface="Calibri"/>
+              </a:rPr>
+              <a:t>• Smoking declined in several states, but does not by itself explain the diagnosis increase.</a:t>
+            </a:r>
+            <a:endParaRPr/>
+          </a:p>
+          <a:p>
+            <a:r>
+              <a:rPr sz="2325" b="0" i="0">
+                <a:solidFill>
+                  <a:srgbClr val="111111"/>
+                </a:solidFill>
+                <a:latin typeface="Calibri"/>
+                <a:ea typeface="Calibri"/>
+                <a:cs typeface="Calibri"/>
+              </a:rPr>
+              <a:t>• Findings suggest more diagnosis without proportional improvement in disease control.</a:t>
+            </a:r>
+            <a:endParaRPr/>
           </a:p>
         </p:txBody>
       </p:sp>
       <p:sp>
         <p:nvSpPr>
           <p:cNvPr id="79" name="references-compact-classic">
-            <a:extLst xmlns:a="http://schemas.openxmlformats.org/drawingml/2006/main">
-              <a:ext uri="{FF2B5EF4-FFF2-40B4-BE49-F238E27FC236}">
-                <a16:creationId xmlns:a16="http://schemas.microsoft.com/office/drawing/2014/main" id="{7EC50D04-C9C4-4C8A-A647-FA02AC0CE47F}"/>
-              </a:ext>
-            </a:extLst>
-          </p:cNvPr>
-          <p:cNvSpPr>
-            <a:spLocks xmlns:a="http://schemas.openxmlformats.org/drawingml/2006/main" noGrp="1"/>
+            <a:extLst>
+              <a:ext uri="{FF2B5EF4-FFF2-40B4-BE49-F238E27FC236}">
+                <ns3:creationId id="{7EC50D04-C9C4-4C8A-A647-FA02AC0CE47F}"/>
+              </a:ext>
+            </a:extLst>
+          </p:cNvPr>
+          <p:cNvSpPr>
+            <a:spLocks noGrp="1"/>
           </p:cNvSpPr>
           <p:nvPr/>
         </p:nvSpPr>
         <p:spPr>
-          <a:xfrm xmlns:a="http://schemas.openxmlformats.org/drawingml/2006/main">
+          <a:xfrm>
             <a:off x="22098000" y="30289500"/>
-            <a:ext cx="20097750" cy="1238250"/>
+            <a:ext cx="16000000" cy="1238250"/>
           </a:xfrm>
-          <a:prstGeom xmlns:a="http://schemas.openxmlformats.org/drawingml/2006/main" prst="rect">
+          <a:prstGeom prst="rect">
             <a:avLst/>
           </a:prstGeom>
-          <a:noFill xmlns:a="http://schemas.openxmlformats.org/drawingml/2006/main"/>
-          <a:ln xmlns:a="http://schemas.openxmlformats.org/drawingml/2006/main" w="0">
+          <a:noFill/>
+          <a:ln w="0">
             <a:noFill/>
             <a:prstDash val="solid"/>
           </a:ln>
         </p:spPr>
         <p:txBody>
-          <a:bodyPr xmlns:a="http://schemas.openxmlformats.org/drawingml/2006/main"/>
-          <a:lstStyle xmlns:a="http://schemas.openxmlformats.org/drawingml/2006/main"/>
-          <a:p xmlns:a="http://schemas.openxmlformats.org/drawingml/2006/main">
-            <a:pPr algn="l">
-              <a:defRPr sz="1500" b="0" i="0">
-                <a:solidFill>
-                  <a:srgbClr val="111111"/>
-                </a:solidFill>
-              </a:defRPr>
-            </a:pPr>
+          <a:bodyPr/>
+          <a:lstStyle/>
+          <a:p>
             <a:r>
               <a:rPr sz="1500" b="0" i="0">
                 <a:solidFill>
@@ -4970,37 +5114,38 @@
                 <a:ea typeface="Calibri"/>
                 <a:cs typeface="Calibri"/>
               </a:rPr>
-              <a:t>[1] Global Asthma Network, 2022. [2] Souza-Júnior et al., 2015. [3] Dube; Silva, GitHub, 2026. [4] Menezes et al., 2015. [5] Severe Asthma.</a:t>
-            </a:r>
+              <a:t>[1] Global Asthma Network, 2022. [2] Souza-Júnior et al., 2015. [3] Dube; Silva, 2026. [4] Menezes et al., 2015. [5] Santos et al., 2018. [6] Brown; Cai; DasGupta, 2001. [7] Korn; Graubard, 1998.</a:t>
+            </a:r>
+            <a:endParaRPr/>
           </a:p>
         </p:txBody>
       </p:sp>
       <p:sp>
         <p:nvSpPr>
           <p:cNvPr id="80" name="section-PLOTS EXPORTED FROM THE R CODE">
-            <a:extLst xmlns:a="http://schemas.openxmlformats.org/drawingml/2006/main">
-              <a:ext uri="{FF2B5EF4-FFF2-40B4-BE49-F238E27FC236}">
-                <a16:creationId xmlns:a16="http://schemas.microsoft.com/office/drawing/2014/main" id="{E3CF9961-D363-4902-A8B6-F868F346E294}"/>
-              </a:ext>
-            </a:extLst>
-          </p:cNvPr>
-          <p:cNvSpPr>
-            <a:spLocks xmlns:a="http://schemas.openxmlformats.org/drawingml/2006/main" noGrp="1"/>
+            <a:extLst>
+              <a:ext uri="{FF2B5EF4-FFF2-40B4-BE49-F238E27FC236}">
+                <ns3:creationId id="{E3CF9961-D363-4902-A8B6-F868F346E294}"/>
+              </a:ext>
+            </a:extLst>
+          </p:cNvPr>
+          <p:cNvSpPr>
+            <a:spLocks noGrp="1"/>
           </p:cNvSpPr>
           <p:nvPr/>
         </p:nvSpPr>
         <p:spPr>
-          <a:xfrm xmlns:a="http://schemas.openxmlformats.org/drawingml/2006/main">
+          <a:xfrm>
             <a:off x="1095375" y="16954500"/>
             <a:ext cx="41148000" cy="857250"/>
           </a:xfrm>
-          <a:prstGeom xmlns:a="http://schemas.openxmlformats.org/drawingml/2006/main" prst="rect">
+          <a:prstGeom prst="rect">
             <a:avLst/>
           </a:prstGeom>
-          <a:solidFill xmlns:a="http://schemas.openxmlformats.org/drawingml/2006/main">
+          <a:solidFill>
             <a:srgbClr val="1C425B"/>
           </a:solidFill>
-          <a:ln xmlns:a="http://schemas.openxmlformats.org/drawingml/2006/main" w="0">
+          <a:ln w="0">
             <a:solidFill>
               <a:srgbClr val="1C425B"/>
             </a:solidFill>
@@ -5011,35 +5156,35 @@
       <p:sp>
         <p:nvSpPr>
           <p:cNvPr id="81" name="section-label-PLOTS EXPORTED FROM THE R CODE">
-            <a:extLst xmlns:a="http://schemas.openxmlformats.org/drawingml/2006/main">
-              <a:ext uri="{FF2B5EF4-FFF2-40B4-BE49-F238E27FC236}">
-                <a16:creationId xmlns:a16="http://schemas.microsoft.com/office/drawing/2014/main" id="{8455B684-4458-4E86-8E47-69BFBAA9B4D6}"/>
-              </a:ext>
-            </a:extLst>
-          </p:cNvPr>
-          <p:cNvSpPr>
-            <a:spLocks xmlns:a="http://schemas.openxmlformats.org/drawingml/2006/main" noGrp="1"/>
+            <a:extLst>
+              <a:ext uri="{FF2B5EF4-FFF2-40B4-BE49-F238E27FC236}">
+                <ns3:creationId id="{8455B684-4458-4E86-8E47-69BFBAA9B4D6}"/>
+              </a:ext>
+            </a:extLst>
+          </p:cNvPr>
+          <p:cNvSpPr>
+            <a:spLocks noGrp="1"/>
           </p:cNvSpPr>
           <p:nvPr/>
         </p:nvSpPr>
         <p:spPr>
-          <a:xfrm xmlns:a="http://schemas.openxmlformats.org/drawingml/2006/main">
+          <a:xfrm>
             <a:off x="1095375" y="17049750"/>
             <a:ext cx="41148000" cy="781050"/>
           </a:xfrm>
-          <a:prstGeom xmlns:a="http://schemas.openxmlformats.org/drawingml/2006/main" prst="rect">
+          <a:prstGeom prst="rect">
             <a:avLst/>
           </a:prstGeom>
-          <a:noFill xmlns:a="http://schemas.openxmlformats.org/drawingml/2006/main"/>
-          <a:ln xmlns:a="http://schemas.openxmlformats.org/drawingml/2006/main" w="0">
+          <a:noFill/>
+          <a:ln w="0">
             <a:noFill/>
             <a:prstDash val="solid"/>
           </a:ln>
         </p:spPr>
         <p:txBody>
-          <a:bodyPr xmlns:a="http://schemas.openxmlformats.org/drawingml/2006/main"/>
-          <a:lstStyle xmlns:a="http://schemas.openxmlformats.org/drawingml/2006/main"/>
-          <a:p xmlns:a="http://schemas.openxmlformats.org/drawingml/2006/main">
+          <a:bodyPr/>
+          <a:lstStyle/>
+          <a:p>
             <a:pPr algn="ctr">
               <a:defRPr sz="2250" b="1" i="0">
                 <a:solidFill>
@@ -5065,20 +5210,20 @@
         <p:nvPicPr>
           <p:cNvPr id="111" name=""/>
           <p:cNvPicPr>
-            <a:picLocks xmlns:a="http://schemas.openxmlformats.org/drawingml/2006/main" noChangeAspect="1"/>
+            <a:picLocks noChangeAspect="1"/>
           </p:cNvPicPr>
           <p:nvPr/>
         </p:nvPicPr>
         <p:blipFill>
-          <a:blip xmlns:r="http://schemas.openxmlformats.org/officeDocument/2006/relationships" xmlns:a="http://schemas.openxmlformats.org/drawingml/2006/main" r:embed="R74faf17efef34079"/>
-          <a:stretch xmlns:a="http://schemas.openxmlformats.org/drawingml/2006/main"/>
+          <a:blip r:embed="R74faf17efef34079"/>
+          <a:stretch/>
         </p:blipFill>
         <p:spPr>
-          <a:xfrm xmlns:a="http://schemas.openxmlformats.org/drawingml/2006/main">
+          <a:xfrm>
             <a:off x="1319893" y="18097500"/>
             <a:ext cx="19267714" cy="5619750"/>
           </a:xfrm>
-          <a:prstGeom xmlns:a="http://schemas.openxmlformats.org/drawingml/2006/main" prst="rect">
+          <a:prstGeom prst="rect">
             <a:avLst/>
           </a:prstGeom>
         </p:spPr>
@@ -5087,20 +5232,20 @@
         <p:nvPicPr>
           <p:cNvPr id="112" name=""/>
           <p:cNvPicPr>
-            <a:picLocks xmlns:a="http://schemas.openxmlformats.org/drawingml/2006/main" noChangeAspect="1"/>
+            <a:picLocks noChangeAspect="1"/>
           </p:cNvPicPr>
           <p:nvPr/>
         </p:nvPicPr>
         <p:blipFill>
-          <a:blip xmlns:r="http://schemas.openxmlformats.org/officeDocument/2006/relationships" xmlns:a="http://schemas.openxmlformats.org/drawingml/2006/main" r:embed="Rac080a698a904d49"/>
-          <a:stretch xmlns:a="http://schemas.openxmlformats.org/drawingml/2006/main"/>
+          <a:blip r:embed="Rac080a698a904d49"/>
+          <a:stretch/>
         </p:blipFill>
         <p:spPr>
-          <a:xfrm xmlns:a="http://schemas.openxmlformats.org/drawingml/2006/main">
+          <a:xfrm>
             <a:off x="22751143" y="18097500"/>
             <a:ext cx="19267714" cy="5619750"/>
           </a:xfrm>
-          <a:prstGeom xmlns:a="http://schemas.openxmlformats.org/drawingml/2006/main" prst="rect">
+          <a:prstGeom prst="rect">
             <a:avLst/>
           </a:prstGeom>
         </p:spPr>
@@ -5109,20 +5254,20 @@
         <p:nvPicPr>
           <p:cNvPr id="113" name=""/>
           <p:cNvPicPr>
-            <a:picLocks xmlns:a="http://schemas.openxmlformats.org/drawingml/2006/main" noChangeAspect="1"/>
+            <a:picLocks noChangeAspect="1"/>
           </p:cNvPicPr>
           <p:nvPr/>
         </p:nvPicPr>
         <p:blipFill>
-          <a:blip xmlns:r="http://schemas.openxmlformats.org/officeDocument/2006/relationships" xmlns:a="http://schemas.openxmlformats.org/drawingml/2006/main" r:embed="R54b955d7ea1f4f19"/>
-          <a:stretch xmlns:a="http://schemas.openxmlformats.org/drawingml/2006/main"/>
+          <a:blip r:embed="R54b955d7ea1f4f19"/>
+          <a:stretch/>
         </p:blipFill>
         <p:spPr>
-          <a:xfrm xmlns:a="http://schemas.openxmlformats.org/drawingml/2006/main">
+          <a:xfrm>
             <a:off x="1319893" y="24098250"/>
             <a:ext cx="19267714" cy="5619750"/>
           </a:xfrm>
-          <a:prstGeom xmlns:a="http://schemas.openxmlformats.org/drawingml/2006/main" prst="rect">
+          <a:prstGeom prst="rect">
             <a:avLst/>
           </a:prstGeom>
         </p:spPr>
@@ -5131,20 +5276,20 @@
         <p:nvPicPr>
           <p:cNvPr id="114" name=""/>
           <p:cNvPicPr>
-            <a:picLocks xmlns:a="http://schemas.openxmlformats.org/drawingml/2006/main" noChangeAspect="1"/>
+            <a:picLocks noChangeAspect="1"/>
           </p:cNvPicPr>
           <p:nvPr/>
         </p:nvPicPr>
         <p:blipFill>
-          <a:blip xmlns:r="http://schemas.openxmlformats.org/officeDocument/2006/relationships" xmlns:a="http://schemas.openxmlformats.org/drawingml/2006/main" r:embed="Rb38f6300ddc549e8"/>
-          <a:stretch xmlns:a="http://schemas.openxmlformats.org/drawingml/2006/main"/>
+          <a:blip r:embed="Rb38f6300ddc549e8"/>
+          <a:stretch/>
         </p:blipFill>
         <p:spPr>
-          <a:xfrm xmlns:a="http://schemas.openxmlformats.org/drawingml/2006/main">
+          <a:xfrm>
             <a:off x="22751143" y="24098250"/>
             <a:ext cx="19267714" cy="5619750"/>
           </a:xfrm>
-          <a:prstGeom xmlns:a="http://schemas.openxmlformats.org/drawingml/2006/main" prst="rect">
+          <a:prstGeom prst="rect">
             <a:avLst/>
           </a:prstGeom>
         </p:spPr>
@@ -5152,42 +5297,35 @@
       <p:sp>
         <p:nvSpPr>
           <p:cNvPr id="86" name="chart-caption-classic">
-            <a:extLst xmlns:a="http://schemas.openxmlformats.org/drawingml/2006/main">
-              <a:ext uri="{FF2B5EF4-FFF2-40B4-BE49-F238E27FC236}">
-                <a16:creationId xmlns:a16="http://schemas.microsoft.com/office/drawing/2014/main" id="{B636EB6F-7F30-4B69-92DF-8D920586EB46}"/>
-              </a:ext>
-            </a:extLst>
-          </p:cNvPr>
-          <p:cNvSpPr>
-            <a:spLocks xmlns:a="http://schemas.openxmlformats.org/drawingml/2006/main" noGrp="1"/>
+            <a:extLst>
+              <a:ext uri="{FF2B5EF4-FFF2-40B4-BE49-F238E27FC236}">
+                <ns3:creationId id="{B636EB6F-7F30-4B69-92DF-8D920586EB46}"/>
+              </a:ext>
+            </a:extLst>
+          </p:cNvPr>
+          <p:cNvSpPr>
+            <a:spLocks noGrp="1"/>
           </p:cNvSpPr>
           <p:nvPr/>
         </p:nvSpPr>
         <p:spPr>
-          <a:xfrm xmlns:a="http://schemas.openxmlformats.org/drawingml/2006/main">
+          <a:xfrm>
             <a:off x="1095375" y="29860875"/>
             <a:ext cx="21050250" cy="1238250"/>
           </a:xfrm>
-          <a:prstGeom xmlns:a="http://schemas.openxmlformats.org/drawingml/2006/main" prst="rect">
+          <a:prstGeom prst="rect">
             <a:avLst/>
           </a:prstGeom>
-          <a:noFill xmlns:a="http://schemas.openxmlformats.org/drawingml/2006/main"/>
-          <a:ln xmlns:a="http://schemas.openxmlformats.org/drawingml/2006/main" w="0">
+          <a:noFill/>
+          <a:ln w="0">
             <a:noFill/>
             <a:prstDash val="solid"/>
           </a:ln>
         </p:spPr>
         <p:txBody>
-          <a:bodyPr xmlns:a="http://schemas.openxmlformats.org/drawingml/2006/main"/>
-          <a:lstStyle xmlns:a="http://schemas.openxmlformats.org/drawingml/2006/main"/>
-          <a:p xmlns:a="http://schemas.openxmlformats.org/drawingml/2006/main">
-            <a:pPr algn="l">
-              <a:defRPr sz="1650" b="0" i="0">
-                <a:solidFill>
-                  <a:srgbClr val="555555"/>
-                </a:solidFill>
-              </a:defRPr>
-            </a:pPr>
+          <a:bodyPr/>
+          <a:lstStyle/>
+          <a:p>
             <a:r>
               <a:rPr sz="1650" b="0" i="0">
                 <a:solidFill>
@@ -5197,7 +5335,164 @@
                 <a:ea typeface="Calibri"/>
                 <a:cs typeface="Calibri"/>
               </a:rPr>
-              <a:t>The plots above are direct exports from the R plotting pattern: horizontal state-level bars, 2013/2019 comparison and 95% CI error bars. Brazil appears at the end of the scale as defined in the code.</a:t>
+              <a:t>• Figures are exported from the R code using `geom_col`, `geom_errorbar`, `coord_flip` and 95% CIs.</a:t>
+            </a:r>
+            <a:endParaRPr/>
+          </a:p>
+          <a:p>
+            <a:r>
+              <a:rPr sz="1650" b="0" i="0">
+                <a:solidFill>
+                  <a:srgbClr val="555555"/>
+                </a:solidFill>
+                <a:latin typeface="Calibri"/>
+                <a:ea typeface="Calibri"/>
+                <a:cs typeface="Calibri"/>
+              </a:rPr>
+              <a:t>• CI bars prevent interpretation based only on bar height.</a:t>
+            </a:r>
+            <a:endParaRPr/>
+          </a:p>
+          <a:p>
+            <a:r>
+              <a:rPr sz="1650" b="0" i="0">
+                <a:solidFill>
+                  <a:srgbClr val="555555"/>
+                </a:solidFill>
+                <a:latin typeface="Calibri"/>
+                <a:ea typeface="Calibri"/>
+                <a:cs typeface="Calibri"/>
+              </a:rPr>
+              <a:t>• State-level patterns remain exploratory when intervals overlap.</a:t>
+            </a:r>
+            <a:endParaRPr/>
+          </a:p>
+        </p:txBody>
+      </p:sp>
+      <p:sp>
+        <p:nvSpPr>
+          <p:cNvPr id="115" name="formula-box-classic-en"/>
+          <p:cNvSpPr txBox="1"/>
+          <p:nvPr/>
+        </p:nvSpPr>
+        <p:spPr>
+          <a:xfrm>
+            <a:off x="1190625" y="14720000"/>
+            <a:ext cx="19907250" cy="1750000"/>
+          </a:xfrm>
+          <a:prstGeom prst="rect">
+            <a:avLst/>
+          </a:prstGeom>
+          <a:solidFill>
+            <a:srgbClr val="F2F7FB"/>
+          </a:solidFill>
+          <a:ln w="19050">
+            <a:solidFill>
+              <a:srgbClr val="1F4E79"/>
+            </a:solidFill>
+          </a:ln>
+        </p:spPr>
+        <p:txBody>
+          <a:bodyPr wrap="square" lIns="91440" rIns="91440" tIns="91440" bIns="91440" anchor="ctr"/>
+          <a:lstStyle/>
+          <a:p>
+            <a:pPr algn="ctr"/>
+            <a:r>
+              <a:rPr lang="pt-BR" sz="1300" b="1">
+                <a:latin typeface="Aptos"/>
+              </a:rPr>
+              <a:t>FORMULAS</a:t>
+            </a:r>
+          </a:p>
+          <a:p>
+            <a:pPr algn="ctr"/>
+            <a:r>
+              <a:rPr lang="pt-BR" sz="1300" b="1">
+                <a:latin typeface="Cambria Math"/>
+              </a:rPr>
+              <a:t>p̂ = Σ wᵢyᵢ / Σ wᵢ</a:t>
+            </a:r>
+          </a:p>
+          <a:p>
+            <a:pPr algn="ctr"/>
+            <a:r>
+              <a:rPr lang="pt-BR" sz="1300" b="1">
+                <a:latin typeface="Cambria Math"/>
+              </a:rPr>
+              <a:t>% = 100 × p̂</a:t>
+            </a:r>
+          </a:p>
+          <a:p>
+            <a:pPr algn="ctr"/>
+            <a:r>
+              <a:rPr lang="pt-BR" sz="1300" b="1">
+                <a:latin typeface="Cambria Math"/>
+              </a:rPr>
+              <a:t>rate₁₀₀k = 100000 × p̂</a:t>
+            </a:r>
+          </a:p>
+          <a:p>
+            <a:pPr algn="ctr"/>
+            <a:r>
+              <a:rPr lang="pt-BR" sz="1300" b="1">
+                <a:latin typeface="Aptos"/>
+              </a:rPr>
+              <a:t>95% CI: beta</a:t>
+            </a:r>
+          </a:p>
+        </p:txBody>
+      </p:sp>
+      <p:sp>
+        <p:nvSpPr>
+          <p:cNvPr id="116" name="qr-placeholder-classic-en"/>
+          <p:cNvSpPr txBox="1"/>
+          <p:nvPr/>
+        </p:nvSpPr>
+        <p:spPr>
+          <a:xfrm>
+            <a:off x="39200000" y="29620000"/>
+            <a:ext cx="2300000" cy="2300000"/>
+          </a:xfrm>
+          <a:prstGeom prst="rect">
+            <a:avLst/>
+          </a:prstGeom>
+          <a:solidFill>
+            <a:srgbClr val="FFFFFF"/>
+          </a:solidFill>
+          <a:ln w="19050">
+            <a:solidFill>
+              <a:srgbClr val="1F4E79"/>
+            </a:solidFill>
+          </a:ln>
+        </p:spPr>
+        <p:txBody>
+          <a:bodyPr wrap="square" lIns="91440" rIns="91440" tIns="91440" bIns="91440" anchor="ctr"/>
+          <a:lstStyle/>
+          <a:p>
+            <a:pPr algn="ctr"/>
+            <a:r>
+              <a:rPr lang="pt-BR" sz="850" b="1">
+                <a:latin typeface="Aptos"/>
+              </a:rPr>
+              <a:t>QR CODE</a:t>
+            </a:r>
+          </a:p>
+          <a:p>
+            <a:pPr algn="ctr"/>
+            <a:r>
+              <a:rPr lang="pt-BR" sz="850" b="1">
+                <a:latin typeface="Aptos"/>
+              </a:rPr>
+              <a:t>Methodological report</a:t>
+            </a:r>
+          </a:p>
+          <a:p>
+            <a:pPr algn="ctr"/>
+            <a:r>
+              <a:rPr lang="pt-BR" sz="850" b="1">
+                <a:latin typeface="Aptos"/>
+              </a:rPr>
+              <a:t>ingodube.github.io/PNS_2013_2019</a:t>
             </a:r>
           </a:p>
         </p:txBody>
@@ -5205,7 +5500,7 @@
     </p:spTree>
     <p:extLst>
       <p:ext uri="{BB962C8B-B14F-4D97-AF65-F5344CB8AC3E}">
-        <p14:creationId xmlns:p14="http://schemas.microsoft.com/office/powerpoint/2010/main" val="654859156"/>
+        <ns4:creationId val="654859156"/>
       </p:ext>
     </p:extLst>
   </p:cSld>

</xml_diff>

<commit_message>
Expand methodological detail in asthma posters
</commit_message>
<xml_diff>
--- a/outputs/posters/poster_pns_asma_classico_en.pptx
+++ b/outputs/posters/poster_pns_asma_classico_en.pptx
@@ -3908,7 +3908,7 @@
 </file>
 
 <file path=ppt/slides/slide1.xml><?xml version="1.0" encoding="utf-8"?>
-<p:sld xmlns:a="http://schemas.openxmlformats.org/drawingml/2006/main" xmlns:ns3="http://schemas.microsoft.com/office/drawing/2014/main" xmlns:ns4="http://schemas.microsoft.com/office/powerpoint/2010/main" xmlns:p="http://schemas.openxmlformats.org/presentationml/2006/main" xmlns:r="http://schemas.openxmlformats.org/officeDocument/2006/relationships">
+<p:sld xmlns:a="http://schemas.openxmlformats.org/drawingml/2006/main" xmlns:ns2="http://schemas.openxmlformats.org/officeDocument/2006/relationships" xmlns:ns3="http://schemas.microsoft.com/office/drawing/2014/main" xmlns:ns4="http://schemas.microsoft.com/office/powerpoint/2010/main" xmlns:p="http://schemas.openxmlformats.org/presentationml/2006/main">
   <p:cSld>
     <p:spTree>
       <p:nvGrpSpPr>
@@ -3928,7 +3928,7 @@
           <p:nvPr/>
         </p:nvPicPr>
         <p:blipFill>
-          <a:blip r:embed="R92a6a4354c494ac2"/>
+          <a:blip ns2:embed="R92a6a4354c494ac2"/>
           <a:srcRect l="0" t="41985" r="50251" b="34197"/>
           <a:stretch/>
         </p:blipFill>
@@ -3951,7 +3951,7 @@
           <p:nvPr/>
         </p:nvPicPr>
         <p:blipFill>
-          <a:blip r:embed="R92a6a4354c494ac2"/>
+          <a:blip ns2:embed="R92a6a4354c494ac2"/>
           <a:srcRect l="0" t="0" r="0" b="0"/>
           <a:stretch/>
         </p:blipFill>
@@ -3974,7 +3974,7 @@
           <p:nvPr/>
         </p:nvPicPr>
         <p:blipFill>
-          <a:blip r:embed="R92a6a4354c494ac2"/>
+          <a:blip ns2:embed="R92a6a4354c494ac2"/>
           <a:srcRect l="0" t="41985" r="50251" b="34197"/>
           <a:stretch/>
         </p:blipFill>
@@ -3997,7 +3997,7 @@
           <p:nvPr/>
         </p:nvPicPr>
         <p:blipFill>
-          <a:blip r:embed="R5e1ee536de09402a"/>
+          <a:blip ns2:embed="R5e1ee536de09402a"/>
           <a:stretch>
             <a:fillRect l="0" t="0" r="0" b="0"/>
           </a:stretch>
@@ -4290,49 +4290,175 @@
           <a:fontRef idx="minor"/>
         </p:style>
         <p:txBody>
-          <a:bodyPr lIns="90000" tIns="45000" rIns="90000" bIns="45000">
+          <a:bodyPr lIns="90000" tIns="45000" rIns="90000" bIns="45000" wrap="square">
             <a:spAutoFit/>
           </a:bodyPr>
           <a:lstStyle/>
           <a:p>
             <a:r>
-              <a:rPr sz="2475" b="0" i="0">
-                <a:solidFill>
-                  <a:srgbClr val="111111"/>
-                </a:solidFill>
-                <a:latin typeface="Calibri"/>
-                <a:ea typeface="Calibri"/>
-                <a:cs typeface="Calibri"/>
-              </a:rPr>
-              <a:t>• PNS 2013/2019 selected-resident microdata.</a:t>
-            </a:r>
-            <a:endParaRPr/>
-          </a:p>
-          <a:p>
-            <a:r>
-              <a:rPr sz="2475" b="0" i="0">
-                <a:solidFill>
-                  <a:srgbClr val="111111"/>
-                </a:solidFill>
-                <a:latin typeface="Calibri"/>
-                <a:ea typeface="Calibri"/>
-                <a:cs typeface="Calibri"/>
-              </a:rPr>
-              <a:t>• Survey design with `pns_design()`: PSU, strata and weights.</a:t>
-            </a:r>
-            <a:endParaRPr/>
-          </a:p>
-          <a:p>
-            <a:r>
-              <a:rPr sz="2475" b="0" i="0">
-                <a:solidFill>
-                  <a:srgbClr val="111111"/>
-                </a:solidFill>
-                <a:latin typeface="Calibri"/>
-                <a:ea typeface="Calibri"/>
-                <a:cs typeface="Calibri"/>
-              </a:rPr>
-              <a:t>• Proportions estimated with `svyciprop(method = "beta")`, avoiding Wald weaknesses in states and small domains.</a:t>
+              <a:rPr sz="1300" b="1" i="0">
+                <a:solidFill>
+                  <a:srgbClr val="111111"/>
+                </a:solidFill>
+                <a:latin typeface="Calibri"/>
+                <a:ea typeface="Calibri"/>
+                <a:cs typeface="Calibri"/>
+              </a:rPr>
+              <a:t>• Source: PNS 2013/2019; selected</a:t>
+            </a:r>
+            <a:endParaRPr/>
+          </a:p>
+          <a:p>
+            <a:r>
+              <a:rPr sz="1300" b="0" i="0">
+                <a:solidFill>
+                  <a:srgbClr val="111111"/>
+                </a:solidFill>
+                <a:latin typeface="Calibri"/>
+                <a:ea typeface="Calibri"/>
+                <a:cs typeface="Calibri"/>
+              </a:rPr>
+              <a:t>  resident; Q074, Q076,</a:t>
+            </a:r>
+            <a:endParaRPr/>
+          </a:p>
+          <a:p>
+            <a:r>
+              <a:rPr sz="1300" b="0" i="0">
+                <a:solidFill>
+                  <a:srgbClr val="111111"/>
+                </a:solidFill>
+                <a:latin typeface="Calibri"/>
+                <a:ea typeface="Calibri"/>
+                <a:cs typeface="Calibri"/>
+              </a:rPr>
+              <a:t>  Q07701/Q07704/Q07708, P050 and</a:t>
+            </a:r>
+            <a:endParaRPr/>
+          </a:p>
+          <a:p>
+            <a:r>
+              <a:rPr sz="1300" b="0" i="0">
+                <a:solidFill>
+                  <a:srgbClr val="111111"/>
+                </a:solidFill>
+                <a:latin typeface="Calibri"/>
+                <a:ea typeface="Calibri"/>
+                <a:cs typeface="Calibri"/>
+              </a:rPr>
+              <a:t>  complementary modules.</a:t>
+            </a:r>
+            <a:endParaRPr/>
+          </a:p>
+          <a:p>
+            <a:r>
+              <a:rPr sz="1300" b="0" i="0">
+                <a:solidFill>
+                  <a:srgbClr val="111111"/>
+                </a:solidFill>
+                <a:latin typeface="Calibri"/>
+                <a:ea typeface="Calibri"/>
+                <a:cs typeface="Calibri"/>
+              </a:rPr>
+              <a:t>• Design: `PNSIBGE::pns_design()` includes</a:t>
+            </a:r>
+            <a:endParaRPr/>
+          </a:p>
+          <a:p>
+            <a:r>
+              <a:rPr sz="1300" b="0" i="0">
+                <a:solidFill>
+                  <a:srgbClr val="111111"/>
+                </a:solidFill>
+                <a:latin typeface="Calibri"/>
+                <a:ea typeface="Calibri"/>
+                <a:cs typeface="Calibri"/>
+              </a:rPr>
+              <a:t>  PSU, strata and calibrated weights.</a:t>
+            </a:r>
+            <a:endParaRPr/>
+          </a:p>
+          <a:p>
+            <a:r>
+              <a:rPr sz="1300" b="0" i="0">
+                <a:solidFill>
+                  <a:srgbClr val="111111"/>
+                </a:solidFill>
+                <a:latin typeface="Calibri"/>
+                <a:ea typeface="Calibri"/>
+                <a:cs typeface="Calibri"/>
+              </a:rPr>
+              <a:t>• Estimation: `survey` for proportions,</a:t>
+            </a:r>
+            <a:endParaRPr/>
+          </a:p>
+          <a:p>
+            <a:r>
+              <a:rPr sz="1300" b="0" i="0">
+                <a:solidFill>
+                  <a:srgbClr val="111111"/>
+                </a:solidFill>
+                <a:latin typeface="Calibri"/>
+                <a:ea typeface="Calibri"/>
+                <a:cs typeface="Calibri"/>
+              </a:rPr>
+              <a:t>  means, totals and rates; lonely PSUs</a:t>
+            </a:r>
+            <a:endParaRPr/>
+          </a:p>
+          <a:p>
+            <a:r>
+              <a:rPr sz="1300" b="0" i="0">
+                <a:solidFill>
+                  <a:srgbClr val="111111"/>
+                </a:solidFill>
+                <a:latin typeface="Calibri"/>
+                <a:ea typeface="Calibri"/>
+                <a:cs typeface="Calibri"/>
+              </a:rPr>
+              <a:t>  handled through design options.</a:t>
+            </a:r>
+            <a:endParaRPr/>
+          </a:p>
+          <a:p>
+            <a:r>
+              <a:rPr sz="1300" b="0" i="0">
+                <a:solidFill>
+                  <a:srgbClr val="111111"/>
+                </a:solidFill>
+                <a:latin typeface="Calibri"/>
+                <a:ea typeface="Calibri"/>
+                <a:cs typeface="Calibri"/>
+              </a:rPr>
+              <a:t>• 95% CI: `svyciprop(method = "beta")`,</a:t>
+            </a:r>
+            <a:endParaRPr/>
+          </a:p>
+          <a:p>
+            <a:r>
+              <a:rPr sz="1300" b="0" i="0">
+                <a:solidFill>
+                  <a:srgbClr val="111111"/>
+                </a:solidFill>
+                <a:latin typeface="Calibri"/>
+                <a:ea typeface="Calibri"/>
+                <a:cs typeface="Calibri"/>
+              </a:rPr>
+              <a:t>  suited to proportions, states and</a:t>
+            </a:r>
+            <a:endParaRPr/>
+          </a:p>
+          <a:p>
+            <a:r>
+              <a:rPr sz="1300" b="0" i="0">
+                <a:solidFill>
+                  <a:srgbClr val="111111"/>
+                </a:solidFill>
+                <a:latin typeface="Calibri"/>
+                <a:ea typeface="Calibri"/>
+                <a:cs typeface="Calibri"/>
+              </a:rPr>
+              <a:t>  small-event subgroups.</a:t>
             </a:r>
             <a:endParaRPr/>
           </a:p>
@@ -4372,49 +4498,189 @@
           <a:fontRef idx="minor"/>
         </p:style>
         <p:txBody>
-          <a:bodyPr lIns="90000" tIns="45000" rIns="90000" bIns="45000">
+          <a:bodyPr lIns="90000" tIns="45000" rIns="90000" bIns="45000" wrap="square">
             <a:spAutoFit/>
           </a:bodyPr>
           <a:lstStyle/>
           <a:p>
             <a:r>
-              <a:rPr sz="2475" b="0" i="0">
-                <a:solidFill>
-                  <a:srgbClr val="111111"/>
-                </a:solidFill>
-                <a:latin typeface="Calibri"/>
-                <a:ea typeface="Calibri"/>
-                <a:cs typeface="Calibri"/>
-              </a:rPr>
-              <a:t>• PNS is a population-based household survey with a complex sampling design.</a:t>
-            </a:r>
-            <a:endParaRPr/>
-          </a:p>
-          <a:p>
-            <a:r>
-              <a:rPr sz="2475" b="0" i="0">
-                <a:solidFill>
-                  <a:srgbClr val="111111"/>
-                </a:solidFill>
-                <a:latin typeface="Calibri"/>
-                <a:ea typeface="Calibri"/>
-                <a:cs typeface="Calibri"/>
-              </a:rPr>
-              <a:t>• Epidemiological indicators summarize diagnosis, attacks, treatment and risk factors.</a:t>
-            </a:r>
-            <a:endParaRPr/>
-          </a:p>
-          <a:p>
-            <a:r>
-              <a:rPr sz="2475" b="0" i="0">
-                <a:solidFill>
-                  <a:srgbClr val="111111"/>
-                </a:solidFill>
-                <a:latin typeface="Calibri"/>
-                <a:ea typeface="Calibri"/>
-                <a:cs typeface="Calibri"/>
-              </a:rPr>
-              <a:t>• Asthma combines chronic burden, acute episodes and continuous management needs.</a:t>
+              <a:rPr sz="1300" b="1" i="0">
+                <a:solidFill>
+                  <a:srgbClr val="111111"/>
+                </a:solidFill>
+                <a:latin typeface="Calibri"/>
+                <a:ea typeface="Calibri"/>
+                <a:cs typeface="Calibri"/>
+              </a:rPr>
+              <a:t>• Epidemiological indicators summarize</a:t>
+            </a:r>
+            <a:endParaRPr/>
+          </a:p>
+          <a:p>
+            <a:r>
+              <a:rPr sz="1300" b="0" i="0">
+                <a:solidFill>
+                  <a:srgbClr val="111111"/>
+                </a:solidFill>
+                <a:latin typeface="Calibri"/>
+                <a:ea typeface="Calibri"/>
+                <a:cs typeface="Calibri"/>
+              </a:rPr>
+              <a:t>  frequency, distribution and change in</a:t>
+            </a:r>
+            <a:endParaRPr/>
+          </a:p>
+          <a:p>
+            <a:r>
+              <a:rPr sz="1300" b="0" i="0">
+                <a:solidFill>
+                  <a:srgbClr val="111111"/>
+                </a:solidFill>
+                <a:latin typeface="Calibri"/>
+                <a:ea typeface="Calibri"/>
+                <a:cs typeface="Calibri"/>
+              </a:rPr>
+              <a:t>  health events.</a:t>
+            </a:r>
+            <a:endParaRPr/>
+          </a:p>
+          <a:p>
+            <a:r>
+              <a:rPr sz="1300" b="0" i="0">
+                <a:solidFill>
+                  <a:srgbClr val="111111"/>
+                </a:solidFill>
+                <a:latin typeface="Calibri"/>
+                <a:ea typeface="Calibri"/>
+                <a:cs typeface="Calibri"/>
+              </a:rPr>
+              <a:t>• For asthma, prevalence, attacks,</a:t>
+            </a:r>
+            <a:endParaRPr/>
+          </a:p>
+          <a:p>
+            <a:r>
+              <a:rPr sz="1300" b="0" i="0">
+                <a:solidFill>
+                  <a:srgbClr val="111111"/>
+                </a:solidFill>
+                <a:latin typeface="Calibri"/>
+                <a:ea typeface="Calibri"/>
+                <a:cs typeface="Calibri"/>
+              </a:rPr>
+              <a:t>  medication and smoking separate disease</a:t>
+            </a:r>
+            <a:endParaRPr/>
+          </a:p>
+          <a:p>
+            <a:r>
+              <a:rPr sz="1300" b="0" i="0">
+                <a:solidFill>
+                  <a:srgbClr val="111111"/>
+                </a:solidFill>
+                <a:latin typeface="Calibri"/>
+                <a:ea typeface="Calibri"/>
+                <a:cs typeface="Calibri"/>
+              </a:rPr>
+              <a:t>  burden, diagnostic access, management</a:t>
+            </a:r>
+            <a:endParaRPr/>
+          </a:p>
+          <a:p>
+            <a:r>
+              <a:rPr sz="1300" b="0" i="0">
+                <a:solidFill>
+                  <a:srgbClr val="111111"/>
+                </a:solidFill>
+                <a:latin typeface="Calibri"/>
+                <a:ea typeface="Calibri"/>
+                <a:cs typeface="Calibri"/>
+              </a:rPr>
+              <a:t>  and risk factors.</a:t>
+            </a:r>
+            <a:endParaRPr/>
+          </a:p>
+          <a:p>
+            <a:r>
+              <a:rPr sz="1300" b="0" i="0">
+                <a:solidFill>
+                  <a:srgbClr val="111111"/>
+                </a:solidFill>
+                <a:latin typeface="Calibri"/>
+                <a:ea typeface="Calibri"/>
+                <a:cs typeface="Calibri"/>
+              </a:rPr>
+              <a:t>• PNS has complex sampling; ignoring PSU,</a:t>
+            </a:r>
+            <a:endParaRPr/>
+          </a:p>
+          <a:p>
+            <a:r>
+              <a:rPr sz="1300" b="0" i="0">
+                <a:solidFill>
+                  <a:srgbClr val="111111"/>
+                </a:solidFill>
+                <a:latin typeface="Calibri"/>
+                <a:ea typeface="Calibri"/>
+                <a:cs typeface="Calibri"/>
+              </a:rPr>
+              <a:t>  strata and weights distorts variances,</a:t>
+            </a:r>
+            <a:endParaRPr/>
+          </a:p>
+          <a:p>
+            <a:r>
+              <a:rPr sz="1300" b="0" i="0">
+                <a:solidFill>
+                  <a:srgbClr val="111111"/>
+                </a:solidFill>
+                <a:latin typeface="Calibri"/>
+                <a:ea typeface="Calibri"/>
+                <a:cs typeface="Calibri"/>
+              </a:rPr>
+              <a:t>  CIs and state comparisons.</a:t>
+            </a:r>
+            <a:endParaRPr/>
+          </a:p>
+          <a:p>
+            <a:r>
+              <a:rPr sz="1300" b="0" i="0">
+                <a:solidFill>
+                  <a:srgbClr val="111111"/>
+                </a:solidFill>
+                <a:latin typeface="Calibri"/>
+                <a:ea typeface="Calibri"/>
+                <a:cs typeface="Calibri"/>
+              </a:rPr>
+              <a:t>• The study converts individual responses</a:t>
+            </a:r>
+            <a:endParaRPr/>
+          </a:p>
+          <a:p>
+            <a:r>
+              <a:rPr sz="1300" b="0" i="0">
+                <a:solidFill>
+                  <a:srgbClr val="111111"/>
+                </a:solidFill>
+                <a:latin typeface="Calibri"/>
+                <a:ea typeface="Calibri"/>
+                <a:cs typeface="Calibri"/>
+              </a:rPr>
+              <a:t>  into reproducible population evidence</a:t>
+            </a:r>
+            <a:endParaRPr/>
+          </a:p>
+          <a:p>
+            <a:r>
+              <a:rPr sz="1300" b="0" i="0">
+                <a:solidFill>
+                  <a:srgbClr val="111111"/>
+                </a:solidFill>
+                <a:latin typeface="Calibri"/>
+                <a:ea typeface="Calibri"/>
+                <a:cs typeface="Calibri"/>
+              </a:rPr>
+              <a:t>  for surveillance and policy.</a:t>
             </a:r>
             <a:endParaRPr/>
           </a:p>
@@ -4454,49 +4720,175 @@
           <a:fontRef idx="minor"/>
         </p:style>
         <p:txBody>
-          <a:bodyPr lIns="90000" tIns="45000" rIns="90000" bIns="45000">
+          <a:bodyPr lIns="90000" tIns="45000" rIns="90000" bIns="45000" wrap="square">
             <a:spAutoFit/>
           </a:bodyPr>
           <a:lstStyle/>
           <a:p>
             <a:r>
-              <a:rPr sz="2475" b="0" i="0">
-                <a:solidFill>
-                  <a:srgbClr val="111111"/>
-                </a:solidFill>
-                <a:latin typeface="Calibri"/>
-                <a:ea typeface="Calibri"/>
-                <a:cs typeface="Calibri"/>
-              </a:rPr>
-              <a:t>• Compare Brazil and states between 2013 and 2019.</a:t>
-            </a:r>
-            <a:endParaRPr/>
-          </a:p>
-          <a:p>
-            <a:r>
-              <a:rPr sz="2475" b="0" i="0">
-                <a:solidFill>
-                  <a:srgbClr val="111111"/>
-                </a:solidFill>
-                <a:latin typeface="Calibri"/>
-                <a:ea typeface="Calibri"/>
-                <a:cs typeface="Calibri"/>
-              </a:rPr>
-              <a:t>• Estimate prevalence, attacks, medication use, smoking and complementary indicators.</a:t>
-            </a:r>
-            <a:endParaRPr/>
-          </a:p>
-          <a:p>
-            <a:r>
-              <a:rPr sz="2475" b="0" i="0">
-                <a:solidFill>
-                  <a:srgbClr val="111111"/>
-                </a:solidFill>
-                <a:latin typeface="Calibri"/>
-                <a:ea typeface="Calibri"/>
-                <a:cs typeface="Calibri"/>
-              </a:rPr>
-              <a:t>• Interpret change through effect size and 95% CI overlap.</a:t>
+              <a:rPr sz="1300" b="1" i="0">
+                <a:solidFill>
+                  <a:srgbClr val="111111"/>
+                </a:solidFill>
+                <a:latin typeface="Calibri"/>
+                <a:ea typeface="Calibri"/>
+                <a:cs typeface="Calibri"/>
+              </a:rPr>
+              <a:t>• Implement the 2013 and 2019 PNS sampling</a:t>
+            </a:r>
+            <a:endParaRPr/>
+          </a:p>
+          <a:p>
+            <a:r>
+              <a:rPr sz="1300" b="0" i="0">
+                <a:solidFill>
+                  <a:srgbClr val="111111"/>
+                </a:solidFill>
+                <a:latin typeface="Calibri"/>
+                <a:ea typeface="Calibri"/>
+                <a:cs typeface="Calibri"/>
+              </a:rPr>
+              <a:t>  design in R for the selected resident.</a:t>
+            </a:r>
+            <a:endParaRPr/>
+          </a:p>
+          <a:p>
+            <a:r>
+              <a:rPr sz="1300" b="0" i="0">
+                <a:solidFill>
+                  <a:srgbClr val="111111"/>
+                </a:solidFill>
+                <a:latin typeface="Calibri"/>
+                <a:ea typeface="Calibri"/>
+                <a:cs typeface="Calibri"/>
+              </a:rPr>
+              <a:t>• Estimate physician-diagnosed asthma,</a:t>
+            </a:r>
+            <a:endParaRPr/>
+          </a:p>
+          <a:p>
+            <a:r>
+              <a:rPr sz="1300" b="0" i="0">
+                <a:solidFill>
+                  <a:srgbClr val="111111"/>
+                </a:solidFill>
+                <a:latin typeface="Calibri"/>
+                <a:ea typeface="Calibri"/>
+                <a:cs typeface="Calibri"/>
+              </a:rPr>
+              <a:t>  12-month attack, oral/inhaler</a:t>
+            </a:r>
+            <a:endParaRPr/>
+          </a:p>
+          <a:p>
+            <a:r>
+              <a:rPr sz="1300" b="0" i="0">
+                <a:solidFill>
+                  <a:srgbClr val="111111"/>
+                </a:solidFill>
+                <a:latin typeface="Calibri"/>
+                <a:ea typeface="Calibri"/>
+                <a:cs typeface="Calibri"/>
+              </a:rPr>
+              <a:t>  medication, smoking and complementary</a:t>
+            </a:r>
+            <a:endParaRPr/>
+          </a:p>
+          <a:p>
+            <a:r>
+              <a:rPr sz="1300" b="0" i="0">
+                <a:solidFill>
+                  <a:srgbClr val="111111"/>
+                </a:solidFill>
+                <a:latin typeface="Calibri"/>
+                <a:ea typeface="Calibri"/>
+                <a:cs typeface="Calibri"/>
+              </a:rPr>
+              <a:t>  indicators.</a:t>
+            </a:r>
+            <a:endParaRPr/>
+          </a:p>
+          <a:p>
+            <a:r>
+              <a:rPr sz="1300" b="0" i="0">
+                <a:solidFill>
+                  <a:srgbClr val="111111"/>
+                </a:solidFill>
+                <a:latin typeface="Calibri"/>
+                <a:ea typeface="Calibri"/>
+                <a:cs typeface="Calibri"/>
+              </a:rPr>
+              <a:t>• Compare Brazil and states by point</a:t>
+            </a:r>
+            <a:endParaRPr/>
+          </a:p>
+          <a:p>
+            <a:r>
+              <a:rPr sz="1300" b="0" i="0">
+                <a:solidFill>
+                  <a:srgbClr val="111111"/>
+                </a:solidFill>
+                <a:latin typeface="Calibri"/>
+                <a:ea typeface="Calibri"/>
+                <a:cs typeface="Calibri"/>
+              </a:rPr>
+              <a:t>  estimate, beta 95% CI, magnitude and</a:t>
+            </a:r>
+            <a:endParaRPr/>
+          </a:p>
+          <a:p>
+            <a:r>
+              <a:rPr sz="1300" b="0" i="0">
+                <a:solidFill>
+                  <a:srgbClr val="111111"/>
+                </a:solidFill>
+                <a:latin typeface="Calibri"/>
+                <a:ea typeface="Calibri"/>
+                <a:cs typeface="Calibri"/>
+              </a:rPr>
+              <a:t>  interval overlap.</a:t>
+            </a:r>
+            <a:endParaRPr/>
+          </a:p>
+          <a:p>
+            <a:r>
+              <a:rPr sz="1300" b="0" i="0">
+                <a:solidFill>
+                  <a:srgbClr val="111111"/>
+                </a:solidFill>
+                <a:latin typeface="Calibri"/>
+                <a:ea typeface="Calibri"/>
+                <a:cs typeface="Calibri"/>
+              </a:rPr>
+              <a:t>• Provide code, tables, figures and the</a:t>
+            </a:r>
+            <a:endParaRPr/>
+          </a:p>
+          <a:p>
+            <a:r>
+              <a:rPr sz="1300" b="0" i="0">
+                <a:solidFill>
+                  <a:srgbClr val="111111"/>
+                </a:solidFill>
+                <a:latin typeface="Calibri"/>
+                <a:ea typeface="Calibri"/>
+                <a:cs typeface="Calibri"/>
+              </a:rPr>
+              <a:t>  methodological report for audit and</a:t>
+            </a:r>
+            <a:endParaRPr/>
+          </a:p>
+          <a:p>
+            <a:r>
+              <a:rPr sz="1300" b="0" i="0">
+                <a:solidFill>
+                  <a:srgbClr val="111111"/>
+                </a:solidFill>
+                <a:latin typeface="Calibri"/>
+                <a:ea typeface="Calibri"/>
+                <a:cs typeface="Calibri"/>
+              </a:rPr>
+              <a:t>  reproduction.</a:t>
             </a:r>
             <a:endParaRPr/>
           </a:p>
@@ -4536,49 +4928,189 @@
           <a:fontRef idx="minor"/>
         </p:style>
         <p:txBody>
-          <a:bodyPr lIns="90000" tIns="45000" rIns="90000" bIns="45000">
+          <a:bodyPr lIns="90000" tIns="45000" rIns="90000" bIns="45000" wrap="square">
             <a:spAutoFit/>
           </a:bodyPr>
           <a:lstStyle/>
           <a:p>
             <a:r>
-              <a:rPr sz="2475" b="0" i="0">
-                <a:solidFill>
-                  <a:srgbClr val="111111"/>
-                </a:solidFill>
-                <a:latin typeface="Calibri"/>
-                <a:ea typeface="Calibri"/>
-                <a:cs typeface="Calibri"/>
-              </a:rPr>
-              <a:t>• Weights, strata and clusters are required for valid inference.</a:t>
-            </a:r>
-            <a:endParaRPr/>
-          </a:p>
-          <a:p>
-            <a:r>
-              <a:rPr sz="2475" b="0" i="0">
-                <a:solidFill>
-                  <a:srgbClr val="111111"/>
-                </a:solidFill>
-                <a:latin typeface="Calibri"/>
-                <a:ea typeface="Calibri"/>
-                <a:cs typeface="Calibri"/>
-              </a:rPr>
-              <a:t>• The reproducible R workflow makes the analysis auditable and reusable.</a:t>
-            </a:r>
-            <a:endParaRPr/>
-          </a:p>
-          <a:p>
-            <a:r>
-              <a:rPr sz="2475" b="0" i="0">
-                <a:solidFill>
-                  <a:srgbClr val="111111"/>
-                </a:solidFill>
-                <a:latin typeface="Calibri"/>
-                <a:ea typeface="Calibri"/>
-                <a:cs typeface="Calibri"/>
-              </a:rPr>
-              <a:t>• The methodological report documents ETL, indicators, figures and cross-linked references.</a:t>
+              <a:rPr sz="1300" b="1" i="0">
+                <a:solidFill>
+                  <a:srgbClr val="111111"/>
+                </a:solidFill>
+                <a:latin typeface="Calibri"/>
+                <a:ea typeface="Calibri"/>
+                <a:cs typeface="Calibri"/>
+              </a:rPr>
+              <a:t>• The diagnosis increase may indicate</a:t>
+            </a:r>
+            <a:endParaRPr/>
+          </a:p>
+          <a:p>
+            <a:r>
+              <a:rPr sz="1300" b="0" i="0">
+                <a:solidFill>
+                  <a:srgbClr val="111111"/>
+                </a:solidFill>
+                <a:latin typeface="Calibri"/>
+                <a:ea typeface="Calibri"/>
+                <a:cs typeface="Calibri"/>
+              </a:rPr>
+              <a:t>  higher occurrence, better diagnostic</a:t>
+            </a:r>
+            <a:endParaRPr/>
+          </a:p>
+          <a:p>
+            <a:r>
+              <a:rPr sz="1300" b="0" i="0">
+                <a:solidFill>
+                  <a:srgbClr val="111111"/>
+                </a:solidFill>
+                <a:latin typeface="Calibri"/>
+                <a:ea typeface="Calibri"/>
+                <a:cs typeface="Calibri"/>
+              </a:rPr>
+              <a:t>  access or both.</a:t>
+            </a:r>
+            <a:endParaRPr/>
+          </a:p>
+          <a:p>
+            <a:r>
+              <a:rPr sz="1300" b="0" i="0">
+                <a:solidFill>
+                  <a:srgbClr val="111111"/>
+                </a:solidFill>
+                <a:latin typeface="Calibri"/>
+                <a:ea typeface="Calibri"/>
+                <a:cs typeface="Calibri"/>
+              </a:rPr>
+              <a:t>• Attacks and medication evaluate whether</a:t>
+            </a:r>
+            <a:endParaRPr/>
+          </a:p>
+          <a:p>
+            <a:r>
+              <a:rPr sz="1300" b="0" i="0">
+                <a:solidFill>
+                  <a:srgbClr val="111111"/>
+                </a:solidFill>
+                <a:latin typeface="Calibri"/>
+                <a:ea typeface="Calibri"/>
+                <a:cs typeface="Calibri"/>
+              </a:rPr>
+              <a:t>  diagnosis growth came with better</a:t>
+            </a:r>
+            <a:endParaRPr/>
+          </a:p>
+          <a:p>
+            <a:r>
+              <a:rPr sz="1300" b="0" i="0">
+                <a:solidFill>
+                  <a:srgbClr val="111111"/>
+                </a:solidFill>
+                <a:latin typeface="Calibri"/>
+                <a:ea typeface="Calibri"/>
+                <a:cs typeface="Calibri"/>
+              </a:rPr>
+              <a:t>  disease control.</a:t>
+            </a:r>
+            <a:endParaRPr/>
+          </a:p>
+          <a:p>
+            <a:r>
+              <a:rPr sz="1300" b="0" i="0">
+                <a:solidFill>
+                  <a:srgbClr val="111111"/>
+                </a:solidFill>
+                <a:latin typeface="Calibri"/>
+                <a:ea typeface="Calibri"/>
+                <a:cs typeface="Calibri"/>
+              </a:rPr>
+              <a:t>• Rates per 100,000 separate total</a:t>
+            </a:r>
+            <a:endParaRPr/>
+          </a:p>
+          <a:p>
+            <a:r>
+              <a:rPr sz="1300" b="0" i="0">
+                <a:solidFill>
+                  <a:srgbClr val="111111"/>
+                </a:solidFill>
+                <a:latin typeface="Calibri"/>
+                <a:ea typeface="Calibri"/>
+                <a:cs typeface="Calibri"/>
+              </a:rPr>
+              <a:t>  population burden from proportions among</a:t>
+            </a:r>
+            <a:endParaRPr/>
+          </a:p>
+          <a:p>
+            <a:r>
+              <a:rPr sz="1300" b="0" i="0">
+                <a:solidFill>
+                  <a:srgbClr val="111111"/>
+                </a:solidFill>
+                <a:latin typeface="Calibri"/>
+                <a:ea typeface="Calibri"/>
+                <a:cs typeface="Calibri"/>
+              </a:rPr>
+              <a:t>  diagnosed people.</a:t>
+            </a:r>
+            <a:endParaRPr/>
+          </a:p>
+          <a:p>
+            <a:r>
+              <a:rPr sz="1300" b="0" i="0">
+                <a:solidFill>
+                  <a:srgbClr val="111111"/>
+                </a:solidFill>
+                <a:latin typeface="Calibri"/>
+                <a:ea typeface="Calibri"/>
+                <a:cs typeface="Calibri"/>
+              </a:rPr>
+              <a:t>• ETL documents extraction,</a:t>
+            </a:r>
+            <a:endParaRPr/>
+          </a:p>
+          <a:p>
+            <a:r>
+              <a:rPr sz="1300" b="0" i="0">
+                <a:solidFill>
+                  <a:srgbClr val="111111"/>
+                </a:solidFill>
+                <a:latin typeface="Calibri"/>
+                <a:ea typeface="Calibri"/>
+                <a:cs typeface="Calibri"/>
+              </a:rPr>
+              <a:t>  transformation, denominators and</a:t>
+            </a:r>
+            <a:endParaRPr/>
+          </a:p>
+          <a:p>
+            <a:r>
+              <a:rPr sz="1300" b="0" i="0">
+                <a:solidFill>
+                  <a:srgbClr val="111111"/>
+                </a:solidFill>
+                <a:latin typeface="Calibri"/>
+                <a:ea typeface="Calibri"/>
+                <a:cs typeface="Calibri"/>
+              </a:rPr>
+              <a:t>  outputs; OMOP/OHDSI guides</a:t>
+            </a:r>
+            <a:endParaRPr/>
+          </a:p>
+          <a:p>
+            <a:r>
+              <a:rPr sz="1300" b="0" i="0">
+                <a:solidFill>
+                  <a:srgbClr val="111111"/>
+                </a:solidFill>
+                <a:latin typeface="Calibri"/>
+                <a:ea typeface="Calibri"/>
+                <a:cs typeface="Calibri"/>
+              </a:rPr>
+              <a:t>  standardization and interoperability.</a:t>
             </a:r>
             <a:endParaRPr/>
           </a:p>
@@ -4593,7 +5125,7 @@
           <p:nvPr/>
         </p:nvPicPr>
         <p:blipFill>
-          <a:blip r:embed="Rf68f1039f77b468b"/>
+          <a:blip ns2:embed="Rf68f1039f77b468b"/>
           <a:stretch>
             <a:fillRect l="0" t="0" r="0" b="0"/>
           </a:stretch>
@@ -4637,11 +5169,11 @@
           </a:ln>
         </p:spPr>
         <p:txBody>
-          <a:bodyPr/>
+          <a:bodyPr wrap="square"/>
           <a:lstStyle/>
           <a:p>
             <a:r>
-              <a:rPr sz="3225" b="1" i="0">
+              <a:rPr sz="1500" b="1" i="0">
                 <a:solidFill>
                   <a:srgbClr val="1C425B"/>
                 </a:solidFill>
@@ -4649,7 +5181,7 @@
                 <a:ea typeface="Calibri"/>
                 <a:cs typeface="Calibri"/>
               </a:rPr>
-              <a:t>Asthma in Brazil, 2013-2019: reproducible estimates using the National Health Survey sampling design</a:t>
+              <a:t>Implementing the PNS sampling design in R: asthma in Brazil, 2013-2019</a:t>
             </a:r>
             <a:endParaRPr/>
           </a:p>
@@ -4811,8 +5343,8 @@
         </p:nvSpPr>
         <p:spPr>
           <a:xfrm>
-            <a:off x="1190625" y="12430125"/>
-            <a:ext cx="19907250" cy="2150000"/>
+            <a:off x="1190625" y="12300000"/>
+            <a:ext cx="19907250" cy="3500000"/>
           </a:xfrm>
           <a:prstGeom prst="rect">
             <a:avLst/>
@@ -4824,47 +5356,131 @@
           </a:ln>
         </p:spPr>
         <p:txBody>
-          <a:bodyPr/>
+          <a:bodyPr wrap="square"/>
           <a:lstStyle/>
           <a:p>
             <a:r>
-              <a:rPr sz="2325" b="0" i="0">
-                <a:solidFill>
-                  <a:srgbClr val="111111"/>
-                </a:solidFill>
-                <a:latin typeface="Calibri"/>
-                <a:ea typeface="Calibri"/>
-                <a:cs typeface="Calibri"/>
-              </a:rPr>
-              <a:t>• Q074, Q076, Q07701/Q07704/Q07708 and P050 were recoded into comparable indicators.</a:t>
-            </a:r>
-            <a:endParaRPr/>
-          </a:p>
-          <a:p>
-            <a:r>
-              <a:rPr sz="2325" b="0" i="0">
-                <a:solidFill>
-                  <a:srgbClr val="111111"/>
-                </a:solidFill>
-                <a:latin typeface="Calibri"/>
-                <a:ea typeface="Calibri"/>
-                <a:cs typeface="Calibri"/>
-              </a:rPr>
-              <a:t>• Rates per 100,000 rescale weighted proportions while preserving original uncertainty.</a:t>
-            </a:r>
-            <a:endParaRPr/>
-          </a:p>
-          <a:p>
-            <a:r>
-              <a:rPr sz="2325" b="0" i="0">
-                <a:solidFill>
-                  <a:srgbClr val="111111"/>
-                </a:solidFill>
-                <a:latin typeface="Calibri"/>
-                <a:ea typeface="Calibri"/>
-                <a:cs typeface="Calibri"/>
-              </a:rPr>
-              <a:t>• 2013-2019 comparisons combine point estimates, 95% CIs and state-level reading.</a:t>
+              <a:rPr sz="1019" b="1" i="0">
+                <a:solidFill>
+                  <a:srgbClr val="111111"/>
+                </a:solidFill>
+                <a:latin typeface="Calibri"/>
+                <a:ea typeface="Calibri"/>
+                <a:cs typeface="Calibri"/>
+              </a:rPr>
+              <a:t>• Analytical ETL: extract microdata, select variables, recode binary outcomes, define</a:t>
+            </a:r>
+            <a:endParaRPr/>
+          </a:p>
+          <a:p>
+            <a:r>
+              <a:rPr sz="1019" b="0" i="0">
+                <a:solidFill>
+                  <a:srgbClr val="111111"/>
+                </a:solidFill>
+                <a:latin typeface="Calibri"/>
+                <a:ea typeface="Calibri"/>
+                <a:cs typeface="Calibri"/>
+              </a:rPr>
+              <a:t>  valid denominators and generate `df_*.csv`/`df_*.xlsx`.</a:t>
+            </a:r>
+            <a:endParaRPr/>
+          </a:p>
+          <a:p>
+            <a:r>
+              <a:rPr sz="1019" b="0" i="0">
+                <a:solidFill>
+                  <a:srgbClr val="111111"/>
+                </a:solidFill>
+                <a:latin typeface="Calibri"/>
+                <a:ea typeface="Calibri"/>
+                <a:cs typeface="Calibri"/>
+              </a:rPr>
+              <a:t>• Indicators: asthma diagnosis; recent attack; medication among people with asthma;</a:t>
+            </a:r>
+            <a:endParaRPr/>
+          </a:p>
+          <a:p>
+            <a:r>
+              <a:rPr sz="1019" b="0" i="0">
+                <a:solidFill>
+                  <a:srgbClr val="111111"/>
+                </a:solidFill>
+                <a:latin typeface="Calibri"/>
+                <a:ea typeface="Calibri"/>
+                <a:cs typeface="Calibri"/>
+              </a:rPr>
+              <a:t>  medication among people with attack; population medication rate; smokers per 100,000;</a:t>
+            </a:r>
+            <a:endParaRPr/>
+          </a:p>
+          <a:p>
+            <a:r>
+              <a:rPr sz="1019" b="0" i="0">
+                <a:solidFill>
+                  <a:srgbClr val="111111"/>
+                </a:solidFill>
+                <a:latin typeface="Calibri"/>
+                <a:ea typeface="Calibri"/>
+                <a:cs typeface="Calibri"/>
+              </a:rPr>
+              <a:t>  Farmácia Popular/out-of-pocket payment; absenteeism, lost days and deflated income.</a:t>
+            </a:r>
+            <a:endParaRPr/>
+          </a:p>
+          <a:p>
+            <a:r>
+              <a:rPr sz="1019" b="0" i="0">
+                <a:solidFill>
+                  <a:srgbClr val="111111"/>
+                </a:solidFill>
+                <a:latin typeface="Calibri"/>
+                <a:ea typeface="Calibri"/>
+                <a:cs typeface="Calibri"/>
+              </a:rPr>
+              <a:t>• The beta CI respects the 0-1 scale and avoids Wald weaknesses for extreme proportions</a:t>
+            </a:r>
+            <a:endParaRPr/>
+          </a:p>
+          <a:p>
+            <a:r>
+              <a:rPr sz="1019" b="0" i="0">
+                <a:solidFill>
+                  <a:srgbClr val="111111"/>
+                </a:solidFill>
+                <a:latin typeface="Calibri"/>
+                <a:ea typeface="Calibri"/>
+                <a:cs typeface="Calibri"/>
+              </a:rPr>
+              <a:t>  or small domains.</a:t>
+            </a:r>
+            <a:endParaRPr/>
+          </a:p>
+          <a:p>
+            <a:r>
+              <a:rPr sz="1019" b="0" i="0">
+                <a:solidFill>
+                  <a:srgbClr val="111111"/>
+                </a:solidFill>
+                <a:latin typeface="Calibri"/>
+                <a:ea typeface="Calibri"/>
+                <a:cs typeface="Calibri"/>
+              </a:rPr>
+              <a:t>• Interpretation: consider magnitude, direction, denominator and 95% CI overlap; bar</a:t>
+            </a:r>
+            <a:endParaRPr/>
+          </a:p>
+          <a:p>
+            <a:r>
+              <a:rPr sz="1019" b="0" i="0">
+                <a:solidFill>
+                  <a:srgbClr val="111111"/>
+                </a:solidFill>
+                <a:latin typeface="Calibri"/>
+                <a:ea typeface="Calibri"/>
+                <a:cs typeface="Calibri"/>
+              </a:rPr>
+              <a:t>  height alone is insufficient.</a:t>
             </a:r>
             <a:endParaRPr/>
           </a:p>
@@ -4985,89 +5601,201 @@
           </a:ln>
         </p:spPr>
         <p:txBody>
-          <a:bodyPr/>
+          <a:bodyPr wrap="square"/>
           <a:lstStyle/>
           <a:p>
             <a:r>
-              <a:rPr sz="2325" b="0" i="0">
-                <a:solidFill>
-                  <a:srgbClr val="111111"/>
-                </a:solidFill>
-                <a:latin typeface="Calibri"/>
-                <a:ea typeface="Calibri"/>
-                <a:cs typeface="Calibri"/>
-              </a:rPr>
-              <a:t>• Physician-diagnosed asthma increased in Brazil: 4.41% -&gt; 5.40%; CIs did not overlap.</a:t>
-            </a:r>
-            <a:endParaRPr/>
-          </a:p>
-          <a:p>
-            <a:r>
-              <a:rPr sz="2325" b="0" i="0">
-                <a:solidFill>
-                  <a:srgbClr val="111111"/>
-                </a:solidFill>
-                <a:latin typeface="Calibri"/>
-                <a:ea typeface="Calibri"/>
-                <a:cs typeface="Calibri"/>
-              </a:rPr>
-              <a:t>• Attacks in the previous 12 months were approximately stable: 38.3% -&gt; 37.7%.</a:t>
-            </a:r>
-            <a:endParaRPr/>
-          </a:p>
-          <a:p>
-            <a:r>
-              <a:rPr sz="2325" b="0" i="0">
-                <a:solidFill>
-                  <a:srgbClr val="111111"/>
-                </a:solidFill>
-                <a:latin typeface="Calibri"/>
-                <a:ea typeface="Calibri"/>
-                <a:cs typeface="Calibri"/>
-              </a:rPr>
-              <a:t>• Oral medication or inhaler use among people with asthma declined: 81.5% -&gt; 64.4%; interpret cautiously.</a:t>
-            </a:r>
-            <a:endParaRPr/>
-          </a:p>
-          <a:p>
-            <a:r>
-              <a:rPr sz="2325" b="0" i="0">
-                <a:solidFill>
-                  <a:srgbClr val="111111"/>
-                </a:solidFill>
-                <a:latin typeface="Calibri"/>
-                <a:ea typeface="Calibri"/>
-                <a:cs typeface="Calibri"/>
-              </a:rPr>
-              <a:t>• Population medication rates separate total burden from the share among diagnosed people.</a:t>
-            </a:r>
-            <a:endParaRPr/>
-          </a:p>
-          <a:p>
-            <a:r>
-              <a:rPr sz="2325" b="0" i="0">
-                <a:solidFill>
-                  <a:srgbClr val="111111"/>
-                </a:solidFill>
-                <a:latin typeface="Calibri"/>
-                <a:ea typeface="Calibri"/>
-                <a:cs typeface="Calibri"/>
-              </a:rPr>
-              <a:t>• Smoking declined in several states, but does not by itself explain the diagnosis increase.</a:t>
-            </a:r>
-            <a:endParaRPr/>
-          </a:p>
-          <a:p>
-            <a:r>
-              <a:rPr sz="2325" b="0" i="0">
-                <a:solidFill>
-                  <a:srgbClr val="111111"/>
-                </a:solidFill>
-                <a:latin typeface="Calibri"/>
-                <a:ea typeface="Calibri"/>
-                <a:cs typeface="Calibri"/>
-              </a:rPr>
-              <a:t>• Findings suggest more diagnosis without proportional improvement in disease control.</a:t>
+              <a:rPr sz="900" b="1" i="0">
+                <a:solidFill>
+                  <a:srgbClr val="111111"/>
+                </a:solidFill>
+                <a:latin typeface="Calibri"/>
+                <a:ea typeface="Calibri"/>
+                <a:cs typeface="Calibri"/>
+              </a:rPr>
+              <a:t>• National physician-diagnosed asthma prevalence: 4.41% in 2013 to 5.40% in 2019;</a:t>
+            </a:r>
+            <a:endParaRPr/>
+          </a:p>
+          <a:p>
+            <a:r>
+              <a:rPr sz="900" b="0" i="0">
+                <a:solidFill>
+                  <a:srgbClr val="111111"/>
+                </a:solidFill>
+                <a:latin typeface="Calibri"/>
+                <a:ea typeface="Calibri"/>
+                <a:cs typeface="Calibri"/>
+              </a:rPr>
+              <a:t>  non-overlapping CIs indicate statistically relevant growth.</a:t>
+            </a:r>
+            <a:endParaRPr/>
+          </a:p>
+          <a:p>
+            <a:r>
+              <a:rPr sz="900" b="0" i="0">
+                <a:solidFill>
+                  <a:srgbClr val="111111"/>
+                </a:solidFill>
+                <a:latin typeface="Calibri"/>
+                <a:ea typeface="Calibri"/>
+                <a:cs typeface="Calibri"/>
+              </a:rPr>
+              <a:t>• States: Rio Grande do Sul remained among the highest prevalences; Espírito Santo and</a:t>
+            </a:r>
+            <a:endParaRPr/>
+          </a:p>
+          <a:p>
+            <a:r>
+              <a:rPr sz="900" b="0" i="0">
+                <a:solidFill>
+                  <a:srgbClr val="111111"/>
+                </a:solidFill>
+                <a:latin typeface="Calibri"/>
+                <a:ea typeface="Calibri"/>
+                <a:cs typeface="Calibri"/>
+              </a:rPr>
+              <a:t>  Amapá stand out; Bahia, Rondônia and Mato Grosso were among the lowest levels in</a:t>
+            </a:r>
+            <a:endParaRPr/>
+          </a:p>
+          <a:p>
+            <a:r>
+              <a:rPr sz="900" b="0" i="0">
+                <a:solidFill>
+                  <a:srgbClr val="111111"/>
+                </a:solidFill>
+                <a:latin typeface="Calibri"/>
+                <a:ea typeface="Calibri"/>
+                <a:cs typeface="Calibri"/>
+              </a:rPr>
+              <a:t>  2019. Overlapping CIs limit inference in several states.</a:t>
+            </a:r>
+            <a:endParaRPr/>
+          </a:p>
+          <a:p>
+            <a:r>
+              <a:rPr sz="900" b="0" i="0">
+                <a:solidFill>
+                  <a:srgbClr val="111111"/>
+                </a:solidFill>
+                <a:latin typeface="Calibri"/>
+                <a:ea typeface="Calibri"/>
+                <a:cs typeface="Calibri"/>
+              </a:rPr>
+              <a:t>• Attacks in 12 months: 38.3% to 37.7%; stability suggests more diagnosis did not</a:t>
+            </a:r>
+            <a:endParaRPr/>
+          </a:p>
+          <a:p>
+            <a:r>
+              <a:rPr sz="900" b="0" i="0">
+                <a:solidFill>
+                  <a:srgbClr val="111111"/>
+                </a:solidFill>
+                <a:latin typeface="Calibri"/>
+                <a:ea typeface="Calibri"/>
+                <a:cs typeface="Calibri"/>
+              </a:rPr>
+              <a:t>  translate into proportional improvement in control.</a:t>
+            </a:r>
+            <a:endParaRPr/>
+          </a:p>
+          <a:p>
+            <a:r>
+              <a:rPr sz="900" b="0" i="0">
+                <a:solidFill>
+                  <a:srgbClr val="111111"/>
+                </a:solidFill>
+                <a:latin typeface="Calibri"/>
+                <a:ea typeface="Calibri"/>
+                <a:cs typeface="Calibri"/>
+              </a:rPr>
+              <a:t>• Oral/inhaler medication among people with asthma: 81.5% to 64.4%; reading requires</a:t>
+            </a:r>
+            <a:endParaRPr/>
+          </a:p>
+          <a:p>
+            <a:r>
+              <a:rPr sz="900" b="0" i="0">
+                <a:solidFill>
+                  <a:srgbClr val="111111"/>
+                </a:solidFill>
+                <a:latin typeface="Calibri"/>
+                <a:ea typeface="Calibri"/>
+                <a:cs typeface="Calibri"/>
+              </a:rPr>
+              <a:t>  caution because of denominator, 95% CI and the distinction between diagnosed-person</a:t>
+            </a:r>
+            <a:endParaRPr/>
+          </a:p>
+          <a:p>
+            <a:r>
+              <a:rPr sz="900" b="0" i="0">
+                <a:solidFill>
+                  <a:srgbClr val="111111"/>
+                </a:solidFill>
+                <a:latin typeface="Calibri"/>
+                <a:ea typeface="Calibri"/>
+                <a:cs typeface="Calibri"/>
+              </a:rPr>
+              <a:t>  proportion and population rate.</a:t>
+            </a:r>
+            <a:endParaRPr/>
+          </a:p>
+          <a:p>
+            <a:r>
+              <a:rPr sz="900" b="0" i="0">
+                <a:solidFill>
+                  <a:srgbClr val="111111"/>
+                </a:solidFill>
+                <a:latin typeface="Calibri"/>
+                <a:ea typeface="Calibri"/>
+                <a:cs typeface="Calibri"/>
+              </a:rPr>
+              <a:t>• Smoking declined in several states; the national rate cited changed from 14,650 to</a:t>
+            </a:r>
+            <a:endParaRPr/>
+          </a:p>
+          <a:p>
+            <a:r>
+              <a:rPr sz="900" b="0" i="0">
+                <a:solidFill>
+                  <a:srgbClr val="111111"/>
+                </a:solidFill>
+                <a:latin typeface="Calibri"/>
+                <a:ea typeface="Calibri"/>
+                <a:cs typeface="Calibri"/>
+              </a:rPr>
+              <a:t>  12,151 per 100,000, insufficient by itself to explain the diagnosis increase.</a:t>
+            </a:r>
+            <a:endParaRPr/>
+          </a:p>
+          <a:p>
+            <a:r>
+              <a:rPr sz="900" b="0" i="0">
+                <a:solidFill>
+                  <a:srgbClr val="111111"/>
+                </a:solidFill>
+                <a:latin typeface="Calibri"/>
+                <a:ea typeface="Calibri"/>
+                <a:cs typeface="Calibri"/>
+              </a:rPr>
+              <a:t>• Implication: asthma management requires medication access, clinical follow-up,</a:t>
+            </a:r>
+            <a:endParaRPr/>
+          </a:p>
+          <a:p>
+            <a:r>
+              <a:rPr sz="900" b="0" i="0">
+                <a:solidFill>
+                  <a:srgbClr val="111111"/>
+                </a:solidFill>
+                <a:latin typeface="Calibri"/>
+                <a:ea typeface="Calibri"/>
+                <a:cs typeface="Calibri"/>
+              </a:rPr>
+              <a:t>  education, exposure control and non-pharmacological interventions.</a:t>
             </a:r>
             <a:endParaRPr/>
           </a:p>
@@ -5089,8 +5817,8 @@
         </p:nvSpPr>
         <p:spPr>
           <a:xfrm>
-            <a:off x="22098000" y="30289500"/>
-            <a:ext cx="16000000" cy="1238250"/>
+            <a:off x="20150000" y="29190000"/>
+            <a:ext cx="18400000" cy="3100000"/>
           </a:xfrm>
           <a:prstGeom prst="rect">
             <a:avLst/>
@@ -5102,19 +5830,341 @@
           </a:ln>
         </p:spPr>
         <p:txBody>
-          <a:bodyPr/>
+          <a:bodyPr wrap="square"/>
           <a:lstStyle/>
           <a:p>
             <a:r>
-              <a:rPr sz="1500" b="0" i="0">
-                <a:solidFill>
-                  <a:srgbClr val="111111"/>
-                </a:solidFill>
-                <a:latin typeface="Calibri"/>
-                <a:ea typeface="Calibri"/>
-                <a:cs typeface="Calibri"/>
-              </a:rPr>
-              <a:t>[1] Global Asthma Network, 2022. [2] Souza-Júnior et al., 2015. [3] Dube; Silva, 2026. [4] Menezes et al., 2015. [5] Santos et al., 2018. [6] Brown; Cai; DasGupta, 2001. [7] Korn; Graubard, 1998.</a:t>
+              <a:rPr sz="500" b="1" i="0">
+                <a:solidFill>
+                  <a:srgbClr val="111111"/>
+                </a:solidFill>
+                <a:latin typeface="Calibri"/>
+                <a:ea typeface="Calibri"/>
+                <a:cs typeface="Calibri"/>
+              </a:rPr>
+              <a:t>[1] GLOBAL ASTHMA NETWORK. Global Asthma Report 2022. Auckland, New Zealand: Global Asthma Network, 2022. Disponível em:</a:t>
+            </a:r>
+            <a:endParaRPr/>
+          </a:p>
+          <a:p>
+            <a:r>
+              <a:rPr sz="500" b="0" i="0">
+                <a:solidFill>
+                  <a:srgbClr val="111111"/>
+                </a:solidFill>
+                <a:latin typeface="Calibri"/>
+                <a:ea typeface="Calibri"/>
+                <a:cs typeface="Calibri"/>
+              </a:rPr>
+              <a:t>    https://globalasthmareport.org/resources/Global_Asthma_Report_2022.pdf. Acesso em: 19 set. 2025.</a:t>
+            </a:r>
+            <a:endParaRPr/>
+          </a:p>
+          <a:p>
+            <a:r>
+              <a:rPr sz="500" b="0" i="0">
+                <a:solidFill>
+                  <a:srgbClr val="111111"/>
+                </a:solidFill>
+                <a:latin typeface="Calibri"/>
+                <a:ea typeface="Calibri"/>
+                <a:cs typeface="Calibri"/>
+              </a:rPr>
+              <a:t>[2] SOUZA-JÚNIOR, Paulo Roberto Borges de et al. Desenho da amostra da Pesquisa Nacional de Saúde 2013. Epidemiologia e Serviços</a:t>
+            </a:r>
+            <a:endParaRPr/>
+          </a:p>
+          <a:p>
+            <a:r>
+              <a:rPr sz="500" b="0" i="0">
+                <a:solidFill>
+                  <a:srgbClr val="111111"/>
+                </a:solidFill>
+                <a:latin typeface="Calibri"/>
+                <a:ea typeface="Calibri"/>
+                <a:cs typeface="Calibri"/>
+              </a:rPr>
+              <a:t>    de Saúde, v. 24, p. 207-216, 2015.</a:t>
+            </a:r>
+            <a:endParaRPr/>
+          </a:p>
+          <a:p>
+            <a:r>
+              <a:rPr sz="500" b="0" i="0">
+                <a:solidFill>
+                  <a:srgbClr val="111111"/>
+                </a:solidFill>
+                <a:latin typeface="Calibri"/>
+                <a:ea typeface="Calibri"/>
+                <a:cs typeface="Calibri"/>
+              </a:rPr>
+              <a:t>[3] DUBE, I.; SILVA, M. E. L. PNS_2013_2019. GitHub, 2026. Disponível em: https://github.com/ingodube/PNS_2013_2019. Acesso em: 28</a:t>
+            </a:r>
+            <a:endParaRPr/>
+          </a:p>
+          <a:p>
+            <a:r>
+              <a:rPr sz="500" b="0" i="0">
+                <a:solidFill>
+                  <a:srgbClr val="111111"/>
+                </a:solidFill>
+                <a:latin typeface="Calibri"/>
+                <a:ea typeface="Calibri"/>
+                <a:cs typeface="Calibri"/>
+              </a:rPr>
+              <a:t>    mai. 2026.</a:t>
+            </a:r>
+            <a:endParaRPr/>
+          </a:p>
+          <a:p>
+            <a:r>
+              <a:rPr sz="500" b="0" i="0">
+                <a:solidFill>
+                  <a:srgbClr val="111111"/>
+                </a:solidFill>
+                <a:latin typeface="Calibri"/>
+                <a:ea typeface="Calibri"/>
+                <a:cs typeface="Calibri"/>
+              </a:rPr>
+              <a:t>[4] MENEZES, A. M. B. et al. Prevalência de diagnóstico médico de asma em adultos brasileiros: Pesquisa Nacional de Saúde, 2013.</a:t>
+            </a:r>
+            <a:endParaRPr/>
+          </a:p>
+          <a:p>
+            <a:r>
+              <a:rPr sz="500" b="0" i="0">
+                <a:solidFill>
+                  <a:srgbClr val="111111"/>
+                </a:solidFill>
+                <a:latin typeface="Calibri"/>
+                <a:ea typeface="Calibri"/>
+                <a:cs typeface="Calibri"/>
+              </a:rPr>
+              <a:t>    Revista Brasileira de Epidemiologia, São Paulo, v. 18, supl. 2, p. 204-213, 2015.</a:t>
+            </a:r>
+            <a:endParaRPr/>
+          </a:p>
+          <a:p>
+            <a:r>
+              <a:rPr sz="500" b="0" i="0">
+                <a:solidFill>
+                  <a:srgbClr val="111111"/>
+                </a:solidFill>
+                <a:latin typeface="Calibri"/>
+                <a:ea typeface="Calibri"/>
+                <a:cs typeface="Calibri"/>
+              </a:rPr>
+              <a:t>[5] SEVERE ASTHMA. Non-Pharmacological Interventions for Asthma. Disponível em:</a:t>
+            </a:r>
+            <a:endParaRPr/>
+          </a:p>
+          <a:p>
+            <a:r>
+              <a:rPr sz="500" b="0" i="0">
+                <a:solidFill>
+                  <a:srgbClr val="111111"/>
+                </a:solidFill>
+                <a:latin typeface="Calibri"/>
+                <a:ea typeface="Calibri"/>
+                <a:cs typeface="Calibri"/>
+              </a:rPr>
+              <a:t>    https://www.severeasthma.org.au/non-pharmacological-interventions-asthma/. Acesso em: 19 set. 2025.</a:t>
+            </a:r>
+            <a:endParaRPr/>
+          </a:p>
+          <a:p>
+            <a:r>
+              <a:rPr sz="500" b="0" i="0">
+                <a:solidFill>
+                  <a:srgbClr val="111111"/>
+                </a:solidFill>
+                <a:latin typeface="Calibri"/>
+                <a:ea typeface="Calibri"/>
+                <a:cs typeface="Calibri"/>
+              </a:rPr>
+              <a:t>[6] SANTOS, Felipe Moraes dos et al. Tendência da prevalência de asma autorreferida no Brasil de 2003 a 2013 em adultos e fatores</a:t>
+            </a:r>
+            <a:endParaRPr/>
+          </a:p>
+          <a:p>
+            <a:r>
+              <a:rPr sz="500" b="0" i="0">
+                <a:solidFill>
+                  <a:srgbClr val="111111"/>
+                </a:solidFill>
+                <a:latin typeface="Calibri"/>
+                <a:ea typeface="Calibri"/>
+                <a:cs typeface="Calibri"/>
+              </a:rPr>
+              <a:t>    associados à prevalência. Jornal Brasileiro de Pneumologia, v. 44, n. 6, p. 491-497, 2018.</a:t>
+            </a:r>
+            <a:endParaRPr/>
+          </a:p>
+          <a:p>
+            <a:r>
+              <a:rPr sz="500" b="0" i="0">
+                <a:solidFill>
+                  <a:srgbClr val="111111"/>
+                </a:solidFill>
+                <a:latin typeface="Calibri"/>
+                <a:ea typeface="Calibri"/>
+                <a:cs typeface="Calibri"/>
+              </a:rPr>
+              <a:t>    doi:10.1590/S1806-37562017000000328.</a:t>
+            </a:r>
+            <a:endParaRPr/>
+          </a:p>
+          <a:p>
+            <a:r>
+              <a:rPr sz="500" b="0" i="0">
+                <a:solidFill>
+                  <a:srgbClr val="111111"/>
+                </a:solidFill>
+                <a:latin typeface="Calibri"/>
+                <a:ea typeface="Calibri"/>
+                <a:cs typeface="Calibri"/>
+              </a:rPr>
+              <a:t>[7] TO, T. et al. Global asthma prevalence in adults: findings from the cross-sectional world health survey. BMC Public Health, v.</a:t>
+            </a:r>
+            <a:endParaRPr/>
+          </a:p>
+          <a:p>
+            <a:r>
+              <a:rPr sz="500" b="0" i="0">
+                <a:solidFill>
+                  <a:srgbClr val="111111"/>
+                </a:solidFill>
+                <a:latin typeface="Calibri"/>
+                <a:ea typeface="Calibri"/>
+                <a:cs typeface="Calibri"/>
+              </a:rPr>
+              <a:t>    12, art. 204, 2012. doi:10.1186/1471-2458-12-204.</a:t>
+            </a:r>
+            <a:endParaRPr/>
+          </a:p>
+          <a:p>
+            <a:r>
+              <a:rPr sz="500" b="0" i="0">
+                <a:solidFill>
+                  <a:srgbClr val="111111"/>
+                </a:solidFill>
+                <a:latin typeface="Calibri"/>
+                <a:ea typeface="Calibri"/>
+                <a:cs typeface="Calibri"/>
+              </a:rPr>
+              <a:t>[8] OHDSI. Standardized Data: The OMOP Common Data Model. Disponível em: https://www.ohdsi.org/data-standardization/.</a:t>
+            </a:r>
+            <a:endParaRPr/>
+          </a:p>
+          <a:p>
+            <a:r>
+              <a:rPr sz="500" b="0" i="0">
+                <a:solidFill>
+                  <a:srgbClr val="111111"/>
+                </a:solidFill>
+                <a:latin typeface="Calibri"/>
+                <a:ea typeface="Calibri"/>
+                <a:cs typeface="Calibri"/>
+              </a:rPr>
+              <a:t>[9] OHDSI. OMOP Common Data Model. Disponível em: https://ohdsi.github.io/CommonDataModel/.</a:t>
+            </a:r>
+            <a:endParaRPr/>
+          </a:p>
+          <a:p>
+            <a:r>
+              <a:rPr sz="500" b="0" i="0">
+                <a:solidFill>
+                  <a:srgbClr val="111111"/>
+                </a:solidFill>
+                <a:latin typeface="Calibri"/>
+                <a:ea typeface="Calibri"/>
+                <a:cs typeface="Calibri"/>
+              </a:rPr>
+              <a:t>[10] OHDSI. ETL Creation Best Practices. Disponível em:</a:t>
+            </a:r>
+            <a:endParaRPr/>
+          </a:p>
+          <a:p>
+            <a:r>
+              <a:rPr sz="500" b="0" i="0">
+                <a:solidFill>
+                  <a:srgbClr val="111111"/>
+                </a:solidFill>
+                <a:latin typeface="Calibri"/>
+                <a:ea typeface="Calibri"/>
+                <a:cs typeface="Calibri"/>
+              </a:rPr>
+              <a:t>    https://www.ohdsi.org/web/wiki/doku.php?id=documentation:etl_best_practices.</a:t>
+            </a:r>
+            <a:endParaRPr/>
+          </a:p>
+          <a:p>
+            <a:r>
+              <a:rPr sz="500" b="0" i="0">
+                <a:solidFill>
+                  <a:srgbClr val="111111"/>
+                </a:solidFill>
+                <a:latin typeface="Calibri"/>
+                <a:ea typeface="Calibri"/>
+                <a:cs typeface="Calibri"/>
+              </a:rPr>
+              <a:t>[11] LUMLEY, Thomas. Complex Surveys: A Guide to Analysis Using R. Hoboken: Wiley, 2010.</a:t>
+            </a:r>
+            <a:endParaRPr/>
+          </a:p>
+          <a:p>
+            <a:r>
+              <a:rPr sz="500" b="0" i="0">
+                <a:solidFill>
+                  <a:srgbClr val="111111"/>
+                </a:solidFill>
+                <a:latin typeface="Calibri"/>
+                <a:ea typeface="Calibri"/>
+                <a:cs typeface="Calibri"/>
+              </a:rPr>
+              <a:t>[12] BROWN, Lawrence D.; CAI, T. Tony; DASGUPTA, Anirban. Interval estimation for a binomial proportion. Statistical Science, v.</a:t>
+            </a:r>
+            <a:endParaRPr/>
+          </a:p>
+          <a:p>
+            <a:r>
+              <a:rPr sz="500" b="0" i="0">
+                <a:solidFill>
+                  <a:srgbClr val="111111"/>
+                </a:solidFill>
+                <a:latin typeface="Calibri"/>
+                <a:ea typeface="Calibri"/>
+                <a:cs typeface="Calibri"/>
+              </a:rPr>
+              <a:t>    16, n. 2, p. 101-133, 2001. doi:10.1214/ss/1009213286.</a:t>
+            </a:r>
+            <a:endParaRPr/>
+          </a:p>
+          <a:p>
+            <a:r>
+              <a:rPr sz="500" b="0" i="0">
+                <a:solidFill>
+                  <a:srgbClr val="111111"/>
+                </a:solidFill>
+                <a:latin typeface="Calibri"/>
+                <a:ea typeface="Calibri"/>
+                <a:cs typeface="Calibri"/>
+              </a:rPr>
+              <a:t>[13] KORN, Edward L.; GRAUBARD, Barry I. Confidence intervals for proportions with small expected number of positive counts</a:t>
+            </a:r>
+            <a:endParaRPr/>
+          </a:p>
+          <a:p>
+            <a:r>
+              <a:rPr sz="500" b="0" i="0">
+                <a:solidFill>
+                  <a:srgbClr val="111111"/>
+                </a:solidFill>
+                <a:latin typeface="Calibri"/>
+                <a:ea typeface="Calibri"/>
+                <a:cs typeface="Calibri"/>
+              </a:rPr>
+              <a:t>    estimated from survey data. Survey Methodology, v. 24, n. 2, p. 193-201, 1998.</a:t>
             </a:r>
             <a:endParaRPr/>
           </a:p>
@@ -5215,7 +6265,7 @@
           <p:nvPr/>
         </p:nvPicPr>
         <p:blipFill>
-          <a:blip r:embed="R74faf17efef34079"/>
+          <a:blip ns2:embed="R74faf17efef34079"/>
           <a:stretch/>
         </p:blipFill>
         <p:spPr>
@@ -5237,7 +6287,7 @@
           <p:nvPr/>
         </p:nvPicPr>
         <p:blipFill>
-          <a:blip r:embed="Rac080a698a904d49"/>
+          <a:blip ns2:embed="Rac080a698a904d49"/>
           <a:stretch/>
         </p:blipFill>
         <p:spPr>
@@ -5259,7 +6309,7 @@
           <p:nvPr/>
         </p:nvPicPr>
         <p:blipFill>
-          <a:blip r:embed="R54b955d7ea1f4f19"/>
+          <a:blip ns2:embed="R54b955d7ea1f4f19"/>
           <a:stretch/>
         </p:blipFill>
         <p:spPr>
@@ -5281,7 +6331,7 @@
           <p:nvPr/>
         </p:nvPicPr>
         <p:blipFill>
-          <a:blip r:embed="Rb38f6300ddc549e8"/>
+          <a:blip ns2:embed="Rb38f6300ddc549e8"/>
           <a:stretch/>
         </p:blipFill>
         <p:spPr>
@@ -5323,11 +6373,11 @@
           </a:ln>
         </p:spPr>
         <p:txBody>
-          <a:bodyPr/>
+          <a:bodyPr wrap="square"/>
           <a:lstStyle/>
           <a:p>
             <a:r>
-              <a:rPr sz="1650" b="0" i="0">
+              <a:rPr sz="700" b="1" i="0">
                 <a:solidFill>
                   <a:srgbClr val="555555"/>
                 </a:solidFill>
@@ -5335,13 +6385,13 @@
                 <a:ea typeface="Calibri"/>
                 <a:cs typeface="Calibri"/>
               </a:rPr>
-              <a:t>• Figures are exported from the R code using `geom_col`, `geom_errorbar`, `coord_flip` and 95% CIs.</a:t>
-            </a:r>
-            <a:endParaRPr/>
-          </a:p>
-          <a:p>
-            <a:r>
-              <a:rPr sz="1650" b="0" i="0">
+              <a:t>• Figures exported from the R code: `geom_col`, `geom_errorbar`, `coord_flip`, beta 95% CIs</a:t>
+            </a:r>
+            <a:endParaRPr/>
+          </a:p>
+          <a:p>
+            <a:r>
+              <a:rPr sz="700" b="0" i="0">
                 <a:solidFill>
                   <a:srgbClr val="555555"/>
                 </a:solidFill>
@@ -5349,13 +6399,13 @@
                 <a:ea typeface="Calibri"/>
                 <a:cs typeface="Calibri"/>
               </a:rPr>
-              <a:t>• CI bars prevent interpretation based only on bar height.</a:t>
-            </a:r>
-            <a:endParaRPr/>
-          </a:p>
-          <a:p>
-            <a:r>
-              <a:rPr sz="1650" b="0" i="0">
+              <a:t>  and original palette.</a:t>
+            </a:r>
+            <a:endParaRPr/>
+          </a:p>
+          <a:p>
+            <a:r>
+              <a:rPr sz="700" b="0" i="0">
                 <a:solidFill>
                   <a:srgbClr val="555555"/>
                 </a:solidFill>
@@ -5363,7 +6413,21 @@
                 <a:ea typeface="Calibri"/>
                 <a:cs typeface="Calibri"/>
               </a:rPr>
-              <a:t>• State-level patterns remain exploratory when intervals overlap.</a:t>
+              <a:t>• Bars = weighted estimates; whiskers = complex-design uncertainty. States with overlapping</a:t>
+            </a:r>
+            <a:endParaRPr/>
+          </a:p>
+          <a:p>
+            <a:r>
+              <a:rPr sz="700" b="0" i="0">
+                <a:solidFill>
+                  <a:srgbClr val="555555"/>
+                </a:solidFill>
+                <a:latin typeface="Calibri"/>
+                <a:ea typeface="Calibri"/>
+                <a:cs typeface="Calibri"/>
+              </a:rPr>
+              <a:t>  95% CIs require cautious reading.</a:t>
             </a:r>
             <a:endParaRPr/>
           </a:p>
@@ -5377,8 +6441,8 @@
         </p:nvSpPr>
         <p:spPr>
           <a:xfrm>
-            <a:off x="1190625" y="14720000"/>
-            <a:ext cx="19907250" cy="1750000"/>
+            <a:off x="1190625" y="15630000"/>
+            <a:ext cx="19907250" cy="1250000"/>
           </a:xfrm>
           <a:prstGeom prst="rect">
             <a:avLst/>
@@ -5398,47 +6462,62 @@
           <a:p>
             <a:pPr algn="ctr"/>
             <a:r>
-              <a:rPr lang="pt-BR" sz="1300" b="1">
-                <a:latin typeface="Aptos"/>
-              </a:rPr>
-              <a:t>FORMULAS</a:t>
-            </a:r>
+              <a:rPr lang="pt-BR" sz="800" b="1">
+                <a:latin typeface="Cambria Math"/>
+              </a:rPr>
+              <a:t>ESTIMATORS AND NOTATION</a:t>
+            </a:r>
+            <a:endParaRPr/>
           </a:p>
           <a:p>
             <a:pPr algn="ctr"/>
             <a:r>
-              <a:rPr lang="pt-BR" sz="1300" b="1">
+              <a:rPr lang="pt-BR" sz="800" b="0">
                 <a:latin typeface="Cambria Math"/>
               </a:rPr>
-              <a:t>p̂ = Σ wᵢyᵢ / Σ wᵢ</a:t>
-            </a:r>
+              <a:t>Weighted proportion: p̂ = Σᵢ wᵢyᵢ / Σᵢ wᵢ</a:t>
+            </a:r>
+            <a:endParaRPr/>
           </a:p>
           <a:p>
             <a:pPr algn="ctr"/>
             <a:r>
-              <a:rPr lang="pt-BR" sz="1300" b="1">
+              <a:rPr lang="pt-BR" sz="800" b="0">
                 <a:latin typeface="Cambria Math"/>
               </a:rPr>
-              <a:t>% = 100 × p̂</a:t>
-            </a:r>
+              <a:t>wᵢ = sampling weight; yᵢ = binary event</a:t>
+            </a:r>
+            <a:endParaRPr/>
           </a:p>
           <a:p>
             <a:pPr algn="ctr"/>
             <a:r>
-              <a:rPr lang="pt-BR" sz="1300" b="1">
+              <a:rPr lang="pt-BR" sz="800" b="0">
                 <a:latin typeface="Cambria Math"/>
               </a:rPr>
-              <a:t>rate₁₀₀k = 100000 × p̂</a:t>
-            </a:r>
+              <a:t>Percentage: % = 100 × p̂</a:t>
+            </a:r>
+            <a:endParaRPr/>
           </a:p>
           <a:p>
             <a:pPr algn="ctr"/>
             <a:r>
-              <a:rPr lang="pt-BR" sz="1300" b="1">
-                <a:latin typeface="Aptos"/>
-              </a:rPr>
-              <a:t>95% CI: beta</a:t>
-            </a:r>
+              <a:rPr lang="pt-BR" sz="800" b="0">
+                <a:latin typeface="Cambria Math"/>
+              </a:rPr>
+              <a:t>Population rate: rate₁₀₀k = 100000 × p̂</a:t>
+            </a:r>
+            <a:endParaRPr/>
+          </a:p>
+          <a:p>
+            <a:pPr algn="ctr"/>
+            <a:r>
+              <a:rPr lang="pt-BR" sz="800" b="0">
+                <a:latin typeface="Cambria Math"/>
+              </a:rPr>
+              <a:t>Applied interval: CI₉₅%(p̂) = survey::svyciprop(method = "beta")</a:t>
+            </a:r>
+            <a:endParaRPr/>
           </a:p>
         </p:txBody>
       </p:sp>
@@ -5450,8 +6529,8 @@
         </p:nvSpPr>
         <p:spPr>
           <a:xfrm>
-            <a:off x="39200000" y="29620000"/>
-            <a:ext cx="2300000" cy="2300000"/>
+            <a:off x="38930000" y="29250000"/>
+            <a:ext cx="3150000" cy="2850000"/>
           </a:xfrm>
           <a:prstGeom prst="rect">
             <a:avLst/>
@@ -5471,29 +6550,176 @@
           <a:p>
             <a:pPr algn="ctr"/>
             <a:r>
-              <a:rPr lang="pt-BR" sz="850" b="1">
+              <a:rPr lang="pt-BR" sz="680" b="1">
                 <a:latin typeface="Aptos"/>
               </a:rPr>
               <a:t>QR CODE</a:t>
             </a:r>
+            <a:endParaRPr/>
           </a:p>
           <a:p>
             <a:pPr algn="ctr"/>
             <a:r>
-              <a:rPr lang="pt-BR" sz="850" b="1">
+              <a:rPr lang="pt-BR" sz="680" b="0">
                 <a:latin typeface="Aptos"/>
               </a:rPr>
               <a:t>Methodological report</a:t>
             </a:r>
+            <a:endParaRPr/>
           </a:p>
           <a:p>
             <a:pPr algn="ctr"/>
             <a:r>
-              <a:rPr lang="pt-BR" sz="850" b="1">
+              <a:rPr lang="pt-BR" sz="680" b="0">
                 <a:latin typeface="Aptos"/>
               </a:rPr>
-              <a:t>ingodube.github.io/PNS_2013_2019</a:t>
-            </a:r>
+              <a:t>https://ingodube.github.io/PNS_2013_2019/metodologia.html</a:t>
+            </a:r>
+            <a:endParaRPr/>
+          </a:p>
+        </p:txBody>
+      </p:sp>
+      <p:sp>
+        <p:nvSpPr>
+          <p:cNvPr id="117" name="chart-caption-above-classic-en-1"/>
+          <p:cNvSpPr txBox="1"/>
+          <p:nvPr/>
+        </p:nvSpPr>
+        <p:spPr>
+          <a:xfrm>
+            <a:off x="1319893" y="17730000"/>
+            <a:ext cx="19267714" cy="330000"/>
+          </a:xfrm>
+          <a:prstGeom prst="rect">
+            <a:avLst/>
+          </a:prstGeom>
+          <a:solidFill>
+            <a:srgbClr val="FFFFFF"/>
+          </a:solidFill>
+          <a:ln w="12700">
+            <a:solidFill>
+              <a:srgbClr val="FFFFFF"/>
+            </a:solidFill>
+          </a:ln>
+        </p:spPr>
+        <p:txBody>
+          <a:bodyPr wrap="square" lIns="76200" rIns="76200" tIns="76200" bIns="76200" anchor="t"/>
+          <a:lstStyle/>
+          <a:p>
+            <a:pPr algn="ctr"/>
+            <a:r>
+              <a:rPr lang="pt-BR" sz="680" b="1"/>
+              <a:t>Figure 1: Physician-diagnosed asthma prevalence by state, PNS 2013 and 2019.</a:t>
+            </a:r>
+            <a:endParaRPr/>
+          </a:p>
+        </p:txBody>
+      </p:sp>
+      <p:sp>
+        <p:nvSpPr>
+          <p:cNvPr id="118" name="chart-caption-above-classic-en-2"/>
+          <p:cNvSpPr txBox="1"/>
+          <p:nvPr/>
+        </p:nvSpPr>
+        <p:spPr>
+          <a:xfrm>
+            <a:off x="22751143" y="17730000"/>
+            <a:ext cx="19267714" cy="330000"/>
+          </a:xfrm>
+          <a:prstGeom prst="rect">
+            <a:avLst/>
+          </a:prstGeom>
+          <a:solidFill>
+            <a:srgbClr val="FFFFFF"/>
+          </a:solidFill>
+          <a:ln w="12700">
+            <a:solidFill>
+              <a:srgbClr val="FFFFFF"/>
+            </a:solidFill>
+          </a:ln>
+        </p:spPr>
+        <p:txBody>
+          <a:bodyPr wrap="square" lIns="76200" rIns="76200" tIns="76200" bIns="76200" anchor="t"/>
+          <a:lstStyle/>
+          <a:p>
+            <a:pPr algn="ctr"/>
+            <a:r>
+              <a:rPr lang="pt-BR" sz="680" b="1"/>
+              <a:t>Figure 2: Asthma attacks in the previous 12 months among diagnosed people, PNS 2013 and 2019.</a:t>
+            </a:r>
+            <a:endParaRPr/>
+          </a:p>
+        </p:txBody>
+      </p:sp>
+      <p:sp>
+        <p:nvSpPr>
+          <p:cNvPr id="119" name="chart-caption-above-classic-en-3"/>
+          <p:cNvSpPr txBox="1"/>
+          <p:nvPr/>
+        </p:nvSpPr>
+        <p:spPr>
+          <a:xfrm>
+            <a:off x="1319893" y="23725000"/>
+            <a:ext cx="19267714" cy="330000"/>
+          </a:xfrm>
+          <a:prstGeom prst="rect">
+            <a:avLst/>
+          </a:prstGeom>
+          <a:solidFill>
+            <a:srgbClr val="FFFFFF"/>
+          </a:solidFill>
+          <a:ln w="12700">
+            <a:solidFill>
+              <a:srgbClr val="FFFFFF"/>
+            </a:solidFill>
+          </a:ln>
+        </p:spPr>
+        <p:txBody>
+          <a:bodyPr wrap="square" lIns="76200" rIns="76200" tIns="76200" bIns="76200" anchor="t"/>
+          <a:lstStyle/>
+          <a:p>
+            <a:pPr algn="ctr"/>
+            <a:r>
+              <a:rPr lang="pt-BR" sz="680" b="1"/>
+              <a:t>Figure 3: Oral medication or inhaler use among people with asthma, PNS 2013 and 2019.</a:t>
+            </a:r>
+            <a:endParaRPr/>
+          </a:p>
+        </p:txBody>
+      </p:sp>
+      <p:sp>
+        <p:nvSpPr>
+          <p:cNvPr id="120" name="chart-caption-above-classic-en-4"/>
+          <p:cNvSpPr txBox="1"/>
+          <p:nvPr/>
+        </p:nvSpPr>
+        <p:spPr>
+          <a:xfrm>
+            <a:off x="22751143" y="23725000"/>
+            <a:ext cx="19267714" cy="330000"/>
+          </a:xfrm>
+          <a:prstGeom prst="rect">
+            <a:avLst/>
+          </a:prstGeom>
+          <a:solidFill>
+            <a:srgbClr val="FFFFFF"/>
+          </a:solidFill>
+          <a:ln w="12700">
+            <a:solidFill>
+              <a:srgbClr val="FFFFFF"/>
+            </a:solidFill>
+          </a:ln>
+        </p:spPr>
+        <p:txBody>
+          <a:bodyPr wrap="square" lIns="76200" rIns="76200" tIns="76200" bIns="76200" anchor="t"/>
+          <a:lstStyle/>
+          <a:p>
+            <a:pPr algn="ctr"/>
+            <a:r>
+              <a:rPr lang="pt-BR" sz="680" b="1"/>
+              <a:t>Figure 4: Population rate of current smokers per 100,000 inhabitants, PNS 2013 and 2019.</a:t>
+            </a:r>
+            <a:endParaRPr/>
           </a:p>
         </p:txBody>
       </p:sp>

</xml_diff>

<commit_message>
Improve poster chart resolution
</commit_message>
<xml_diff>
--- a/outputs/posters/poster_pns_asma_classico_en.pptx
+++ b/outputs/posters/poster_pns_asma_classico_en.pptx
@@ -2,13 +2,13 @@
 <file path=ppt/presentation.xml><?xml version="1.0" encoding="utf-8"?>
 <p:presentation xmlns:p="http://schemas.openxmlformats.org/presentationml/2006/main">
   <p:sldMasterIdLst>
-    <p:sldMasterId xmlns:r="http://schemas.openxmlformats.org/officeDocument/2006/relationships" id="2147483648" r:id="Rcbcb9672094c4289"/>
+    <p:sldMasterId xmlns:r="http://schemas.openxmlformats.org/officeDocument/2006/relationships" id="2147483648" r:id="Rd57426a0ac824ce8"/>
   </p:sldMasterIdLst>
   <p:notesMasterIdLst>
-    <p:notesMasterId xmlns:r="http://schemas.openxmlformats.org/officeDocument/2006/relationships" r:id="R9f2b7d81921b4ace"/>
+    <p:notesMasterId xmlns:r="http://schemas.openxmlformats.org/officeDocument/2006/relationships" r:id="R6374eed4585547b0"/>
   </p:notesMasterIdLst>
   <p:sldIdLst>
-    <p:sldId xmlns:r="http://schemas.openxmlformats.org/officeDocument/2006/relationships" id="256" r:id="R42337bd5c0e9496d"/>
+    <p:sldId xmlns:r="http://schemas.openxmlformats.org/officeDocument/2006/relationships" id="256" r:id="R6f4bdc7da59e414d"/>
   </p:sldIdLst>
   <p:sldSz cx="9525000" cy="13468350"/>
   <p:notesSz cx="6858000" cy="9144000"/>
@@ -601,7 +601,7 @@
   </p:cSld>
   <p:clrMap bg1="lt1" tx1="dk1" bg2="lt2" tx2="dk2" accent1="accent1" accent2="accent2" accent3="accent3" accent4="accent4" accent5="accent5" accent6="accent6" hlink="hlink" folHlink="folHlink"/>
   <p:sldLayoutIdLst>
-    <p:sldLayoutId xmlns:r="http://schemas.openxmlformats.org/officeDocument/2006/relationships" id="2147483649" r:id="R2a9aa1be6abe45e9"/>
+    <p:sldLayoutId xmlns:r="http://schemas.openxmlformats.org/officeDocument/2006/relationships" id="2147483649" r:id="R5a92b3f67f1049e1"/>
   </p:sldLayoutIdLst>
   <p:txStyles>
     <p:titleStyle>
@@ -1156,7 +1156,7 @@
           <p:nvPr/>
         </p:nvPicPr>
         <p:blipFill>
-          <a:blip xmlns:r="http://schemas.openxmlformats.org/officeDocument/2006/relationships" xmlns:a="http://schemas.openxmlformats.org/drawingml/2006/main" r:embed="R3bf9a07775da4eea"/>
+          <a:blip xmlns:r="http://schemas.openxmlformats.org/officeDocument/2006/relationships" xmlns:a="http://schemas.openxmlformats.org/drawingml/2006/main" r:embed="Rfc4aed48359b456b"/>
           <a:srcRect xmlns:a="http://schemas.openxmlformats.org/drawingml/2006/main" l="0" t="38622" r="0" b="38622"/>
           <a:stretch xmlns:a="http://schemas.openxmlformats.org/drawingml/2006/main">
             <a:fillRect l="0" t="0" r="0" b="0"/>
@@ -1181,7 +1181,7 @@
           <p:nvPr/>
         </p:nvPicPr>
         <p:blipFill>
-          <a:blip xmlns:r="http://schemas.openxmlformats.org/officeDocument/2006/relationships" xmlns:a="http://schemas.openxmlformats.org/drawingml/2006/main" r:embed="R45453a274ccc4203"/>
+          <a:blip xmlns:r="http://schemas.openxmlformats.org/officeDocument/2006/relationships" xmlns:a="http://schemas.openxmlformats.org/drawingml/2006/main" r:embed="R075ffd0c56a445c2"/>
           <a:stretch xmlns:a="http://schemas.openxmlformats.org/drawingml/2006/main"/>
         </p:blipFill>
         <p:spPr>
@@ -1203,7 +1203,7 @@
           <p:nvPr/>
         </p:nvPicPr>
         <p:blipFill>
-          <a:blip xmlns:r="http://schemas.openxmlformats.org/officeDocument/2006/relationships" xmlns:a="http://schemas.openxmlformats.org/drawingml/2006/main" r:embed="Rc2feaffbec5a4138"/>
+          <a:blip xmlns:r="http://schemas.openxmlformats.org/officeDocument/2006/relationships" xmlns:a="http://schemas.openxmlformats.org/drawingml/2006/main" r:embed="R9142d174a78a4bed"/>
           <a:stretch xmlns:a="http://schemas.openxmlformats.org/drawingml/2006/main"/>
         </p:blipFill>
         <p:spPr>
@@ -1221,7 +1221,7 @@
           <p:cNvPr id="4" name="classic-title">
             <a:extLst xmlns:a="http://schemas.openxmlformats.org/drawingml/2006/main">
               <a:ext uri="{FF2B5EF4-FFF2-40B4-BE49-F238E27FC236}">
-                <a16:creationId xmlns:a16="http://schemas.microsoft.com/office/drawing/2014/main" id="{494EDFAC-7815-40B5-B5A3-886CC61EF07A}"/>
+                <a16:creationId xmlns:a16="http://schemas.microsoft.com/office/drawing/2014/main" id="{5F431656-3658-4CE3-BE77-BCCCB78A08BF}"/>
               </a:ext>
             </a:extLst>
           </p:cNvPr>
@@ -1271,7 +1271,7 @@
           <p:cNvPr id="5" name="classic-authors">
             <a:extLst xmlns:a="http://schemas.openxmlformats.org/drawingml/2006/main">
               <a:ext uri="{FF2B5EF4-FFF2-40B4-BE49-F238E27FC236}">
-                <a16:creationId xmlns:a16="http://schemas.microsoft.com/office/drawing/2014/main" id="{AA742C82-50D0-417A-88F1-07C4C75A6E83}"/>
+                <a16:creationId xmlns:a16="http://schemas.microsoft.com/office/drawing/2014/main" id="{0073896C-1FEA-462E-B695-0EA02D6DCF2C}"/>
               </a:ext>
             </a:extLst>
           </p:cNvPr>
@@ -1321,7 +1321,7 @@
           <p:cNvPr id="6" name="1-Introduction-box">
             <a:extLst xmlns:a="http://schemas.openxmlformats.org/drawingml/2006/main">
               <a:ext uri="{FF2B5EF4-FFF2-40B4-BE49-F238E27FC236}">
-                <a16:creationId xmlns:a16="http://schemas.microsoft.com/office/drawing/2014/main" id="{16EABA7A-DFD8-406A-A242-02A15C2E4E22}"/>
+                <a16:creationId xmlns:a16="http://schemas.microsoft.com/office/drawing/2014/main" id="{1377DB2F-65F1-481C-8E22-B39795FA8E8F}"/>
               </a:ext>
             </a:extLst>
           </p:cNvPr>
@@ -1354,7 +1354,7 @@
           <p:cNvPr id="7" name="1-Introduction-head">
             <a:extLst xmlns:a="http://schemas.openxmlformats.org/drawingml/2006/main">
               <a:ext uri="{FF2B5EF4-FFF2-40B4-BE49-F238E27FC236}">
-                <a16:creationId xmlns:a16="http://schemas.microsoft.com/office/drawing/2014/main" id="{97C1424E-557A-4929-B928-2E7D59C749C0}"/>
+                <a16:creationId xmlns:a16="http://schemas.microsoft.com/office/drawing/2014/main" id="{C2AFE87F-F8AA-4A24-96F5-B7F3D8095A3C}"/>
               </a:ext>
             </a:extLst>
           </p:cNvPr>
@@ -1387,7 +1387,7 @@
           <p:cNvPr id="8" name="1-Introduction-title">
             <a:extLst xmlns:a="http://schemas.openxmlformats.org/drawingml/2006/main">
               <a:ext uri="{FF2B5EF4-FFF2-40B4-BE49-F238E27FC236}">
-                <a16:creationId xmlns:a16="http://schemas.microsoft.com/office/drawing/2014/main" id="{DF78FD89-1292-4620-A9FA-D640C206C37B}"/>
+                <a16:creationId xmlns:a16="http://schemas.microsoft.com/office/drawing/2014/main" id="{0544C84D-792B-42A9-9BFB-CF6750C3CD84}"/>
               </a:ext>
             </a:extLst>
           </p:cNvPr>
@@ -1437,7 +1437,7 @@
           <p:cNvPr id="9" name="1-Introduction-body">
             <a:extLst xmlns:a="http://schemas.openxmlformats.org/drawingml/2006/main">
               <a:ext uri="{FF2B5EF4-FFF2-40B4-BE49-F238E27FC236}">
-                <a16:creationId xmlns:a16="http://schemas.microsoft.com/office/drawing/2014/main" id="{A3F0A901-72D6-48F3-BC44-8AFEDDEFD731}"/>
+                <a16:creationId xmlns:a16="http://schemas.microsoft.com/office/drawing/2014/main" id="{95CDEE0A-2FDA-4A55-A6E0-E3FA46B2513A}"/>
               </a:ext>
             </a:extLst>
           </p:cNvPr>
@@ -1521,7 +1521,7 @@
           <p:cNvPr id="10" name="2-Objectives-box">
             <a:extLst xmlns:a="http://schemas.openxmlformats.org/drawingml/2006/main">
               <a:ext uri="{FF2B5EF4-FFF2-40B4-BE49-F238E27FC236}">
-                <a16:creationId xmlns:a16="http://schemas.microsoft.com/office/drawing/2014/main" id="{0E099E0B-7F24-4239-885F-FFF0AA9EC778}"/>
+                <a16:creationId xmlns:a16="http://schemas.microsoft.com/office/drawing/2014/main" id="{69980493-EB0F-44C4-BFFB-92DBEFED5DDE}"/>
               </a:ext>
             </a:extLst>
           </p:cNvPr>
@@ -1554,7 +1554,7 @@
           <p:cNvPr id="11" name="2-Objectives-head">
             <a:extLst xmlns:a="http://schemas.openxmlformats.org/drawingml/2006/main">
               <a:ext uri="{FF2B5EF4-FFF2-40B4-BE49-F238E27FC236}">
-                <a16:creationId xmlns:a16="http://schemas.microsoft.com/office/drawing/2014/main" id="{92627B39-4C25-4653-833E-5A01DAC15ACA}"/>
+                <a16:creationId xmlns:a16="http://schemas.microsoft.com/office/drawing/2014/main" id="{67F71AA9-95F3-48D1-B186-301B49040A98}"/>
               </a:ext>
             </a:extLst>
           </p:cNvPr>
@@ -1587,7 +1587,7 @@
           <p:cNvPr id="12" name="2-Objectives-title">
             <a:extLst xmlns:a="http://schemas.openxmlformats.org/drawingml/2006/main">
               <a:ext uri="{FF2B5EF4-FFF2-40B4-BE49-F238E27FC236}">
-                <a16:creationId xmlns:a16="http://schemas.microsoft.com/office/drawing/2014/main" id="{79139914-756B-4733-873D-62CA9D327B19}"/>
+                <a16:creationId xmlns:a16="http://schemas.microsoft.com/office/drawing/2014/main" id="{A2AC13C5-7AC7-40A0-83AD-8A809BCE7B01}"/>
               </a:ext>
             </a:extLst>
           </p:cNvPr>
@@ -1637,7 +1637,7 @@
           <p:cNvPr id="13" name="2-Objectives-body">
             <a:extLst xmlns:a="http://schemas.openxmlformats.org/drawingml/2006/main">
               <a:ext uri="{FF2B5EF4-FFF2-40B4-BE49-F238E27FC236}">
-                <a16:creationId xmlns:a16="http://schemas.microsoft.com/office/drawing/2014/main" id="{25D42EC0-9F79-42D8-BEBF-7375657BA7AD}"/>
+                <a16:creationId xmlns:a16="http://schemas.microsoft.com/office/drawing/2014/main" id="{47EB8FE4-9A20-4E76-ADE8-0B5E80694B97}"/>
               </a:ext>
             </a:extLst>
           </p:cNvPr>
@@ -1721,7 +1721,7 @@
           <p:cNvPr id="14" name="3-Data and indicators-box">
             <a:extLst xmlns:a="http://schemas.openxmlformats.org/drawingml/2006/main">
               <a:ext uri="{FF2B5EF4-FFF2-40B4-BE49-F238E27FC236}">
-                <a16:creationId xmlns:a16="http://schemas.microsoft.com/office/drawing/2014/main" id="{276C63DB-422F-4C6C-9BEE-1FE34700401E}"/>
+                <a16:creationId xmlns:a16="http://schemas.microsoft.com/office/drawing/2014/main" id="{D25837DD-6944-4DD0-A50E-B6B17096CE96}"/>
               </a:ext>
             </a:extLst>
           </p:cNvPr>
@@ -1754,7 +1754,7 @@
           <p:cNvPr id="15" name="3-Data and indicators-head">
             <a:extLst xmlns:a="http://schemas.openxmlformats.org/drawingml/2006/main">
               <a:ext uri="{FF2B5EF4-FFF2-40B4-BE49-F238E27FC236}">
-                <a16:creationId xmlns:a16="http://schemas.microsoft.com/office/drawing/2014/main" id="{A5A8F2D0-B160-4B12-80CB-70FF708AF132}"/>
+                <a16:creationId xmlns:a16="http://schemas.microsoft.com/office/drawing/2014/main" id="{511F4C8B-E147-42B8-ABBA-3761FDFAC543}"/>
               </a:ext>
             </a:extLst>
           </p:cNvPr>
@@ -1787,7 +1787,7 @@
           <p:cNvPr id="16" name="3-Data and indicators-title">
             <a:extLst xmlns:a="http://schemas.openxmlformats.org/drawingml/2006/main">
               <a:ext uri="{FF2B5EF4-FFF2-40B4-BE49-F238E27FC236}">
-                <a16:creationId xmlns:a16="http://schemas.microsoft.com/office/drawing/2014/main" id="{D64AB2C7-3244-4379-932A-D61693B68DDE}"/>
+                <a16:creationId xmlns:a16="http://schemas.microsoft.com/office/drawing/2014/main" id="{19BF9F7B-918E-4953-A80C-852FA22C351C}"/>
               </a:ext>
             </a:extLst>
           </p:cNvPr>
@@ -1837,7 +1837,7 @@
           <p:cNvPr id="17" name="3-Data and indicators-body">
             <a:extLst xmlns:a="http://schemas.openxmlformats.org/drawingml/2006/main">
               <a:ext uri="{FF2B5EF4-FFF2-40B4-BE49-F238E27FC236}">
-                <a16:creationId xmlns:a16="http://schemas.microsoft.com/office/drawing/2014/main" id="{8C706A12-6387-4648-825A-E2F22FD53A69}"/>
+                <a16:creationId xmlns:a16="http://schemas.microsoft.com/office/drawing/2014/main" id="{F8F5B830-1331-4DF4-B665-D696AB7981FD}"/>
               </a:ext>
             </a:extLst>
           </p:cNvPr>
@@ -1921,7 +1921,7 @@
           <p:cNvPr id="18" name="4-Sampling design-box">
             <a:extLst xmlns:a="http://schemas.openxmlformats.org/drawingml/2006/main">
               <a:ext uri="{FF2B5EF4-FFF2-40B4-BE49-F238E27FC236}">
-                <a16:creationId xmlns:a16="http://schemas.microsoft.com/office/drawing/2014/main" id="{2606A339-2E05-4DE2-91A1-081F3E905267}"/>
+                <a16:creationId xmlns:a16="http://schemas.microsoft.com/office/drawing/2014/main" id="{41AC5313-D00D-4396-B580-F6E7CB270650}"/>
               </a:ext>
             </a:extLst>
           </p:cNvPr>
@@ -1954,7 +1954,7 @@
           <p:cNvPr id="19" name="4-Sampling design-head">
             <a:extLst xmlns:a="http://schemas.openxmlformats.org/drawingml/2006/main">
               <a:ext uri="{FF2B5EF4-FFF2-40B4-BE49-F238E27FC236}">
-                <a16:creationId xmlns:a16="http://schemas.microsoft.com/office/drawing/2014/main" id="{7EFB5372-FF81-4697-8154-3CE1A09A3A16}"/>
+                <a16:creationId xmlns:a16="http://schemas.microsoft.com/office/drawing/2014/main" id="{25C6E703-7FED-479E-BBFD-EED82F4828B1}"/>
               </a:ext>
             </a:extLst>
           </p:cNvPr>
@@ -1987,7 +1987,7 @@
           <p:cNvPr id="20" name="4-Sampling design-title">
             <a:extLst xmlns:a="http://schemas.openxmlformats.org/drawingml/2006/main">
               <a:ext uri="{FF2B5EF4-FFF2-40B4-BE49-F238E27FC236}">
-                <a16:creationId xmlns:a16="http://schemas.microsoft.com/office/drawing/2014/main" id="{19289E63-A820-4C7B-A252-4F29012C925D}"/>
+                <a16:creationId xmlns:a16="http://schemas.microsoft.com/office/drawing/2014/main" id="{8EA8C06D-2F0F-4559-9C30-84550D4D064A}"/>
               </a:ext>
             </a:extLst>
           </p:cNvPr>
@@ -2037,7 +2037,7 @@
           <p:cNvPr id="21" name="4-Sampling design-body">
             <a:extLst xmlns:a="http://schemas.openxmlformats.org/drawingml/2006/main">
               <a:ext uri="{FF2B5EF4-FFF2-40B4-BE49-F238E27FC236}">
-                <a16:creationId xmlns:a16="http://schemas.microsoft.com/office/drawing/2014/main" id="{967611BA-9CCE-4C24-A695-BB593D9EF2BA}"/>
+                <a16:creationId xmlns:a16="http://schemas.microsoft.com/office/drawing/2014/main" id="{8BBE7488-2551-460F-B38B-55AE8FAFDEEE}"/>
               </a:ext>
             </a:extLst>
           </p:cNvPr>
@@ -2138,7 +2138,7 @@
           <p:cNvPr id="22" name="classic-formula-box">
             <a:extLst xmlns:a="http://schemas.openxmlformats.org/drawingml/2006/main">
               <a:ext uri="{FF2B5EF4-FFF2-40B4-BE49-F238E27FC236}">
-                <a16:creationId xmlns:a16="http://schemas.microsoft.com/office/drawing/2014/main" id="{26CA2E9B-0913-4A9F-9F75-E1850585A169}"/>
+                <a16:creationId xmlns:a16="http://schemas.microsoft.com/office/drawing/2014/main" id="{C6DE3371-E6A5-4A8E-BD88-59592848D1B0}"/>
               </a:ext>
             </a:extLst>
           </p:cNvPr>
@@ -2171,7 +2171,7 @@
           <p:cNvPr id="23" name="classic-formula-title">
             <a:extLst xmlns:a="http://schemas.openxmlformats.org/drawingml/2006/main">
               <a:ext uri="{FF2B5EF4-FFF2-40B4-BE49-F238E27FC236}">
-                <a16:creationId xmlns:a16="http://schemas.microsoft.com/office/drawing/2014/main" id="{A3D6F19D-9E8F-40EB-8C58-443E63397990}"/>
+                <a16:creationId xmlns:a16="http://schemas.microsoft.com/office/drawing/2014/main" id="{63C778E5-F808-4EF8-96B2-FEFCAD14CECC}"/>
               </a:ext>
             </a:extLst>
           </p:cNvPr>
@@ -2221,7 +2221,7 @@
           <p:cNvPr id="24" name="classic-formula">
             <a:extLst xmlns:a="http://schemas.openxmlformats.org/drawingml/2006/main">
               <a:ext uri="{FF2B5EF4-FFF2-40B4-BE49-F238E27FC236}">
-                <a16:creationId xmlns:a16="http://schemas.microsoft.com/office/drawing/2014/main" id="{AA719B50-B6F5-4CB7-B7D1-19CD3B436D81}"/>
+                <a16:creationId xmlns:a16="http://schemas.microsoft.com/office/drawing/2014/main" id="{003DEF2E-78BA-47B2-846A-F0FDF2022FCD}"/>
               </a:ext>
             </a:extLst>
           </p:cNvPr>
@@ -2339,7 +2339,7 @@
           <p:cNvPr id="25" name="prev-metric">
             <a:extLst xmlns:a="http://schemas.openxmlformats.org/drawingml/2006/main">
               <a:ext uri="{FF2B5EF4-FFF2-40B4-BE49-F238E27FC236}">
-                <a16:creationId xmlns:a16="http://schemas.microsoft.com/office/drawing/2014/main" id="{D08C46F7-253B-448A-B3D7-4766D66539A9}"/>
+                <a16:creationId xmlns:a16="http://schemas.microsoft.com/office/drawing/2014/main" id="{CB703F16-2625-46CA-AB4E-F279EE504E21}"/>
               </a:ext>
             </a:extLst>
           </p:cNvPr>
@@ -2372,7 +2372,7 @@
           <p:cNvPr id="26" name="prev-metric-title">
             <a:extLst xmlns:a="http://schemas.openxmlformats.org/drawingml/2006/main">
               <a:ext uri="{FF2B5EF4-FFF2-40B4-BE49-F238E27FC236}">
-                <a16:creationId xmlns:a16="http://schemas.microsoft.com/office/drawing/2014/main" id="{8495BF29-15E5-4AAB-8AF2-002810F84F5A}"/>
+                <a16:creationId xmlns:a16="http://schemas.microsoft.com/office/drawing/2014/main" id="{E4EB352B-8374-4321-8353-AF3516708D96}"/>
               </a:ext>
             </a:extLst>
           </p:cNvPr>
@@ -2422,7 +2422,7 @@
           <p:cNvPr id="27" name="prev-metric-value">
             <a:extLst xmlns:a="http://schemas.openxmlformats.org/drawingml/2006/main">
               <a:ext uri="{FF2B5EF4-FFF2-40B4-BE49-F238E27FC236}">
-                <a16:creationId xmlns:a16="http://schemas.microsoft.com/office/drawing/2014/main" id="{4E30284F-1E5E-48FE-835E-BA0A0DD65E7D}"/>
+                <a16:creationId xmlns:a16="http://schemas.microsoft.com/office/drawing/2014/main" id="{2592A6C1-C144-4147-8111-D9E553219A9B}"/>
               </a:ext>
             </a:extLst>
           </p:cNvPr>
@@ -2472,7 +2472,7 @@
           <p:cNvPr id="28" name="prev-metric-note">
             <a:extLst xmlns:a="http://schemas.openxmlformats.org/drawingml/2006/main">
               <a:ext uri="{FF2B5EF4-FFF2-40B4-BE49-F238E27FC236}">
-                <a16:creationId xmlns:a16="http://schemas.microsoft.com/office/drawing/2014/main" id="{F6F84951-ADBF-4FF7-A1D3-B39BD01B54D6}"/>
+                <a16:creationId xmlns:a16="http://schemas.microsoft.com/office/drawing/2014/main" id="{C95FDF37-8C8B-4FB0-AC7D-2C79D88A8686}"/>
               </a:ext>
             </a:extLst>
           </p:cNvPr>
@@ -2522,7 +2522,7 @@
           <p:cNvPr id="29" name="crisis-metric">
             <a:extLst xmlns:a="http://schemas.openxmlformats.org/drawingml/2006/main">
               <a:ext uri="{FF2B5EF4-FFF2-40B4-BE49-F238E27FC236}">
-                <a16:creationId xmlns:a16="http://schemas.microsoft.com/office/drawing/2014/main" id="{2631B137-1BC2-4BD3-B1B0-AD523D489DE4}"/>
+                <a16:creationId xmlns:a16="http://schemas.microsoft.com/office/drawing/2014/main" id="{CE7B99A7-C125-4025-A1E3-80FFD0387688}"/>
               </a:ext>
             </a:extLst>
           </p:cNvPr>
@@ -2555,7 +2555,7 @@
           <p:cNvPr id="30" name="crisis-metric-title">
             <a:extLst xmlns:a="http://schemas.openxmlformats.org/drawingml/2006/main">
               <a:ext uri="{FF2B5EF4-FFF2-40B4-BE49-F238E27FC236}">
-                <a16:creationId xmlns:a16="http://schemas.microsoft.com/office/drawing/2014/main" id="{7246EA2D-9D96-4774-88E8-CA9768D595CB}"/>
+                <a16:creationId xmlns:a16="http://schemas.microsoft.com/office/drawing/2014/main" id="{0D5CA9F8-DA51-4380-9B29-0C6D7044FD46}"/>
               </a:ext>
             </a:extLst>
           </p:cNvPr>
@@ -2605,7 +2605,7 @@
           <p:cNvPr id="31" name="crisis-metric-value">
             <a:extLst xmlns:a="http://schemas.openxmlformats.org/drawingml/2006/main">
               <a:ext uri="{FF2B5EF4-FFF2-40B4-BE49-F238E27FC236}">
-                <a16:creationId xmlns:a16="http://schemas.microsoft.com/office/drawing/2014/main" id="{A3E2FFDB-45F6-41BA-92C7-E645282124D3}"/>
+                <a16:creationId xmlns:a16="http://schemas.microsoft.com/office/drawing/2014/main" id="{A16D39EE-6A70-4CF7-9CB0-6B31AF17CBE7}"/>
               </a:ext>
             </a:extLst>
           </p:cNvPr>
@@ -2655,7 +2655,7 @@
           <p:cNvPr id="32" name="crisis-metric-note">
             <a:extLst xmlns:a="http://schemas.openxmlformats.org/drawingml/2006/main">
               <a:ext uri="{FF2B5EF4-FFF2-40B4-BE49-F238E27FC236}">
-                <a16:creationId xmlns:a16="http://schemas.microsoft.com/office/drawing/2014/main" id="{E6AD24AB-916E-4348-8850-F1E837D5406C}"/>
+                <a16:creationId xmlns:a16="http://schemas.microsoft.com/office/drawing/2014/main" id="{29AC69EF-007A-4ECA-8DE8-71C8B78C689C}"/>
               </a:ext>
             </a:extLst>
           </p:cNvPr>
@@ -2705,7 +2705,7 @@
           <p:cNvPr id="33" name="chart-prev-caption">
             <a:extLst xmlns:a="http://schemas.openxmlformats.org/drawingml/2006/main">
               <a:ext uri="{FF2B5EF4-FFF2-40B4-BE49-F238E27FC236}">
-                <a16:creationId xmlns:a16="http://schemas.microsoft.com/office/drawing/2014/main" id="{8FADD98F-106D-4951-B780-6B9199EE62B9}"/>
+                <a16:creationId xmlns:a16="http://schemas.microsoft.com/office/drawing/2014/main" id="{8A0F99F7-744B-44DF-A890-723D1934C331}"/>
               </a:ext>
             </a:extLst>
           </p:cNvPr>
@@ -2755,7 +2755,7 @@
           <p:cNvPr id="34" name="chart-prev-frame">
             <a:extLst xmlns:a="http://schemas.openxmlformats.org/drawingml/2006/main">
               <a:ext uri="{FF2B5EF4-FFF2-40B4-BE49-F238E27FC236}">
-                <a16:creationId xmlns:a16="http://schemas.microsoft.com/office/drawing/2014/main" id="{B5A829D9-2563-4751-9CDF-019DDDA2BCC7}"/>
+                <a16:creationId xmlns:a16="http://schemas.microsoft.com/office/drawing/2014/main" id="{E4770F09-94FB-4D7E-9016-95CC79136ABB}"/>
               </a:ext>
             </a:extLst>
           </p:cNvPr>
@@ -2792,13 +2792,13 @@
           <p:nvPr/>
         </p:nvPicPr>
         <p:blipFill>
-          <a:blip xmlns:r="http://schemas.openxmlformats.org/officeDocument/2006/relationships" xmlns:a="http://schemas.openxmlformats.org/drawingml/2006/main" r:embed="R8b23d6d7b15746d7"/>
+          <a:blip xmlns:r="http://schemas.openxmlformats.org/officeDocument/2006/relationships" xmlns:a="http://schemas.openxmlformats.org/drawingml/2006/main" r:embed="R301bb8b3853a4c73"/>
           <a:stretch xmlns:a="http://schemas.openxmlformats.org/drawingml/2006/main"/>
         </p:blipFill>
         <p:spPr>
           <a:xfrm xmlns:a="http://schemas.openxmlformats.org/drawingml/2006/main">
-            <a:off x="3384550" y="5313098"/>
-            <a:ext cx="2755900" cy="803804"/>
+            <a:off x="3387790" y="4724400"/>
+            <a:ext cx="2749420" cy="1981200"/>
           </a:xfrm>
           <a:prstGeom xmlns:a="http://schemas.openxmlformats.org/drawingml/2006/main" prst="rect">
             <a:avLst/>
@@ -2810,7 +2810,7 @@
           <p:cNvPr id="36" name="chart-crisis-caption">
             <a:extLst xmlns:a="http://schemas.openxmlformats.org/drawingml/2006/main">
               <a:ext uri="{FF2B5EF4-FFF2-40B4-BE49-F238E27FC236}">
-                <a16:creationId xmlns:a16="http://schemas.microsoft.com/office/drawing/2014/main" id="{96F9265D-4955-4510-9B42-3943EF50A667}"/>
+                <a16:creationId xmlns:a16="http://schemas.microsoft.com/office/drawing/2014/main" id="{83236B61-B6BC-4DA2-B119-43BD1F213F60}"/>
               </a:ext>
             </a:extLst>
           </p:cNvPr>
@@ -2860,7 +2860,7 @@
           <p:cNvPr id="37" name="chart-crisis-frame">
             <a:extLst xmlns:a="http://schemas.openxmlformats.org/drawingml/2006/main">
               <a:ext uri="{FF2B5EF4-FFF2-40B4-BE49-F238E27FC236}">
-                <a16:creationId xmlns:a16="http://schemas.microsoft.com/office/drawing/2014/main" id="{169A0B57-CBAF-4A01-A9CA-93B9DEA2E231}"/>
+                <a16:creationId xmlns:a16="http://schemas.microsoft.com/office/drawing/2014/main" id="{682F7BA2-B78D-4EEC-9F79-F3B1D5AF746B}"/>
               </a:ext>
             </a:extLst>
           </p:cNvPr>
@@ -2897,13 +2897,13 @@
           <p:nvPr/>
         </p:nvPicPr>
         <p:blipFill>
-          <a:blip xmlns:r="http://schemas.openxmlformats.org/officeDocument/2006/relationships" xmlns:a="http://schemas.openxmlformats.org/drawingml/2006/main" r:embed="Rffc7265042a24dff"/>
+          <a:blip xmlns:r="http://schemas.openxmlformats.org/officeDocument/2006/relationships" xmlns:a="http://schemas.openxmlformats.org/drawingml/2006/main" r:embed="R8c28228802cf4fa9"/>
           <a:stretch xmlns:a="http://schemas.openxmlformats.org/drawingml/2006/main"/>
         </p:blipFill>
         <p:spPr>
           <a:xfrm xmlns:a="http://schemas.openxmlformats.org/drawingml/2006/main">
-            <a:off x="3384550" y="7789598"/>
-            <a:ext cx="2755900" cy="803804"/>
+            <a:off x="3387790" y="7200900"/>
+            <a:ext cx="2749420" cy="1981200"/>
           </a:xfrm>
           <a:prstGeom xmlns:a="http://schemas.openxmlformats.org/drawingml/2006/main" prst="rect">
             <a:avLst/>
@@ -2915,7 +2915,7 @@
           <p:cNvPr id="39" name="5-Results and interpretation-box">
             <a:extLst xmlns:a="http://schemas.openxmlformats.org/drawingml/2006/main">
               <a:ext uri="{FF2B5EF4-FFF2-40B4-BE49-F238E27FC236}">
-                <a16:creationId xmlns:a16="http://schemas.microsoft.com/office/drawing/2014/main" id="{3C6C80AF-E91C-4F20-8E7D-8AF43BE3A4C3}"/>
+                <a16:creationId xmlns:a16="http://schemas.microsoft.com/office/drawing/2014/main" id="{1173D15C-2060-48DF-82F2-2BFD2D37C078}"/>
               </a:ext>
             </a:extLst>
           </p:cNvPr>
@@ -2948,7 +2948,7 @@
           <p:cNvPr id="40" name="5-Results and interpretation-head">
             <a:extLst xmlns:a="http://schemas.openxmlformats.org/drawingml/2006/main">
               <a:ext uri="{FF2B5EF4-FFF2-40B4-BE49-F238E27FC236}">
-                <a16:creationId xmlns:a16="http://schemas.microsoft.com/office/drawing/2014/main" id="{846F4F70-4049-4162-A8F4-90F8B314F8E2}"/>
+                <a16:creationId xmlns:a16="http://schemas.microsoft.com/office/drawing/2014/main" id="{E8B12DF9-FAA9-4C25-8A3A-4F795B713069}"/>
               </a:ext>
             </a:extLst>
           </p:cNvPr>
@@ -2981,7 +2981,7 @@
           <p:cNvPr id="41" name="5-Results and interpretation-title">
             <a:extLst xmlns:a="http://schemas.openxmlformats.org/drawingml/2006/main">
               <a:ext uri="{FF2B5EF4-FFF2-40B4-BE49-F238E27FC236}">
-                <a16:creationId xmlns:a16="http://schemas.microsoft.com/office/drawing/2014/main" id="{6F3F5D3B-6349-44CE-9943-1A415A28DF1F}"/>
+                <a16:creationId xmlns:a16="http://schemas.microsoft.com/office/drawing/2014/main" id="{525DC13C-146C-47D8-AF5F-7E50BA581F4B}"/>
               </a:ext>
             </a:extLst>
           </p:cNvPr>
@@ -3031,7 +3031,7 @@
           <p:cNvPr id="42" name="5-Results and interpretation-body">
             <a:extLst xmlns:a="http://schemas.openxmlformats.org/drawingml/2006/main">
               <a:ext uri="{FF2B5EF4-FFF2-40B4-BE49-F238E27FC236}">
-                <a16:creationId xmlns:a16="http://schemas.microsoft.com/office/drawing/2014/main" id="{70722B75-A74B-47E6-8C2E-536283109ABF}"/>
+                <a16:creationId xmlns:a16="http://schemas.microsoft.com/office/drawing/2014/main" id="{61D21BA1-7236-49C6-9B59-D1C9CA6F75B7}"/>
               </a:ext>
             </a:extLst>
           </p:cNvPr>
@@ -3132,7 +3132,7 @@
           <p:cNvPr id="43" name="meds-metric">
             <a:extLst xmlns:a="http://schemas.openxmlformats.org/drawingml/2006/main">
               <a:ext uri="{FF2B5EF4-FFF2-40B4-BE49-F238E27FC236}">
-                <a16:creationId xmlns:a16="http://schemas.microsoft.com/office/drawing/2014/main" id="{C30D736F-A2A9-4C41-841A-B0582E3799C3}"/>
+                <a16:creationId xmlns:a16="http://schemas.microsoft.com/office/drawing/2014/main" id="{3C86BEBC-6C8E-4ADB-8AB9-656B9A985FE2}"/>
               </a:ext>
             </a:extLst>
           </p:cNvPr>
@@ -3165,7 +3165,7 @@
           <p:cNvPr id="44" name="meds-metric-title">
             <a:extLst xmlns:a="http://schemas.openxmlformats.org/drawingml/2006/main">
               <a:ext uri="{FF2B5EF4-FFF2-40B4-BE49-F238E27FC236}">
-                <a16:creationId xmlns:a16="http://schemas.microsoft.com/office/drawing/2014/main" id="{9031807D-9E32-4A0B-AE18-3F759B4CFBA7}"/>
+                <a16:creationId xmlns:a16="http://schemas.microsoft.com/office/drawing/2014/main" id="{3F20A1BA-1F39-4E40-958C-D041C096D4D0}"/>
               </a:ext>
             </a:extLst>
           </p:cNvPr>
@@ -3215,7 +3215,7 @@
           <p:cNvPr id="45" name="meds-metric-value">
             <a:extLst xmlns:a="http://schemas.openxmlformats.org/drawingml/2006/main">
               <a:ext uri="{FF2B5EF4-FFF2-40B4-BE49-F238E27FC236}">
-                <a16:creationId xmlns:a16="http://schemas.microsoft.com/office/drawing/2014/main" id="{968A277B-9BE2-4792-8D69-1DF9CA0D6421}"/>
+                <a16:creationId xmlns:a16="http://schemas.microsoft.com/office/drawing/2014/main" id="{91E0FDBE-17E3-41F7-B64A-1FFFDC65E5D6}"/>
               </a:ext>
             </a:extLst>
           </p:cNvPr>
@@ -3265,7 +3265,7 @@
           <p:cNvPr id="46" name="meds-metric-note">
             <a:extLst xmlns:a="http://schemas.openxmlformats.org/drawingml/2006/main">
               <a:ext uri="{FF2B5EF4-FFF2-40B4-BE49-F238E27FC236}">
-                <a16:creationId xmlns:a16="http://schemas.microsoft.com/office/drawing/2014/main" id="{3959BB1B-7966-404F-BC8C-03246A32C1D0}"/>
+                <a16:creationId xmlns:a16="http://schemas.microsoft.com/office/drawing/2014/main" id="{72647CCB-030D-4205-9E32-60CBBAF7F0B8}"/>
               </a:ext>
             </a:extLst>
           </p:cNvPr>
@@ -3315,7 +3315,7 @@
           <p:cNvPr id="47" name="chart-meds-caption">
             <a:extLst xmlns:a="http://schemas.openxmlformats.org/drawingml/2006/main">
               <a:ext uri="{FF2B5EF4-FFF2-40B4-BE49-F238E27FC236}">
-                <a16:creationId xmlns:a16="http://schemas.microsoft.com/office/drawing/2014/main" id="{233EA8AC-1189-498A-AB6A-3BAA5BD5A080}"/>
+                <a16:creationId xmlns:a16="http://schemas.microsoft.com/office/drawing/2014/main" id="{C7A70351-504E-41A7-A408-8C00F1D4A484}"/>
               </a:ext>
             </a:extLst>
           </p:cNvPr>
@@ -3365,7 +3365,7 @@
           <p:cNvPr id="48" name="chart-meds-frame">
             <a:extLst xmlns:a="http://schemas.openxmlformats.org/drawingml/2006/main">
               <a:ext uri="{FF2B5EF4-FFF2-40B4-BE49-F238E27FC236}">
-                <a16:creationId xmlns:a16="http://schemas.microsoft.com/office/drawing/2014/main" id="{06D9FB92-318C-4E9A-9053-9F63DA89AD7A}"/>
+                <a16:creationId xmlns:a16="http://schemas.microsoft.com/office/drawing/2014/main" id="{F1C15067-9494-46CD-8658-6726A83FE3E5}"/>
               </a:ext>
             </a:extLst>
           </p:cNvPr>
@@ -3402,13 +3402,13 @@
           <p:nvPr/>
         </p:nvPicPr>
         <p:blipFill>
-          <a:blip xmlns:r="http://schemas.openxmlformats.org/officeDocument/2006/relationships" xmlns:a="http://schemas.openxmlformats.org/drawingml/2006/main" r:embed="R0e9b68bdba684bc5"/>
+          <a:blip xmlns:r="http://schemas.openxmlformats.org/officeDocument/2006/relationships" xmlns:a="http://schemas.openxmlformats.org/drawingml/2006/main" r:embed="R7aed54e2ebec42da"/>
           <a:stretch xmlns:a="http://schemas.openxmlformats.org/drawingml/2006/main"/>
         </p:blipFill>
         <p:spPr>
           <a:xfrm xmlns:a="http://schemas.openxmlformats.org/drawingml/2006/main">
-            <a:off x="6407150" y="4265348"/>
-            <a:ext cx="2755900" cy="803804"/>
+            <a:off x="6410390" y="3676650"/>
+            <a:ext cx="2749420" cy="1981200"/>
           </a:xfrm>
           <a:prstGeom xmlns:a="http://schemas.openxmlformats.org/drawingml/2006/main" prst="rect">
             <a:avLst/>
@@ -3420,7 +3420,7 @@
           <p:cNvPr id="50" name="chart-smoke-caption">
             <a:extLst xmlns:a="http://schemas.openxmlformats.org/drawingml/2006/main">
               <a:ext uri="{FF2B5EF4-FFF2-40B4-BE49-F238E27FC236}">
-                <a16:creationId xmlns:a16="http://schemas.microsoft.com/office/drawing/2014/main" id="{ADFBB0A8-E8CE-4783-BC7D-E0BEF33B2083}"/>
+                <a16:creationId xmlns:a16="http://schemas.microsoft.com/office/drawing/2014/main" id="{E2C82A8C-E1F1-4CA5-B9BB-AB8E0D92D989}"/>
               </a:ext>
             </a:extLst>
           </p:cNvPr>
@@ -3470,7 +3470,7 @@
           <p:cNvPr id="51" name="chart-smoke-frame">
             <a:extLst xmlns:a="http://schemas.openxmlformats.org/drawingml/2006/main">
               <a:ext uri="{FF2B5EF4-FFF2-40B4-BE49-F238E27FC236}">
-                <a16:creationId xmlns:a16="http://schemas.microsoft.com/office/drawing/2014/main" id="{B03FD4A9-28FF-4036-AE3A-EE29E6EFA9E2}"/>
+                <a16:creationId xmlns:a16="http://schemas.microsoft.com/office/drawing/2014/main" id="{04F31219-59B5-4AF2-880C-D1D9BC65765B}"/>
               </a:ext>
             </a:extLst>
           </p:cNvPr>
@@ -3507,13 +3507,13 @@
           <p:nvPr/>
         </p:nvPicPr>
         <p:blipFill>
-          <a:blip xmlns:r="http://schemas.openxmlformats.org/officeDocument/2006/relationships" xmlns:a="http://schemas.openxmlformats.org/drawingml/2006/main" r:embed="R4fac9599c99b4c07"/>
+          <a:blip xmlns:r="http://schemas.openxmlformats.org/officeDocument/2006/relationships" xmlns:a="http://schemas.openxmlformats.org/drawingml/2006/main" r:embed="Rccdfb0793fec4d4f"/>
           <a:stretch xmlns:a="http://schemas.openxmlformats.org/drawingml/2006/main"/>
         </p:blipFill>
         <p:spPr>
           <a:xfrm xmlns:a="http://schemas.openxmlformats.org/drawingml/2006/main">
-            <a:off x="6407150" y="6741848"/>
-            <a:ext cx="2755900" cy="803804"/>
+            <a:off x="6410390" y="6153150"/>
+            <a:ext cx="2749420" cy="1981200"/>
           </a:xfrm>
           <a:prstGeom xmlns:a="http://schemas.openxmlformats.org/drawingml/2006/main" prst="rect">
             <a:avLst/>
@@ -3525,7 +3525,7 @@
           <p:cNvPr id="53" name="6-Beta CI and chart reading-box">
             <a:extLst xmlns:a="http://schemas.openxmlformats.org/drawingml/2006/main">
               <a:ext uri="{FF2B5EF4-FFF2-40B4-BE49-F238E27FC236}">
-                <a16:creationId xmlns:a16="http://schemas.microsoft.com/office/drawing/2014/main" id="{2168D813-74F9-4824-B1A7-45CBC2707803}"/>
+                <a16:creationId xmlns:a16="http://schemas.microsoft.com/office/drawing/2014/main" id="{8867B644-F1DE-4B03-A5EA-4D3B90D0B235}"/>
               </a:ext>
             </a:extLst>
           </p:cNvPr>
@@ -3558,7 +3558,7 @@
           <p:cNvPr id="54" name="6-Beta CI and chart reading-head">
             <a:extLst xmlns:a="http://schemas.openxmlformats.org/drawingml/2006/main">
               <a:ext uri="{FF2B5EF4-FFF2-40B4-BE49-F238E27FC236}">
-                <a16:creationId xmlns:a16="http://schemas.microsoft.com/office/drawing/2014/main" id="{5EEC6C69-0FE4-4F56-86BE-22A2BA1CE336}"/>
+                <a16:creationId xmlns:a16="http://schemas.microsoft.com/office/drawing/2014/main" id="{5E04AA62-661E-459D-AD11-7BD9346B8BE6}"/>
               </a:ext>
             </a:extLst>
           </p:cNvPr>
@@ -3591,7 +3591,7 @@
           <p:cNvPr id="55" name="6-Beta CI and chart reading-title">
             <a:extLst xmlns:a="http://schemas.openxmlformats.org/drawingml/2006/main">
               <a:ext uri="{FF2B5EF4-FFF2-40B4-BE49-F238E27FC236}">
-                <a16:creationId xmlns:a16="http://schemas.microsoft.com/office/drawing/2014/main" id="{8FDE33DC-BCA6-445E-B9BC-82F0FA8B1A35}"/>
+                <a16:creationId xmlns:a16="http://schemas.microsoft.com/office/drawing/2014/main" id="{7C813ABF-98AA-4FBB-B0A8-88F9402B1CFC}"/>
               </a:ext>
             </a:extLst>
           </p:cNvPr>
@@ -3641,7 +3641,7 @@
           <p:cNvPr id="56" name="6-Beta CI and chart reading-body">
             <a:extLst xmlns:a="http://schemas.openxmlformats.org/drawingml/2006/main">
               <a:ext uri="{FF2B5EF4-FFF2-40B4-BE49-F238E27FC236}">
-                <a16:creationId xmlns:a16="http://schemas.microsoft.com/office/drawing/2014/main" id="{4B12AF38-89DB-4B25-A35E-867C6B3AB410}"/>
+                <a16:creationId xmlns:a16="http://schemas.microsoft.com/office/drawing/2014/main" id="{6597AECA-D9CF-45D5-85FD-6695CEF2D68F}"/>
               </a:ext>
             </a:extLst>
           </p:cNvPr>
@@ -3725,7 +3725,7 @@
           <p:cNvPr id="57" name="7-Discussion and implications-box">
             <a:extLst xmlns:a="http://schemas.openxmlformats.org/drawingml/2006/main">
               <a:ext uri="{FF2B5EF4-FFF2-40B4-BE49-F238E27FC236}">
-                <a16:creationId xmlns:a16="http://schemas.microsoft.com/office/drawing/2014/main" id="{EDD1FC17-11D8-4E24-A274-CD4DA070C986}"/>
+                <a16:creationId xmlns:a16="http://schemas.microsoft.com/office/drawing/2014/main" id="{F2A2F906-BF08-41F7-93DE-31B5E8C3E226}"/>
               </a:ext>
             </a:extLst>
           </p:cNvPr>
@@ -3758,7 +3758,7 @@
           <p:cNvPr id="58" name="7-Discussion and implications-head">
             <a:extLst xmlns:a="http://schemas.openxmlformats.org/drawingml/2006/main">
               <a:ext uri="{FF2B5EF4-FFF2-40B4-BE49-F238E27FC236}">
-                <a16:creationId xmlns:a16="http://schemas.microsoft.com/office/drawing/2014/main" id="{21134341-A77E-4EFE-AC14-611ADB6E2E01}"/>
+                <a16:creationId xmlns:a16="http://schemas.microsoft.com/office/drawing/2014/main" id="{910DBD68-ABDD-446D-B5D3-D69DE2CF6D55}"/>
               </a:ext>
             </a:extLst>
           </p:cNvPr>
@@ -3791,7 +3791,7 @@
           <p:cNvPr id="59" name="7-Discussion and implications-title">
             <a:extLst xmlns:a="http://schemas.openxmlformats.org/drawingml/2006/main">
               <a:ext uri="{FF2B5EF4-FFF2-40B4-BE49-F238E27FC236}">
-                <a16:creationId xmlns:a16="http://schemas.microsoft.com/office/drawing/2014/main" id="{28EAFDE0-CEEE-4CE6-B29D-0AC23CA644CC}"/>
+                <a16:creationId xmlns:a16="http://schemas.microsoft.com/office/drawing/2014/main" id="{C1B3D27B-8E3D-4236-8E5A-F6396A22B6EA}"/>
               </a:ext>
             </a:extLst>
           </p:cNvPr>
@@ -3841,7 +3841,7 @@
           <p:cNvPr id="60" name="7-Discussion and implications-body">
             <a:extLst xmlns:a="http://schemas.openxmlformats.org/drawingml/2006/main">
               <a:ext uri="{FF2B5EF4-FFF2-40B4-BE49-F238E27FC236}">
-                <a16:creationId xmlns:a16="http://schemas.microsoft.com/office/drawing/2014/main" id="{FFF8CA9B-4D22-484A-8368-20EFE57F9BF4}"/>
+                <a16:creationId xmlns:a16="http://schemas.microsoft.com/office/drawing/2014/main" id="{558FFE49-954C-4D78-9E9D-57DAA095FCED}"/>
               </a:ext>
             </a:extLst>
           </p:cNvPr>
@@ -3925,7 +3925,7 @@
           <p:cNvPr id="61" name="8-ETL, OMOP and OHDSI-box">
             <a:extLst xmlns:a="http://schemas.openxmlformats.org/drawingml/2006/main">
               <a:ext uri="{FF2B5EF4-FFF2-40B4-BE49-F238E27FC236}">
-                <a16:creationId xmlns:a16="http://schemas.microsoft.com/office/drawing/2014/main" id="{88BB0946-6497-4009-922D-F36A34C62F02}"/>
+                <a16:creationId xmlns:a16="http://schemas.microsoft.com/office/drawing/2014/main" id="{E6DB3855-ACAF-4315-A7BB-887F993A5608}"/>
               </a:ext>
             </a:extLst>
           </p:cNvPr>
@@ -3958,7 +3958,7 @@
           <p:cNvPr id="62" name="8-ETL, OMOP and OHDSI-head">
             <a:extLst xmlns:a="http://schemas.openxmlformats.org/drawingml/2006/main">
               <a:ext uri="{FF2B5EF4-FFF2-40B4-BE49-F238E27FC236}">
-                <a16:creationId xmlns:a16="http://schemas.microsoft.com/office/drawing/2014/main" id="{3D9A634C-6775-498B-9B54-1D1707CD8BBB}"/>
+                <a16:creationId xmlns:a16="http://schemas.microsoft.com/office/drawing/2014/main" id="{27555DE4-BFC9-4539-AB05-E1106DF74282}"/>
               </a:ext>
             </a:extLst>
           </p:cNvPr>
@@ -3991,7 +3991,7 @@
           <p:cNvPr id="63" name="8-ETL, OMOP and OHDSI-title">
             <a:extLst xmlns:a="http://schemas.openxmlformats.org/drawingml/2006/main">
               <a:ext uri="{FF2B5EF4-FFF2-40B4-BE49-F238E27FC236}">
-                <a16:creationId xmlns:a16="http://schemas.microsoft.com/office/drawing/2014/main" id="{700E01F2-009B-4CB0-85A6-160543658088}"/>
+                <a16:creationId xmlns:a16="http://schemas.microsoft.com/office/drawing/2014/main" id="{FF69A9A8-6CED-49FA-A52A-7997B6E29B7E}"/>
               </a:ext>
             </a:extLst>
           </p:cNvPr>
@@ -4041,7 +4041,7 @@
           <p:cNvPr id="64" name="8-ETL, OMOP and OHDSI-body">
             <a:extLst xmlns:a="http://schemas.openxmlformats.org/drawingml/2006/main">
               <a:ext uri="{FF2B5EF4-FFF2-40B4-BE49-F238E27FC236}">
-                <a16:creationId xmlns:a16="http://schemas.microsoft.com/office/drawing/2014/main" id="{3F081A21-003C-4FD5-A4BD-4C2D6E3F1C78}"/>
+                <a16:creationId xmlns:a16="http://schemas.microsoft.com/office/drawing/2014/main" id="{A3B187D7-B498-4AB0-8352-A2A4185D0345}"/>
               </a:ext>
             </a:extLst>
           </p:cNvPr>
@@ -4125,7 +4125,7 @@
           <p:cNvPr id="65" name="9-Conclusions-box">
             <a:extLst xmlns:a="http://schemas.openxmlformats.org/drawingml/2006/main">
               <a:ext uri="{FF2B5EF4-FFF2-40B4-BE49-F238E27FC236}">
-                <a16:creationId xmlns:a16="http://schemas.microsoft.com/office/drawing/2014/main" id="{C8426B32-F875-4E5B-8B16-5C30D8D36A3C}"/>
+                <a16:creationId xmlns:a16="http://schemas.microsoft.com/office/drawing/2014/main" id="{D831C47F-236B-4A9A-A5E1-746BB9F1E201}"/>
               </a:ext>
             </a:extLst>
           </p:cNvPr>
@@ -4158,7 +4158,7 @@
           <p:cNvPr id="66" name="9-Conclusions-head">
             <a:extLst xmlns:a="http://schemas.openxmlformats.org/drawingml/2006/main">
               <a:ext uri="{FF2B5EF4-FFF2-40B4-BE49-F238E27FC236}">
-                <a16:creationId xmlns:a16="http://schemas.microsoft.com/office/drawing/2014/main" id="{615C42CA-E645-40D5-AC67-13B617708268}"/>
+                <a16:creationId xmlns:a16="http://schemas.microsoft.com/office/drawing/2014/main" id="{4D107024-DB95-4770-8677-361C5F6B5DEE}"/>
               </a:ext>
             </a:extLst>
           </p:cNvPr>
@@ -4191,7 +4191,7 @@
           <p:cNvPr id="67" name="9-Conclusions-title">
             <a:extLst xmlns:a="http://schemas.openxmlformats.org/drawingml/2006/main">
               <a:ext uri="{FF2B5EF4-FFF2-40B4-BE49-F238E27FC236}">
-                <a16:creationId xmlns:a16="http://schemas.microsoft.com/office/drawing/2014/main" id="{AFC553AA-F5CC-4EDB-99C6-3595FE856140}"/>
+                <a16:creationId xmlns:a16="http://schemas.microsoft.com/office/drawing/2014/main" id="{2CC9A875-5380-48D0-A371-3B2DDBB96931}"/>
               </a:ext>
             </a:extLst>
           </p:cNvPr>
@@ -4241,7 +4241,7 @@
           <p:cNvPr id="68" name="9-Conclusions-body">
             <a:extLst xmlns:a="http://schemas.openxmlformats.org/drawingml/2006/main">
               <a:ext uri="{FF2B5EF4-FFF2-40B4-BE49-F238E27FC236}">
-                <a16:creationId xmlns:a16="http://schemas.microsoft.com/office/drawing/2014/main" id="{27CD07D1-5533-47AD-A1D2-F76572F75C25}"/>
+                <a16:creationId xmlns:a16="http://schemas.microsoft.com/office/drawing/2014/main" id="{7FD30094-AA70-41A8-B9DE-C4E1E91FF89C}"/>
               </a:ext>
             </a:extLst>
           </p:cNvPr>
@@ -4325,7 +4325,7 @@
           <p:cNvPr id="69" name="references-box">
             <a:extLst xmlns:a="http://schemas.openxmlformats.org/drawingml/2006/main">
               <a:ext uri="{FF2B5EF4-FFF2-40B4-BE49-F238E27FC236}">
-                <a16:creationId xmlns:a16="http://schemas.microsoft.com/office/drawing/2014/main" id="{5AD09F37-02C1-41EE-BC7F-AB399255D566}"/>
+                <a16:creationId xmlns:a16="http://schemas.microsoft.com/office/drawing/2014/main" id="{D2CAA9F6-B227-4CFE-9B31-8F7D8F9C0D9B}"/>
               </a:ext>
             </a:extLst>
           </p:cNvPr>
@@ -4358,7 +4358,7 @@
           <p:cNvPr id="70" name="references-title">
             <a:extLst xmlns:a="http://schemas.openxmlformats.org/drawingml/2006/main">
               <a:ext uri="{FF2B5EF4-FFF2-40B4-BE49-F238E27FC236}">
-                <a16:creationId xmlns:a16="http://schemas.microsoft.com/office/drawing/2014/main" id="{0898327D-61AB-4B69-8107-6F3C22110742}"/>
+                <a16:creationId xmlns:a16="http://schemas.microsoft.com/office/drawing/2014/main" id="{F4FCCC3F-C4AC-44D5-A7AC-848D83E6B055}"/>
               </a:ext>
             </a:extLst>
           </p:cNvPr>
@@ -4408,7 +4408,7 @@
           <p:cNvPr id="71" name="references-body">
             <a:extLst xmlns:a="http://schemas.openxmlformats.org/drawingml/2006/main">
               <a:ext uri="{FF2B5EF4-FFF2-40B4-BE49-F238E27FC236}">
-                <a16:creationId xmlns:a16="http://schemas.microsoft.com/office/drawing/2014/main" id="{4CFF413B-2EE5-410C-B316-1F6275993CE8}"/>
+                <a16:creationId xmlns:a16="http://schemas.microsoft.com/office/drawing/2014/main" id="{43E2EEC6-C583-49CE-90BD-C20615EE6EB9}"/>
               </a:ext>
             </a:extLst>
           </p:cNvPr>
@@ -4662,7 +4662,7 @@
           <p:cNvPr id="72" name="qr-box">
             <a:extLst xmlns:a="http://schemas.openxmlformats.org/drawingml/2006/main">
               <a:ext uri="{FF2B5EF4-FFF2-40B4-BE49-F238E27FC236}">
-                <a16:creationId xmlns:a16="http://schemas.microsoft.com/office/drawing/2014/main" id="{1D956A99-8C23-4C01-A0F0-0333F3E7F7A4}"/>
+                <a16:creationId xmlns:a16="http://schemas.microsoft.com/office/drawing/2014/main" id="{F1008704-6C31-4D8D-B683-E815FB4ADD9F}"/>
               </a:ext>
             </a:extLst>
           </p:cNvPr>
@@ -4699,7 +4699,7 @@
           <p:nvPr/>
         </p:nvPicPr>
         <p:blipFill>
-          <a:blip xmlns:r="http://schemas.openxmlformats.org/officeDocument/2006/relationships" xmlns:a="http://schemas.openxmlformats.org/drawingml/2006/main" r:embed="R5d1076c6dfe24bad"/>
+          <a:blip xmlns:r="http://schemas.openxmlformats.org/officeDocument/2006/relationships" xmlns:a="http://schemas.openxmlformats.org/drawingml/2006/main" r:embed="Radf0f6386cd54fd6"/>
           <a:stretch xmlns:a="http://schemas.openxmlformats.org/drawingml/2006/main"/>
         </p:blipFill>
         <p:spPr>
@@ -4717,7 +4717,7 @@
           <p:cNvPr id="74" name="qr-label">
             <a:extLst xmlns:a="http://schemas.openxmlformats.org/drawingml/2006/main">
               <a:ext uri="{FF2B5EF4-FFF2-40B4-BE49-F238E27FC236}">
-                <a16:creationId xmlns:a16="http://schemas.microsoft.com/office/drawing/2014/main" id="{13824500-2351-4D38-81FF-7B9057A1979E}"/>
+                <a16:creationId xmlns:a16="http://schemas.microsoft.com/office/drawing/2014/main" id="{A9716E5B-13CB-475F-A999-66887DA7C357}"/>
               </a:ext>
             </a:extLst>
           </p:cNvPr>
@@ -4782,7 +4782,7 @@
     </p:spTree>
     <p:extLst>
       <p:ext uri="{BB962C8B-B14F-4D97-AF65-F5344CB8AC3E}">
-        <p14:creationId xmlns:p14="http://schemas.microsoft.com/office/powerpoint/2010/main" val="1163170890"/>
+        <p14:creationId xmlns:p14="http://schemas.microsoft.com/office/powerpoint/2010/main" val="323538422"/>
       </p:ext>
     </p:extLst>
   </p:cSld>

</xml_diff>

<commit_message>
Clarify Brazil poster summary cards
</commit_message>
<xml_diff>
--- a/outputs/posters/poster_pns_asma_classico_en.pptx
+++ b/outputs/posters/poster_pns_asma_classico_en.pptx
@@ -2,13 +2,13 @@
 <file path=ppt/presentation.xml><?xml version="1.0" encoding="utf-8"?>
 <p:presentation xmlns:p="http://schemas.openxmlformats.org/presentationml/2006/main">
   <p:sldMasterIdLst>
-    <p:sldMasterId xmlns:r="http://schemas.openxmlformats.org/officeDocument/2006/relationships" id="2147483648" r:id="Rd57426a0ac824ce8"/>
+    <p:sldMasterId xmlns:r="http://schemas.openxmlformats.org/officeDocument/2006/relationships" id="2147483648" r:id="Rc4354873120c4607"/>
   </p:sldMasterIdLst>
   <p:notesMasterIdLst>
-    <p:notesMasterId xmlns:r="http://schemas.openxmlformats.org/officeDocument/2006/relationships" r:id="R6374eed4585547b0"/>
+    <p:notesMasterId xmlns:r="http://schemas.openxmlformats.org/officeDocument/2006/relationships" r:id="R2f7547e61d9a428e"/>
   </p:notesMasterIdLst>
   <p:sldIdLst>
-    <p:sldId xmlns:r="http://schemas.openxmlformats.org/officeDocument/2006/relationships" id="256" r:id="R6f4bdc7da59e414d"/>
+    <p:sldId xmlns:r="http://schemas.openxmlformats.org/officeDocument/2006/relationships" id="256" r:id="Ra8232c91f1374f21"/>
   </p:sldIdLst>
   <p:sldSz cx="9525000" cy="13468350"/>
   <p:notesSz cx="6858000" cy="9144000"/>
@@ -601,7 +601,7 @@
   </p:cSld>
   <p:clrMap bg1="lt1" tx1="dk1" bg2="lt2" tx2="dk2" accent1="accent1" accent2="accent2" accent3="accent3" accent4="accent4" accent5="accent5" accent6="accent6" hlink="hlink" folHlink="folHlink"/>
   <p:sldLayoutIdLst>
-    <p:sldLayoutId xmlns:r="http://schemas.openxmlformats.org/officeDocument/2006/relationships" id="2147483649" r:id="R5a92b3f67f1049e1"/>
+    <p:sldLayoutId xmlns:r="http://schemas.openxmlformats.org/officeDocument/2006/relationships" id="2147483649" r:id="R3b9e7ab91d504009"/>
   </p:sldLayoutIdLst>
   <p:txStyles>
     <p:titleStyle>
@@ -1156,7 +1156,7 @@
           <p:nvPr/>
         </p:nvPicPr>
         <p:blipFill>
-          <a:blip xmlns:r="http://schemas.openxmlformats.org/officeDocument/2006/relationships" xmlns:a="http://schemas.openxmlformats.org/drawingml/2006/main" r:embed="Rfc4aed48359b456b"/>
+          <a:blip xmlns:r="http://schemas.openxmlformats.org/officeDocument/2006/relationships" xmlns:a="http://schemas.openxmlformats.org/drawingml/2006/main" r:embed="R8ff9619181fd4121"/>
           <a:srcRect xmlns:a="http://schemas.openxmlformats.org/drawingml/2006/main" l="0" t="38622" r="0" b="38622"/>
           <a:stretch xmlns:a="http://schemas.openxmlformats.org/drawingml/2006/main">
             <a:fillRect l="0" t="0" r="0" b="0"/>
@@ -1181,7 +1181,7 @@
           <p:nvPr/>
         </p:nvPicPr>
         <p:blipFill>
-          <a:blip xmlns:r="http://schemas.openxmlformats.org/officeDocument/2006/relationships" xmlns:a="http://schemas.openxmlformats.org/drawingml/2006/main" r:embed="R075ffd0c56a445c2"/>
+          <a:blip xmlns:r="http://schemas.openxmlformats.org/officeDocument/2006/relationships" xmlns:a="http://schemas.openxmlformats.org/drawingml/2006/main" r:embed="R4fe31b8eb68c4419"/>
           <a:stretch xmlns:a="http://schemas.openxmlformats.org/drawingml/2006/main"/>
         </p:blipFill>
         <p:spPr>
@@ -1203,7 +1203,7 @@
           <p:nvPr/>
         </p:nvPicPr>
         <p:blipFill>
-          <a:blip xmlns:r="http://schemas.openxmlformats.org/officeDocument/2006/relationships" xmlns:a="http://schemas.openxmlformats.org/drawingml/2006/main" r:embed="R9142d174a78a4bed"/>
+          <a:blip xmlns:r="http://schemas.openxmlformats.org/officeDocument/2006/relationships" xmlns:a="http://schemas.openxmlformats.org/drawingml/2006/main" r:embed="Rcd32d62a571942d5"/>
           <a:stretch xmlns:a="http://schemas.openxmlformats.org/drawingml/2006/main"/>
         </p:blipFill>
         <p:spPr>
@@ -1221,7 +1221,7 @@
           <p:cNvPr id="4" name="classic-title">
             <a:extLst xmlns:a="http://schemas.openxmlformats.org/drawingml/2006/main">
               <a:ext uri="{FF2B5EF4-FFF2-40B4-BE49-F238E27FC236}">
-                <a16:creationId xmlns:a16="http://schemas.microsoft.com/office/drawing/2014/main" id="{5F431656-3658-4CE3-BE77-BCCCB78A08BF}"/>
+                <a16:creationId xmlns:a16="http://schemas.microsoft.com/office/drawing/2014/main" id="{A5E2AA4E-4A5B-46AF-A5A1-2BF980F977B1}"/>
               </a:ext>
             </a:extLst>
           </p:cNvPr>
@@ -1271,7 +1271,7 @@
           <p:cNvPr id="5" name="classic-authors">
             <a:extLst xmlns:a="http://schemas.openxmlformats.org/drawingml/2006/main">
               <a:ext uri="{FF2B5EF4-FFF2-40B4-BE49-F238E27FC236}">
-                <a16:creationId xmlns:a16="http://schemas.microsoft.com/office/drawing/2014/main" id="{0073896C-1FEA-462E-B695-0EA02D6DCF2C}"/>
+                <a16:creationId xmlns:a16="http://schemas.microsoft.com/office/drawing/2014/main" id="{E8E69C95-1BE9-46B3-B01C-4321D29E2D14}"/>
               </a:ext>
             </a:extLst>
           </p:cNvPr>
@@ -1321,7 +1321,7 @@
           <p:cNvPr id="6" name="1-Introduction-box">
             <a:extLst xmlns:a="http://schemas.openxmlformats.org/drawingml/2006/main">
               <a:ext uri="{FF2B5EF4-FFF2-40B4-BE49-F238E27FC236}">
-                <a16:creationId xmlns:a16="http://schemas.microsoft.com/office/drawing/2014/main" id="{1377DB2F-65F1-481C-8E22-B39795FA8E8F}"/>
+                <a16:creationId xmlns:a16="http://schemas.microsoft.com/office/drawing/2014/main" id="{C7F526C1-A233-49C9-A10E-416C3DCB228F}"/>
               </a:ext>
             </a:extLst>
           </p:cNvPr>
@@ -1354,7 +1354,7 @@
           <p:cNvPr id="7" name="1-Introduction-head">
             <a:extLst xmlns:a="http://schemas.openxmlformats.org/drawingml/2006/main">
               <a:ext uri="{FF2B5EF4-FFF2-40B4-BE49-F238E27FC236}">
-                <a16:creationId xmlns:a16="http://schemas.microsoft.com/office/drawing/2014/main" id="{C2AFE87F-F8AA-4A24-96F5-B7F3D8095A3C}"/>
+                <a16:creationId xmlns:a16="http://schemas.microsoft.com/office/drawing/2014/main" id="{A616FC0A-2D7C-47D3-B431-C206CB4EA3D0}"/>
               </a:ext>
             </a:extLst>
           </p:cNvPr>
@@ -1387,7 +1387,7 @@
           <p:cNvPr id="8" name="1-Introduction-title">
             <a:extLst xmlns:a="http://schemas.openxmlformats.org/drawingml/2006/main">
               <a:ext uri="{FF2B5EF4-FFF2-40B4-BE49-F238E27FC236}">
-                <a16:creationId xmlns:a16="http://schemas.microsoft.com/office/drawing/2014/main" id="{0544C84D-792B-42A9-9BFB-CF6750C3CD84}"/>
+                <a16:creationId xmlns:a16="http://schemas.microsoft.com/office/drawing/2014/main" id="{BE8B4996-8206-4730-912D-AA0C24FA94BE}"/>
               </a:ext>
             </a:extLst>
           </p:cNvPr>
@@ -1437,7 +1437,7 @@
           <p:cNvPr id="9" name="1-Introduction-body">
             <a:extLst xmlns:a="http://schemas.openxmlformats.org/drawingml/2006/main">
               <a:ext uri="{FF2B5EF4-FFF2-40B4-BE49-F238E27FC236}">
-                <a16:creationId xmlns:a16="http://schemas.microsoft.com/office/drawing/2014/main" id="{95CDEE0A-2FDA-4A55-A6E0-E3FA46B2513A}"/>
+                <a16:creationId xmlns:a16="http://schemas.microsoft.com/office/drawing/2014/main" id="{0754B327-BF77-4A7C-90F9-606786E7126A}"/>
               </a:ext>
             </a:extLst>
           </p:cNvPr>
@@ -1521,7 +1521,7 @@
           <p:cNvPr id="10" name="2-Objectives-box">
             <a:extLst xmlns:a="http://schemas.openxmlformats.org/drawingml/2006/main">
               <a:ext uri="{FF2B5EF4-FFF2-40B4-BE49-F238E27FC236}">
-                <a16:creationId xmlns:a16="http://schemas.microsoft.com/office/drawing/2014/main" id="{69980493-EB0F-44C4-BFFB-92DBEFED5DDE}"/>
+                <a16:creationId xmlns:a16="http://schemas.microsoft.com/office/drawing/2014/main" id="{00B51BDD-36CB-4E15-9042-07C712372420}"/>
               </a:ext>
             </a:extLst>
           </p:cNvPr>
@@ -1554,7 +1554,7 @@
           <p:cNvPr id="11" name="2-Objectives-head">
             <a:extLst xmlns:a="http://schemas.openxmlformats.org/drawingml/2006/main">
               <a:ext uri="{FF2B5EF4-FFF2-40B4-BE49-F238E27FC236}">
-                <a16:creationId xmlns:a16="http://schemas.microsoft.com/office/drawing/2014/main" id="{67F71AA9-95F3-48D1-B186-301B49040A98}"/>
+                <a16:creationId xmlns:a16="http://schemas.microsoft.com/office/drawing/2014/main" id="{C0DAB95D-5F0B-4D5B-8D27-B5DDD22AC746}"/>
               </a:ext>
             </a:extLst>
           </p:cNvPr>
@@ -1587,7 +1587,7 @@
           <p:cNvPr id="12" name="2-Objectives-title">
             <a:extLst xmlns:a="http://schemas.openxmlformats.org/drawingml/2006/main">
               <a:ext uri="{FF2B5EF4-FFF2-40B4-BE49-F238E27FC236}">
-                <a16:creationId xmlns:a16="http://schemas.microsoft.com/office/drawing/2014/main" id="{A2AC13C5-7AC7-40A0-83AD-8A809BCE7B01}"/>
+                <a16:creationId xmlns:a16="http://schemas.microsoft.com/office/drawing/2014/main" id="{AA34715A-E7A4-42A5-BF49-1BD3B6D1B5C1}"/>
               </a:ext>
             </a:extLst>
           </p:cNvPr>
@@ -1637,7 +1637,7 @@
           <p:cNvPr id="13" name="2-Objectives-body">
             <a:extLst xmlns:a="http://schemas.openxmlformats.org/drawingml/2006/main">
               <a:ext uri="{FF2B5EF4-FFF2-40B4-BE49-F238E27FC236}">
-                <a16:creationId xmlns:a16="http://schemas.microsoft.com/office/drawing/2014/main" id="{47EB8FE4-9A20-4E76-ADE8-0B5E80694B97}"/>
+                <a16:creationId xmlns:a16="http://schemas.microsoft.com/office/drawing/2014/main" id="{218C8EEC-2FC6-44C6-96A5-EDCB13B9C3B7}"/>
               </a:ext>
             </a:extLst>
           </p:cNvPr>
@@ -1721,7 +1721,7 @@
           <p:cNvPr id="14" name="3-Data and indicators-box">
             <a:extLst xmlns:a="http://schemas.openxmlformats.org/drawingml/2006/main">
               <a:ext uri="{FF2B5EF4-FFF2-40B4-BE49-F238E27FC236}">
-                <a16:creationId xmlns:a16="http://schemas.microsoft.com/office/drawing/2014/main" id="{D25837DD-6944-4DD0-A50E-B6B17096CE96}"/>
+                <a16:creationId xmlns:a16="http://schemas.microsoft.com/office/drawing/2014/main" id="{D1550EC8-393E-45B7-8F38-1638F6F36CC8}"/>
               </a:ext>
             </a:extLst>
           </p:cNvPr>
@@ -1754,7 +1754,7 @@
           <p:cNvPr id="15" name="3-Data and indicators-head">
             <a:extLst xmlns:a="http://schemas.openxmlformats.org/drawingml/2006/main">
               <a:ext uri="{FF2B5EF4-FFF2-40B4-BE49-F238E27FC236}">
-                <a16:creationId xmlns:a16="http://schemas.microsoft.com/office/drawing/2014/main" id="{511F4C8B-E147-42B8-ABBA-3761FDFAC543}"/>
+                <a16:creationId xmlns:a16="http://schemas.microsoft.com/office/drawing/2014/main" id="{13923DB1-5245-4D15-853C-67254A2DE431}"/>
               </a:ext>
             </a:extLst>
           </p:cNvPr>
@@ -1787,7 +1787,7 @@
           <p:cNvPr id="16" name="3-Data and indicators-title">
             <a:extLst xmlns:a="http://schemas.openxmlformats.org/drawingml/2006/main">
               <a:ext uri="{FF2B5EF4-FFF2-40B4-BE49-F238E27FC236}">
-                <a16:creationId xmlns:a16="http://schemas.microsoft.com/office/drawing/2014/main" id="{19BF9F7B-918E-4953-A80C-852FA22C351C}"/>
+                <a16:creationId xmlns:a16="http://schemas.microsoft.com/office/drawing/2014/main" id="{B297F4FB-EC62-4307-9D4E-40EE875E7A0D}"/>
               </a:ext>
             </a:extLst>
           </p:cNvPr>
@@ -1837,7 +1837,7 @@
           <p:cNvPr id="17" name="3-Data and indicators-body">
             <a:extLst xmlns:a="http://schemas.openxmlformats.org/drawingml/2006/main">
               <a:ext uri="{FF2B5EF4-FFF2-40B4-BE49-F238E27FC236}">
-                <a16:creationId xmlns:a16="http://schemas.microsoft.com/office/drawing/2014/main" id="{F8F5B830-1331-4DF4-B665-D696AB7981FD}"/>
+                <a16:creationId xmlns:a16="http://schemas.microsoft.com/office/drawing/2014/main" id="{39165ABB-83BC-4CC7-BE5C-FBFB2E42F5CC}"/>
               </a:ext>
             </a:extLst>
           </p:cNvPr>
@@ -1921,7 +1921,7 @@
           <p:cNvPr id="18" name="4-Sampling design-box">
             <a:extLst xmlns:a="http://schemas.openxmlformats.org/drawingml/2006/main">
               <a:ext uri="{FF2B5EF4-FFF2-40B4-BE49-F238E27FC236}">
-                <a16:creationId xmlns:a16="http://schemas.microsoft.com/office/drawing/2014/main" id="{41AC5313-D00D-4396-B580-F6E7CB270650}"/>
+                <a16:creationId xmlns:a16="http://schemas.microsoft.com/office/drawing/2014/main" id="{EEB3DAE7-B6F4-48E1-8029-7BD76F514FF9}"/>
               </a:ext>
             </a:extLst>
           </p:cNvPr>
@@ -1954,7 +1954,7 @@
           <p:cNvPr id="19" name="4-Sampling design-head">
             <a:extLst xmlns:a="http://schemas.openxmlformats.org/drawingml/2006/main">
               <a:ext uri="{FF2B5EF4-FFF2-40B4-BE49-F238E27FC236}">
-                <a16:creationId xmlns:a16="http://schemas.microsoft.com/office/drawing/2014/main" id="{25C6E703-7FED-479E-BBFD-EED82F4828B1}"/>
+                <a16:creationId xmlns:a16="http://schemas.microsoft.com/office/drawing/2014/main" id="{9B4192DE-E9F8-4613-8F31-BFF2E1F749FB}"/>
               </a:ext>
             </a:extLst>
           </p:cNvPr>
@@ -1987,7 +1987,7 @@
           <p:cNvPr id="20" name="4-Sampling design-title">
             <a:extLst xmlns:a="http://schemas.openxmlformats.org/drawingml/2006/main">
               <a:ext uri="{FF2B5EF4-FFF2-40B4-BE49-F238E27FC236}">
-                <a16:creationId xmlns:a16="http://schemas.microsoft.com/office/drawing/2014/main" id="{8EA8C06D-2F0F-4559-9C30-84550D4D064A}"/>
+                <a16:creationId xmlns:a16="http://schemas.microsoft.com/office/drawing/2014/main" id="{B9F57A8E-4A68-4DCC-B31B-CA0FE122A922}"/>
               </a:ext>
             </a:extLst>
           </p:cNvPr>
@@ -2037,7 +2037,7 @@
           <p:cNvPr id="21" name="4-Sampling design-body">
             <a:extLst xmlns:a="http://schemas.openxmlformats.org/drawingml/2006/main">
               <a:ext uri="{FF2B5EF4-FFF2-40B4-BE49-F238E27FC236}">
-                <a16:creationId xmlns:a16="http://schemas.microsoft.com/office/drawing/2014/main" id="{8BBE7488-2551-460F-B38B-55AE8FAFDEEE}"/>
+                <a16:creationId xmlns:a16="http://schemas.microsoft.com/office/drawing/2014/main" id="{3B1A2F2F-EE7D-4036-AA48-BADD72F7D1A8}"/>
               </a:ext>
             </a:extLst>
           </p:cNvPr>
@@ -2138,7 +2138,7 @@
           <p:cNvPr id="22" name="classic-formula-box">
             <a:extLst xmlns:a="http://schemas.openxmlformats.org/drawingml/2006/main">
               <a:ext uri="{FF2B5EF4-FFF2-40B4-BE49-F238E27FC236}">
-                <a16:creationId xmlns:a16="http://schemas.microsoft.com/office/drawing/2014/main" id="{C6DE3371-E6A5-4A8E-BD88-59592848D1B0}"/>
+                <a16:creationId xmlns:a16="http://schemas.microsoft.com/office/drawing/2014/main" id="{794E9961-8EEE-40F5-9730-867E4825BB71}"/>
               </a:ext>
             </a:extLst>
           </p:cNvPr>
@@ -2171,7 +2171,7 @@
           <p:cNvPr id="23" name="classic-formula-title">
             <a:extLst xmlns:a="http://schemas.openxmlformats.org/drawingml/2006/main">
               <a:ext uri="{FF2B5EF4-FFF2-40B4-BE49-F238E27FC236}">
-                <a16:creationId xmlns:a16="http://schemas.microsoft.com/office/drawing/2014/main" id="{63C778E5-F808-4EF8-96B2-FEFCAD14CECC}"/>
+                <a16:creationId xmlns:a16="http://schemas.microsoft.com/office/drawing/2014/main" id="{B26EF3DA-0715-4B85-9158-A119435C4D88}"/>
               </a:ext>
             </a:extLst>
           </p:cNvPr>
@@ -2221,7 +2221,7 @@
           <p:cNvPr id="24" name="classic-formula">
             <a:extLst xmlns:a="http://schemas.openxmlformats.org/drawingml/2006/main">
               <a:ext uri="{FF2B5EF4-FFF2-40B4-BE49-F238E27FC236}">
-                <a16:creationId xmlns:a16="http://schemas.microsoft.com/office/drawing/2014/main" id="{003DEF2E-78BA-47B2-846A-F0FDF2022FCD}"/>
+                <a16:creationId xmlns:a16="http://schemas.microsoft.com/office/drawing/2014/main" id="{9D35DE7E-CA57-44F1-926E-5FC5B103BA3D}"/>
               </a:ext>
             </a:extLst>
           </p:cNvPr>
@@ -2339,7 +2339,7 @@
           <p:cNvPr id="25" name="prev-metric">
             <a:extLst xmlns:a="http://schemas.openxmlformats.org/drawingml/2006/main">
               <a:ext uri="{FF2B5EF4-FFF2-40B4-BE49-F238E27FC236}">
-                <a16:creationId xmlns:a16="http://schemas.microsoft.com/office/drawing/2014/main" id="{CB703F16-2625-46CA-AB4E-F279EE504E21}"/>
+                <a16:creationId xmlns:a16="http://schemas.microsoft.com/office/drawing/2014/main" id="{BEC00AD7-CA25-4CFA-8D88-973549EEFC10}"/>
               </a:ext>
             </a:extLst>
           </p:cNvPr>
@@ -2372,7 +2372,7 @@
           <p:cNvPr id="26" name="prev-metric-title">
             <a:extLst xmlns:a="http://schemas.openxmlformats.org/drawingml/2006/main">
               <a:ext uri="{FF2B5EF4-FFF2-40B4-BE49-F238E27FC236}">
-                <a16:creationId xmlns:a16="http://schemas.microsoft.com/office/drawing/2014/main" id="{E4EB352B-8374-4321-8353-AF3516708D96}"/>
+                <a16:creationId xmlns:a16="http://schemas.microsoft.com/office/drawing/2014/main" id="{DAF306CA-A7F4-42C7-8692-A68F5D5DCA9D}"/>
               </a:ext>
             </a:extLst>
           </p:cNvPr>
@@ -2412,7 +2412,7 @@
                   <a:srgbClr val="153F59"/>
                 </a:solidFill>
               </a:rPr>
-              <a:t>National prevalence</a:t>
+              <a:t>Brazil: diagnosis</a:t>
             </a:r>
           </a:p>
         </p:txBody>
@@ -2422,7 +2422,7 @@
           <p:cNvPr id="27" name="prev-metric-value">
             <a:extLst xmlns:a="http://schemas.openxmlformats.org/drawingml/2006/main">
               <a:ext uri="{FF2B5EF4-FFF2-40B4-BE49-F238E27FC236}">
-                <a16:creationId xmlns:a16="http://schemas.microsoft.com/office/drawing/2014/main" id="{2592A6C1-C144-4147-8111-D9E553219A9B}"/>
+                <a16:creationId xmlns:a16="http://schemas.microsoft.com/office/drawing/2014/main" id="{B0F22488-1B73-4A74-951D-197CBB501C1C}"/>
               </a:ext>
             </a:extLst>
           </p:cNvPr>
@@ -2472,7 +2472,7 @@
           <p:cNvPr id="28" name="prev-metric-note">
             <a:extLst xmlns:a="http://schemas.openxmlformats.org/drawingml/2006/main">
               <a:ext uri="{FF2B5EF4-FFF2-40B4-BE49-F238E27FC236}">
-                <a16:creationId xmlns:a16="http://schemas.microsoft.com/office/drawing/2014/main" id="{C95FDF37-8C8B-4FB0-AC7D-2C79D88A8686}"/>
+                <a16:creationId xmlns:a16="http://schemas.microsoft.com/office/drawing/2014/main" id="{D7F129B0-7C65-4A65-A758-D17D60DAA4FA}"/>
               </a:ext>
             </a:extLst>
           </p:cNvPr>
@@ -2512,7 +2512,7 @@
                   <a:srgbClr val="102536"/>
                 </a:solidFill>
               </a:rPr>
-              <a:t>Physician-diagnosed asthma increased with non-overlapping 95% CIs.</a:t>
+              <a:t>Physician-diagnosed asthma increased, with non-overlapping 95% CIs.</a:t>
             </a:r>
           </a:p>
         </p:txBody>
@@ -2522,7 +2522,7 @@
           <p:cNvPr id="29" name="crisis-metric">
             <a:extLst xmlns:a="http://schemas.openxmlformats.org/drawingml/2006/main">
               <a:ext uri="{FF2B5EF4-FFF2-40B4-BE49-F238E27FC236}">
-                <a16:creationId xmlns:a16="http://schemas.microsoft.com/office/drawing/2014/main" id="{CE7B99A7-C125-4025-A1E3-80FFD0387688}"/>
+                <a16:creationId xmlns:a16="http://schemas.microsoft.com/office/drawing/2014/main" id="{01646118-2EB7-4FE2-B7EA-DB84D06CA3C6}"/>
               </a:ext>
             </a:extLst>
           </p:cNvPr>
@@ -2555,7 +2555,7 @@
           <p:cNvPr id="30" name="crisis-metric-title">
             <a:extLst xmlns:a="http://schemas.openxmlformats.org/drawingml/2006/main">
               <a:ext uri="{FF2B5EF4-FFF2-40B4-BE49-F238E27FC236}">
-                <a16:creationId xmlns:a16="http://schemas.microsoft.com/office/drawing/2014/main" id="{0D5CA9F8-DA51-4380-9B29-0C6D7044FD46}"/>
+                <a16:creationId xmlns:a16="http://schemas.microsoft.com/office/drawing/2014/main" id="{AB195CFA-8A47-4E48-BA28-916385FE6758}"/>
               </a:ext>
             </a:extLst>
           </p:cNvPr>
@@ -2595,7 +2595,7 @@
                   <a:srgbClr val="153F59"/>
                 </a:solidFill>
               </a:rPr>
-              <a:t>12-month attacks</a:t>
+              <a:t>Brazil: attacks</a:t>
             </a:r>
           </a:p>
         </p:txBody>
@@ -2605,7 +2605,7 @@
           <p:cNvPr id="31" name="crisis-metric-value">
             <a:extLst xmlns:a="http://schemas.openxmlformats.org/drawingml/2006/main">
               <a:ext uri="{FF2B5EF4-FFF2-40B4-BE49-F238E27FC236}">
-                <a16:creationId xmlns:a16="http://schemas.microsoft.com/office/drawing/2014/main" id="{A16D39EE-6A70-4CF7-9CB0-6B31AF17CBE7}"/>
+                <a16:creationId xmlns:a16="http://schemas.microsoft.com/office/drawing/2014/main" id="{8C819B23-7598-4F7D-90D6-B37F7B12C972}"/>
               </a:ext>
             </a:extLst>
           </p:cNvPr>
@@ -2655,7 +2655,7 @@
           <p:cNvPr id="32" name="crisis-metric-note">
             <a:extLst xmlns:a="http://schemas.openxmlformats.org/drawingml/2006/main">
               <a:ext uri="{FF2B5EF4-FFF2-40B4-BE49-F238E27FC236}">
-                <a16:creationId xmlns:a16="http://schemas.microsoft.com/office/drawing/2014/main" id="{29AC69EF-007A-4ECA-8DE8-71C8B78C689C}"/>
+                <a16:creationId xmlns:a16="http://schemas.microsoft.com/office/drawing/2014/main" id="{DE710182-4982-4810-87DE-6A8765E782A1}"/>
               </a:ext>
             </a:extLst>
           </p:cNvPr>
@@ -2695,7 +2695,7 @@
                   <a:srgbClr val="102536"/>
                 </a:solidFill>
               </a:rPr>
-              <a:t>Approximate stability, suggesting insufficient disease control.</a:t>
+              <a:t>12-month attacks were stable; control did not improve proportionally.</a:t>
             </a:r>
           </a:p>
         </p:txBody>
@@ -2705,7 +2705,7 @@
           <p:cNvPr id="33" name="chart-prev-caption">
             <a:extLst xmlns:a="http://schemas.openxmlformats.org/drawingml/2006/main">
               <a:ext uri="{FF2B5EF4-FFF2-40B4-BE49-F238E27FC236}">
-                <a16:creationId xmlns:a16="http://schemas.microsoft.com/office/drawing/2014/main" id="{8A0F99F7-744B-44DF-A890-723D1934C331}"/>
+                <a16:creationId xmlns:a16="http://schemas.microsoft.com/office/drawing/2014/main" id="{1CDB1A6B-6FF3-4E31-9755-D6898E4D1237}"/>
               </a:ext>
             </a:extLst>
           </p:cNvPr>
@@ -2755,7 +2755,7 @@
           <p:cNvPr id="34" name="chart-prev-frame">
             <a:extLst xmlns:a="http://schemas.openxmlformats.org/drawingml/2006/main">
               <a:ext uri="{FF2B5EF4-FFF2-40B4-BE49-F238E27FC236}">
-                <a16:creationId xmlns:a16="http://schemas.microsoft.com/office/drawing/2014/main" id="{E4770F09-94FB-4D7E-9016-95CC79136ABB}"/>
+                <a16:creationId xmlns:a16="http://schemas.microsoft.com/office/drawing/2014/main" id="{AFBAA7ED-F610-49A2-90C2-CA138048F300}"/>
               </a:ext>
             </a:extLst>
           </p:cNvPr>
@@ -2792,7 +2792,7 @@
           <p:nvPr/>
         </p:nvPicPr>
         <p:blipFill>
-          <a:blip xmlns:r="http://schemas.openxmlformats.org/officeDocument/2006/relationships" xmlns:a="http://schemas.openxmlformats.org/drawingml/2006/main" r:embed="R301bb8b3853a4c73"/>
+          <a:blip xmlns:r="http://schemas.openxmlformats.org/officeDocument/2006/relationships" xmlns:a="http://schemas.openxmlformats.org/drawingml/2006/main" r:embed="R40000a130a694919"/>
           <a:stretch xmlns:a="http://schemas.openxmlformats.org/drawingml/2006/main"/>
         </p:blipFill>
         <p:spPr>
@@ -2810,7 +2810,7 @@
           <p:cNvPr id="36" name="chart-crisis-caption">
             <a:extLst xmlns:a="http://schemas.openxmlformats.org/drawingml/2006/main">
               <a:ext uri="{FF2B5EF4-FFF2-40B4-BE49-F238E27FC236}">
-                <a16:creationId xmlns:a16="http://schemas.microsoft.com/office/drawing/2014/main" id="{83236B61-B6BC-4DA2-B119-43BD1F213F60}"/>
+                <a16:creationId xmlns:a16="http://schemas.microsoft.com/office/drawing/2014/main" id="{E0BD6DE2-EB60-4E30-84F9-EF4A4E11B24E}"/>
               </a:ext>
             </a:extLst>
           </p:cNvPr>
@@ -2860,7 +2860,7 @@
           <p:cNvPr id="37" name="chart-crisis-frame">
             <a:extLst xmlns:a="http://schemas.openxmlformats.org/drawingml/2006/main">
               <a:ext uri="{FF2B5EF4-FFF2-40B4-BE49-F238E27FC236}">
-                <a16:creationId xmlns:a16="http://schemas.microsoft.com/office/drawing/2014/main" id="{682F7BA2-B78D-4EEC-9F79-F3B1D5AF746B}"/>
+                <a16:creationId xmlns:a16="http://schemas.microsoft.com/office/drawing/2014/main" id="{09D287B2-CF88-4ED0-B2AE-84395B20C1B5}"/>
               </a:ext>
             </a:extLst>
           </p:cNvPr>
@@ -2897,7 +2897,7 @@
           <p:nvPr/>
         </p:nvPicPr>
         <p:blipFill>
-          <a:blip xmlns:r="http://schemas.openxmlformats.org/officeDocument/2006/relationships" xmlns:a="http://schemas.openxmlformats.org/drawingml/2006/main" r:embed="R8c28228802cf4fa9"/>
+          <a:blip xmlns:r="http://schemas.openxmlformats.org/officeDocument/2006/relationships" xmlns:a="http://schemas.openxmlformats.org/drawingml/2006/main" r:embed="R4eb36c3b26934253"/>
           <a:stretch xmlns:a="http://schemas.openxmlformats.org/drawingml/2006/main"/>
         </p:blipFill>
         <p:spPr>
@@ -2915,7 +2915,7 @@
           <p:cNvPr id="39" name="5-Results and interpretation-box">
             <a:extLst xmlns:a="http://schemas.openxmlformats.org/drawingml/2006/main">
               <a:ext uri="{FF2B5EF4-FFF2-40B4-BE49-F238E27FC236}">
-                <a16:creationId xmlns:a16="http://schemas.microsoft.com/office/drawing/2014/main" id="{1173D15C-2060-48DF-82F2-2BFD2D37C078}"/>
+                <a16:creationId xmlns:a16="http://schemas.microsoft.com/office/drawing/2014/main" id="{F6EC4668-5524-4A57-AA3C-82B511DFB032}"/>
               </a:ext>
             </a:extLst>
           </p:cNvPr>
@@ -2948,7 +2948,7 @@
           <p:cNvPr id="40" name="5-Results and interpretation-head">
             <a:extLst xmlns:a="http://schemas.openxmlformats.org/drawingml/2006/main">
               <a:ext uri="{FF2B5EF4-FFF2-40B4-BE49-F238E27FC236}">
-                <a16:creationId xmlns:a16="http://schemas.microsoft.com/office/drawing/2014/main" id="{E8B12DF9-FAA9-4C25-8A3A-4F795B713069}"/>
+                <a16:creationId xmlns:a16="http://schemas.microsoft.com/office/drawing/2014/main" id="{FF7F832D-1718-4075-8064-79EFBB042A11}"/>
               </a:ext>
             </a:extLst>
           </p:cNvPr>
@@ -2981,7 +2981,7 @@
           <p:cNvPr id="41" name="5-Results and interpretation-title">
             <a:extLst xmlns:a="http://schemas.openxmlformats.org/drawingml/2006/main">
               <a:ext uri="{FF2B5EF4-FFF2-40B4-BE49-F238E27FC236}">
-                <a16:creationId xmlns:a16="http://schemas.microsoft.com/office/drawing/2014/main" id="{525DC13C-146C-47D8-AF5F-7E50BA581F4B}"/>
+                <a16:creationId xmlns:a16="http://schemas.microsoft.com/office/drawing/2014/main" id="{275D82DB-1554-4459-BA59-6AED1775C00F}"/>
               </a:ext>
             </a:extLst>
           </p:cNvPr>
@@ -3031,7 +3031,7 @@
           <p:cNvPr id="42" name="5-Results and interpretation-body">
             <a:extLst xmlns:a="http://schemas.openxmlformats.org/drawingml/2006/main">
               <a:ext uri="{FF2B5EF4-FFF2-40B4-BE49-F238E27FC236}">
-                <a16:creationId xmlns:a16="http://schemas.microsoft.com/office/drawing/2014/main" id="{61D21BA1-7236-49C6-9B59-D1C9CA6F75B7}"/>
+                <a16:creationId xmlns:a16="http://schemas.microsoft.com/office/drawing/2014/main" id="{23A0740A-3921-4068-A3C3-6A9AD8C7A184}"/>
               </a:ext>
             </a:extLst>
           </p:cNvPr>
@@ -3071,7 +3071,7 @@
                   <a:srgbClr val="102536"/>
                 </a:solidFill>
               </a:rPr>
-              <a:t>• Physician-diagnosed asthma: 4.41% in 2013 to 5.40% in 2019, with non-overlapping CIs.</a:t>
+              <a:t>• Brazil: physician-diagnosed asthma increased from 4.41% in 2013 to 5.40% in 2019, with non-overlapping 95% CIs.</a:t>
             </a:r>
           </a:p>
           <a:p xmlns:a="http://schemas.openxmlformats.org/drawingml/2006/main">
@@ -3088,7 +3088,7 @@
                   <a:srgbClr val="102536"/>
                 </a:solidFill>
               </a:rPr>
-              <a:t>• Attacks in the previous 12 months: 38.3% to 37.7%, indicating approximate stability.</a:t>
+              <a:t>• Brazil: attacks in the previous 12 months were stable, from 38.3% to 37.7%.</a:t>
             </a:r>
           </a:p>
           <a:p xmlns:a="http://schemas.openxmlformats.org/drawingml/2006/main">
@@ -3105,7 +3105,7 @@
                   <a:srgbClr val="102536"/>
                 </a:solidFill>
               </a:rPr>
-              <a:t>• Oral/inhaler medication use among people with asthma: 81.5% to 64.4%; reading requires denominator and CI caution.</a:t>
+              <a:t>• Brazil: oral/inhaler medication use among people with asthma changed from 81.5% to 64.4%; interpretation should consider 95% CIs, the diagnosed group and the population rate.</a:t>
             </a:r>
           </a:p>
           <a:p xmlns:a="http://schemas.openxmlformats.org/drawingml/2006/main">
@@ -3132,7 +3132,7 @@
           <p:cNvPr id="43" name="meds-metric">
             <a:extLst xmlns:a="http://schemas.openxmlformats.org/drawingml/2006/main">
               <a:ext uri="{FF2B5EF4-FFF2-40B4-BE49-F238E27FC236}">
-                <a16:creationId xmlns:a16="http://schemas.microsoft.com/office/drawing/2014/main" id="{3C86BEBC-6C8E-4ADB-8AB9-656B9A985FE2}"/>
+                <a16:creationId xmlns:a16="http://schemas.microsoft.com/office/drawing/2014/main" id="{614BF93D-9AAF-44F1-BD55-C8359429ADDC}"/>
               </a:ext>
             </a:extLst>
           </p:cNvPr>
@@ -3165,7 +3165,7 @@
           <p:cNvPr id="44" name="meds-metric-title">
             <a:extLst xmlns:a="http://schemas.openxmlformats.org/drawingml/2006/main">
               <a:ext uri="{FF2B5EF4-FFF2-40B4-BE49-F238E27FC236}">
-                <a16:creationId xmlns:a16="http://schemas.microsoft.com/office/drawing/2014/main" id="{3F20A1BA-1F39-4E40-958C-D041C096D4D0}"/>
+                <a16:creationId xmlns:a16="http://schemas.microsoft.com/office/drawing/2014/main" id="{7F7386CF-6710-48AF-B7F3-A8E0C8273A1B}"/>
               </a:ext>
             </a:extLst>
           </p:cNvPr>
@@ -3205,7 +3205,7 @@
                   <a:srgbClr val="153F59"/>
                 </a:solidFill>
               </a:rPr>
-              <a:t>Medication</a:t>
+              <a:t>Brazil: medication</a:t>
             </a:r>
           </a:p>
         </p:txBody>
@@ -3215,7 +3215,7 @@
           <p:cNvPr id="45" name="meds-metric-value">
             <a:extLst xmlns:a="http://schemas.openxmlformats.org/drawingml/2006/main">
               <a:ext uri="{FF2B5EF4-FFF2-40B4-BE49-F238E27FC236}">
-                <a16:creationId xmlns:a16="http://schemas.microsoft.com/office/drawing/2014/main" id="{91E0FDBE-17E3-41F7-B64A-1FFFDC65E5D6}"/>
+                <a16:creationId xmlns:a16="http://schemas.microsoft.com/office/drawing/2014/main" id="{1DBB9A23-EDC6-4D2E-97A5-FACDD5992001}"/>
               </a:ext>
             </a:extLst>
           </p:cNvPr>
@@ -3265,7 +3265,7 @@
           <p:cNvPr id="46" name="meds-metric-note">
             <a:extLst xmlns:a="http://schemas.openxmlformats.org/drawingml/2006/main">
               <a:ext uri="{FF2B5EF4-FFF2-40B4-BE49-F238E27FC236}">
-                <a16:creationId xmlns:a16="http://schemas.microsoft.com/office/drawing/2014/main" id="{72647CCB-030D-4205-9E32-60CBBAF7F0B8}"/>
+                <a16:creationId xmlns:a16="http://schemas.microsoft.com/office/drawing/2014/main" id="{D0861812-2DF5-44A9-9258-28777DC20115}"/>
               </a:ext>
             </a:extLst>
           </p:cNvPr>
@@ -3305,7 +3305,7 @@
                   <a:srgbClr val="102536"/>
                 </a:solidFill>
               </a:rPr>
-              <a:t>Lower proportion among people with asthma; inference depends on 95% CI and denominator.</a:t>
+              <a:t>Lower use among people with asthma; read with 95% CIs and the diagnosed-group profile.</a:t>
             </a:r>
           </a:p>
         </p:txBody>
@@ -3315,7 +3315,7 @@
           <p:cNvPr id="47" name="chart-meds-caption">
             <a:extLst xmlns:a="http://schemas.openxmlformats.org/drawingml/2006/main">
               <a:ext uri="{FF2B5EF4-FFF2-40B4-BE49-F238E27FC236}">
-                <a16:creationId xmlns:a16="http://schemas.microsoft.com/office/drawing/2014/main" id="{C7A70351-504E-41A7-A408-8C00F1D4A484}"/>
+                <a16:creationId xmlns:a16="http://schemas.microsoft.com/office/drawing/2014/main" id="{767D8124-516A-464E-A382-B8410EC57790}"/>
               </a:ext>
             </a:extLst>
           </p:cNvPr>
@@ -3365,7 +3365,7 @@
           <p:cNvPr id="48" name="chart-meds-frame">
             <a:extLst xmlns:a="http://schemas.openxmlformats.org/drawingml/2006/main">
               <a:ext uri="{FF2B5EF4-FFF2-40B4-BE49-F238E27FC236}">
-                <a16:creationId xmlns:a16="http://schemas.microsoft.com/office/drawing/2014/main" id="{F1C15067-9494-46CD-8658-6726A83FE3E5}"/>
+                <a16:creationId xmlns:a16="http://schemas.microsoft.com/office/drawing/2014/main" id="{1498CF57-054A-4225-A038-73691FF5641D}"/>
               </a:ext>
             </a:extLst>
           </p:cNvPr>
@@ -3402,7 +3402,7 @@
           <p:nvPr/>
         </p:nvPicPr>
         <p:blipFill>
-          <a:blip xmlns:r="http://schemas.openxmlformats.org/officeDocument/2006/relationships" xmlns:a="http://schemas.openxmlformats.org/drawingml/2006/main" r:embed="R7aed54e2ebec42da"/>
+          <a:blip xmlns:r="http://schemas.openxmlformats.org/officeDocument/2006/relationships" xmlns:a="http://schemas.openxmlformats.org/drawingml/2006/main" r:embed="Rdfa13ff962a84ee9"/>
           <a:stretch xmlns:a="http://schemas.openxmlformats.org/drawingml/2006/main"/>
         </p:blipFill>
         <p:spPr>
@@ -3420,7 +3420,7 @@
           <p:cNvPr id="50" name="chart-smoke-caption">
             <a:extLst xmlns:a="http://schemas.openxmlformats.org/drawingml/2006/main">
               <a:ext uri="{FF2B5EF4-FFF2-40B4-BE49-F238E27FC236}">
-                <a16:creationId xmlns:a16="http://schemas.microsoft.com/office/drawing/2014/main" id="{E2C82A8C-E1F1-4CA5-B9BB-AB8E0D92D989}"/>
+                <a16:creationId xmlns:a16="http://schemas.microsoft.com/office/drawing/2014/main" id="{1CA97DB8-56AC-40C7-8833-B7A8E077F631}"/>
               </a:ext>
             </a:extLst>
           </p:cNvPr>
@@ -3470,7 +3470,7 @@
           <p:cNvPr id="51" name="chart-smoke-frame">
             <a:extLst xmlns:a="http://schemas.openxmlformats.org/drawingml/2006/main">
               <a:ext uri="{FF2B5EF4-FFF2-40B4-BE49-F238E27FC236}">
-                <a16:creationId xmlns:a16="http://schemas.microsoft.com/office/drawing/2014/main" id="{04F31219-59B5-4AF2-880C-D1D9BC65765B}"/>
+                <a16:creationId xmlns:a16="http://schemas.microsoft.com/office/drawing/2014/main" id="{B60A42E8-CBA2-4D30-BE69-B23BAFD7F36A}"/>
               </a:ext>
             </a:extLst>
           </p:cNvPr>
@@ -3507,7 +3507,7 @@
           <p:nvPr/>
         </p:nvPicPr>
         <p:blipFill>
-          <a:blip xmlns:r="http://schemas.openxmlformats.org/officeDocument/2006/relationships" xmlns:a="http://schemas.openxmlformats.org/drawingml/2006/main" r:embed="Rccdfb0793fec4d4f"/>
+          <a:blip xmlns:r="http://schemas.openxmlformats.org/officeDocument/2006/relationships" xmlns:a="http://schemas.openxmlformats.org/drawingml/2006/main" r:embed="Rcd3d24d3e86a4a04"/>
           <a:stretch xmlns:a="http://schemas.openxmlformats.org/drawingml/2006/main"/>
         </p:blipFill>
         <p:spPr>
@@ -3525,7 +3525,7 @@
           <p:cNvPr id="53" name="6-Beta CI and chart reading-box">
             <a:extLst xmlns:a="http://schemas.openxmlformats.org/drawingml/2006/main">
               <a:ext uri="{FF2B5EF4-FFF2-40B4-BE49-F238E27FC236}">
-                <a16:creationId xmlns:a16="http://schemas.microsoft.com/office/drawing/2014/main" id="{8867B644-F1DE-4B03-A5EA-4D3B90D0B235}"/>
+                <a16:creationId xmlns:a16="http://schemas.microsoft.com/office/drawing/2014/main" id="{7C61FB6F-AD39-4DC5-9E8C-C717471573BE}"/>
               </a:ext>
             </a:extLst>
           </p:cNvPr>
@@ -3558,7 +3558,7 @@
           <p:cNvPr id="54" name="6-Beta CI and chart reading-head">
             <a:extLst xmlns:a="http://schemas.openxmlformats.org/drawingml/2006/main">
               <a:ext uri="{FF2B5EF4-FFF2-40B4-BE49-F238E27FC236}">
-                <a16:creationId xmlns:a16="http://schemas.microsoft.com/office/drawing/2014/main" id="{5E04AA62-661E-459D-AD11-7BD9346B8BE6}"/>
+                <a16:creationId xmlns:a16="http://schemas.microsoft.com/office/drawing/2014/main" id="{2DAACF49-C35B-48D2-B296-199F2D82A473}"/>
               </a:ext>
             </a:extLst>
           </p:cNvPr>
@@ -3591,7 +3591,7 @@
           <p:cNvPr id="55" name="6-Beta CI and chart reading-title">
             <a:extLst xmlns:a="http://schemas.openxmlformats.org/drawingml/2006/main">
               <a:ext uri="{FF2B5EF4-FFF2-40B4-BE49-F238E27FC236}">
-                <a16:creationId xmlns:a16="http://schemas.microsoft.com/office/drawing/2014/main" id="{7C813ABF-98AA-4FBB-B0A8-88F9402B1CFC}"/>
+                <a16:creationId xmlns:a16="http://schemas.microsoft.com/office/drawing/2014/main" id="{33ACE7BD-D554-4E13-8DC9-63F57108A6D0}"/>
               </a:ext>
             </a:extLst>
           </p:cNvPr>
@@ -3641,7 +3641,7 @@
           <p:cNvPr id="56" name="6-Beta CI and chart reading-body">
             <a:extLst xmlns:a="http://schemas.openxmlformats.org/drawingml/2006/main">
               <a:ext uri="{FF2B5EF4-FFF2-40B4-BE49-F238E27FC236}">
-                <a16:creationId xmlns:a16="http://schemas.microsoft.com/office/drawing/2014/main" id="{6597AECA-D9CF-45D5-85FD-6695CEF2D68F}"/>
+                <a16:creationId xmlns:a16="http://schemas.microsoft.com/office/drawing/2014/main" id="{236A7B6E-33D6-40D4-8D65-033EFB993010}"/>
               </a:ext>
             </a:extLst>
           </p:cNvPr>
@@ -3725,7 +3725,7 @@
           <p:cNvPr id="57" name="7-Discussion and implications-box">
             <a:extLst xmlns:a="http://schemas.openxmlformats.org/drawingml/2006/main">
               <a:ext uri="{FF2B5EF4-FFF2-40B4-BE49-F238E27FC236}">
-                <a16:creationId xmlns:a16="http://schemas.microsoft.com/office/drawing/2014/main" id="{F2A2F906-BF08-41F7-93DE-31B5E8C3E226}"/>
+                <a16:creationId xmlns:a16="http://schemas.microsoft.com/office/drawing/2014/main" id="{1BB92D7E-B50F-49C5-9D0B-D1CE5C164E95}"/>
               </a:ext>
             </a:extLst>
           </p:cNvPr>
@@ -3758,7 +3758,7 @@
           <p:cNvPr id="58" name="7-Discussion and implications-head">
             <a:extLst xmlns:a="http://schemas.openxmlformats.org/drawingml/2006/main">
               <a:ext uri="{FF2B5EF4-FFF2-40B4-BE49-F238E27FC236}">
-                <a16:creationId xmlns:a16="http://schemas.microsoft.com/office/drawing/2014/main" id="{910DBD68-ABDD-446D-B5D3-D69DE2CF6D55}"/>
+                <a16:creationId xmlns:a16="http://schemas.microsoft.com/office/drawing/2014/main" id="{7BBD83F2-0D3C-4DCC-AE0C-B824F68D17FF}"/>
               </a:ext>
             </a:extLst>
           </p:cNvPr>
@@ -3791,7 +3791,7 @@
           <p:cNvPr id="59" name="7-Discussion and implications-title">
             <a:extLst xmlns:a="http://schemas.openxmlformats.org/drawingml/2006/main">
               <a:ext uri="{FF2B5EF4-FFF2-40B4-BE49-F238E27FC236}">
-                <a16:creationId xmlns:a16="http://schemas.microsoft.com/office/drawing/2014/main" id="{C1B3D27B-8E3D-4236-8E5A-F6396A22B6EA}"/>
+                <a16:creationId xmlns:a16="http://schemas.microsoft.com/office/drawing/2014/main" id="{25DE4049-5F85-4E2C-BB23-ADCB316EE4BB}"/>
               </a:ext>
             </a:extLst>
           </p:cNvPr>
@@ -3841,7 +3841,7 @@
           <p:cNvPr id="60" name="7-Discussion and implications-body">
             <a:extLst xmlns:a="http://schemas.openxmlformats.org/drawingml/2006/main">
               <a:ext uri="{FF2B5EF4-FFF2-40B4-BE49-F238E27FC236}">
-                <a16:creationId xmlns:a16="http://schemas.microsoft.com/office/drawing/2014/main" id="{558FFE49-954C-4D78-9E9D-57DAA095FCED}"/>
+                <a16:creationId xmlns:a16="http://schemas.microsoft.com/office/drawing/2014/main" id="{EB803D2D-1E5D-4FDA-A71C-5E4BB7D5E743}"/>
               </a:ext>
             </a:extLst>
           </p:cNvPr>
@@ -3881,6 +3881,23 @@
                   <a:srgbClr val="102536"/>
                 </a:solidFill>
               </a:rPr>
+              <a:t>• The pattern diagnosis↑, attacks≈ and medication use↓ suggests broader asthma recognition without proportional improvement in control.</a:t>
+            </a:r>
+          </a:p>
+          <a:p xmlns:a="http://schemas.openxmlformats.org/drawingml/2006/main">
+            <a:pPr algn="l">
+              <a:defRPr sz="578" b="0">
+                <a:solidFill>
+                  <a:srgbClr val="102536"/>
+                </a:solidFill>
+              </a:defRPr>
+            </a:pPr>
+            <a:r>
+              <a:rPr sz="578" b="0">
+                <a:solidFill>
+                  <a:srgbClr val="102536"/>
+                </a:solidFill>
+              </a:rPr>
               <a:t>• The diagnosis increase may reflect higher occurrence, better diagnostic access or both.</a:t>
             </a:r>
           </a:p>
@@ -3898,23 +3915,6 @@
                   <a:srgbClr val="102536"/>
                 </a:solidFill>
               </a:rPr>
-              <a:t>• Stable attacks suggest clinical management did not improve proportionally.</a:t>
-            </a:r>
-          </a:p>
-          <a:p xmlns:a="http://schemas.openxmlformats.org/drawingml/2006/main">
-            <a:pPr algn="l">
-              <a:defRPr sz="578" b="0">
-                <a:solidFill>
-                  <a:srgbClr val="102536"/>
-                </a:solidFill>
-              </a:defRPr>
-            </a:pPr>
-            <a:r>
-              <a:rPr sz="578" b="0">
-                <a:solidFill>
-                  <a:srgbClr val="102536"/>
-                </a:solidFill>
-              </a:rPr>
               <a:t>• Asthma control depends on medication access, clinical follow-up, education, exposure control and non-pharmacological interventions.</a:t>
             </a:r>
           </a:p>
@@ -3925,7 +3925,7 @@
           <p:cNvPr id="61" name="8-ETL, OMOP and OHDSI-box">
             <a:extLst xmlns:a="http://schemas.openxmlformats.org/drawingml/2006/main">
               <a:ext uri="{FF2B5EF4-FFF2-40B4-BE49-F238E27FC236}">
-                <a16:creationId xmlns:a16="http://schemas.microsoft.com/office/drawing/2014/main" id="{E6DB3855-ACAF-4315-A7BB-887F993A5608}"/>
+                <a16:creationId xmlns:a16="http://schemas.microsoft.com/office/drawing/2014/main" id="{016887D4-D89B-47B9-BC55-B2B837BD1335}"/>
               </a:ext>
             </a:extLst>
           </p:cNvPr>
@@ -3958,7 +3958,7 @@
           <p:cNvPr id="62" name="8-ETL, OMOP and OHDSI-head">
             <a:extLst xmlns:a="http://schemas.openxmlformats.org/drawingml/2006/main">
               <a:ext uri="{FF2B5EF4-FFF2-40B4-BE49-F238E27FC236}">
-                <a16:creationId xmlns:a16="http://schemas.microsoft.com/office/drawing/2014/main" id="{27555DE4-BFC9-4539-AB05-E1106DF74282}"/>
+                <a16:creationId xmlns:a16="http://schemas.microsoft.com/office/drawing/2014/main" id="{C26FDF28-C157-46CC-BDA2-715042A06299}"/>
               </a:ext>
             </a:extLst>
           </p:cNvPr>
@@ -3991,7 +3991,7 @@
           <p:cNvPr id="63" name="8-ETL, OMOP and OHDSI-title">
             <a:extLst xmlns:a="http://schemas.openxmlformats.org/drawingml/2006/main">
               <a:ext uri="{FF2B5EF4-FFF2-40B4-BE49-F238E27FC236}">
-                <a16:creationId xmlns:a16="http://schemas.microsoft.com/office/drawing/2014/main" id="{FF69A9A8-6CED-49FA-A52A-7997B6E29B7E}"/>
+                <a16:creationId xmlns:a16="http://schemas.microsoft.com/office/drawing/2014/main" id="{32DE33A8-9C10-401D-AFB1-3033FC4D0992}"/>
               </a:ext>
             </a:extLst>
           </p:cNvPr>
@@ -4041,7 +4041,7 @@
           <p:cNvPr id="64" name="8-ETL, OMOP and OHDSI-body">
             <a:extLst xmlns:a="http://schemas.openxmlformats.org/drawingml/2006/main">
               <a:ext uri="{FF2B5EF4-FFF2-40B4-BE49-F238E27FC236}">
-                <a16:creationId xmlns:a16="http://schemas.microsoft.com/office/drawing/2014/main" id="{A3B187D7-B498-4AB0-8352-A2A4185D0345}"/>
+                <a16:creationId xmlns:a16="http://schemas.microsoft.com/office/drawing/2014/main" id="{1516A939-4B9C-47CF-B878-4DCAC14179B7}"/>
               </a:ext>
             </a:extLst>
           </p:cNvPr>
@@ -4125,7 +4125,7 @@
           <p:cNvPr id="65" name="9-Conclusions-box">
             <a:extLst xmlns:a="http://schemas.openxmlformats.org/drawingml/2006/main">
               <a:ext uri="{FF2B5EF4-FFF2-40B4-BE49-F238E27FC236}">
-                <a16:creationId xmlns:a16="http://schemas.microsoft.com/office/drawing/2014/main" id="{D831C47F-236B-4A9A-A5E1-746BB9F1E201}"/>
+                <a16:creationId xmlns:a16="http://schemas.microsoft.com/office/drawing/2014/main" id="{B27D149B-3790-41F4-A796-3EC966A034C6}"/>
               </a:ext>
             </a:extLst>
           </p:cNvPr>
@@ -4158,7 +4158,7 @@
           <p:cNvPr id="66" name="9-Conclusions-head">
             <a:extLst xmlns:a="http://schemas.openxmlformats.org/drawingml/2006/main">
               <a:ext uri="{FF2B5EF4-FFF2-40B4-BE49-F238E27FC236}">
-                <a16:creationId xmlns:a16="http://schemas.microsoft.com/office/drawing/2014/main" id="{4D107024-DB95-4770-8677-361C5F6B5DEE}"/>
+                <a16:creationId xmlns:a16="http://schemas.microsoft.com/office/drawing/2014/main" id="{0BE59DDA-E150-498A-96EA-50B166D14E10}"/>
               </a:ext>
             </a:extLst>
           </p:cNvPr>
@@ -4191,7 +4191,7 @@
           <p:cNvPr id="67" name="9-Conclusions-title">
             <a:extLst xmlns:a="http://schemas.openxmlformats.org/drawingml/2006/main">
               <a:ext uri="{FF2B5EF4-FFF2-40B4-BE49-F238E27FC236}">
-                <a16:creationId xmlns:a16="http://schemas.microsoft.com/office/drawing/2014/main" id="{2CC9A875-5380-48D0-A371-3B2DDBB96931}"/>
+                <a16:creationId xmlns:a16="http://schemas.microsoft.com/office/drawing/2014/main" id="{470A79A6-2303-4814-A813-87F431EE2966}"/>
               </a:ext>
             </a:extLst>
           </p:cNvPr>
@@ -4241,7 +4241,7 @@
           <p:cNvPr id="68" name="9-Conclusions-body">
             <a:extLst xmlns:a="http://schemas.openxmlformats.org/drawingml/2006/main">
               <a:ext uri="{FF2B5EF4-FFF2-40B4-BE49-F238E27FC236}">
-                <a16:creationId xmlns:a16="http://schemas.microsoft.com/office/drawing/2014/main" id="{7FD30094-AA70-41A8-B9DE-C4E1E91FF89C}"/>
+                <a16:creationId xmlns:a16="http://schemas.microsoft.com/office/drawing/2014/main" id="{CD2FB299-1A50-4353-B23D-968B0EFD9052}"/>
               </a:ext>
             </a:extLst>
           </p:cNvPr>
@@ -4325,7 +4325,7 @@
           <p:cNvPr id="69" name="references-box">
             <a:extLst xmlns:a="http://schemas.openxmlformats.org/drawingml/2006/main">
               <a:ext uri="{FF2B5EF4-FFF2-40B4-BE49-F238E27FC236}">
-                <a16:creationId xmlns:a16="http://schemas.microsoft.com/office/drawing/2014/main" id="{D2CAA9F6-B227-4CFE-9B31-8F7D8F9C0D9B}"/>
+                <a16:creationId xmlns:a16="http://schemas.microsoft.com/office/drawing/2014/main" id="{0717DBC0-D021-4192-945A-33BB1B02A439}"/>
               </a:ext>
             </a:extLst>
           </p:cNvPr>
@@ -4358,7 +4358,7 @@
           <p:cNvPr id="70" name="references-title">
             <a:extLst xmlns:a="http://schemas.openxmlformats.org/drawingml/2006/main">
               <a:ext uri="{FF2B5EF4-FFF2-40B4-BE49-F238E27FC236}">
-                <a16:creationId xmlns:a16="http://schemas.microsoft.com/office/drawing/2014/main" id="{F4FCCC3F-C4AC-44D5-A7AC-848D83E6B055}"/>
+                <a16:creationId xmlns:a16="http://schemas.microsoft.com/office/drawing/2014/main" id="{14F4505C-0549-4F59-9303-5CA32A4229F2}"/>
               </a:ext>
             </a:extLst>
           </p:cNvPr>
@@ -4408,7 +4408,7 @@
           <p:cNvPr id="71" name="references-body">
             <a:extLst xmlns:a="http://schemas.openxmlformats.org/drawingml/2006/main">
               <a:ext uri="{FF2B5EF4-FFF2-40B4-BE49-F238E27FC236}">
-                <a16:creationId xmlns:a16="http://schemas.microsoft.com/office/drawing/2014/main" id="{43E2EEC6-C583-49CE-90BD-C20615EE6EB9}"/>
+                <a16:creationId xmlns:a16="http://schemas.microsoft.com/office/drawing/2014/main" id="{B90361D6-CE57-4CE2-8C57-BEF92B497AC4}"/>
               </a:ext>
             </a:extLst>
           </p:cNvPr>
@@ -4662,7 +4662,7 @@
           <p:cNvPr id="72" name="qr-box">
             <a:extLst xmlns:a="http://schemas.openxmlformats.org/drawingml/2006/main">
               <a:ext uri="{FF2B5EF4-FFF2-40B4-BE49-F238E27FC236}">
-                <a16:creationId xmlns:a16="http://schemas.microsoft.com/office/drawing/2014/main" id="{F1008704-6C31-4D8D-B683-E815FB4ADD9F}"/>
+                <a16:creationId xmlns:a16="http://schemas.microsoft.com/office/drawing/2014/main" id="{026A1FE6-13D9-43F7-9F5C-9DBE46B0A3E5}"/>
               </a:ext>
             </a:extLst>
           </p:cNvPr>
@@ -4699,7 +4699,7 @@
           <p:nvPr/>
         </p:nvPicPr>
         <p:blipFill>
-          <a:blip xmlns:r="http://schemas.openxmlformats.org/officeDocument/2006/relationships" xmlns:a="http://schemas.openxmlformats.org/drawingml/2006/main" r:embed="Radf0f6386cd54fd6"/>
+          <a:blip xmlns:r="http://schemas.openxmlformats.org/officeDocument/2006/relationships" xmlns:a="http://schemas.openxmlformats.org/drawingml/2006/main" r:embed="R8822f1ebdfa54f3d"/>
           <a:stretch xmlns:a="http://schemas.openxmlformats.org/drawingml/2006/main"/>
         </p:blipFill>
         <p:spPr>
@@ -4717,7 +4717,7 @@
           <p:cNvPr id="74" name="qr-label">
             <a:extLst xmlns:a="http://schemas.openxmlformats.org/drawingml/2006/main">
               <a:ext uri="{FF2B5EF4-FFF2-40B4-BE49-F238E27FC236}">
-                <a16:creationId xmlns:a16="http://schemas.microsoft.com/office/drawing/2014/main" id="{A9716E5B-13CB-475F-A999-66887DA7C357}"/>
+                <a16:creationId xmlns:a16="http://schemas.microsoft.com/office/drawing/2014/main" id="{7C7F8AE6-BF7F-42EE-B801-58B3CB2B4DCA}"/>
               </a:ext>
             </a:extLst>
           </p:cNvPr>
@@ -4782,7 +4782,7 @@
     </p:spTree>
     <p:extLst>
       <p:ext uri="{BB962C8B-B14F-4D97-AF65-F5344CB8AC3E}">
-        <p14:creationId xmlns:p14="http://schemas.microsoft.com/office/powerpoint/2010/main" val="323538422"/>
+        <p14:creationId xmlns:p14="http://schemas.microsoft.com/office/powerpoint/2010/main" val="31060767"/>
       </p:ext>
     </p:extLst>
   </p:cSld>

</xml_diff>

<commit_message>
Emphasize workforce impact in asthma posters
</commit_message>
<xml_diff>
--- a/outputs/posters/poster_pns_asma_classico_en.pptx
+++ b/outputs/posters/poster_pns_asma_classico_en.pptx
@@ -2,13 +2,13 @@
 <file path=ppt/presentation.xml><?xml version="1.0" encoding="utf-8"?>
 <p:presentation xmlns:p="http://schemas.openxmlformats.org/presentationml/2006/main">
   <p:sldMasterIdLst>
-    <p:sldMasterId xmlns:r="http://schemas.openxmlformats.org/officeDocument/2006/relationships" id="2147483648" r:id="Rc4354873120c4607"/>
+    <p:sldMasterId xmlns:r="http://schemas.openxmlformats.org/officeDocument/2006/relationships" id="2147483648" r:id="R4cc5b38da25f4654"/>
   </p:sldMasterIdLst>
   <p:notesMasterIdLst>
-    <p:notesMasterId xmlns:r="http://schemas.openxmlformats.org/officeDocument/2006/relationships" r:id="R2f7547e61d9a428e"/>
+    <p:notesMasterId xmlns:r="http://schemas.openxmlformats.org/officeDocument/2006/relationships" r:id="Rc7dbf3f9235b4e1e"/>
   </p:notesMasterIdLst>
   <p:sldIdLst>
-    <p:sldId xmlns:r="http://schemas.openxmlformats.org/officeDocument/2006/relationships" id="256" r:id="Ra8232c91f1374f21"/>
+    <p:sldId xmlns:r="http://schemas.openxmlformats.org/officeDocument/2006/relationships" id="256" r:id="Rb5670a333fed4934"/>
   </p:sldIdLst>
   <p:sldSz cx="9525000" cy="13468350"/>
   <p:notesSz cx="6858000" cy="9144000"/>
@@ -601,7 +601,7 @@
   </p:cSld>
   <p:clrMap bg1="lt1" tx1="dk1" bg2="lt2" tx2="dk2" accent1="accent1" accent2="accent2" accent3="accent3" accent4="accent4" accent5="accent5" accent6="accent6" hlink="hlink" folHlink="folHlink"/>
   <p:sldLayoutIdLst>
-    <p:sldLayoutId xmlns:r="http://schemas.openxmlformats.org/officeDocument/2006/relationships" id="2147483649" r:id="R3b9e7ab91d504009"/>
+    <p:sldLayoutId xmlns:r="http://schemas.openxmlformats.org/officeDocument/2006/relationships" id="2147483649" r:id="R1950a7fd80b5444f"/>
   </p:sldLayoutIdLst>
   <p:txStyles>
     <p:titleStyle>
@@ -1156,7 +1156,7 @@
           <p:nvPr/>
         </p:nvPicPr>
         <p:blipFill>
-          <a:blip xmlns:r="http://schemas.openxmlformats.org/officeDocument/2006/relationships" xmlns:a="http://schemas.openxmlformats.org/drawingml/2006/main" r:embed="R8ff9619181fd4121"/>
+          <a:blip xmlns:r="http://schemas.openxmlformats.org/officeDocument/2006/relationships" xmlns:a="http://schemas.openxmlformats.org/drawingml/2006/main" r:embed="Re603665e29c1484f"/>
           <a:srcRect xmlns:a="http://schemas.openxmlformats.org/drawingml/2006/main" l="0" t="38622" r="0" b="38622"/>
           <a:stretch xmlns:a="http://schemas.openxmlformats.org/drawingml/2006/main">
             <a:fillRect l="0" t="0" r="0" b="0"/>
@@ -1181,7 +1181,7 @@
           <p:nvPr/>
         </p:nvPicPr>
         <p:blipFill>
-          <a:blip xmlns:r="http://schemas.openxmlformats.org/officeDocument/2006/relationships" xmlns:a="http://schemas.openxmlformats.org/drawingml/2006/main" r:embed="R4fe31b8eb68c4419"/>
+          <a:blip xmlns:r="http://schemas.openxmlformats.org/officeDocument/2006/relationships" xmlns:a="http://schemas.openxmlformats.org/drawingml/2006/main" r:embed="R770c1e93c8224360"/>
           <a:stretch xmlns:a="http://schemas.openxmlformats.org/drawingml/2006/main"/>
         </p:blipFill>
         <p:spPr>
@@ -1203,7 +1203,7 @@
           <p:nvPr/>
         </p:nvPicPr>
         <p:blipFill>
-          <a:blip xmlns:r="http://schemas.openxmlformats.org/officeDocument/2006/relationships" xmlns:a="http://schemas.openxmlformats.org/drawingml/2006/main" r:embed="Rcd32d62a571942d5"/>
+          <a:blip xmlns:r="http://schemas.openxmlformats.org/officeDocument/2006/relationships" xmlns:a="http://schemas.openxmlformats.org/drawingml/2006/main" r:embed="Rae1be7aad46d4090"/>
           <a:stretch xmlns:a="http://schemas.openxmlformats.org/drawingml/2006/main"/>
         </p:blipFill>
         <p:spPr>
@@ -1221,7 +1221,7 @@
           <p:cNvPr id="4" name="classic-title">
             <a:extLst xmlns:a="http://schemas.openxmlformats.org/drawingml/2006/main">
               <a:ext uri="{FF2B5EF4-FFF2-40B4-BE49-F238E27FC236}">
-                <a16:creationId xmlns:a16="http://schemas.microsoft.com/office/drawing/2014/main" id="{A5E2AA4E-4A5B-46AF-A5A1-2BF980F977B1}"/>
+                <a16:creationId xmlns:a16="http://schemas.microsoft.com/office/drawing/2014/main" id="{7C9BF154-223F-4F74-9853-0C8C58FCF3DC}"/>
               </a:ext>
             </a:extLst>
           </p:cNvPr>
@@ -1271,7 +1271,7 @@
           <p:cNvPr id="5" name="classic-authors">
             <a:extLst xmlns:a="http://schemas.openxmlformats.org/drawingml/2006/main">
               <a:ext uri="{FF2B5EF4-FFF2-40B4-BE49-F238E27FC236}">
-                <a16:creationId xmlns:a16="http://schemas.microsoft.com/office/drawing/2014/main" id="{E8E69C95-1BE9-46B3-B01C-4321D29E2D14}"/>
+                <a16:creationId xmlns:a16="http://schemas.microsoft.com/office/drawing/2014/main" id="{4C5442EE-3D93-482A-804C-89E45E5ADA0B}"/>
               </a:ext>
             </a:extLst>
           </p:cNvPr>
@@ -1321,7 +1321,7 @@
           <p:cNvPr id="6" name="1-Introduction-box">
             <a:extLst xmlns:a="http://schemas.openxmlformats.org/drawingml/2006/main">
               <a:ext uri="{FF2B5EF4-FFF2-40B4-BE49-F238E27FC236}">
-                <a16:creationId xmlns:a16="http://schemas.microsoft.com/office/drawing/2014/main" id="{C7F526C1-A233-49C9-A10E-416C3DCB228F}"/>
+                <a16:creationId xmlns:a16="http://schemas.microsoft.com/office/drawing/2014/main" id="{C15F6560-3C78-4B21-88D9-8E4BFA2CF4F6}"/>
               </a:ext>
             </a:extLst>
           </p:cNvPr>
@@ -1354,7 +1354,7 @@
           <p:cNvPr id="7" name="1-Introduction-head">
             <a:extLst xmlns:a="http://schemas.openxmlformats.org/drawingml/2006/main">
               <a:ext uri="{FF2B5EF4-FFF2-40B4-BE49-F238E27FC236}">
-                <a16:creationId xmlns:a16="http://schemas.microsoft.com/office/drawing/2014/main" id="{A616FC0A-2D7C-47D3-B431-C206CB4EA3D0}"/>
+                <a16:creationId xmlns:a16="http://schemas.microsoft.com/office/drawing/2014/main" id="{0368E232-72CE-496C-AD46-4B9E57547854}"/>
               </a:ext>
             </a:extLst>
           </p:cNvPr>
@@ -1387,7 +1387,7 @@
           <p:cNvPr id="8" name="1-Introduction-title">
             <a:extLst xmlns:a="http://schemas.openxmlformats.org/drawingml/2006/main">
               <a:ext uri="{FF2B5EF4-FFF2-40B4-BE49-F238E27FC236}">
-                <a16:creationId xmlns:a16="http://schemas.microsoft.com/office/drawing/2014/main" id="{BE8B4996-8206-4730-912D-AA0C24FA94BE}"/>
+                <a16:creationId xmlns:a16="http://schemas.microsoft.com/office/drawing/2014/main" id="{4B830F6B-89D9-4AC7-9394-BF6D0C6B7561}"/>
               </a:ext>
             </a:extLst>
           </p:cNvPr>
@@ -1437,7 +1437,7 @@
           <p:cNvPr id="9" name="1-Introduction-body">
             <a:extLst xmlns:a="http://schemas.openxmlformats.org/drawingml/2006/main">
               <a:ext uri="{FF2B5EF4-FFF2-40B4-BE49-F238E27FC236}">
-                <a16:creationId xmlns:a16="http://schemas.microsoft.com/office/drawing/2014/main" id="{0754B327-BF77-4A7C-90F9-606786E7126A}"/>
+                <a16:creationId xmlns:a16="http://schemas.microsoft.com/office/drawing/2014/main" id="{7FA8AE28-8018-4367-84B7-0F4A6CB34CEB}"/>
               </a:ext>
             </a:extLst>
           </p:cNvPr>
@@ -1494,7 +1494,7 @@
                   <a:srgbClr val="102536"/>
                 </a:solidFill>
               </a:rPr>
-              <a:t>• In asthma, prevalence, attacks, medication use and smoking help separate disease burden, diagnostic access, clinical management and risk factors.</a:t>
+              <a:t>• In asthma, prevalence, medication use, absenteeism and lost days help separate clinical burden, management and effects on work.</a:t>
             </a:r>
           </a:p>
           <a:p xmlns:a="http://schemas.openxmlformats.org/drawingml/2006/main">
@@ -1521,7 +1521,7 @@
           <p:cNvPr id="10" name="2-Objectives-box">
             <a:extLst xmlns:a="http://schemas.openxmlformats.org/drawingml/2006/main">
               <a:ext uri="{FF2B5EF4-FFF2-40B4-BE49-F238E27FC236}">
-                <a16:creationId xmlns:a16="http://schemas.microsoft.com/office/drawing/2014/main" id="{00B51BDD-36CB-4E15-9042-07C712372420}"/>
+                <a16:creationId xmlns:a16="http://schemas.microsoft.com/office/drawing/2014/main" id="{E2601E58-6FEE-40E4-B3E0-87519BA1599E}"/>
               </a:ext>
             </a:extLst>
           </p:cNvPr>
@@ -1554,7 +1554,7 @@
           <p:cNvPr id="11" name="2-Objectives-head">
             <a:extLst xmlns:a="http://schemas.openxmlformats.org/drawingml/2006/main">
               <a:ext uri="{FF2B5EF4-FFF2-40B4-BE49-F238E27FC236}">
-                <a16:creationId xmlns:a16="http://schemas.microsoft.com/office/drawing/2014/main" id="{C0DAB95D-5F0B-4D5B-8D27-B5DDD22AC746}"/>
+                <a16:creationId xmlns:a16="http://schemas.microsoft.com/office/drawing/2014/main" id="{21400EFA-1C70-4371-94AF-2CEE5448CDC9}"/>
               </a:ext>
             </a:extLst>
           </p:cNvPr>
@@ -1587,7 +1587,7 @@
           <p:cNvPr id="12" name="2-Objectives-title">
             <a:extLst xmlns:a="http://schemas.openxmlformats.org/drawingml/2006/main">
               <a:ext uri="{FF2B5EF4-FFF2-40B4-BE49-F238E27FC236}">
-                <a16:creationId xmlns:a16="http://schemas.microsoft.com/office/drawing/2014/main" id="{AA34715A-E7A4-42A5-BF49-1BD3B6D1B5C1}"/>
+                <a16:creationId xmlns:a16="http://schemas.microsoft.com/office/drawing/2014/main" id="{11A115CE-E140-4EE9-99FD-3FB882DC4FA3}"/>
               </a:ext>
             </a:extLst>
           </p:cNvPr>
@@ -1637,7 +1637,7 @@
           <p:cNvPr id="13" name="2-Objectives-body">
             <a:extLst xmlns:a="http://schemas.openxmlformats.org/drawingml/2006/main">
               <a:ext uri="{FF2B5EF4-FFF2-40B4-BE49-F238E27FC236}">
-                <a16:creationId xmlns:a16="http://schemas.microsoft.com/office/drawing/2014/main" id="{218C8EEC-2FC6-44C6-96A5-EDCB13B9C3B7}"/>
+                <a16:creationId xmlns:a16="http://schemas.microsoft.com/office/drawing/2014/main" id="{CC9BE6D7-2A4C-439B-AE5E-DC2452578740}"/>
               </a:ext>
             </a:extLst>
           </p:cNvPr>
@@ -1721,7 +1721,7 @@
           <p:cNvPr id="14" name="3-Data and indicators-box">
             <a:extLst xmlns:a="http://schemas.openxmlformats.org/drawingml/2006/main">
               <a:ext uri="{FF2B5EF4-FFF2-40B4-BE49-F238E27FC236}">
-                <a16:creationId xmlns:a16="http://schemas.microsoft.com/office/drawing/2014/main" id="{D1550EC8-393E-45B7-8F38-1638F6F36CC8}"/>
+                <a16:creationId xmlns:a16="http://schemas.microsoft.com/office/drawing/2014/main" id="{68E179F6-B616-4873-906D-DF10A5D37073}"/>
               </a:ext>
             </a:extLst>
           </p:cNvPr>
@@ -1754,7 +1754,7 @@
           <p:cNvPr id="15" name="3-Data and indicators-head">
             <a:extLst xmlns:a="http://schemas.openxmlformats.org/drawingml/2006/main">
               <a:ext uri="{FF2B5EF4-FFF2-40B4-BE49-F238E27FC236}">
-                <a16:creationId xmlns:a16="http://schemas.microsoft.com/office/drawing/2014/main" id="{13923DB1-5245-4D15-853C-67254A2DE431}"/>
+                <a16:creationId xmlns:a16="http://schemas.microsoft.com/office/drawing/2014/main" id="{ADB7A46C-D182-4C59-9918-0A5C155FB2D9}"/>
               </a:ext>
             </a:extLst>
           </p:cNvPr>
@@ -1787,7 +1787,7 @@
           <p:cNvPr id="16" name="3-Data and indicators-title">
             <a:extLst xmlns:a="http://schemas.openxmlformats.org/drawingml/2006/main">
               <a:ext uri="{FF2B5EF4-FFF2-40B4-BE49-F238E27FC236}">
-                <a16:creationId xmlns:a16="http://schemas.microsoft.com/office/drawing/2014/main" id="{B297F4FB-EC62-4307-9D4E-40EE875E7A0D}"/>
+                <a16:creationId xmlns:a16="http://schemas.microsoft.com/office/drawing/2014/main" id="{FB5B171E-744F-4E9C-9505-5485F8BADB22}"/>
               </a:ext>
             </a:extLst>
           </p:cNvPr>
@@ -1837,7 +1837,7 @@
           <p:cNvPr id="17" name="3-Data and indicators-body">
             <a:extLst xmlns:a="http://schemas.openxmlformats.org/drawingml/2006/main">
               <a:ext uri="{FF2B5EF4-FFF2-40B4-BE49-F238E27FC236}">
-                <a16:creationId xmlns:a16="http://schemas.microsoft.com/office/drawing/2014/main" id="{39165ABB-83BC-4CC7-BE5C-FBFB2E42F5CC}"/>
+                <a16:creationId xmlns:a16="http://schemas.microsoft.com/office/drawing/2014/main" id="{F8ED97BF-BC98-464F-8D79-17D7C18B26CA}"/>
               </a:ext>
             </a:extLst>
           </p:cNvPr>
@@ -1921,7 +1921,7 @@
           <p:cNvPr id="18" name="4-Sampling design-box">
             <a:extLst xmlns:a="http://schemas.openxmlformats.org/drawingml/2006/main">
               <a:ext uri="{FF2B5EF4-FFF2-40B4-BE49-F238E27FC236}">
-                <a16:creationId xmlns:a16="http://schemas.microsoft.com/office/drawing/2014/main" id="{EEB3DAE7-B6F4-48E1-8029-7BD76F514FF9}"/>
+                <a16:creationId xmlns:a16="http://schemas.microsoft.com/office/drawing/2014/main" id="{7FD8824A-61AE-4D53-ADEE-0076920EDED9}"/>
               </a:ext>
             </a:extLst>
           </p:cNvPr>
@@ -1954,7 +1954,7 @@
           <p:cNvPr id="19" name="4-Sampling design-head">
             <a:extLst xmlns:a="http://schemas.openxmlformats.org/drawingml/2006/main">
               <a:ext uri="{FF2B5EF4-FFF2-40B4-BE49-F238E27FC236}">
-                <a16:creationId xmlns:a16="http://schemas.microsoft.com/office/drawing/2014/main" id="{9B4192DE-E9F8-4613-8F31-BFF2E1F749FB}"/>
+                <a16:creationId xmlns:a16="http://schemas.microsoft.com/office/drawing/2014/main" id="{7A2B7F5C-0251-4D72-A8A3-406490DD2729}"/>
               </a:ext>
             </a:extLst>
           </p:cNvPr>
@@ -1987,7 +1987,7 @@
           <p:cNvPr id="20" name="4-Sampling design-title">
             <a:extLst xmlns:a="http://schemas.openxmlformats.org/drawingml/2006/main">
               <a:ext uri="{FF2B5EF4-FFF2-40B4-BE49-F238E27FC236}">
-                <a16:creationId xmlns:a16="http://schemas.microsoft.com/office/drawing/2014/main" id="{B9F57A8E-4A68-4DCC-B31B-CA0FE122A922}"/>
+                <a16:creationId xmlns:a16="http://schemas.microsoft.com/office/drawing/2014/main" id="{F71F7C3D-2D3B-4870-A39E-374C933429B4}"/>
               </a:ext>
             </a:extLst>
           </p:cNvPr>
@@ -2037,7 +2037,7 @@
           <p:cNvPr id="21" name="4-Sampling design-body">
             <a:extLst xmlns:a="http://schemas.openxmlformats.org/drawingml/2006/main">
               <a:ext uri="{FF2B5EF4-FFF2-40B4-BE49-F238E27FC236}">
-                <a16:creationId xmlns:a16="http://schemas.microsoft.com/office/drawing/2014/main" id="{3B1A2F2F-EE7D-4036-AA48-BADD72F7D1A8}"/>
+                <a16:creationId xmlns:a16="http://schemas.microsoft.com/office/drawing/2014/main" id="{DC5DB49B-7726-4B03-ABCB-A6A59E1A4D0A}"/>
               </a:ext>
             </a:extLst>
           </p:cNvPr>
@@ -2138,7 +2138,7 @@
           <p:cNvPr id="22" name="classic-formula-box">
             <a:extLst xmlns:a="http://schemas.openxmlformats.org/drawingml/2006/main">
               <a:ext uri="{FF2B5EF4-FFF2-40B4-BE49-F238E27FC236}">
-                <a16:creationId xmlns:a16="http://schemas.microsoft.com/office/drawing/2014/main" id="{794E9961-8EEE-40F5-9730-867E4825BB71}"/>
+                <a16:creationId xmlns:a16="http://schemas.microsoft.com/office/drawing/2014/main" id="{19CB154A-381B-4301-BB09-51AE72E0366F}"/>
               </a:ext>
             </a:extLst>
           </p:cNvPr>
@@ -2171,7 +2171,7 @@
           <p:cNvPr id="23" name="classic-formula-title">
             <a:extLst xmlns:a="http://schemas.openxmlformats.org/drawingml/2006/main">
               <a:ext uri="{FF2B5EF4-FFF2-40B4-BE49-F238E27FC236}">
-                <a16:creationId xmlns:a16="http://schemas.microsoft.com/office/drawing/2014/main" id="{B26EF3DA-0715-4B85-9158-A119435C4D88}"/>
+                <a16:creationId xmlns:a16="http://schemas.microsoft.com/office/drawing/2014/main" id="{F3B0562F-48F4-4637-92E4-CF87CBD51B24}"/>
               </a:ext>
             </a:extLst>
           </p:cNvPr>
@@ -2221,7 +2221,7 @@
           <p:cNvPr id="24" name="classic-formula">
             <a:extLst xmlns:a="http://schemas.openxmlformats.org/drawingml/2006/main">
               <a:ext uri="{FF2B5EF4-FFF2-40B4-BE49-F238E27FC236}">
-                <a16:creationId xmlns:a16="http://schemas.microsoft.com/office/drawing/2014/main" id="{9D35DE7E-CA57-44F1-926E-5FC5B103BA3D}"/>
+                <a16:creationId xmlns:a16="http://schemas.microsoft.com/office/drawing/2014/main" id="{F1BA0F45-B5AF-4CBF-93D6-2C461C507EDB}"/>
               </a:ext>
             </a:extLst>
           </p:cNvPr>
@@ -2339,7 +2339,7 @@
           <p:cNvPr id="25" name="prev-metric">
             <a:extLst xmlns:a="http://schemas.openxmlformats.org/drawingml/2006/main">
               <a:ext uri="{FF2B5EF4-FFF2-40B4-BE49-F238E27FC236}">
-                <a16:creationId xmlns:a16="http://schemas.microsoft.com/office/drawing/2014/main" id="{BEC00AD7-CA25-4CFA-8D88-973549EEFC10}"/>
+                <a16:creationId xmlns:a16="http://schemas.microsoft.com/office/drawing/2014/main" id="{B8F957F0-52AB-4D5A-B3D4-A6F1D48AEE3B}"/>
               </a:ext>
             </a:extLst>
           </p:cNvPr>
@@ -2372,7 +2372,7 @@
           <p:cNvPr id="26" name="prev-metric-title">
             <a:extLst xmlns:a="http://schemas.openxmlformats.org/drawingml/2006/main">
               <a:ext uri="{FF2B5EF4-FFF2-40B4-BE49-F238E27FC236}">
-                <a16:creationId xmlns:a16="http://schemas.microsoft.com/office/drawing/2014/main" id="{DAF306CA-A7F4-42C7-8692-A68F5D5DCA9D}"/>
+                <a16:creationId xmlns:a16="http://schemas.microsoft.com/office/drawing/2014/main" id="{03CF7E72-A6B5-4572-A4F5-4B24DC18F9DC}"/>
               </a:ext>
             </a:extLst>
           </p:cNvPr>
@@ -2422,7 +2422,7 @@
           <p:cNvPr id="27" name="prev-metric-value">
             <a:extLst xmlns:a="http://schemas.openxmlformats.org/drawingml/2006/main">
               <a:ext uri="{FF2B5EF4-FFF2-40B4-BE49-F238E27FC236}">
-                <a16:creationId xmlns:a16="http://schemas.microsoft.com/office/drawing/2014/main" id="{B0F22488-1B73-4A74-951D-197CBB501C1C}"/>
+                <a16:creationId xmlns:a16="http://schemas.microsoft.com/office/drawing/2014/main" id="{3C299F39-0660-40E1-A7A7-7CCB43922B7B}"/>
               </a:ext>
             </a:extLst>
           </p:cNvPr>
@@ -2472,7 +2472,7 @@
           <p:cNvPr id="28" name="prev-metric-note">
             <a:extLst xmlns:a="http://schemas.openxmlformats.org/drawingml/2006/main">
               <a:ext uri="{FF2B5EF4-FFF2-40B4-BE49-F238E27FC236}">
-                <a16:creationId xmlns:a16="http://schemas.microsoft.com/office/drawing/2014/main" id="{D7F129B0-7C65-4A65-A758-D17D60DAA4FA}"/>
+                <a16:creationId xmlns:a16="http://schemas.microsoft.com/office/drawing/2014/main" id="{CE508BD9-2BBB-41CF-9B0C-7A744CCE32D4}"/>
               </a:ext>
             </a:extLst>
           </p:cNvPr>
@@ -2522,7 +2522,7 @@
           <p:cNvPr id="29" name="crisis-metric">
             <a:extLst xmlns:a="http://schemas.openxmlformats.org/drawingml/2006/main">
               <a:ext uri="{FF2B5EF4-FFF2-40B4-BE49-F238E27FC236}">
-                <a16:creationId xmlns:a16="http://schemas.microsoft.com/office/drawing/2014/main" id="{01646118-2EB7-4FE2-B7EA-DB84D06CA3C6}"/>
+                <a16:creationId xmlns:a16="http://schemas.microsoft.com/office/drawing/2014/main" id="{454D1B46-AF73-431E-9CAA-AB21BB940CDF}"/>
               </a:ext>
             </a:extLst>
           </p:cNvPr>
@@ -2555,7 +2555,7 @@
           <p:cNvPr id="30" name="crisis-metric-title">
             <a:extLst xmlns:a="http://schemas.openxmlformats.org/drawingml/2006/main">
               <a:ext uri="{FF2B5EF4-FFF2-40B4-BE49-F238E27FC236}">
-                <a16:creationId xmlns:a16="http://schemas.microsoft.com/office/drawing/2014/main" id="{AB195CFA-8A47-4E48-BA28-916385FE6758}"/>
+                <a16:creationId xmlns:a16="http://schemas.microsoft.com/office/drawing/2014/main" id="{628B0A5D-9781-4409-807D-D28C4E800F42}"/>
               </a:ext>
             </a:extLst>
           </p:cNvPr>
@@ -2595,7 +2595,7 @@
                   <a:srgbClr val="153F59"/>
                 </a:solidFill>
               </a:rPr>
-              <a:t>Brazil: attacks</a:t>
+              <a:t>Brazil: work</a:t>
             </a:r>
           </a:p>
         </p:txBody>
@@ -2605,7 +2605,7 @@
           <p:cNvPr id="31" name="crisis-metric-value">
             <a:extLst xmlns:a="http://schemas.openxmlformats.org/drawingml/2006/main">
               <a:ext uri="{FF2B5EF4-FFF2-40B4-BE49-F238E27FC236}">
-                <a16:creationId xmlns:a16="http://schemas.microsoft.com/office/drawing/2014/main" id="{8C819B23-7598-4F7D-90D6-B37F7B12C972}"/>
+                <a16:creationId xmlns:a16="http://schemas.microsoft.com/office/drawing/2014/main" id="{8B93F2AB-6955-48E3-BA99-6E46BC4F5CA9}"/>
               </a:ext>
             </a:extLst>
           </p:cNvPr>
@@ -2645,7 +2645,7 @@
                   <a:srgbClr val="153F59"/>
                 </a:solidFill>
               </a:rPr>
-              <a:t>38.3%→37.7%</a:t>
+              <a:t>15.2%; 4.8 days</a:t>
             </a:r>
           </a:p>
         </p:txBody>
@@ -2655,7 +2655,7 @@
           <p:cNvPr id="32" name="crisis-metric-note">
             <a:extLst xmlns:a="http://schemas.openxmlformats.org/drawingml/2006/main">
               <a:ext uri="{FF2B5EF4-FFF2-40B4-BE49-F238E27FC236}">
-                <a16:creationId xmlns:a16="http://schemas.microsoft.com/office/drawing/2014/main" id="{DE710182-4982-4810-87DE-6A8765E782A1}"/>
+                <a16:creationId xmlns:a16="http://schemas.microsoft.com/office/drawing/2014/main" id="{B8A6F01E-D007-4285-BEDA-854499FE6530}"/>
               </a:ext>
             </a:extLst>
           </p:cNvPr>
@@ -2695,7 +2695,7 @@
                   <a:srgbClr val="102536"/>
                 </a:solidFill>
               </a:rPr>
-              <a:t>12-month attacks were stable; control did not improve proportionally.</a:t>
+              <a:t>Respiratory causes: absenteeism and average lost workdays.</a:t>
             </a:r>
           </a:p>
         </p:txBody>
@@ -2705,7 +2705,7 @@
           <p:cNvPr id="33" name="chart-prev-caption">
             <a:extLst xmlns:a="http://schemas.openxmlformats.org/drawingml/2006/main">
               <a:ext uri="{FF2B5EF4-FFF2-40B4-BE49-F238E27FC236}">
-                <a16:creationId xmlns:a16="http://schemas.microsoft.com/office/drawing/2014/main" id="{1CDB1A6B-6FF3-4E31-9755-D6898E4D1237}"/>
+                <a16:creationId xmlns:a16="http://schemas.microsoft.com/office/drawing/2014/main" id="{6C158926-CCB2-42B6-9379-32BB74A94580}"/>
               </a:ext>
             </a:extLst>
           </p:cNvPr>
@@ -2755,7 +2755,7 @@
           <p:cNvPr id="34" name="chart-prev-frame">
             <a:extLst xmlns:a="http://schemas.openxmlformats.org/drawingml/2006/main">
               <a:ext uri="{FF2B5EF4-FFF2-40B4-BE49-F238E27FC236}">
-                <a16:creationId xmlns:a16="http://schemas.microsoft.com/office/drawing/2014/main" id="{AFBAA7ED-F610-49A2-90C2-CA138048F300}"/>
+                <a16:creationId xmlns:a16="http://schemas.microsoft.com/office/drawing/2014/main" id="{3DBEDA56-214F-45A6-93B7-57987F81123B}"/>
               </a:ext>
             </a:extLst>
           </p:cNvPr>
@@ -2792,7 +2792,7 @@
           <p:nvPr/>
         </p:nvPicPr>
         <p:blipFill>
-          <a:blip xmlns:r="http://schemas.openxmlformats.org/officeDocument/2006/relationships" xmlns:a="http://schemas.openxmlformats.org/drawingml/2006/main" r:embed="R40000a130a694919"/>
+          <a:blip xmlns:r="http://schemas.openxmlformats.org/officeDocument/2006/relationships" xmlns:a="http://schemas.openxmlformats.org/drawingml/2006/main" r:embed="R083dd2e93b704850"/>
           <a:stretch xmlns:a="http://schemas.openxmlformats.org/drawingml/2006/main"/>
         </p:blipFill>
         <p:spPr>
@@ -2810,7 +2810,7 @@
           <p:cNvPr id="36" name="chart-crisis-caption">
             <a:extLst xmlns:a="http://schemas.openxmlformats.org/drawingml/2006/main">
               <a:ext uri="{FF2B5EF4-FFF2-40B4-BE49-F238E27FC236}">
-                <a16:creationId xmlns:a16="http://schemas.microsoft.com/office/drawing/2014/main" id="{E0BD6DE2-EB60-4E30-84F9-EF4A4E11B24E}"/>
+                <a16:creationId xmlns:a16="http://schemas.microsoft.com/office/drawing/2014/main" id="{8D2B7A6B-B913-4D6F-A2B2-15A639531EA7}"/>
               </a:ext>
             </a:extLst>
           </p:cNvPr>
@@ -2850,7 +2850,7 @@
                   <a:srgbClr val="153F59"/>
                 </a:solidFill>
               </a:rPr>
-              <a:t>Figure 2: Asthma attacks in the previous 12 months (%) by state and Brazil, PNS 2013 and 2019.</a:t>
+              <a:t>Figure 2: Health-related absenteeism in Brazil, highlighting respiratory causes, PNS 2019.</a:t>
             </a:r>
           </a:p>
         </p:txBody>
@@ -2860,7 +2860,7 @@
           <p:cNvPr id="37" name="chart-crisis-frame">
             <a:extLst xmlns:a="http://schemas.openxmlformats.org/drawingml/2006/main">
               <a:ext uri="{FF2B5EF4-FFF2-40B4-BE49-F238E27FC236}">
-                <a16:creationId xmlns:a16="http://schemas.microsoft.com/office/drawing/2014/main" id="{09D287B2-CF88-4ED0-B2AE-84395B20C1B5}"/>
+                <a16:creationId xmlns:a16="http://schemas.microsoft.com/office/drawing/2014/main" id="{8B0DB653-809F-4162-B25B-0AD399D44748}"/>
               </a:ext>
             </a:extLst>
           </p:cNvPr>
@@ -2897,7 +2897,7 @@
           <p:nvPr/>
         </p:nvPicPr>
         <p:blipFill>
-          <a:blip xmlns:r="http://schemas.openxmlformats.org/officeDocument/2006/relationships" xmlns:a="http://schemas.openxmlformats.org/drawingml/2006/main" r:embed="R4eb36c3b26934253"/>
+          <a:blip xmlns:r="http://schemas.openxmlformats.org/officeDocument/2006/relationships" xmlns:a="http://schemas.openxmlformats.org/drawingml/2006/main" r:embed="R15cf23d38ee340b9"/>
           <a:stretch xmlns:a="http://schemas.openxmlformats.org/drawingml/2006/main"/>
         </p:blipFill>
         <p:spPr>
@@ -2912,10 +2912,10 @@
       </p:pic>
       <p:sp>
         <p:nvSpPr>
-          <p:cNvPr id="39" name="5-Results and interpretation-box">
-            <a:extLst xmlns:a="http://schemas.openxmlformats.org/drawingml/2006/main">
-              <a:ext uri="{FF2B5EF4-FFF2-40B4-BE49-F238E27FC236}">
-                <a16:creationId xmlns:a16="http://schemas.microsoft.com/office/drawing/2014/main" id="{F6EC4668-5524-4A57-AA3C-82B511DFB032}"/>
+          <p:cNvPr id="39" name="5-Discussion-box">
+            <a:extLst xmlns:a="http://schemas.openxmlformats.org/drawingml/2006/main">
+              <a:ext uri="{FF2B5EF4-FFF2-40B4-BE49-F238E27FC236}">
+                <a16:creationId xmlns:a16="http://schemas.microsoft.com/office/drawing/2014/main" id="{198CE6CA-A414-4FD6-AA80-F6113EDC0035}"/>
               </a:ext>
             </a:extLst>
           </p:cNvPr>
@@ -2927,7 +2927,7 @@
         <p:spPr>
           <a:xfrm xmlns:a="http://schemas.openxmlformats.org/drawingml/2006/main">
             <a:off x="3327400" y="9372600"/>
-            <a:ext cx="2870200" cy="1962150"/>
+            <a:ext cx="2870200" cy="1066800"/>
           </a:xfrm>
           <a:prstGeom xmlns:a="http://schemas.openxmlformats.org/drawingml/2006/main" prst="rect">
             <a:avLst/>
@@ -2945,10 +2945,10 @@
       </p:sp>
       <p:sp>
         <p:nvSpPr>
-          <p:cNvPr id="40" name="5-Results and interpretation-head">
-            <a:extLst xmlns:a="http://schemas.openxmlformats.org/drawingml/2006/main">
-              <a:ext uri="{FF2B5EF4-FFF2-40B4-BE49-F238E27FC236}">
-                <a16:creationId xmlns:a16="http://schemas.microsoft.com/office/drawing/2014/main" id="{FF7F832D-1718-4075-8064-79EFBB042A11}"/>
+          <p:cNvPr id="40" name="5-Discussion-head">
+            <a:extLst xmlns:a="http://schemas.openxmlformats.org/drawingml/2006/main">
+              <a:ext uri="{FF2B5EF4-FFF2-40B4-BE49-F238E27FC236}">
+                <a16:creationId xmlns:a16="http://schemas.microsoft.com/office/drawing/2014/main" id="{72D348F3-07EE-4CA5-AA64-BE491E2DA8EC}"/>
               </a:ext>
             </a:extLst>
           </p:cNvPr>
@@ -2978,10 +2978,10 @@
       </p:sp>
       <p:sp>
         <p:nvSpPr>
-          <p:cNvPr id="41" name="5-Results and interpretation-title">
-            <a:extLst xmlns:a="http://schemas.openxmlformats.org/drawingml/2006/main">
-              <a:ext uri="{FF2B5EF4-FFF2-40B4-BE49-F238E27FC236}">
-                <a16:creationId xmlns:a16="http://schemas.microsoft.com/office/drawing/2014/main" id="{275D82DB-1554-4459-BA59-6AED1775C00F}"/>
+          <p:cNvPr id="41" name="5-Discussion-title">
+            <a:extLst xmlns:a="http://schemas.openxmlformats.org/drawingml/2006/main">
+              <a:ext uri="{FF2B5EF4-FFF2-40B4-BE49-F238E27FC236}">
+                <a16:creationId xmlns:a16="http://schemas.microsoft.com/office/drawing/2014/main" id="{BB93E8AF-623C-4D96-8058-1344416553BF}"/>
               </a:ext>
             </a:extLst>
           </p:cNvPr>
@@ -3021,17 +3021,17 @@
                   <a:srgbClr val="FFFFFF"/>
                 </a:solidFill>
               </a:rPr>
-              <a:t>5. Results and interpretation</a:t>
+              <a:t>5. Discussion</a:t>
             </a:r>
           </a:p>
         </p:txBody>
       </p:sp>
       <p:sp>
         <p:nvSpPr>
-          <p:cNvPr id="42" name="5-Results and interpretation-body">
-            <a:extLst xmlns:a="http://schemas.openxmlformats.org/drawingml/2006/main">
-              <a:ext uri="{FF2B5EF4-FFF2-40B4-BE49-F238E27FC236}">
-                <a16:creationId xmlns:a16="http://schemas.microsoft.com/office/drawing/2014/main" id="{23A0740A-3921-4068-A3C3-6A9AD8C7A184}"/>
+          <p:cNvPr id="42" name="5-Discussion-body">
+            <a:extLst xmlns:a="http://schemas.openxmlformats.org/drawingml/2006/main">
+              <a:ext uri="{FF2B5EF4-FFF2-40B4-BE49-F238E27FC236}">
+                <a16:creationId xmlns:a16="http://schemas.microsoft.com/office/drawing/2014/main" id="{FE5D33EF-0CF9-47FB-984E-9D5AEDB1B47F}"/>
               </a:ext>
             </a:extLst>
           </p:cNvPr>
@@ -3043,7 +3043,7 @@
         <p:spPr>
           <a:xfrm xmlns:a="http://schemas.openxmlformats.org/drawingml/2006/main">
             <a:off x="3422650" y="9715500"/>
-            <a:ext cx="2679700" cy="1562100"/>
+            <a:ext cx="2679700" cy="666750"/>
           </a:xfrm>
           <a:prstGeom xmlns:a="http://schemas.openxmlformats.org/drawingml/2006/main" prst="rect">
             <a:avLst/>
@@ -3059,70 +3059,53 @@
           <a:lstStyle xmlns:a="http://schemas.openxmlformats.org/drawingml/2006/main"/>
           <a:p xmlns:a="http://schemas.openxmlformats.org/drawingml/2006/main">
             <a:pPr algn="l">
-              <a:defRPr sz="555" b="0">
-                <a:solidFill>
-                  <a:srgbClr val="102536"/>
-                </a:solidFill>
-              </a:defRPr>
-            </a:pPr>
-            <a:r>
-              <a:rPr sz="555" b="0">
-                <a:solidFill>
-                  <a:srgbClr val="102536"/>
-                </a:solidFill>
-              </a:rPr>
-              <a:t>• Brazil: physician-diagnosed asthma increased from 4.41% in 2013 to 5.40% in 2019, with non-overlapping 95% CIs.</a:t>
-            </a:r>
-          </a:p>
-          <a:p xmlns:a="http://schemas.openxmlformats.org/drawingml/2006/main">
-            <a:pPr algn="l">
-              <a:defRPr sz="555" b="0">
-                <a:solidFill>
-                  <a:srgbClr val="102536"/>
-                </a:solidFill>
-              </a:defRPr>
-            </a:pPr>
-            <a:r>
-              <a:rPr sz="555" b="0">
-                <a:solidFill>
-                  <a:srgbClr val="102536"/>
-                </a:solidFill>
-              </a:rPr>
-              <a:t>• Brazil: attacks in the previous 12 months were stable, from 38.3% to 37.7%.</a:t>
-            </a:r>
-          </a:p>
-          <a:p xmlns:a="http://schemas.openxmlformats.org/drawingml/2006/main">
-            <a:pPr algn="l">
-              <a:defRPr sz="555" b="0">
-                <a:solidFill>
-                  <a:srgbClr val="102536"/>
-                </a:solidFill>
-              </a:defRPr>
-            </a:pPr>
-            <a:r>
-              <a:rPr sz="555" b="0">
-                <a:solidFill>
-                  <a:srgbClr val="102536"/>
-                </a:solidFill>
-              </a:rPr>
-              <a:t>• Brazil: oral/inhaler medication use among people with asthma changed from 81.5% to 64.4%; interpretation should consider 95% CIs, the diagnosed group and the population rate.</a:t>
-            </a:r>
-          </a:p>
-          <a:p xmlns:a="http://schemas.openxmlformats.org/drawingml/2006/main">
-            <a:pPr algn="l">
-              <a:defRPr sz="555" b="0">
-                <a:solidFill>
-                  <a:srgbClr val="102536"/>
-                </a:solidFill>
-              </a:defRPr>
-            </a:pPr>
-            <a:r>
-              <a:rPr sz="555" b="0">
-                <a:solidFill>
-                  <a:srgbClr val="102536"/>
-                </a:solidFill>
-              </a:rPr>
-              <a:t>• Smoking declined in several states; the national rate cited changed from 14,650 to 12,151 per 100,000.</a:t>
+              <a:defRPr sz="472" b="0">
+                <a:solidFill>
+                  <a:srgbClr val="102536"/>
+                </a:solidFill>
+              </a:defRPr>
+            </a:pPr>
+            <a:r>
+              <a:rPr sz="472" b="0">
+                <a:solidFill>
+                  <a:srgbClr val="102536"/>
+                </a:solidFill>
+              </a:rPr>
+              <a:t>• Asthma diagnosis increased in Brazil; respiratory causes account for 15.2% of health-related absenteeism.</a:t>
+            </a:r>
+          </a:p>
+          <a:p xmlns:a="http://schemas.openxmlformats.org/drawingml/2006/main">
+            <a:pPr algn="l">
+              <a:defRPr sz="472" b="0">
+                <a:solidFill>
+                  <a:srgbClr val="102536"/>
+                </a:solidFill>
+              </a:defRPr>
+            </a:pPr>
+            <a:r>
+              <a:rPr sz="472" b="0">
+                <a:solidFill>
+                  <a:srgbClr val="102536"/>
+                </a:solidFill>
+              </a:rPr>
+              <a:t>• Respiratory causes averaged 4.8 lost days, signaling potential productivity and income costs.</a:t>
+            </a:r>
+          </a:p>
+          <a:p xmlns:a="http://schemas.openxmlformats.org/drawingml/2006/main">
+            <a:pPr algn="l">
+              <a:defRPr sz="472" b="0">
+                <a:solidFill>
+                  <a:srgbClr val="102536"/>
+                </a:solidFill>
+              </a:defRPr>
+            </a:pPr>
+            <a:r>
+              <a:rPr sz="472" b="0">
+                <a:solidFill>
+                  <a:srgbClr val="102536"/>
+                </a:solidFill>
+              </a:rPr>
+              <a:t>• Better control may reduce absences, lost days and acute-care demand.</a:t>
             </a:r>
           </a:p>
         </p:txBody>
@@ -3132,7 +3115,7 @@
           <p:cNvPr id="43" name="meds-metric">
             <a:extLst xmlns:a="http://schemas.openxmlformats.org/drawingml/2006/main">
               <a:ext uri="{FF2B5EF4-FFF2-40B4-BE49-F238E27FC236}">
-                <a16:creationId xmlns:a16="http://schemas.microsoft.com/office/drawing/2014/main" id="{614BF93D-9AAF-44F1-BD55-C8359429ADDC}"/>
+                <a16:creationId xmlns:a16="http://schemas.microsoft.com/office/drawing/2014/main" id="{F5BA26C1-637E-4044-9F81-7D3D965DC959}"/>
               </a:ext>
             </a:extLst>
           </p:cNvPr>
@@ -3165,7 +3148,7 @@
           <p:cNvPr id="44" name="meds-metric-title">
             <a:extLst xmlns:a="http://schemas.openxmlformats.org/drawingml/2006/main">
               <a:ext uri="{FF2B5EF4-FFF2-40B4-BE49-F238E27FC236}">
-                <a16:creationId xmlns:a16="http://schemas.microsoft.com/office/drawing/2014/main" id="{7F7386CF-6710-48AF-B7F3-A8E0C8273A1B}"/>
+                <a16:creationId xmlns:a16="http://schemas.microsoft.com/office/drawing/2014/main" id="{A4C4B4F2-B87E-4228-BF50-488A28BE6559}"/>
               </a:ext>
             </a:extLst>
           </p:cNvPr>
@@ -3215,7 +3198,7 @@
           <p:cNvPr id="45" name="meds-metric-value">
             <a:extLst xmlns:a="http://schemas.openxmlformats.org/drawingml/2006/main">
               <a:ext uri="{FF2B5EF4-FFF2-40B4-BE49-F238E27FC236}">
-                <a16:creationId xmlns:a16="http://schemas.microsoft.com/office/drawing/2014/main" id="{1DBB9A23-EDC6-4D2E-97A5-FACDD5992001}"/>
+                <a16:creationId xmlns:a16="http://schemas.microsoft.com/office/drawing/2014/main" id="{E0BA0341-7A36-424F-A8CA-07612EE03C7D}"/>
               </a:ext>
             </a:extLst>
           </p:cNvPr>
@@ -3265,7 +3248,7 @@
           <p:cNvPr id="46" name="meds-metric-note">
             <a:extLst xmlns:a="http://schemas.openxmlformats.org/drawingml/2006/main">
               <a:ext uri="{FF2B5EF4-FFF2-40B4-BE49-F238E27FC236}">
-                <a16:creationId xmlns:a16="http://schemas.microsoft.com/office/drawing/2014/main" id="{D0861812-2DF5-44A9-9258-28777DC20115}"/>
+                <a16:creationId xmlns:a16="http://schemas.microsoft.com/office/drawing/2014/main" id="{96A6538F-F379-4585-B69F-6506F9492E99}"/>
               </a:ext>
             </a:extLst>
           </p:cNvPr>
@@ -3315,7 +3298,7 @@
           <p:cNvPr id="47" name="chart-meds-caption">
             <a:extLst xmlns:a="http://schemas.openxmlformats.org/drawingml/2006/main">
               <a:ext uri="{FF2B5EF4-FFF2-40B4-BE49-F238E27FC236}">
-                <a16:creationId xmlns:a16="http://schemas.microsoft.com/office/drawing/2014/main" id="{767D8124-516A-464E-A382-B8410EC57790}"/>
+                <a16:creationId xmlns:a16="http://schemas.microsoft.com/office/drawing/2014/main" id="{BB8BD4A0-6A10-43E7-93F3-3D7B9C766656}"/>
               </a:ext>
             </a:extLst>
           </p:cNvPr>
@@ -3365,7 +3348,7 @@
           <p:cNvPr id="48" name="chart-meds-frame">
             <a:extLst xmlns:a="http://schemas.openxmlformats.org/drawingml/2006/main">
               <a:ext uri="{FF2B5EF4-FFF2-40B4-BE49-F238E27FC236}">
-                <a16:creationId xmlns:a16="http://schemas.microsoft.com/office/drawing/2014/main" id="{1498CF57-054A-4225-A038-73691FF5641D}"/>
+                <a16:creationId xmlns:a16="http://schemas.microsoft.com/office/drawing/2014/main" id="{0C5036B7-EF33-4D8C-BA4B-E072ED7D396D}"/>
               </a:ext>
             </a:extLst>
           </p:cNvPr>
@@ -3402,7 +3385,7 @@
           <p:nvPr/>
         </p:nvPicPr>
         <p:blipFill>
-          <a:blip xmlns:r="http://schemas.openxmlformats.org/officeDocument/2006/relationships" xmlns:a="http://schemas.openxmlformats.org/drawingml/2006/main" r:embed="Rdfa13ff962a84ee9"/>
+          <a:blip xmlns:r="http://schemas.openxmlformats.org/officeDocument/2006/relationships" xmlns:a="http://schemas.openxmlformats.org/drawingml/2006/main" r:embed="Rcc8d79da89e74385"/>
           <a:stretch xmlns:a="http://schemas.openxmlformats.org/drawingml/2006/main"/>
         </p:blipFill>
         <p:spPr>
@@ -3420,7 +3403,7 @@
           <p:cNvPr id="50" name="chart-smoke-caption">
             <a:extLst xmlns:a="http://schemas.openxmlformats.org/drawingml/2006/main">
               <a:ext uri="{FF2B5EF4-FFF2-40B4-BE49-F238E27FC236}">
-                <a16:creationId xmlns:a16="http://schemas.microsoft.com/office/drawing/2014/main" id="{1CA97DB8-56AC-40C7-8833-B7A8E077F631}"/>
+                <a16:creationId xmlns:a16="http://schemas.microsoft.com/office/drawing/2014/main" id="{379BF85E-D139-4B61-BCCF-2207E55C18E9}"/>
               </a:ext>
             </a:extLst>
           </p:cNvPr>
@@ -3460,7 +3443,7 @@
                   <a:srgbClr val="153F59"/>
                 </a:solidFill>
               </a:rPr>
-              <a:t>Figure 4: Current smokers per 100,000 inhabitants by state, PNS 2013 and 2019.</a:t>
+              <a:t>Figure 4: Mean lost days by health reason in Brazil, highlighting respiratory causes, PNS 2019.</a:t>
             </a:r>
           </a:p>
         </p:txBody>
@@ -3470,7 +3453,7 @@
           <p:cNvPr id="51" name="chart-smoke-frame">
             <a:extLst xmlns:a="http://schemas.openxmlformats.org/drawingml/2006/main">
               <a:ext uri="{FF2B5EF4-FFF2-40B4-BE49-F238E27FC236}">
-                <a16:creationId xmlns:a16="http://schemas.microsoft.com/office/drawing/2014/main" id="{B60A42E8-CBA2-4D30-BE69-B23BAFD7F36A}"/>
+                <a16:creationId xmlns:a16="http://schemas.microsoft.com/office/drawing/2014/main" id="{AE0A04AE-046F-47C9-A879-B16E48B5DFFB}"/>
               </a:ext>
             </a:extLst>
           </p:cNvPr>
@@ -3507,7 +3490,7 @@
           <p:nvPr/>
         </p:nvPicPr>
         <p:blipFill>
-          <a:blip xmlns:r="http://schemas.openxmlformats.org/officeDocument/2006/relationships" xmlns:a="http://schemas.openxmlformats.org/drawingml/2006/main" r:embed="Rcd3d24d3e86a4a04"/>
+          <a:blip xmlns:r="http://schemas.openxmlformats.org/officeDocument/2006/relationships" xmlns:a="http://schemas.openxmlformats.org/drawingml/2006/main" r:embed="Ra5cadbe934904671"/>
           <a:stretch xmlns:a="http://schemas.openxmlformats.org/drawingml/2006/main"/>
         </p:blipFill>
         <p:spPr>
@@ -3525,7 +3508,7 @@
           <p:cNvPr id="53" name="6-Beta CI and chart reading-box">
             <a:extLst xmlns:a="http://schemas.openxmlformats.org/drawingml/2006/main">
               <a:ext uri="{FF2B5EF4-FFF2-40B4-BE49-F238E27FC236}">
-                <a16:creationId xmlns:a16="http://schemas.microsoft.com/office/drawing/2014/main" id="{7C61FB6F-AD39-4DC5-9E8C-C717471573BE}"/>
+                <a16:creationId xmlns:a16="http://schemas.microsoft.com/office/drawing/2014/main" id="{E2A3A153-1A1A-44EF-A3F8-CF116D84EC95}"/>
               </a:ext>
             </a:extLst>
           </p:cNvPr>
@@ -3558,7 +3541,7 @@
           <p:cNvPr id="54" name="6-Beta CI and chart reading-head">
             <a:extLst xmlns:a="http://schemas.openxmlformats.org/drawingml/2006/main">
               <a:ext uri="{FF2B5EF4-FFF2-40B4-BE49-F238E27FC236}">
-                <a16:creationId xmlns:a16="http://schemas.microsoft.com/office/drawing/2014/main" id="{2DAACF49-C35B-48D2-B296-199F2D82A473}"/>
+                <a16:creationId xmlns:a16="http://schemas.microsoft.com/office/drawing/2014/main" id="{2ED1805B-D6CD-4879-B272-C303DF9C0AA1}"/>
               </a:ext>
             </a:extLst>
           </p:cNvPr>
@@ -3591,7 +3574,7 @@
           <p:cNvPr id="55" name="6-Beta CI and chart reading-title">
             <a:extLst xmlns:a="http://schemas.openxmlformats.org/drawingml/2006/main">
               <a:ext uri="{FF2B5EF4-FFF2-40B4-BE49-F238E27FC236}">
-                <a16:creationId xmlns:a16="http://schemas.microsoft.com/office/drawing/2014/main" id="{33ACE7BD-D554-4E13-8DC9-63F57108A6D0}"/>
+                <a16:creationId xmlns:a16="http://schemas.microsoft.com/office/drawing/2014/main" id="{0696C765-AA29-42E4-9706-5A5976089BB1}"/>
               </a:ext>
             </a:extLst>
           </p:cNvPr>
@@ -3641,7 +3624,7 @@
           <p:cNvPr id="56" name="6-Beta CI and chart reading-body">
             <a:extLst xmlns:a="http://schemas.openxmlformats.org/drawingml/2006/main">
               <a:ext uri="{FF2B5EF4-FFF2-40B4-BE49-F238E27FC236}">
-                <a16:creationId xmlns:a16="http://schemas.microsoft.com/office/drawing/2014/main" id="{236A7B6E-33D6-40D4-8D65-033EFB993010}"/>
+                <a16:creationId xmlns:a16="http://schemas.microsoft.com/office/drawing/2014/main" id="{74D2AF5D-400A-47C6-A0D8-A652F2897E0C}"/>
               </a:ext>
             </a:extLst>
           </p:cNvPr>
@@ -3722,10 +3705,10 @@
       </p:sp>
       <p:sp>
         <p:nvSpPr>
-          <p:cNvPr id="57" name="7-Discussion and implications-box">
-            <a:extLst xmlns:a="http://schemas.openxmlformats.org/drawingml/2006/main">
-              <a:ext uri="{FF2B5EF4-FFF2-40B4-BE49-F238E27FC236}">
-                <a16:creationId xmlns:a16="http://schemas.microsoft.com/office/drawing/2014/main" id="{1BB92D7E-B50F-49C5-9D0B-D1CE5C164E95}"/>
+          <p:cNvPr id="57" name="7-Economic impact-box">
+            <a:extLst xmlns:a="http://schemas.openxmlformats.org/drawingml/2006/main">
+              <a:ext uri="{FF2B5EF4-FFF2-40B4-BE49-F238E27FC236}">
+                <a16:creationId xmlns:a16="http://schemas.microsoft.com/office/drawing/2014/main" id="{0A9532C9-E1E5-4B57-A8DA-2622846763AB}"/>
               </a:ext>
             </a:extLst>
           </p:cNvPr>
@@ -3755,10 +3738,10 @@
       </p:sp>
       <p:sp>
         <p:nvSpPr>
-          <p:cNvPr id="58" name="7-Discussion and implications-head">
-            <a:extLst xmlns:a="http://schemas.openxmlformats.org/drawingml/2006/main">
-              <a:ext uri="{FF2B5EF4-FFF2-40B4-BE49-F238E27FC236}">
-                <a16:creationId xmlns:a16="http://schemas.microsoft.com/office/drawing/2014/main" id="{7BBD83F2-0D3C-4DCC-AE0C-B824F68D17FF}"/>
+          <p:cNvPr id="58" name="7-Economic impact-head">
+            <a:extLst xmlns:a="http://schemas.openxmlformats.org/drawingml/2006/main">
+              <a:ext uri="{FF2B5EF4-FFF2-40B4-BE49-F238E27FC236}">
+                <a16:creationId xmlns:a16="http://schemas.microsoft.com/office/drawing/2014/main" id="{D5BB2D5D-AFA4-438D-96CB-B1501C368708}"/>
               </a:ext>
             </a:extLst>
           </p:cNvPr>
@@ -3788,10 +3771,10 @@
       </p:sp>
       <p:sp>
         <p:nvSpPr>
-          <p:cNvPr id="59" name="7-Discussion and implications-title">
-            <a:extLst xmlns:a="http://schemas.openxmlformats.org/drawingml/2006/main">
-              <a:ext uri="{FF2B5EF4-FFF2-40B4-BE49-F238E27FC236}">
-                <a16:creationId xmlns:a16="http://schemas.microsoft.com/office/drawing/2014/main" id="{25DE4049-5F85-4E2C-BB23-ADCB316EE4BB}"/>
+          <p:cNvPr id="59" name="7-Economic impact-title">
+            <a:extLst xmlns:a="http://schemas.openxmlformats.org/drawingml/2006/main">
+              <a:ext uri="{FF2B5EF4-FFF2-40B4-BE49-F238E27FC236}">
+                <a16:creationId xmlns:a16="http://schemas.microsoft.com/office/drawing/2014/main" id="{3FEAE7B9-52BD-4445-87A4-325581646954}"/>
               </a:ext>
             </a:extLst>
           </p:cNvPr>
@@ -3831,17 +3814,17 @@
                   <a:srgbClr val="FFFFFF"/>
                 </a:solidFill>
               </a:rPr>
-              <a:t>7. Discussion and implications</a:t>
+              <a:t>7. Economic impact</a:t>
             </a:r>
           </a:p>
         </p:txBody>
       </p:sp>
       <p:sp>
         <p:nvSpPr>
-          <p:cNvPr id="60" name="7-Discussion and implications-body">
-            <a:extLst xmlns:a="http://schemas.openxmlformats.org/drawingml/2006/main">
-              <a:ext uri="{FF2B5EF4-FFF2-40B4-BE49-F238E27FC236}">
-                <a16:creationId xmlns:a16="http://schemas.microsoft.com/office/drawing/2014/main" id="{EB803D2D-1E5D-4FDA-A71C-5E4BB7D5E743}"/>
+          <p:cNvPr id="60" name="7-Economic impact-body">
+            <a:extLst xmlns:a="http://schemas.openxmlformats.org/drawingml/2006/main">
+              <a:ext uri="{FF2B5EF4-FFF2-40B4-BE49-F238E27FC236}">
+                <a16:creationId xmlns:a16="http://schemas.microsoft.com/office/drawing/2014/main" id="{F60FA900-F154-40EF-93A3-1A5E9C60A9F6}"/>
               </a:ext>
             </a:extLst>
           </p:cNvPr>
@@ -3869,53 +3852,36 @@
           <a:lstStyle xmlns:a="http://schemas.openxmlformats.org/drawingml/2006/main"/>
           <a:p xmlns:a="http://schemas.openxmlformats.org/drawingml/2006/main">
             <a:pPr algn="l">
-              <a:defRPr sz="578" b="0">
-                <a:solidFill>
-                  <a:srgbClr val="102536"/>
-                </a:solidFill>
-              </a:defRPr>
-            </a:pPr>
-            <a:r>
-              <a:rPr sz="578" b="0">
-                <a:solidFill>
-                  <a:srgbClr val="102536"/>
-                </a:solidFill>
-              </a:rPr>
-              <a:t>• The pattern diagnosis↑, attacks≈ and medication use↓ suggests broader asthma recognition without proportional improvement in control.</a:t>
-            </a:r>
-          </a:p>
-          <a:p xmlns:a="http://schemas.openxmlformats.org/drawingml/2006/main">
-            <a:pPr algn="l">
-              <a:defRPr sz="578" b="0">
-                <a:solidFill>
-                  <a:srgbClr val="102536"/>
-                </a:solidFill>
-              </a:defRPr>
-            </a:pPr>
-            <a:r>
-              <a:rPr sz="578" b="0">
-                <a:solidFill>
-                  <a:srgbClr val="102536"/>
-                </a:solidFill>
-              </a:rPr>
-              <a:t>• The diagnosis increase may reflect higher occurrence, better diagnostic access or both.</a:t>
-            </a:r>
-          </a:p>
-          <a:p xmlns:a="http://schemas.openxmlformats.org/drawingml/2006/main">
-            <a:pPr algn="l">
-              <a:defRPr sz="578" b="0">
-                <a:solidFill>
-                  <a:srgbClr val="102536"/>
-                </a:solidFill>
-              </a:defRPr>
-            </a:pPr>
-            <a:r>
-              <a:rPr sz="578" b="0">
-                <a:solidFill>
-                  <a:srgbClr val="102536"/>
-                </a:solidFill>
-              </a:rPr>
-              <a:t>• Asthma control depends on medication access, clinical follow-up, education, exposure control and non-pharmacological interventions.</a:t>
+              <a:defRPr sz="544" b="0">
+                <a:solidFill>
+                  <a:srgbClr val="102536"/>
+                </a:solidFill>
+              </a:defRPr>
+            </a:pPr>
+            <a:r>
+              <a:rPr sz="544" b="0">
+                <a:solidFill>
+                  <a:srgbClr val="102536"/>
+                </a:solidFill>
+              </a:rPr>
+              <a:t>• Poorly controlled asthma can reduce productivity through absences, functional limitation and demand for acute care.</a:t>
+            </a:r>
+          </a:p>
+          <a:p xmlns:a="http://schemas.openxmlformats.org/drawingml/2006/main">
+            <a:pPr algn="l">
+              <a:defRPr sz="544" b="0">
+                <a:solidFill>
+                  <a:srgbClr val="102536"/>
+                </a:solidFill>
+              </a:defRPr>
+            </a:pPr>
+            <a:r>
+              <a:rPr sz="544" b="0">
+                <a:solidFill>
+                  <a:srgbClr val="102536"/>
+                </a:solidFill>
+              </a:rPr>
+              <a:t>• The economic reading supports diagnosis, medication access and clinical follow-up policies.</a:t>
             </a:r>
           </a:p>
         </p:txBody>
@@ -3925,7 +3891,7 @@
           <p:cNvPr id="61" name="8-ETL, OMOP and OHDSI-box">
             <a:extLst xmlns:a="http://schemas.openxmlformats.org/drawingml/2006/main">
               <a:ext uri="{FF2B5EF4-FFF2-40B4-BE49-F238E27FC236}">
-                <a16:creationId xmlns:a16="http://schemas.microsoft.com/office/drawing/2014/main" id="{016887D4-D89B-47B9-BC55-B2B837BD1335}"/>
+                <a16:creationId xmlns:a16="http://schemas.microsoft.com/office/drawing/2014/main" id="{A97A3B12-A082-499E-9357-A01E1E483A7B}"/>
               </a:ext>
             </a:extLst>
           </p:cNvPr>
@@ -3958,7 +3924,7 @@
           <p:cNvPr id="62" name="8-ETL, OMOP and OHDSI-head">
             <a:extLst xmlns:a="http://schemas.openxmlformats.org/drawingml/2006/main">
               <a:ext uri="{FF2B5EF4-FFF2-40B4-BE49-F238E27FC236}">
-                <a16:creationId xmlns:a16="http://schemas.microsoft.com/office/drawing/2014/main" id="{C26FDF28-C157-46CC-BDA2-715042A06299}"/>
+                <a16:creationId xmlns:a16="http://schemas.microsoft.com/office/drawing/2014/main" id="{FC570A5F-64CB-43B1-915E-0A18D789F1CD}"/>
               </a:ext>
             </a:extLst>
           </p:cNvPr>
@@ -3991,7 +3957,7 @@
           <p:cNvPr id="63" name="8-ETL, OMOP and OHDSI-title">
             <a:extLst xmlns:a="http://schemas.openxmlformats.org/drawingml/2006/main">
               <a:ext uri="{FF2B5EF4-FFF2-40B4-BE49-F238E27FC236}">
-                <a16:creationId xmlns:a16="http://schemas.microsoft.com/office/drawing/2014/main" id="{32DE33A8-9C10-401D-AFB1-3033FC4D0992}"/>
+                <a16:creationId xmlns:a16="http://schemas.microsoft.com/office/drawing/2014/main" id="{87B4674D-5F45-4B0E-AD4E-C5A2B5926DA5}"/>
               </a:ext>
             </a:extLst>
           </p:cNvPr>
@@ -4041,7 +4007,7 @@
           <p:cNvPr id="64" name="8-ETL, OMOP and OHDSI-body">
             <a:extLst xmlns:a="http://schemas.openxmlformats.org/drawingml/2006/main">
               <a:ext uri="{FF2B5EF4-FFF2-40B4-BE49-F238E27FC236}">
-                <a16:creationId xmlns:a16="http://schemas.microsoft.com/office/drawing/2014/main" id="{1516A939-4B9C-47CF-B878-4DCAC14179B7}"/>
+                <a16:creationId xmlns:a16="http://schemas.microsoft.com/office/drawing/2014/main" id="{8550FE4A-0A34-4FD9-B681-0AF3D0C87EA8}"/>
               </a:ext>
             </a:extLst>
           </p:cNvPr>
@@ -4125,7 +4091,7 @@
           <p:cNvPr id="65" name="9-Conclusions-box">
             <a:extLst xmlns:a="http://schemas.openxmlformats.org/drawingml/2006/main">
               <a:ext uri="{FF2B5EF4-FFF2-40B4-BE49-F238E27FC236}">
-                <a16:creationId xmlns:a16="http://schemas.microsoft.com/office/drawing/2014/main" id="{B27D149B-3790-41F4-A796-3EC966A034C6}"/>
+                <a16:creationId xmlns:a16="http://schemas.microsoft.com/office/drawing/2014/main" id="{A6507B9C-3D93-44F2-BB27-AE65CF96AA1A}"/>
               </a:ext>
             </a:extLst>
           </p:cNvPr>
@@ -4158,7 +4124,7 @@
           <p:cNvPr id="66" name="9-Conclusions-head">
             <a:extLst xmlns:a="http://schemas.openxmlformats.org/drawingml/2006/main">
               <a:ext uri="{FF2B5EF4-FFF2-40B4-BE49-F238E27FC236}">
-                <a16:creationId xmlns:a16="http://schemas.microsoft.com/office/drawing/2014/main" id="{0BE59DDA-E150-498A-96EA-50B166D14E10}"/>
+                <a16:creationId xmlns:a16="http://schemas.microsoft.com/office/drawing/2014/main" id="{0E0A0D6E-DBF4-4DC1-9248-F58AF4A079CB}"/>
               </a:ext>
             </a:extLst>
           </p:cNvPr>
@@ -4191,7 +4157,7 @@
           <p:cNvPr id="67" name="9-Conclusions-title">
             <a:extLst xmlns:a="http://schemas.openxmlformats.org/drawingml/2006/main">
               <a:ext uri="{FF2B5EF4-FFF2-40B4-BE49-F238E27FC236}">
-                <a16:creationId xmlns:a16="http://schemas.microsoft.com/office/drawing/2014/main" id="{470A79A6-2303-4814-A813-87F431EE2966}"/>
+                <a16:creationId xmlns:a16="http://schemas.microsoft.com/office/drawing/2014/main" id="{180A017E-05FE-4D35-B4D9-94C15EC7FEEB}"/>
               </a:ext>
             </a:extLst>
           </p:cNvPr>
@@ -4241,7 +4207,7 @@
           <p:cNvPr id="68" name="9-Conclusions-body">
             <a:extLst xmlns:a="http://schemas.openxmlformats.org/drawingml/2006/main">
               <a:ext uri="{FF2B5EF4-FFF2-40B4-BE49-F238E27FC236}">
-                <a16:creationId xmlns:a16="http://schemas.microsoft.com/office/drawing/2014/main" id="{CD2FB299-1A50-4353-B23D-968B0EFD9052}"/>
+                <a16:creationId xmlns:a16="http://schemas.microsoft.com/office/drawing/2014/main" id="{6CC938EE-5103-47C2-81BE-0F8F9B493B98}"/>
               </a:ext>
             </a:extLst>
           </p:cNvPr>
@@ -4298,7 +4264,7 @@
                   <a:srgbClr val="102536"/>
                 </a:solidFill>
               </a:rPr>
-              <a:t>• Brazil showed increased diagnosis, but not equivalent evidence of improved control.</a:t>
+              <a:t>• Asthma should be treated as both a clinical and economic issue because it can affect productivity, income and the labor force.</a:t>
             </a:r>
           </a:p>
           <a:p xmlns:a="http://schemas.openxmlformats.org/drawingml/2006/main">
@@ -4315,7 +4281,7 @@
                   <a:srgbClr val="102536"/>
                 </a:solidFill>
               </a:rPr>
-              <a:t>• State-level charts must be read with 95% CIs because many comparisons have overlapping intervals.</a:t>
+              <a:t>• Absenteeism results are aggregated respiratory estimates; they should not be read as asthma-only estimates.</a:t>
             </a:r>
           </a:p>
         </p:txBody>
@@ -4325,7 +4291,7 @@
           <p:cNvPr id="69" name="references-box">
             <a:extLst xmlns:a="http://schemas.openxmlformats.org/drawingml/2006/main">
               <a:ext uri="{FF2B5EF4-FFF2-40B4-BE49-F238E27FC236}">
-                <a16:creationId xmlns:a16="http://schemas.microsoft.com/office/drawing/2014/main" id="{0717DBC0-D021-4192-945A-33BB1B02A439}"/>
+                <a16:creationId xmlns:a16="http://schemas.microsoft.com/office/drawing/2014/main" id="{803B685D-1B26-4D1A-955B-14C0EED6A5D4}"/>
               </a:ext>
             </a:extLst>
           </p:cNvPr>
@@ -4358,7 +4324,7 @@
           <p:cNvPr id="70" name="references-title">
             <a:extLst xmlns:a="http://schemas.openxmlformats.org/drawingml/2006/main">
               <a:ext uri="{FF2B5EF4-FFF2-40B4-BE49-F238E27FC236}">
-                <a16:creationId xmlns:a16="http://schemas.microsoft.com/office/drawing/2014/main" id="{14F4505C-0549-4F59-9303-5CA32A4229F2}"/>
+                <a16:creationId xmlns:a16="http://schemas.microsoft.com/office/drawing/2014/main" id="{6652ED7C-E63D-4B11-97F0-8279A2D22D89}"/>
               </a:ext>
             </a:extLst>
           </p:cNvPr>
@@ -4408,7 +4374,7 @@
           <p:cNvPr id="71" name="references-body">
             <a:extLst xmlns:a="http://schemas.openxmlformats.org/drawingml/2006/main">
               <a:ext uri="{FF2B5EF4-FFF2-40B4-BE49-F238E27FC236}">
-                <a16:creationId xmlns:a16="http://schemas.microsoft.com/office/drawing/2014/main" id="{B90361D6-CE57-4CE2-8C57-BEF92B497AC4}"/>
+                <a16:creationId xmlns:a16="http://schemas.microsoft.com/office/drawing/2014/main" id="{2673E975-421F-45A5-B061-AA2FAB35C904}"/>
               </a:ext>
             </a:extLst>
           </p:cNvPr>
@@ -4662,7 +4628,7 @@
           <p:cNvPr id="72" name="qr-box">
             <a:extLst xmlns:a="http://schemas.openxmlformats.org/drawingml/2006/main">
               <a:ext uri="{FF2B5EF4-FFF2-40B4-BE49-F238E27FC236}">
-                <a16:creationId xmlns:a16="http://schemas.microsoft.com/office/drawing/2014/main" id="{026A1FE6-13D9-43F7-9F5C-9DBE46B0A3E5}"/>
+                <a16:creationId xmlns:a16="http://schemas.microsoft.com/office/drawing/2014/main" id="{21FD3BA8-728F-43F1-B8C4-F737A95D3882}"/>
               </a:ext>
             </a:extLst>
           </p:cNvPr>
@@ -4699,7 +4665,7 @@
           <p:nvPr/>
         </p:nvPicPr>
         <p:blipFill>
-          <a:blip xmlns:r="http://schemas.openxmlformats.org/officeDocument/2006/relationships" xmlns:a="http://schemas.openxmlformats.org/drawingml/2006/main" r:embed="R8822f1ebdfa54f3d"/>
+          <a:blip xmlns:r="http://schemas.openxmlformats.org/officeDocument/2006/relationships" xmlns:a="http://schemas.openxmlformats.org/drawingml/2006/main" r:embed="R633ba7de210240f1"/>
           <a:stretch xmlns:a="http://schemas.openxmlformats.org/drawingml/2006/main"/>
         </p:blipFill>
         <p:spPr>
@@ -4717,7 +4683,7 @@
           <p:cNvPr id="74" name="qr-label">
             <a:extLst xmlns:a="http://schemas.openxmlformats.org/drawingml/2006/main">
               <a:ext uri="{FF2B5EF4-FFF2-40B4-BE49-F238E27FC236}">
-                <a16:creationId xmlns:a16="http://schemas.microsoft.com/office/drawing/2014/main" id="{7C7F8AE6-BF7F-42EE-B801-58B3CB2B4DCA}"/>
+                <a16:creationId xmlns:a16="http://schemas.microsoft.com/office/drawing/2014/main" id="{C51A7279-DBB7-4CF1-9DD0-DB455EDD03F6}"/>
               </a:ext>
             </a:extLst>
           </p:cNvPr>
@@ -4782,7 +4748,7 @@
     </p:spTree>
     <p:extLst>
       <p:ext uri="{BB962C8B-B14F-4D97-AF65-F5344CB8AC3E}">
-        <p14:creationId xmlns:p14="http://schemas.microsoft.com/office/powerpoint/2010/main" val="31060767"/>
+        <p14:creationId xmlns:p14="http://schemas.microsoft.com/office/powerpoint/2010/main" val="1982053538"/>
       </p:ext>
     </p:extLst>
   </p:cSld>

</xml_diff>

<commit_message>
Fix medication chart x-axis label in posters
</commit_message>
<xml_diff>
--- a/outputs/posters/poster_pns_asma_classico_en.pptx
+++ b/outputs/posters/poster_pns_asma_classico_en.pptx
@@ -2,13 +2,13 @@
 <file path=ppt/presentation.xml><?xml version="1.0" encoding="utf-8"?>
 <p:presentation xmlns:p="http://schemas.openxmlformats.org/presentationml/2006/main">
   <p:sldMasterIdLst>
-    <p:sldMasterId xmlns:r="http://schemas.openxmlformats.org/officeDocument/2006/relationships" id="2147483648" r:id="R4cc5b38da25f4654"/>
+    <p:sldMasterId xmlns:r="http://schemas.openxmlformats.org/officeDocument/2006/relationships" id="2147483648" r:id="R3b6ad69e1c8848cf"/>
   </p:sldMasterIdLst>
   <p:notesMasterIdLst>
-    <p:notesMasterId xmlns:r="http://schemas.openxmlformats.org/officeDocument/2006/relationships" r:id="Rc7dbf3f9235b4e1e"/>
+    <p:notesMasterId xmlns:r="http://schemas.openxmlformats.org/officeDocument/2006/relationships" r:id="Rd8e0bd6aed08440e"/>
   </p:notesMasterIdLst>
   <p:sldIdLst>
-    <p:sldId xmlns:r="http://schemas.openxmlformats.org/officeDocument/2006/relationships" id="256" r:id="Rb5670a333fed4934"/>
+    <p:sldId xmlns:r="http://schemas.openxmlformats.org/officeDocument/2006/relationships" id="256" r:id="Rf9d4938a31494e17"/>
   </p:sldIdLst>
   <p:sldSz cx="9525000" cy="13468350"/>
   <p:notesSz cx="6858000" cy="9144000"/>
@@ -601,7 +601,7 @@
   </p:cSld>
   <p:clrMap bg1="lt1" tx1="dk1" bg2="lt2" tx2="dk2" accent1="accent1" accent2="accent2" accent3="accent3" accent4="accent4" accent5="accent5" accent6="accent6" hlink="hlink" folHlink="folHlink"/>
   <p:sldLayoutIdLst>
-    <p:sldLayoutId xmlns:r="http://schemas.openxmlformats.org/officeDocument/2006/relationships" id="2147483649" r:id="R1950a7fd80b5444f"/>
+    <p:sldLayoutId xmlns:r="http://schemas.openxmlformats.org/officeDocument/2006/relationships" id="2147483649" r:id="R2942698e6b254d7c"/>
   </p:sldLayoutIdLst>
   <p:txStyles>
     <p:titleStyle>
@@ -1156,7 +1156,7 @@
           <p:nvPr/>
         </p:nvPicPr>
         <p:blipFill>
-          <a:blip xmlns:r="http://schemas.openxmlformats.org/officeDocument/2006/relationships" xmlns:a="http://schemas.openxmlformats.org/drawingml/2006/main" r:embed="Re603665e29c1484f"/>
+          <a:blip xmlns:r="http://schemas.openxmlformats.org/officeDocument/2006/relationships" xmlns:a="http://schemas.openxmlformats.org/drawingml/2006/main" r:embed="R2af8e9d4bcac46e8"/>
           <a:srcRect xmlns:a="http://schemas.openxmlformats.org/drawingml/2006/main" l="0" t="38622" r="0" b="38622"/>
           <a:stretch xmlns:a="http://schemas.openxmlformats.org/drawingml/2006/main">
             <a:fillRect l="0" t="0" r="0" b="0"/>
@@ -1181,7 +1181,7 @@
           <p:nvPr/>
         </p:nvPicPr>
         <p:blipFill>
-          <a:blip xmlns:r="http://schemas.openxmlformats.org/officeDocument/2006/relationships" xmlns:a="http://schemas.openxmlformats.org/drawingml/2006/main" r:embed="R770c1e93c8224360"/>
+          <a:blip xmlns:r="http://schemas.openxmlformats.org/officeDocument/2006/relationships" xmlns:a="http://schemas.openxmlformats.org/drawingml/2006/main" r:embed="R276209a8ddf74df5"/>
           <a:stretch xmlns:a="http://schemas.openxmlformats.org/drawingml/2006/main"/>
         </p:blipFill>
         <p:spPr>
@@ -1203,7 +1203,7 @@
           <p:nvPr/>
         </p:nvPicPr>
         <p:blipFill>
-          <a:blip xmlns:r="http://schemas.openxmlformats.org/officeDocument/2006/relationships" xmlns:a="http://schemas.openxmlformats.org/drawingml/2006/main" r:embed="Rae1be7aad46d4090"/>
+          <a:blip xmlns:r="http://schemas.openxmlformats.org/officeDocument/2006/relationships" xmlns:a="http://schemas.openxmlformats.org/drawingml/2006/main" r:embed="Rfa00a639ca484b68"/>
           <a:stretch xmlns:a="http://schemas.openxmlformats.org/drawingml/2006/main"/>
         </p:blipFill>
         <p:spPr>
@@ -1221,7 +1221,7 @@
           <p:cNvPr id="4" name="classic-title">
             <a:extLst xmlns:a="http://schemas.openxmlformats.org/drawingml/2006/main">
               <a:ext uri="{FF2B5EF4-FFF2-40B4-BE49-F238E27FC236}">
-                <a16:creationId xmlns:a16="http://schemas.microsoft.com/office/drawing/2014/main" id="{7C9BF154-223F-4F74-9853-0C8C58FCF3DC}"/>
+                <a16:creationId xmlns:a16="http://schemas.microsoft.com/office/drawing/2014/main" id="{CE5A1974-D37D-4F2D-9151-FA04A941F221}"/>
               </a:ext>
             </a:extLst>
           </p:cNvPr>
@@ -1271,7 +1271,7 @@
           <p:cNvPr id="5" name="classic-authors">
             <a:extLst xmlns:a="http://schemas.openxmlformats.org/drawingml/2006/main">
               <a:ext uri="{FF2B5EF4-FFF2-40B4-BE49-F238E27FC236}">
-                <a16:creationId xmlns:a16="http://schemas.microsoft.com/office/drawing/2014/main" id="{4C5442EE-3D93-482A-804C-89E45E5ADA0B}"/>
+                <a16:creationId xmlns:a16="http://schemas.microsoft.com/office/drawing/2014/main" id="{945C8C30-E7BF-49DD-80EB-0B1BB4F37CA9}"/>
               </a:ext>
             </a:extLst>
           </p:cNvPr>
@@ -1321,7 +1321,7 @@
           <p:cNvPr id="6" name="1-Introduction-box">
             <a:extLst xmlns:a="http://schemas.openxmlformats.org/drawingml/2006/main">
               <a:ext uri="{FF2B5EF4-FFF2-40B4-BE49-F238E27FC236}">
-                <a16:creationId xmlns:a16="http://schemas.microsoft.com/office/drawing/2014/main" id="{C15F6560-3C78-4B21-88D9-8E4BFA2CF4F6}"/>
+                <a16:creationId xmlns:a16="http://schemas.microsoft.com/office/drawing/2014/main" id="{74338F02-6617-4463-9AF0-64CE6AA06127}"/>
               </a:ext>
             </a:extLst>
           </p:cNvPr>
@@ -1354,7 +1354,7 @@
           <p:cNvPr id="7" name="1-Introduction-head">
             <a:extLst xmlns:a="http://schemas.openxmlformats.org/drawingml/2006/main">
               <a:ext uri="{FF2B5EF4-FFF2-40B4-BE49-F238E27FC236}">
-                <a16:creationId xmlns:a16="http://schemas.microsoft.com/office/drawing/2014/main" id="{0368E232-72CE-496C-AD46-4B9E57547854}"/>
+                <a16:creationId xmlns:a16="http://schemas.microsoft.com/office/drawing/2014/main" id="{2036AF82-5FD2-4BB5-A980-393C4D9AF40A}"/>
               </a:ext>
             </a:extLst>
           </p:cNvPr>
@@ -1387,7 +1387,7 @@
           <p:cNvPr id="8" name="1-Introduction-title">
             <a:extLst xmlns:a="http://schemas.openxmlformats.org/drawingml/2006/main">
               <a:ext uri="{FF2B5EF4-FFF2-40B4-BE49-F238E27FC236}">
-                <a16:creationId xmlns:a16="http://schemas.microsoft.com/office/drawing/2014/main" id="{4B830F6B-89D9-4AC7-9394-BF6D0C6B7561}"/>
+                <a16:creationId xmlns:a16="http://schemas.microsoft.com/office/drawing/2014/main" id="{D2CDDFD0-DFC1-4581-8B11-FC0DD684B8CE}"/>
               </a:ext>
             </a:extLst>
           </p:cNvPr>
@@ -1437,7 +1437,7 @@
           <p:cNvPr id="9" name="1-Introduction-body">
             <a:extLst xmlns:a="http://schemas.openxmlformats.org/drawingml/2006/main">
               <a:ext uri="{FF2B5EF4-FFF2-40B4-BE49-F238E27FC236}">
-                <a16:creationId xmlns:a16="http://schemas.microsoft.com/office/drawing/2014/main" id="{7FA8AE28-8018-4367-84B7-0F4A6CB34CEB}"/>
+                <a16:creationId xmlns:a16="http://schemas.microsoft.com/office/drawing/2014/main" id="{6D32DF28-1458-469E-878A-B14915769454}"/>
               </a:ext>
             </a:extLst>
           </p:cNvPr>
@@ -1521,7 +1521,7 @@
           <p:cNvPr id="10" name="2-Objectives-box">
             <a:extLst xmlns:a="http://schemas.openxmlformats.org/drawingml/2006/main">
               <a:ext uri="{FF2B5EF4-FFF2-40B4-BE49-F238E27FC236}">
-                <a16:creationId xmlns:a16="http://schemas.microsoft.com/office/drawing/2014/main" id="{E2601E58-6FEE-40E4-B3E0-87519BA1599E}"/>
+                <a16:creationId xmlns:a16="http://schemas.microsoft.com/office/drawing/2014/main" id="{ECA34F9B-4FF7-47FB-87D8-93C45C5FCD47}"/>
               </a:ext>
             </a:extLst>
           </p:cNvPr>
@@ -1554,7 +1554,7 @@
           <p:cNvPr id="11" name="2-Objectives-head">
             <a:extLst xmlns:a="http://schemas.openxmlformats.org/drawingml/2006/main">
               <a:ext uri="{FF2B5EF4-FFF2-40B4-BE49-F238E27FC236}">
-                <a16:creationId xmlns:a16="http://schemas.microsoft.com/office/drawing/2014/main" id="{21400EFA-1C70-4371-94AF-2CEE5448CDC9}"/>
+                <a16:creationId xmlns:a16="http://schemas.microsoft.com/office/drawing/2014/main" id="{CF3BD300-4E98-4C6C-A6FF-3A2B08FEE4E3}"/>
               </a:ext>
             </a:extLst>
           </p:cNvPr>
@@ -1587,7 +1587,7 @@
           <p:cNvPr id="12" name="2-Objectives-title">
             <a:extLst xmlns:a="http://schemas.openxmlformats.org/drawingml/2006/main">
               <a:ext uri="{FF2B5EF4-FFF2-40B4-BE49-F238E27FC236}">
-                <a16:creationId xmlns:a16="http://schemas.microsoft.com/office/drawing/2014/main" id="{11A115CE-E140-4EE9-99FD-3FB882DC4FA3}"/>
+                <a16:creationId xmlns:a16="http://schemas.microsoft.com/office/drawing/2014/main" id="{94E5F49C-B4AA-4F6C-B39C-8568CAB2C785}"/>
               </a:ext>
             </a:extLst>
           </p:cNvPr>
@@ -1637,7 +1637,7 @@
           <p:cNvPr id="13" name="2-Objectives-body">
             <a:extLst xmlns:a="http://schemas.openxmlformats.org/drawingml/2006/main">
               <a:ext uri="{FF2B5EF4-FFF2-40B4-BE49-F238E27FC236}">
-                <a16:creationId xmlns:a16="http://schemas.microsoft.com/office/drawing/2014/main" id="{CC9BE6D7-2A4C-439B-AE5E-DC2452578740}"/>
+                <a16:creationId xmlns:a16="http://schemas.microsoft.com/office/drawing/2014/main" id="{02B20919-F11E-4D85-B882-65A28A627EDD}"/>
               </a:ext>
             </a:extLst>
           </p:cNvPr>
@@ -1721,7 +1721,7 @@
           <p:cNvPr id="14" name="3-Data and indicators-box">
             <a:extLst xmlns:a="http://schemas.openxmlformats.org/drawingml/2006/main">
               <a:ext uri="{FF2B5EF4-FFF2-40B4-BE49-F238E27FC236}">
-                <a16:creationId xmlns:a16="http://schemas.microsoft.com/office/drawing/2014/main" id="{68E179F6-B616-4873-906D-DF10A5D37073}"/>
+                <a16:creationId xmlns:a16="http://schemas.microsoft.com/office/drawing/2014/main" id="{9E7BAA7F-EACD-440A-B89D-1DA1BAE842A5}"/>
               </a:ext>
             </a:extLst>
           </p:cNvPr>
@@ -1754,7 +1754,7 @@
           <p:cNvPr id="15" name="3-Data and indicators-head">
             <a:extLst xmlns:a="http://schemas.openxmlformats.org/drawingml/2006/main">
               <a:ext uri="{FF2B5EF4-FFF2-40B4-BE49-F238E27FC236}">
-                <a16:creationId xmlns:a16="http://schemas.microsoft.com/office/drawing/2014/main" id="{ADB7A46C-D182-4C59-9918-0A5C155FB2D9}"/>
+                <a16:creationId xmlns:a16="http://schemas.microsoft.com/office/drawing/2014/main" id="{4BB25401-3A13-4F9E-9244-7C8AD3B9A3F6}"/>
               </a:ext>
             </a:extLst>
           </p:cNvPr>
@@ -1787,7 +1787,7 @@
           <p:cNvPr id="16" name="3-Data and indicators-title">
             <a:extLst xmlns:a="http://schemas.openxmlformats.org/drawingml/2006/main">
               <a:ext uri="{FF2B5EF4-FFF2-40B4-BE49-F238E27FC236}">
-                <a16:creationId xmlns:a16="http://schemas.microsoft.com/office/drawing/2014/main" id="{FB5B171E-744F-4E9C-9505-5485F8BADB22}"/>
+                <a16:creationId xmlns:a16="http://schemas.microsoft.com/office/drawing/2014/main" id="{A728D091-00CC-439B-8D76-1E5447889735}"/>
               </a:ext>
             </a:extLst>
           </p:cNvPr>
@@ -1837,7 +1837,7 @@
           <p:cNvPr id="17" name="3-Data and indicators-body">
             <a:extLst xmlns:a="http://schemas.openxmlformats.org/drawingml/2006/main">
               <a:ext uri="{FF2B5EF4-FFF2-40B4-BE49-F238E27FC236}">
-                <a16:creationId xmlns:a16="http://schemas.microsoft.com/office/drawing/2014/main" id="{F8ED97BF-BC98-464F-8D79-17D7C18B26CA}"/>
+                <a16:creationId xmlns:a16="http://schemas.microsoft.com/office/drawing/2014/main" id="{BD97D7F3-2E56-44F2-A1E8-7E0594173F81}"/>
               </a:ext>
             </a:extLst>
           </p:cNvPr>
@@ -1921,7 +1921,7 @@
           <p:cNvPr id="18" name="4-Sampling design-box">
             <a:extLst xmlns:a="http://schemas.openxmlformats.org/drawingml/2006/main">
               <a:ext uri="{FF2B5EF4-FFF2-40B4-BE49-F238E27FC236}">
-                <a16:creationId xmlns:a16="http://schemas.microsoft.com/office/drawing/2014/main" id="{7FD8824A-61AE-4D53-ADEE-0076920EDED9}"/>
+                <a16:creationId xmlns:a16="http://schemas.microsoft.com/office/drawing/2014/main" id="{C5A8E9C4-D005-46A4-B68B-0751BD88F6F3}"/>
               </a:ext>
             </a:extLst>
           </p:cNvPr>
@@ -1954,7 +1954,7 @@
           <p:cNvPr id="19" name="4-Sampling design-head">
             <a:extLst xmlns:a="http://schemas.openxmlformats.org/drawingml/2006/main">
               <a:ext uri="{FF2B5EF4-FFF2-40B4-BE49-F238E27FC236}">
-                <a16:creationId xmlns:a16="http://schemas.microsoft.com/office/drawing/2014/main" id="{7A2B7F5C-0251-4D72-A8A3-406490DD2729}"/>
+                <a16:creationId xmlns:a16="http://schemas.microsoft.com/office/drawing/2014/main" id="{C67AB3B8-9380-47B9-9E43-4C27FDDD919C}"/>
               </a:ext>
             </a:extLst>
           </p:cNvPr>
@@ -1987,7 +1987,7 @@
           <p:cNvPr id="20" name="4-Sampling design-title">
             <a:extLst xmlns:a="http://schemas.openxmlformats.org/drawingml/2006/main">
               <a:ext uri="{FF2B5EF4-FFF2-40B4-BE49-F238E27FC236}">
-                <a16:creationId xmlns:a16="http://schemas.microsoft.com/office/drawing/2014/main" id="{F71F7C3D-2D3B-4870-A39E-374C933429B4}"/>
+                <a16:creationId xmlns:a16="http://schemas.microsoft.com/office/drawing/2014/main" id="{30C0889D-06AD-456A-B884-65DA9E80E5F3}"/>
               </a:ext>
             </a:extLst>
           </p:cNvPr>
@@ -2037,7 +2037,7 @@
           <p:cNvPr id="21" name="4-Sampling design-body">
             <a:extLst xmlns:a="http://schemas.openxmlformats.org/drawingml/2006/main">
               <a:ext uri="{FF2B5EF4-FFF2-40B4-BE49-F238E27FC236}">
-                <a16:creationId xmlns:a16="http://schemas.microsoft.com/office/drawing/2014/main" id="{DC5DB49B-7726-4B03-ABCB-A6A59E1A4D0A}"/>
+                <a16:creationId xmlns:a16="http://schemas.microsoft.com/office/drawing/2014/main" id="{A9B74A47-B9A4-46F8-B21F-68AB201CA610}"/>
               </a:ext>
             </a:extLst>
           </p:cNvPr>
@@ -2138,7 +2138,7 @@
           <p:cNvPr id="22" name="classic-formula-box">
             <a:extLst xmlns:a="http://schemas.openxmlformats.org/drawingml/2006/main">
               <a:ext uri="{FF2B5EF4-FFF2-40B4-BE49-F238E27FC236}">
-                <a16:creationId xmlns:a16="http://schemas.microsoft.com/office/drawing/2014/main" id="{19CB154A-381B-4301-BB09-51AE72E0366F}"/>
+                <a16:creationId xmlns:a16="http://schemas.microsoft.com/office/drawing/2014/main" id="{65CA7A2A-CA4A-4FD2-85BC-DABB2F40FC84}"/>
               </a:ext>
             </a:extLst>
           </p:cNvPr>
@@ -2171,7 +2171,7 @@
           <p:cNvPr id="23" name="classic-formula-title">
             <a:extLst xmlns:a="http://schemas.openxmlformats.org/drawingml/2006/main">
               <a:ext uri="{FF2B5EF4-FFF2-40B4-BE49-F238E27FC236}">
-                <a16:creationId xmlns:a16="http://schemas.microsoft.com/office/drawing/2014/main" id="{F3B0562F-48F4-4637-92E4-CF87CBD51B24}"/>
+                <a16:creationId xmlns:a16="http://schemas.microsoft.com/office/drawing/2014/main" id="{74E6DD05-49BA-45D5-9F49-77D5724965E0}"/>
               </a:ext>
             </a:extLst>
           </p:cNvPr>
@@ -2221,7 +2221,7 @@
           <p:cNvPr id="24" name="classic-formula">
             <a:extLst xmlns:a="http://schemas.openxmlformats.org/drawingml/2006/main">
               <a:ext uri="{FF2B5EF4-FFF2-40B4-BE49-F238E27FC236}">
-                <a16:creationId xmlns:a16="http://schemas.microsoft.com/office/drawing/2014/main" id="{F1BA0F45-B5AF-4CBF-93D6-2C461C507EDB}"/>
+                <a16:creationId xmlns:a16="http://schemas.microsoft.com/office/drawing/2014/main" id="{1D4C4FAB-CBDE-4AC0-BE4F-97F04E4802A8}"/>
               </a:ext>
             </a:extLst>
           </p:cNvPr>
@@ -2339,7 +2339,7 @@
           <p:cNvPr id="25" name="prev-metric">
             <a:extLst xmlns:a="http://schemas.openxmlformats.org/drawingml/2006/main">
               <a:ext uri="{FF2B5EF4-FFF2-40B4-BE49-F238E27FC236}">
-                <a16:creationId xmlns:a16="http://schemas.microsoft.com/office/drawing/2014/main" id="{B8F957F0-52AB-4D5A-B3D4-A6F1D48AEE3B}"/>
+                <a16:creationId xmlns:a16="http://schemas.microsoft.com/office/drawing/2014/main" id="{992AD704-A3EC-421A-AC6F-006EBE21830B}"/>
               </a:ext>
             </a:extLst>
           </p:cNvPr>
@@ -2372,7 +2372,7 @@
           <p:cNvPr id="26" name="prev-metric-title">
             <a:extLst xmlns:a="http://schemas.openxmlformats.org/drawingml/2006/main">
               <a:ext uri="{FF2B5EF4-FFF2-40B4-BE49-F238E27FC236}">
-                <a16:creationId xmlns:a16="http://schemas.microsoft.com/office/drawing/2014/main" id="{03CF7E72-A6B5-4572-A4F5-4B24DC18F9DC}"/>
+                <a16:creationId xmlns:a16="http://schemas.microsoft.com/office/drawing/2014/main" id="{3FC43ED3-F994-43E5-98F7-2A408A908BA1}"/>
               </a:ext>
             </a:extLst>
           </p:cNvPr>
@@ -2422,7 +2422,7 @@
           <p:cNvPr id="27" name="prev-metric-value">
             <a:extLst xmlns:a="http://schemas.openxmlformats.org/drawingml/2006/main">
               <a:ext uri="{FF2B5EF4-FFF2-40B4-BE49-F238E27FC236}">
-                <a16:creationId xmlns:a16="http://schemas.microsoft.com/office/drawing/2014/main" id="{3C299F39-0660-40E1-A7A7-7CCB43922B7B}"/>
+                <a16:creationId xmlns:a16="http://schemas.microsoft.com/office/drawing/2014/main" id="{1C393D07-EBD3-424C-83A3-5CFD777EFCA8}"/>
               </a:ext>
             </a:extLst>
           </p:cNvPr>
@@ -2472,7 +2472,7 @@
           <p:cNvPr id="28" name="prev-metric-note">
             <a:extLst xmlns:a="http://schemas.openxmlformats.org/drawingml/2006/main">
               <a:ext uri="{FF2B5EF4-FFF2-40B4-BE49-F238E27FC236}">
-                <a16:creationId xmlns:a16="http://schemas.microsoft.com/office/drawing/2014/main" id="{CE508BD9-2BBB-41CF-9B0C-7A744CCE32D4}"/>
+                <a16:creationId xmlns:a16="http://schemas.microsoft.com/office/drawing/2014/main" id="{D130A567-D2CC-4198-99BC-7675209BC8EC}"/>
               </a:ext>
             </a:extLst>
           </p:cNvPr>
@@ -2522,7 +2522,7 @@
           <p:cNvPr id="29" name="crisis-metric">
             <a:extLst xmlns:a="http://schemas.openxmlformats.org/drawingml/2006/main">
               <a:ext uri="{FF2B5EF4-FFF2-40B4-BE49-F238E27FC236}">
-                <a16:creationId xmlns:a16="http://schemas.microsoft.com/office/drawing/2014/main" id="{454D1B46-AF73-431E-9CAA-AB21BB940CDF}"/>
+                <a16:creationId xmlns:a16="http://schemas.microsoft.com/office/drawing/2014/main" id="{F92DF442-D0CC-4366-8143-572FAA0ED3FA}"/>
               </a:ext>
             </a:extLst>
           </p:cNvPr>
@@ -2555,7 +2555,7 @@
           <p:cNvPr id="30" name="crisis-metric-title">
             <a:extLst xmlns:a="http://schemas.openxmlformats.org/drawingml/2006/main">
               <a:ext uri="{FF2B5EF4-FFF2-40B4-BE49-F238E27FC236}">
-                <a16:creationId xmlns:a16="http://schemas.microsoft.com/office/drawing/2014/main" id="{628B0A5D-9781-4409-807D-D28C4E800F42}"/>
+                <a16:creationId xmlns:a16="http://schemas.microsoft.com/office/drawing/2014/main" id="{6CC6847B-A64E-4DA2-867D-E1D7F73893B7}"/>
               </a:ext>
             </a:extLst>
           </p:cNvPr>
@@ -2605,7 +2605,7 @@
           <p:cNvPr id="31" name="crisis-metric-value">
             <a:extLst xmlns:a="http://schemas.openxmlformats.org/drawingml/2006/main">
               <a:ext uri="{FF2B5EF4-FFF2-40B4-BE49-F238E27FC236}">
-                <a16:creationId xmlns:a16="http://schemas.microsoft.com/office/drawing/2014/main" id="{8B93F2AB-6955-48E3-BA99-6E46BC4F5CA9}"/>
+                <a16:creationId xmlns:a16="http://schemas.microsoft.com/office/drawing/2014/main" id="{081E2AB2-6DC7-4A2F-9645-0352D8D95703}"/>
               </a:ext>
             </a:extLst>
           </p:cNvPr>
@@ -2655,7 +2655,7 @@
           <p:cNvPr id="32" name="crisis-metric-note">
             <a:extLst xmlns:a="http://schemas.openxmlformats.org/drawingml/2006/main">
               <a:ext uri="{FF2B5EF4-FFF2-40B4-BE49-F238E27FC236}">
-                <a16:creationId xmlns:a16="http://schemas.microsoft.com/office/drawing/2014/main" id="{B8A6F01E-D007-4285-BEDA-854499FE6530}"/>
+                <a16:creationId xmlns:a16="http://schemas.microsoft.com/office/drawing/2014/main" id="{8B58CEC5-A89A-4599-8AE2-EF4D5E6F2B58}"/>
               </a:ext>
             </a:extLst>
           </p:cNvPr>
@@ -2705,7 +2705,7 @@
           <p:cNvPr id="33" name="chart-prev-caption">
             <a:extLst xmlns:a="http://schemas.openxmlformats.org/drawingml/2006/main">
               <a:ext uri="{FF2B5EF4-FFF2-40B4-BE49-F238E27FC236}">
-                <a16:creationId xmlns:a16="http://schemas.microsoft.com/office/drawing/2014/main" id="{6C158926-CCB2-42B6-9379-32BB74A94580}"/>
+                <a16:creationId xmlns:a16="http://schemas.microsoft.com/office/drawing/2014/main" id="{B230F1E9-C21E-49F1-A850-7633486E3447}"/>
               </a:ext>
             </a:extLst>
           </p:cNvPr>
@@ -2755,7 +2755,7 @@
           <p:cNvPr id="34" name="chart-prev-frame">
             <a:extLst xmlns:a="http://schemas.openxmlformats.org/drawingml/2006/main">
               <a:ext uri="{FF2B5EF4-FFF2-40B4-BE49-F238E27FC236}">
-                <a16:creationId xmlns:a16="http://schemas.microsoft.com/office/drawing/2014/main" id="{3DBEDA56-214F-45A6-93B7-57987F81123B}"/>
+                <a16:creationId xmlns:a16="http://schemas.microsoft.com/office/drawing/2014/main" id="{77E2F75F-78AF-4E77-A9C8-9E28CD3AEB6C}"/>
               </a:ext>
             </a:extLst>
           </p:cNvPr>
@@ -2792,7 +2792,7 @@
           <p:nvPr/>
         </p:nvPicPr>
         <p:blipFill>
-          <a:blip xmlns:r="http://schemas.openxmlformats.org/officeDocument/2006/relationships" xmlns:a="http://schemas.openxmlformats.org/drawingml/2006/main" r:embed="R083dd2e93b704850"/>
+          <a:blip xmlns:r="http://schemas.openxmlformats.org/officeDocument/2006/relationships" xmlns:a="http://schemas.openxmlformats.org/drawingml/2006/main" r:embed="Rd02f173c6b0e47fd"/>
           <a:stretch xmlns:a="http://schemas.openxmlformats.org/drawingml/2006/main"/>
         </p:blipFill>
         <p:spPr>
@@ -2810,7 +2810,7 @@
           <p:cNvPr id="36" name="chart-crisis-caption">
             <a:extLst xmlns:a="http://schemas.openxmlformats.org/drawingml/2006/main">
               <a:ext uri="{FF2B5EF4-FFF2-40B4-BE49-F238E27FC236}">
-                <a16:creationId xmlns:a16="http://schemas.microsoft.com/office/drawing/2014/main" id="{8D2B7A6B-B913-4D6F-A2B2-15A639531EA7}"/>
+                <a16:creationId xmlns:a16="http://schemas.microsoft.com/office/drawing/2014/main" id="{10BF06BF-24AC-40EF-8EA9-96DA86A73B60}"/>
               </a:ext>
             </a:extLst>
           </p:cNvPr>
@@ -2860,7 +2860,7 @@
           <p:cNvPr id="37" name="chart-crisis-frame">
             <a:extLst xmlns:a="http://schemas.openxmlformats.org/drawingml/2006/main">
               <a:ext uri="{FF2B5EF4-FFF2-40B4-BE49-F238E27FC236}">
-                <a16:creationId xmlns:a16="http://schemas.microsoft.com/office/drawing/2014/main" id="{8B0DB653-809F-4162-B25B-0AD399D44748}"/>
+                <a16:creationId xmlns:a16="http://schemas.microsoft.com/office/drawing/2014/main" id="{B2C6AA04-F5FF-467C-89E5-2C99E820DCF9}"/>
               </a:ext>
             </a:extLst>
           </p:cNvPr>
@@ -2897,7 +2897,7 @@
           <p:nvPr/>
         </p:nvPicPr>
         <p:blipFill>
-          <a:blip xmlns:r="http://schemas.openxmlformats.org/officeDocument/2006/relationships" xmlns:a="http://schemas.openxmlformats.org/drawingml/2006/main" r:embed="R15cf23d38ee340b9"/>
+          <a:blip xmlns:r="http://schemas.openxmlformats.org/officeDocument/2006/relationships" xmlns:a="http://schemas.openxmlformats.org/drawingml/2006/main" r:embed="Rcb801952030445c9"/>
           <a:stretch xmlns:a="http://schemas.openxmlformats.org/drawingml/2006/main"/>
         </p:blipFill>
         <p:spPr>
@@ -2915,7 +2915,7 @@
           <p:cNvPr id="39" name="5-Discussion-box">
             <a:extLst xmlns:a="http://schemas.openxmlformats.org/drawingml/2006/main">
               <a:ext uri="{FF2B5EF4-FFF2-40B4-BE49-F238E27FC236}">
-                <a16:creationId xmlns:a16="http://schemas.microsoft.com/office/drawing/2014/main" id="{198CE6CA-A414-4FD6-AA80-F6113EDC0035}"/>
+                <a16:creationId xmlns:a16="http://schemas.microsoft.com/office/drawing/2014/main" id="{20296C46-70AE-4BA9-841C-0A68AD88559C}"/>
               </a:ext>
             </a:extLst>
           </p:cNvPr>
@@ -2948,7 +2948,7 @@
           <p:cNvPr id="40" name="5-Discussion-head">
             <a:extLst xmlns:a="http://schemas.openxmlformats.org/drawingml/2006/main">
               <a:ext uri="{FF2B5EF4-FFF2-40B4-BE49-F238E27FC236}">
-                <a16:creationId xmlns:a16="http://schemas.microsoft.com/office/drawing/2014/main" id="{72D348F3-07EE-4CA5-AA64-BE491E2DA8EC}"/>
+                <a16:creationId xmlns:a16="http://schemas.microsoft.com/office/drawing/2014/main" id="{41C422DD-8C5A-470C-B803-A65BCA9C7B95}"/>
               </a:ext>
             </a:extLst>
           </p:cNvPr>
@@ -2981,7 +2981,7 @@
           <p:cNvPr id="41" name="5-Discussion-title">
             <a:extLst xmlns:a="http://schemas.openxmlformats.org/drawingml/2006/main">
               <a:ext uri="{FF2B5EF4-FFF2-40B4-BE49-F238E27FC236}">
-                <a16:creationId xmlns:a16="http://schemas.microsoft.com/office/drawing/2014/main" id="{BB93E8AF-623C-4D96-8058-1344416553BF}"/>
+                <a16:creationId xmlns:a16="http://schemas.microsoft.com/office/drawing/2014/main" id="{642802D8-0703-43CC-98BA-FF24A7B074CC}"/>
               </a:ext>
             </a:extLst>
           </p:cNvPr>
@@ -3031,7 +3031,7 @@
           <p:cNvPr id="42" name="5-Discussion-body">
             <a:extLst xmlns:a="http://schemas.openxmlformats.org/drawingml/2006/main">
               <a:ext uri="{FF2B5EF4-FFF2-40B4-BE49-F238E27FC236}">
-                <a16:creationId xmlns:a16="http://schemas.microsoft.com/office/drawing/2014/main" id="{FE5D33EF-0CF9-47FB-984E-9D5AEDB1B47F}"/>
+                <a16:creationId xmlns:a16="http://schemas.microsoft.com/office/drawing/2014/main" id="{8488CA81-9BDE-4371-A220-4B3E07B380C6}"/>
               </a:ext>
             </a:extLst>
           </p:cNvPr>
@@ -3115,7 +3115,7 @@
           <p:cNvPr id="43" name="meds-metric">
             <a:extLst xmlns:a="http://schemas.openxmlformats.org/drawingml/2006/main">
               <a:ext uri="{FF2B5EF4-FFF2-40B4-BE49-F238E27FC236}">
-                <a16:creationId xmlns:a16="http://schemas.microsoft.com/office/drawing/2014/main" id="{F5BA26C1-637E-4044-9F81-7D3D965DC959}"/>
+                <a16:creationId xmlns:a16="http://schemas.microsoft.com/office/drawing/2014/main" id="{2BC9D387-DF44-4FF1-AE53-079E6D6F35F9}"/>
               </a:ext>
             </a:extLst>
           </p:cNvPr>
@@ -3148,7 +3148,7 @@
           <p:cNvPr id="44" name="meds-metric-title">
             <a:extLst xmlns:a="http://schemas.openxmlformats.org/drawingml/2006/main">
               <a:ext uri="{FF2B5EF4-FFF2-40B4-BE49-F238E27FC236}">
-                <a16:creationId xmlns:a16="http://schemas.microsoft.com/office/drawing/2014/main" id="{A4C4B4F2-B87E-4228-BF50-488A28BE6559}"/>
+                <a16:creationId xmlns:a16="http://schemas.microsoft.com/office/drawing/2014/main" id="{23A8C17D-2265-4786-9011-BDADA1CCB0BE}"/>
               </a:ext>
             </a:extLst>
           </p:cNvPr>
@@ -3198,7 +3198,7 @@
           <p:cNvPr id="45" name="meds-metric-value">
             <a:extLst xmlns:a="http://schemas.openxmlformats.org/drawingml/2006/main">
               <a:ext uri="{FF2B5EF4-FFF2-40B4-BE49-F238E27FC236}">
-                <a16:creationId xmlns:a16="http://schemas.microsoft.com/office/drawing/2014/main" id="{E0BA0341-7A36-424F-A8CA-07612EE03C7D}"/>
+                <a16:creationId xmlns:a16="http://schemas.microsoft.com/office/drawing/2014/main" id="{C03F5337-7FB3-4DBA-856B-3617DB3FAD43}"/>
               </a:ext>
             </a:extLst>
           </p:cNvPr>
@@ -3248,7 +3248,7 @@
           <p:cNvPr id="46" name="meds-metric-note">
             <a:extLst xmlns:a="http://schemas.openxmlformats.org/drawingml/2006/main">
               <a:ext uri="{FF2B5EF4-FFF2-40B4-BE49-F238E27FC236}">
-                <a16:creationId xmlns:a16="http://schemas.microsoft.com/office/drawing/2014/main" id="{96A6538F-F379-4585-B69F-6506F9492E99}"/>
+                <a16:creationId xmlns:a16="http://schemas.microsoft.com/office/drawing/2014/main" id="{32CE6DD7-E948-4685-91BC-954F613196B6}"/>
               </a:ext>
             </a:extLst>
           </p:cNvPr>
@@ -3298,7 +3298,7 @@
           <p:cNvPr id="47" name="chart-meds-caption">
             <a:extLst xmlns:a="http://schemas.openxmlformats.org/drawingml/2006/main">
               <a:ext uri="{FF2B5EF4-FFF2-40B4-BE49-F238E27FC236}">
-                <a16:creationId xmlns:a16="http://schemas.microsoft.com/office/drawing/2014/main" id="{BB8BD4A0-6A10-43E7-93F3-3D7B9C766656}"/>
+                <a16:creationId xmlns:a16="http://schemas.microsoft.com/office/drawing/2014/main" id="{2BF22512-3602-4575-9EF9-D00DC74808C3}"/>
               </a:ext>
             </a:extLst>
           </p:cNvPr>
@@ -3348,7 +3348,7 @@
           <p:cNvPr id="48" name="chart-meds-frame">
             <a:extLst xmlns:a="http://schemas.openxmlformats.org/drawingml/2006/main">
               <a:ext uri="{FF2B5EF4-FFF2-40B4-BE49-F238E27FC236}">
-                <a16:creationId xmlns:a16="http://schemas.microsoft.com/office/drawing/2014/main" id="{0C5036B7-EF33-4D8C-BA4B-E072ED7D396D}"/>
+                <a16:creationId xmlns:a16="http://schemas.microsoft.com/office/drawing/2014/main" id="{55C4AB6A-6801-47A4-AD15-E8048B9350E3}"/>
               </a:ext>
             </a:extLst>
           </p:cNvPr>
@@ -3385,13 +3385,13 @@
           <p:nvPr/>
         </p:nvPicPr>
         <p:blipFill>
-          <a:blip xmlns:r="http://schemas.openxmlformats.org/officeDocument/2006/relationships" xmlns:a="http://schemas.openxmlformats.org/drawingml/2006/main" r:embed="Rcc8d79da89e74385"/>
+          <a:blip xmlns:r="http://schemas.openxmlformats.org/officeDocument/2006/relationships" xmlns:a="http://schemas.openxmlformats.org/drawingml/2006/main" r:embed="R8c8dfd81c2bd4a74"/>
           <a:stretch xmlns:a="http://schemas.openxmlformats.org/drawingml/2006/main"/>
         </p:blipFill>
         <p:spPr>
           <a:xfrm xmlns:a="http://schemas.openxmlformats.org/drawingml/2006/main">
-            <a:off x="6410390" y="3676650"/>
-            <a:ext cx="2749420" cy="1981200"/>
+            <a:off x="6407150" y="3684712"/>
+            <a:ext cx="2755900" cy="1965077"/>
           </a:xfrm>
           <a:prstGeom xmlns:a="http://schemas.openxmlformats.org/drawingml/2006/main" prst="rect">
             <a:avLst/>
@@ -3403,7 +3403,7 @@
           <p:cNvPr id="50" name="chart-smoke-caption">
             <a:extLst xmlns:a="http://schemas.openxmlformats.org/drawingml/2006/main">
               <a:ext uri="{FF2B5EF4-FFF2-40B4-BE49-F238E27FC236}">
-                <a16:creationId xmlns:a16="http://schemas.microsoft.com/office/drawing/2014/main" id="{379BF85E-D139-4B61-BCCF-2207E55C18E9}"/>
+                <a16:creationId xmlns:a16="http://schemas.microsoft.com/office/drawing/2014/main" id="{36C8D51A-3ED7-44B6-B595-76121074F882}"/>
               </a:ext>
             </a:extLst>
           </p:cNvPr>
@@ -3453,7 +3453,7 @@
           <p:cNvPr id="51" name="chart-smoke-frame">
             <a:extLst xmlns:a="http://schemas.openxmlformats.org/drawingml/2006/main">
               <a:ext uri="{FF2B5EF4-FFF2-40B4-BE49-F238E27FC236}">
-                <a16:creationId xmlns:a16="http://schemas.microsoft.com/office/drawing/2014/main" id="{AE0A04AE-046F-47C9-A879-B16E48B5DFFB}"/>
+                <a16:creationId xmlns:a16="http://schemas.microsoft.com/office/drawing/2014/main" id="{3E26E4C4-48DA-41F3-B579-6BC416BA07A4}"/>
               </a:ext>
             </a:extLst>
           </p:cNvPr>
@@ -3490,7 +3490,7 @@
           <p:nvPr/>
         </p:nvPicPr>
         <p:blipFill>
-          <a:blip xmlns:r="http://schemas.openxmlformats.org/officeDocument/2006/relationships" xmlns:a="http://schemas.openxmlformats.org/drawingml/2006/main" r:embed="Ra5cadbe934904671"/>
+          <a:blip xmlns:r="http://schemas.openxmlformats.org/officeDocument/2006/relationships" xmlns:a="http://schemas.openxmlformats.org/drawingml/2006/main" r:embed="R13d4d144317d4e86"/>
           <a:stretch xmlns:a="http://schemas.openxmlformats.org/drawingml/2006/main"/>
         </p:blipFill>
         <p:spPr>
@@ -3508,7 +3508,7 @@
           <p:cNvPr id="53" name="6-Beta CI and chart reading-box">
             <a:extLst xmlns:a="http://schemas.openxmlformats.org/drawingml/2006/main">
               <a:ext uri="{FF2B5EF4-FFF2-40B4-BE49-F238E27FC236}">
-                <a16:creationId xmlns:a16="http://schemas.microsoft.com/office/drawing/2014/main" id="{E2A3A153-1A1A-44EF-A3F8-CF116D84EC95}"/>
+                <a16:creationId xmlns:a16="http://schemas.microsoft.com/office/drawing/2014/main" id="{7D886288-0A61-4D79-9BEA-0C1AB0E25DF3}"/>
               </a:ext>
             </a:extLst>
           </p:cNvPr>
@@ -3541,7 +3541,7 @@
           <p:cNvPr id="54" name="6-Beta CI and chart reading-head">
             <a:extLst xmlns:a="http://schemas.openxmlformats.org/drawingml/2006/main">
               <a:ext uri="{FF2B5EF4-FFF2-40B4-BE49-F238E27FC236}">
-                <a16:creationId xmlns:a16="http://schemas.microsoft.com/office/drawing/2014/main" id="{2ED1805B-D6CD-4879-B272-C303DF9C0AA1}"/>
+                <a16:creationId xmlns:a16="http://schemas.microsoft.com/office/drawing/2014/main" id="{E0857305-88D4-432A-B210-28E0CDB89FD2}"/>
               </a:ext>
             </a:extLst>
           </p:cNvPr>
@@ -3574,7 +3574,7 @@
           <p:cNvPr id="55" name="6-Beta CI and chart reading-title">
             <a:extLst xmlns:a="http://schemas.openxmlformats.org/drawingml/2006/main">
               <a:ext uri="{FF2B5EF4-FFF2-40B4-BE49-F238E27FC236}">
-                <a16:creationId xmlns:a16="http://schemas.microsoft.com/office/drawing/2014/main" id="{0696C765-AA29-42E4-9706-5A5976089BB1}"/>
+                <a16:creationId xmlns:a16="http://schemas.microsoft.com/office/drawing/2014/main" id="{4A1BF137-9711-4380-9D9C-03B958CCD7D1}"/>
               </a:ext>
             </a:extLst>
           </p:cNvPr>
@@ -3624,7 +3624,7 @@
           <p:cNvPr id="56" name="6-Beta CI and chart reading-body">
             <a:extLst xmlns:a="http://schemas.openxmlformats.org/drawingml/2006/main">
               <a:ext uri="{FF2B5EF4-FFF2-40B4-BE49-F238E27FC236}">
-                <a16:creationId xmlns:a16="http://schemas.microsoft.com/office/drawing/2014/main" id="{74D2AF5D-400A-47C6-A0D8-A652F2897E0C}"/>
+                <a16:creationId xmlns:a16="http://schemas.microsoft.com/office/drawing/2014/main" id="{97D15CD2-D8D9-4A39-B5C1-4880480A118E}"/>
               </a:ext>
             </a:extLst>
           </p:cNvPr>
@@ -3708,7 +3708,7 @@
           <p:cNvPr id="57" name="7-Economic impact-box">
             <a:extLst xmlns:a="http://schemas.openxmlformats.org/drawingml/2006/main">
               <a:ext uri="{FF2B5EF4-FFF2-40B4-BE49-F238E27FC236}">
-                <a16:creationId xmlns:a16="http://schemas.microsoft.com/office/drawing/2014/main" id="{0A9532C9-E1E5-4B57-A8DA-2622846763AB}"/>
+                <a16:creationId xmlns:a16="http://schemas.microsoft.com/office/drawing/2014/main" id="{993EC9D1-0D1E-47E0-AF37-624EB141A4E7}"/>
               </a:ext>
             </a:extLst>
           </p:cNvPr>
@@ -3741,7 +3741,7 @@
           <p:cNvPr id="58" name="7-Economic impact-head">
             <a:extLst xmlns:a="http://schemas.openxmlformats.org/drawingml/2006/main">
               <a:ext uri="{FF2B5EF4-FFF2-40B4-BE49-F238E27FC236}">
-                <a16:creationId xmlns:a16="http://schemas.microsoft.com/office/drawing/2014/main" id="{D5BB2D5D-AFA4-438D-96CB-B1501C368708}"/>
+                <a16:creationId xmlns:a16="http://schemas.microsoft.com/office/drawing/2014/main" id="{72F4F155-4E89-4959-AAAD-33D553433866}"/>
               </a:ext>
             </a:extLst>
           </p:cNvPr>
@@ -3774,7 +3774,7 @@
           <p:cNvPr id="59" name="7-Economic impact-title">
             <a:extLst xmlns:a="http://schemas.openxmlformats.org/drawingml/2006/main">
               <a:ext uri="{FF2B5EF4-FFF2-40B4-BE49-F238E27FC236}">
-                <a16:creationId xmlns:a16="http://schemas.microsoft.com/office/drawing/2014/main" id="{3FEAE7B9-52BD-4445-87A4-325581646954}"/>
+                <a16:creationId xmlns:a16="http://schemas.microsoft.com/office/drawing/2014/main" id="{01488C17-B078-48DC-88BA-9AEBB234CB15}"/>
               </a:ext>
             </a:extLst>
           </p:cNvPr>
@@ -3824,7 +3824,7 @@
           <p:cNvPr id="60" name="7-Economic impact-body">
             <a:extLst xmlns:a="http://schemas.openxmlformats.org/drawingml/2006/main">
               <a:ext uri="{FF2B5EF4-FFF2-40B4-BE49-F238E27FC236}">
-                <a16:creationId xmlns:a16="http://schemas.microsoft.com/office/drawing/2014/main" id="{F60FA900-F154-40EF-93A3-1A5E9C60A9F6}"/>
+                <a16:creationId xmlns:a16="http://schemas.microsoft.com/office/drawing/2014/main" id="{E2F7A55E-2E7D-4D7B-B736-5E251E0B8A65}"/>
               </a:ext>
             </a:extLst>
           </p:cNvPr>
@@ -3891,7 +3891,7 @@
           <p:cNvPr id="61" name="8-ETL, OMOP and OHDSI-box">
             <a:extLst xmlns:a="http://schemas.openxmlformats.org/drawingml/2006/main">
               <a:ext uri="{FF2B5EF4-FFF2-40B4-BE49-F238E27FC236}">
-                <a16:creationId xmlns:a16="http://schemas.microsoft.com/office/drawing/2014/main" id="{A97A3B12-A082-499E-9357-A01E1E483A7B}"/>
+                <a16:creationId xmlns:a16="http://schemas.microsoft.com/office/drawing/2014/main" id="{AEA9E3A2-B8A4-494B-9B99-5716FB9E5321}"/>
               </a:ext>
             </a:extLst>
           </p:cNvPr>
@@ -3924,7 +3924,7 @@
           <p:cNvPr id="62" name="8-ETL, OMOP and OHDSI-head">
             <a:extLst xmlns:a="http://schemas.openxmlformats.org/drawingml/2006/main">
               <a:ext uri="{FF2B5EF4-FFF2-40B4-BE49-F238E27FC236}">
-                <a16:creationId xmlns:a16="http://schemas.microsoft.com/office/drawing/2014/main" id="{FC570A5F-64CB-43B1-915E-0A18D789F1CD}"/>
+                <a16:creationId xmlns:a16="http://schemas.microsoft.com/office/drawing/2014/main" id="{6D224476-5768-4D02-BCD6-8E28A02E0987}"/>
               </a:ext>
             </a:extLst>
           </p:cNvPr>
@@ -3957,7 +3957,7 @@
           <p:cNvPr id="63" name="8-ETL, OMOP and OHDSI-title">
             <a:extLst xmlns:a="http://schemas.openxmlformats.org/drawingml/2006/main">
               <a:ext uri="{FF2B5EF4-FFF2-40B4-BE49-F238E27FC236}">
-                <a16:creationId xmlns:a16="http://schemas.microsoft.com/office/drawing/2014/main" id="{87B4674D-5F45-4B0E-AD4E-C5A2B5926DA5}"/>
+                <a16:creationId xmlns:a16="http://schemas.microsoft.com/office/drawing/2014/main" id="{39EBA4CA-CA38-444A-B307-D9684CBF9BC6}"/>
               </a:ext>
             </a:extLst>
           </p:cNvPr>
@@ -4007,7 +4007,7 @@
           <p:cNvPr id="64" name="8-ETL, OMOP and OHDSI-body">
             <a:extLst xmlns:a="http://schemas.openxmlformats.org/drawingml/2006/main">
               <a:ext uri="{FF2B5EF4-FFF2-40B4-BE49-F238E27FC236}">
-                <a16:creationId xmlns:a16="http://schemas.microsoft.com/office/drawing/2014/main" id="{8550FE4A-0A34-4FD9-B681-0AF3D0C87EA8}"/>
+                <a16:creationId xmlns:a16="http://schemas.microsoft.com/office/drawing/2014/main" id="{7B48A05A-5E5B-4B06-A4FE-ADFAB8911B53}"/>
               </a:ext>
             </a:extLst>
           </p:cNvPr>
@@ -4091,7 +4091,7 @@
           <p:cNvPr id="65" name="9-Conclusions-box">
             <a:extLst xmlns:a="http://schemas.openxmlformats.org/drawingml/2006/main">
               <a:ext uri="{FF2B5EF4-FFF2-40B4-BE49-F238E27FC236}">
-                <a16:creationId xmlns:a16="http://schemas.microsoft.com/office/drawing/2014/main" id="{A6507B9C-3D93-44F2-BB27-AE65CF96AA1A}"/>
+                <a16:creationId xmlns:a16="http://schemas.microsoft.com/office/drawing/2014/main" id="{02013D3C-D16D-48B7-A10E-F5844F05038A}"/>
               </a:ext>
             </a:extLst>
           </p:cNvPr>
@@ -4124,7 +4124,7 @@
           <p:cNvPr id="66" name="9-Conclusions-head">
             <a:extLst xmlns:a="http://schemas.openxmlformats.org/drawingml/2006/main">
               <a:ext uri="{FF2B5EF4-FFF2-40B4-BE49-F238E27FC236}">
-                <a16:creationId xmlns:a16="http://schemas.microsoft.com/office/drawing/2014/main" id="{0E0A0D6E-DBF4-4DC1-9248-F58AF4A079CB}"/>
+                <a16:creationId xmlns:a16="http://schemas.microsoft.com/office/drawing/2014/main" id="{85E02F4F-DBA2-4F36-8073-044BAE21349E}"/>
               </a:ext>
             </a:extLst>
           </p:cNvPr>
@@ -4157,7 +4157,7 @@
           <p:cNvPr id="67" name="9-Conclusions-title">
             <a:extLst xmlns:a="http://schemas.openxmlformats.org/drawingml/2006/main">
               <a:ext uri="{FF2B5EF4-FFF2-40B4-BE49-F238E27FC236}">
-                <a16:creationId xmlns:a16="http://schemas.microsoft.com/office/drawing/2014/main" id="{180A017E-05FE-4D35-B4D9-94C15EC7FEEB}"/>
+                <a16:creationId xmlns:a16="http://schemas.microsoft.com/office/drawing/2014/main" id="{D7CB2C6B-85CF-4705-AE1A-3027E94F219A}"/>
               </a:ext>
             </a:extLst>
           </p:cNvPr>
@@ -4207,7 +4207,7 @@
           <p:cNvPr id="68" name="9-Conclusions-body">
             <a:extLst xmlns:a="http://schemas.openxmlformats.org/drawingml/2006/main">
               <a:ext uri="{FF2B5EF4-FFF2-40B4-BE49-F238E27FC236}">
-                <a16:creationId xmlns:a16="http://schemas.microsoft.com/office/drawing/2014/main" id="{6CC938EE-5103-47C2-81BE-0F8F9B493B98}"/>
+                <a16:creationId xmlns:a16="http://schemas.microsoft.com/office/drawing/2014/main" id="{A96E1086-9322-43E3-B822-BA8C49579D7C}"/>
               </a:ext>
             </a:extLst>
           </p:cNvPr>
@@ -4291,7 +4291,7 @@
           <p:cNvPr id="69" name="references-box">
             <a:extLst xmlns:a="http://schemas.openxmlformats.org/drawingml/2006/main">
               <a:ext uri="{FF2B5EF4-FFF2-40B4-BE49-F238E27FC236}">
-                <a16:creationId xmlns:a16="http://schemas.microsoft.com/office/drawing/2014/main" id="{803B685D-1B26-4D1A-955B-14C0EED6A5D4}"/>
+                <a16:creationId xmlns:a16="http://schemas.microsoft.com/office/drawing/2014/main" id="{4E2AC899-7BD7-4514-8188-06BD7EBC3681}"/>
               </a:ext>
             </a:extLst>
           </p:cNvPr>
@@ -4324,7 +4324,7 @@
           <p:cNvPr id="70" name="references-title">
             <a:extLst xmlns:a="http://schemas.openxmlformats.org/drawingml/2006/main">
               <a:ext uri="{FF2B5EF4-FFF2-40B4-BE49-F238E27FC236}">
-                <a16:creationId xmlns:a16="http://schemas.microsoft.com/office/drawing/2014/main" id="{6652ED7C-E63D-4B11-97F0-8279A2D22D89}"/>
+                <a16:creationId xmlns:a16="http://schemas.microsoft.com/office/drawing/2014/main" id="{11381CB6-9F89-4718-8009-B54E4E66C4D7}"/>
               </a:ext>
             </a:extLst>
           </p:cNvPr>
@@ -4374,7 +4374,7 @@
           <p:cNvPr id="71" name="references-body">
             <a:extLst xmlns:a="http://schemas.openxmlformats.org/drawingml/2006/main">
               <a:ext uri="{FF2B5EF4-FFF2-40B4-BE49-F238E27FC236}">
-                <a16:creationId xmlns:a16="http://schemas.microsoft.com/office/drawing/2014/main" id="{2673E975-421F-45A5-B061-AA2FAB35C904}"/>
+                <a16:creationId xmlns:a16="http://schemas.microsoft.com/office/drawing/2014/main" id="{478638BA-15F6-42E2-9362-368612E06B11}"/>
               </a:ext>
             </a:extLst>
           </p:cNvPr>
@@ -4628,7 +4628,7 @@
           <p:cNvPr id="72" name="qr-box">
             <a:extLst xmlns:a="http://schemas.openxmlformats.org/drawingml/2006/main">
               <a:ext uri="{FF2B5EF4-FFF2-40B4-BE49-F238E27FC236}">
-                <a16:creationId xmlns:a16="http://schemas.microsoft.com/office/drawing/2014/main" id="{21FD3BA8-728F-43F1-B8C4-F737A95D3882}"/>
+                <a16:creationId xmlns:a16="http://schemas.microsoft.com/office/drawing/2014/main" id="{1FEB14FB-E646-46EE-AB17-9EA62DEAEA22}"/>
               </a:ext>
             </a:extLst>
           </p:cNvPr>
@@ -4665,7 +4665,7 @@
           <p:nvPr/>
         </p:nvPicPr>
         <p:blipFill>
-          <a:blip xmlns:r="http://schemas.openxmlformats.org/officeDocument/2006/relationships" xmlns:a="http://schemas.openxmlformats.org/drawingml/2006/main" r:embed="R633ba7de210240f1"/>
+          <a:blip xmlns:r="http://schemas.openxmlformats.org/officeDocument/2006/relationships" xmlns:a="http://schemas.openxmlformats.org/drawingml/2006/main" r:embed="Ra8db20cdfc4c4daf"/>
           <a:stretch xmlns:a="http://schemas.openxmlformats.org/drawingml/2006/main"/>
         </p:blipFill>
         <p:spPr>
@@ -4683,7 +4683,7 @@
           <p:cNvPr id="74" name="qr-label">
             <a:extLst xmlns:a="http://schemas.openxmlformats.org/drawingml/2006/main">
               <a:ext uri="{FF2B5EF4-FFF2-40B4-BE49-F238E27FC236}">
-                <a16:creationId xmlns:a16="http://schemas.microsoft.com/office/drawing/2014/main" id="{C51A7279-DBB7-4CF1-9DD0-DB455EDD03F6}"/>
+                <a16:creationId xmlns:a16="http://schemas.microsoft.com/office/drawing/2014/main" id="{384D5546-2C6E-4E82-91FE-12D0B21CF835}"/>
               </a:ext>
             </a:extLst>
           </p:cNvPr>
@@ -4748,7 +4748,7 @@
     </p:spTree>
     <p:extLst>
       <p:ext uri="{BB962C8B-B14F-4D97-AF65-F5344CB8AC3E}">
-        <p14:creationId xmlns:p14="http://schemas.microsoft.com/office/powerpoint/2010/main" val="1982053538"/>
+        <p14:creationId xmlns:p14="http://schemas.microsoft.com/office/powerpoint/2010/main" val="2064468395"/>
       </p:ext>
     </p:extLst>
   </p:cSld>

</xml_diff>